<commit_message>
Snake deck: same essentials, different form
The content builder as a pipeline, assets as data as real XML and a
question, input buffering as a timeline of two ticks, the collision
refactor as code; old text in the speaker notes, and the site's Check
yourself questions at the end.

Co-Authored-By: Claude Opus 5.5 <noreply@anthropic.com>
Claude-Session: https://claude.ai/code/session_012sjsUQBbC7zon57rWHoo9d
</commit_message>
<xml_diff>
--- a/slides/03 Snake.pptx
+++ b/slides/03 Snake.pptx
@@ -40,6 +40,7 @@
     <p:sldId id="291" r:id="rId41"/>
     <p:sldId id="292" r:id="rId42"/>
     <p:sldId id="293" r:id="rId52"/>
+    <p:sldId id="302" r:id="rId30"/>
     <p:sldId id="294" r:id="rId53"/>
     <p:sldId id="296" r:id="rId55"/>
   </p:sldIdLst>
@@ -1333,6 +1334,333 @@
 </p:notes>
 </file>
 
+<file path=ppt/notesSlides/notesSlide22.xml><?xml version="1.0" encoding="utf-8"?>
+<p:notes xmlns:a="http://schemas.openxmlformats.org/drawingml/2006/main" xmlns:p="http://schemas.openxmlformats.org/presentationml/2006/main" xmlns:r="http://schemas.openxmlformats.org/officeDocument/2006/relationships">
+  <p:cSld>
+    <p:spTree>
+      <p:nvGrpSpPr>
+        <p:cNvPr id="1" name=""/>
+        <p:cNvGrpSpPr/>
+        <p:nvPr/>
+      </p:nvGrpSpPr>
+      <p:grpSpPr>
+        <a:xfrm>
+          <a:off x="0" y="0"/>
+          <a:ext cx="0" cy="0"/>
+          <a:chOff x="0" y="0"/>
+          <a:chExt cx="0" cy="0"/>
+        </a:xfrm>
+      </p:grpSpPr>
+      <p:sp>
+        <p:nvSpPr>
+          <p:cNvPr id="2" name="Slide Image Placeholder 1"/>
+          <p:cNvSpPr>
+            <a:spLocks noGrp="1"/>
+          </p:cNvSpPr>
+          <p:nvPr>
+            <p:ph type="sldImg" idx="2"/>
+          </p:nvPr>
+        </p:nvSpPr>
+        <p:spPr/>
+      </p:sp>
+      <p:sp>
+        <p:nvSpPr>
+          <p:cNvPr id="3" name="Notes Placeholder 2"/>
+          <p:cNvSpPr>
+            <a:spLocks noGrp="1"/>
+          </p:cNvSpPr>
+          <p:nvPr>
+            <p:ph type="body" idx="1"/>
+          </p:nvPr>
+        </p:nvSpPr>
+        <p:spPr/>
+        <p:txBody>
+          <a:bodyPr/>
+          <a:lstStyle/>
+          <a:p>
+            <a:r>
+              <a:t>Ask, let them answer in pairs for a minute, then take a few answers. These are the site’s Check yourself questions.</a:t>
+            </a:r>
+          </a:p>
+        </p:txBody>
+      </p:sp>
+    </p:spTree>
+  </p:cSld>
+  <p:clrMapOvr>
+    <a:masterClrMapping/>
+  </p:clrMapOvr>
+</p:notes>
+</file>
+
+<file path=ppt/notesSlides/notesSlide23.xml><?xml version="1.0" encoding="utf-8"?>
+<p:notes xmlns:a="http://schemas.openxmlformats.org/drawingml/2006/main" xmlns:p="http://schemas.openxmlformats.org/presentationml/2006/main" xmlns:r="http://schemas.openxmlformats.org/officeDocument/2006/relationships">
+  <p:cSld>
+    <p:spTree>
+      <p:nvGrpSpPr>
+        <p:cNvPr id="1" name=""/>
+        <p:cNvGrpSpPr/>
+        <p:nvPr/>
+      </p:nvGrpSpPr>
+      <p:grpSpPr>
+        <a:xfrm>
+          <a:off x="0" y="0"/>
+          <a:ext cx="0" cy="0"/>
+          <a:chOff x="0" y="0"/>
+          <a:chExt cx="0" cy="0"/>
+        </a:xfrm>
+      </p:grpSpPr>
+      <p:sp>
+        <p:nvSpPr>
+          <p:cNvPr id="2" name="Slide Image Placeholder 1"/>
+          <p:cNvSpPr>
+            <a:spLocks noGrp="1"/>
+          </p:cNvSpPr>
+          <p:nvPr>
+            <p:ph type="sldImg" idx="2"/>
+          </p:nvPr>
+        </p:nvSpPr>
+        <p:spPr/>
+      </p:sp>
+      <p:sp>
+        <p:nvSpPr>
+          <p:cNvPr id="3" name="Notes Placeholder 2"/>
+          <p:cNvSpPr>
+            <a:spLocks noGrp="1"/>
+          </p:cNvSpPr>
+          <p:nvPr>
+            <p:ph type="body" idx="1"/>
+          </p:nvPr>
+        </p:nvSpPr>
+        <p:spPr/>
+        <p:txBody>
+          <a:bodyPr/>
+          <a:lstStyle/>
+          <a:p>
+            <a:r>
+              <a:t>Talking points:</a:t>
+            </a:r>
+          </a:p>
+          <a:p>
+            <a:r>
+              <a:t>- Input happens every frame, but the snake acts on a tick</a:t>
+            </a:r>
+          </a:p>
+          <a:p>
+            <a:r>
+              <a:t>  - Up, then Left between two ticks: the second press overwrites the first</a:t>
+            </a:r>
+          </a:p>
+          <a:p>
+            <a:r>
+              <a:t>- Queue the turns, and use one per tick</a:t>
+            </a:r>
+          </a:p>
+          <a:p>
+            <a:r>
+              <a:t>  - Check each turn against the last queued direction</a:t>
+            </a:r>
+          </a:p>
+          <a:p>
+            <a:r>
+              <a:t>  - Keep the queue short: two turns</a:t>
+            </a:r>
+          </a:p>
+          <a:p>
+            <a:r>
+              <a:t>- Common in games: a jump pressed just before landing still counts</a:t>
+            </a:r>
+          </a:p>
+        </p:txBody>
+      </p:sp>
+    </p:spTree>
+  </p:cSld>
+  <p:clrMapOvr>
+    <a:masterClrMapping/>
+  </p:clrMapOvr>
+</p:notes>
+</file>
+
+<file path=ppt/notesSlides/notesSlide24.xml><?xml version="1.0" encoding="utf-8"?>
+<p:notes xmlns:a="http://schemas.openxmlformats.org/drawingml/2006/main" xmlns:p="http://schemas.openxmlformats.org/presentationml/2006/main" xmlns:r="http://schemas.openxmlformats.org/officeDocument/2006/relationships">
+  <p:cSld>
+    <p:spTree>
+      <p:nvGrpSpPr>
+        <p:cNvPr id="1" name=""/>
+        <p:cNvGrpSpPr/>
+        <p:nvPr/>
+      </p:nvGrpSpPr>
+      <p:grpSpPr>
+        <a:xfrm>
+          <a:off x="0" y="0"/>
+          <a:ext cx="0" cy="0"/>
+          <a:chOff x="0" y="0"/>
+          <a:chExt cx="0" cy="0"/>
+        </a:xfrm>
+      </p:grpSpPr>
+      <p:sp>
+        <p:nvSpPr>
+          <p:cNvPr id="2" name="Slide Image Placeholder 1"/>
+          <p:cNvSpPr>
+            <a:spLocks noGrp="1"/>
+          </p:cNvSpPr>
+          <p:nvPr>
+            <p:ph type="sldImg" idx="2"/>
+          </p:nvPr>
+        </p:nvSpPr>
+        <p:spPr/>
+      </p:sp>
+      <p:sp>
+        <p:nvSpPr>
+          <p:cNvPr id="3" name="Notes Placeholder 2"/>
+          <p:cNvSpPr>
+            <a:spLocks noGrp="1"/>
+          </p:cNvSpPr>
+          <p:nvPr>
+            <p:ph type="body" idx="1"/>
+          </p:nvPr>
+        </p:nvSpPr>
+        <p:spPr/>
+        <p:txBody>
+          <a:bodyPr/>
+          <a:lstStyle/>
+          <a:p>
+            <a:r>
+              <a:t>Talking points:</a:t>
+            </a:r>
+          </a:p>
+          <a:p>
+            <a:r>
+              <a:t>- The XML files describe the assets</a:t>
+            </a:r>
+          </a:p>
+          <a:p>
+            <a:r>
+              <a:t>  - Which part of the image is the snake, how the bat’s animation runs, which tile goes where</a:t>
+            </a:r>
+          </a:p>
+          <a:p>
+            <a:r>
+              <a:t>- Data can change without the code changing</a:t>
+            </a:r>
+          </a:p>
+          <a:p>
+            <a:r>
+              <a:t>  - A new frame, a faster animation or a new room: edit a file, not C#</a:t>
+            </a:r>
+          </a:p>
+          <a:p>
+            <a:r>
+              <a:t>  - Artists and designers can work without touching the code</a:t>
+            </a:r>
+          </a:p>
+          <a:p>
+            <a:r>
+              <a:t>- The code gets smaller and more general</a:t>
+            </a:r>
+          </a:p>
+        </p:txBody>
+      </p:sp>
+    </p:spTree>
+  </p:cSld>
+  <p:clrMapOvr>
+    <a:masterClrMapping/>
+  </p:clrMapOvr>
+</p:notes>
+</file>
+
+<file path=ppt/notesSlides/notesSlide25.xml><?xml version="1.0" encoding="utf-8"?>
+<p:notes xmlns:a="http://schemas.openxmlformats.org/drawingml/2006/main" xmlns:p="http://schemas.openxmlformats.org/presentationml/2006/main" xmlns:r="http://schemas.openxmlformats.org/officeDocument/2006/relationships">
+  <p:cSld>
+    <p:spTree>
+      <p:nvGrpSpPr>
+        <p:cNvPr id="1" name=""/>
+        <p:cNvGrpSpPr/>
+        <p:nvPr/>
+      </p:nvGrpSpPr>
+      <p:grpSpPr>
+        <a:xfrm>
+          <a:off x="0" y="0"/>
+          <a:ext cx="0" cy="0"/>
+          <a:chOff x="0" y="0"/>
+          <a:chExt cx="0" cy="0"/>
+        </a:xfrm>
+      </p:grpSpPr>
+      <p:sp>
+        <p:nvSpPr>
+          <p:cNvPr id="2" name="Slide Image Placeholder 1"/>
+          <p:cNvSpPr>
+            <a:spLocks noGrp="1"/>
+          </p:cNvSpPr>
+          <p:nvPr>
+            <p:ph type="sldImg" idx="2"/>
+          </p:nvPr>
+        </p:nvSpPr>
+        <p:spPr/>
+      </p:sp>
+      <p:sp>
+        <p:nvSpPr>
+          <p:cNvPr id="3" name="Notes Placeholder 2"/>
+          <p:cNvSpPr>
+            <a:spLocks noGrp="1"/>
+          </p:cNvSpPr>
+          <p:nvPr>
+            <p:ph type="body" idx="1"/>
+          </p:nvPr>
+        </p:nvSpPr>
+        <p:spPr/>
+        <p:txBody>
+          <a:bodyPr/>
+          <a:lstStyle/>
+          <a:p>
+            <a:r>
+              <a:t>Talking points:</a:t>
+            </a:r>
+          </a:p>
+          <a:p>
+            <a:r>
+              <a:t>- The same content builder as in Pong and Flappy Bird</a:t>
+            </a:r>
+          </a:p>
+          <a:p>
+            <a:r>
+              <a:t>- But here, all steps share one Content project</a:t>
+            </a:r>
+          </a:p>
+          <a:p>
+            <a:r>
+              <a:t>  - Content/Assets: the raw images and XML definitions</a:t>
+            </a:r>
+          </a:p>
+          <a:p>
+            <a:r>
+              <a:t>  - Content/Builder/Builder.cs: the build rules, in C#</a:t>
+            </a:r>
+          </a:p>
+          <a:p>
+            <a:r>
+              <a:t>- The rules decide how each asset is processed</a:t>
+            </a:r>
+          </a:p>
+          <a:p>
+            <a:r>
+              <a:t>  - PNG images are built into textures (magenta = transparent)</a:t>
+            </a:r>
+          </a:p>
+          <a:p>
+            <a:r>
+              <a:t>  - XML definitions are copied as they are</a:t>
+            </a:r>
+          </a:p>
+        </p:txBody>
+      </p:sp>
+    </p:spTree>
+  </p:cSld>
+  <p:clrMapOvr>
+    <a:masterClrMapping/>
+  </p:clrMapOvr>
+</p:notes>
+</file>
+
 <file path=ppt/notesSlides/notesSlide26.xml><?xml version="1.0" encoding="utf-8"?>
 <p:notes xmlns:a="http://schemas.openxmlformats.org/drawingml/2006/main" xmlns:r="http://schemas.openxmlformats.org/officeDocument/2006/relationships" xmlns:mc="http://schemas.openxmlformats.org/markup-compatibility/2006" xmlns:mv="urn:schemas-microsoft-com:mac:vml" xmlns:p="http://schemas.openxmlformats.org/presentationml/2006/main" xmlns:c="http://schemas.openxmlformats.org/drawingml/2006/chart" xmlns:dgm="http://schemas.openxmlformats.org/drawingml/2006/diagram" xmlns:o="urn:schemas-microsoft-com:office:office" xmlns:v="urn:schemas-microsoft-com:vml" xmlns:pvml="urn:schemas-microsoft-com:office:powerpoint" xmlns:com="http://schemas.openxmlformats.org/drawingml/2006/compatibility" xmlns:p14="http://schemas.microsoft.com/office/powerpoint/2010/main" xmlns:p15="http://schemas.microsoft.com/office/powerpoint/2012/main" xmlns:ahyp="http://schemas.microsoft.com/office/drawing/2018/hyperlinkcolor" showMasterPhAnim="0" showMasterSp="0">
   <p:cSld>
@@ -2131,20 +2459,60 @@
           </a:bodyPr>
           <a:lstStyle/>
           <a:p>
-            <a:pPr indent="0" lvl="0" marL="0" rtl="0" algn="l">
-              <a:spcBef>
-                <a:spcPts val="0"/>
-              </a:spcBef>
-              <a:spcAft>
-                <a:spcPts val="0"/>
-              </a:spcAft>
-              <a:buNone/>
-            </a:pPr>
-            <a:r>
-              <a:rPr lang="en"/>
+            <a:r>
               <a:t>Nominal vs. structural typing (records)</a:t>
             </a:r>
-            <a:endParaRPr/>
+          </a:p>
+          <a:p/>
+          <a:p>
+            <a:r>
+              <a:t>Talking points:</a:t>
+            </a:r>
+          </a:p>
+          <a:p>
+            <a:r>
+              <a:t>- No need to add basic AABB collision detection to our library</a:t>
+            </a:r>
+          </a:p>
+          <a:p>
+            <a:r>
+              <a:t>- Rectangle.Intersects(Rectangle)</a:t>
+            </a:r>
+          </a:p>
+          <a:p>
+            <a:r>
+              <a:t>  - Provided by MonoGame</a:t>
+            </a:r>
+          </a:p>
+          <a:p>
+            <a:r>
+              <a:t>    - performs an an AABB collision check for us</a:t>
+            </a:r>
+          </a:p>
+          <a:p>
+            <a:r>
+              <a:t>- Rectangle.Contains()</a:t>
+            </a:r>
+          </a:p>
+          <a:p>
+            <a:r>
+              <a:t>  - Checks if Rectangle/Vector2/Point is contained within the Rectangle</a:t>
+            </a:r>
+          </a:p>
+          <a:p>
+            <a:r>
+              <a:t>- No Circles though</a:t>
+            </a:r>
+          </a:p>
+          <a:p>
+            <a:r>
+              <a:t>  - Add a Circle struct to GMDCore</a:t>
+            </a:r>
+          </a:p>
+          <a:p>
+            <a:r>
+              <a:t>  - Add an Intersects(Circle) method for other Circles</a:t>
+            </a:r>
           </a:p>
         </p:txBody>
       </p:sp>
@@ -2826,19 +3194,39 @@
           </a:bodyPr>
           <a:lstStyle/>
           <a:p>
-            <a:pPr indent="0" lvl="0" marL="0" rtl="0" algn="l">
-              <a:spcBef>
-                <a:spcPts val="0"/>
-              </a:spcBef>
-              <a:spcAft>
-                <a:spcPts val="0"/>
-              </a:spcAft>
-              <a:buNone/>
-            </a:pPr>
-            <a:r>
-              <a:t/>
-            </a:r>
-            <a:endParaRPr/>
+            <a:r>
+              <a:t>Talking points:</a:t>
+            </a:r>
+          </a:p>
+          <a:p>
+            <a:r>
+              <a:t>- All Source code for today’s game can be found here:</a:t>
+            </a:r>
+          </a:p>
+          <a:p>
+            <a:r>
+              <a:t>  - github.com/Metamate/gar-games (folder 03-snake)</a:t>
+            </a:r>
+          </a:p>
+          <a:p>
+            <a:r>
+              <a:t>- The game is built up in steps: Snake0 → Snake9</a:t>
+            </a:r>
+          </a:p>
+          <a:p>
+            <a:r>
+              <a:t>  - Each step is a separate project that adds one concept</a:t>
+            </a:r>
+          </a:p>
+          <a:p>
+            <a:r>
+              <a:t>  - Compare neighbouring steps to see exactly what changed</a:t>
+            </a:r>
+          </a:p>
+          <a:p>
+            <a:r>
+              <a:t>- Snake9 is the finished game, and the starting point for the exercises</a:t>
+            </a:r>
           </a:p>
         </p:txBody>
       </p:sp>
@@ -11385,7 +11773,7 @@
         <p:spPr>
           <a:xfrm>
             <a:off x="311700" y="885950"/>
-            <a:ext cx="8520600" cy="4023300"/>
+            <a:ext cx="8520600" cy="521208"/>
           </a:xfrm>
           <a:prstGeom prst="rect">
             <a:avLst/>
@@ -11409,94 +11797,521 @@
             </a:pPr>
             <a:r>
               <a:rPr lang="en"/>
-              <a:t>Input happens every frame, but the snake acts on a tick</a:t>
+              <a:t>The snake acts once per tick; the player can press twice between two ticks.</a:t>
             </a:r>
             <a:endParaRPr/>
           </a:p>
-          <a:p>
-            <a:pPr indent="-317500" lvl="1" marL="914400" rtl="0" algn="l">
-              <a:spcBef>
-                <a:spcPts val="0"/>
-              </a:spcBef>
-              <a:spcAft>
-                <a:spcPts val="0"/>
-              </a:spcAft>
-              <a:buSzPts val="1400"/>
-              <a:buChar char="○"/>
-            </a:pPr>
-            <a:r>
-              <a:rPr lang="en"/>
-              <a:t>Up, then Left between two ticks: the second press overwrites the first</a:t>
-            </a:r>
-            <a:endParaRPr/>
-          </a:p>
-          <a:p>
-            <a:pPr indent="-330200" lvl="0" marL="457200" rtl="0" algn="l">
-              <a:spcBef>
-                <a:spcPts val="0"/>
-              </a:spcBef>
-              <a:spcAft>
-                <a:spcPts val="0"/>
-              </a:spcAft>
-              <a:buSzPts val="1600"/>
-              <a:buChar char="●"/>
-            </a:pPr>
-            <a:r>
-              <a:rPr lang="en"/>
-              <a:t>Queue the turns, and use one per tick</a:t>
-            </a:r>
-            <a:endParaRPr/>
-          </a:p>
-          <a:p>
-            <a:pPr indent="-317500" lvl="1" marL="914400" rtl="0" algn="l">
-              <a:spcBef>
-                <a:spcPts val="0"/>
-              </a:spcBef>
-              <a:spcAft>
-                <a:spcPts val="0"/>
-              </a:spcAft>
-              <a:buSzPts val="1400"/>
-              <a:buChar char="○"/>
-            </a:pPr>
-            <a:r>
-              <a:rPr lang="en"/>
-              <a:t>Check each turn against the last queued direction</a:t>
-            </a:r>
-            <a:endParaRPr/>
-          </a:p>
-          <a:p>
-            <a:pPr indent="-317500" lvl="1" marL="914400" rtl="0" algn="l">
-              <a:spcBef>
-                <a:spcPts val="0"/>
-              </a:spcBef>
-              <a:spcAft>
-                <a:spcPts val="0"/>
-              </a:spcAft>
-              <a:buSzPts val="1400"/>
-              <a:buChar char="○"/>
-            </a:pPr>
-            <a:r>
-              <a:rPr lang="en"/>
-              <a:t>Keep the queue short: two turns</a:t>
-            </a:r>
-            <a:endParaRPr/>
-          </a:p>
-          <a:p>
-            <a:pPr indent="-330200" lvl="0" marL="457200" rtl="0" algn="l">
-              <a:spcBef>
-                <a:spcPts val="0"/>
-              </a:spcBef>
-              <a:spcAft>
-                <a:spcPts val="0"/>
-              </a:spcAft>
-              <a:buSzPts val="1600"/>
-              <a:buChar char="●"/>
-            </a:pPr>
-            <a:r>
-              <a:rPr lang="en"/>
-              <a:t>Common in games: a jump pressed just before landing still counts</a:t>
-            </a:r>
-            <a:endParaRPr/>
+        </p:txBody>
+      </p:sp>
+      <p:cxnSp>
+        <p:nvCxnSpPr>
+          <p:cNvPr id="295" name="Connector 294"/>
+          <p:cNvCxnSpPr/>
+          <p:nvPr/>
+        </p:nvCxnSpPr>
+        <p:spPr>
+          <a:xfrm>
+            <a:off x="548640" y="2011680"/>
+            <a:ext cx="7955280" cy="0"/>
+          </a:xfrm>
+          <a:prstGeom prst="line">
+            <a:avLst/>
+          </a:prstGeom>
+          <a:ln w="25400">
+            <a:solidFill>
+              <a:srgbClr val="9AA3AB"/>
+            </a:solidFill>
+            <a:tailEnd type="triangle"/>
+          </a:ln>
+        </p:spPr>
+        <p:style>
+          <a:lnRef idx="2">
+            <a:schemeClr val="accent1"/>
+          </a:lnRef>
+          <a:fillRef idx="0">
+            <a:schemeClr val="accent1"/>
+          </a:fillRef>
+          <a:effectRef idx="1">
+            <a:schemeClr val="accent1"/>
+          </a:effectRef>
+          <a:fontRef idx="minor">
+            <a:schemeClr val="tx1"/>
+          </a:fontRef>
+        </p:style>
+      </p:cxnSp>
+      <p:sp>
+        <p:nvSpPr>
+          <p:cNvPr id="296" name="Rectangle 295"/>
+          <p:cNvSpPr/>
+          <p:nvPr/>
+        </p:nvSpPr>
+        <p:spPr>
+          <a:xfrm>
+            <a:off x="1051560" y="1783080"/>
+            <a:ext cx="91440" cy="457200"/>
+          </a:xfrm>
+          <a:prstGeom prst="rect">
+            <a:avLst/>
+          </a:prstGeom>
+          <a:solidFill>
+            <a:srgbClr val="D45D35"/>
+          </a:solidFill>
+          <a:ln>
+            <a:noFill/>
+          </a:ln>
+          <a:effectLst/>
+        </p:spPr>
+        <p:style>
+          <a:lnRef idx="1">
+            <a:schemeClr val="accent1"/>
+          </a:lnRef>
+          <a:fillRef idx="3">
+            <a:schemeClr val="accent1"/>
+          </a:fillRef>
+          <a:effectRef idx="2">
+            <a:schemeClr val="accent1"/>
+          </a:effectRef>
+          <a:fontRef idx="minor">
+            <a:schemeClr val="lt1"/>
+          </a:fontRef>
+        </p:style>
+        <p:txBody>
+          <a:bodyPr rtlCol="0" anchor="ctr" wrap="square" lIns="73152" rIns="73152"/>
+          <a:lstStyle/>
+          <a:p>
+            <a:pPr algn="ctr"/>
+            <a:r>
+              <a:rPr sz="1400" b="0">
+                <a:solidFill>
+                  <a:srgbClr val="DEE2E6"/>
+                </a:solidFill>
+              </a:rPr>
+              <a:t/>
+            </a:r>
+          </a:p>
+        </p:txBody>
+      </p:sp>
+      <p:sp>
+        <p:nvSpPr>
+          <p:cNvPr id="297" name="TextBox 296"/>
+          <p:cNvSpPr txBox="1"/>
+          <p:nvPr/>
+        </p:nvSpPr>
+        <p:spPr>
+          <a:xfrm>
+            <a:off x="640080" y="2286000"/>
+            <a:ext cx="914400" cy="274320"/>
+          </a:xfrm>
+          <a:prstGeom prst="rect">
+            <a:avLst/>
+          </a:prstGeom>
+          <a:noFill/>
+        </p:spPr>
+        <p:txBody>
+          <a:bodyPr wrap="square">
+            <a:spAutoFit/>
+          </a:bodyPr>
+          <a:lstStyle/>
+          <a:p>
+            <a:pPr algn="ctr"/>
+            <a:r>
+              <a:rPr sz="1200" b="0" i="0">
+                <a:solidFill>
+                  <a:srgbClr val="9AA3AB"/>
+                </a:solidFill>
+              </a:rPr>
+              <a:t>tick</a:t>
+            </a:r>
+          </a:p>
+        </p:txBody>
+      </p:sp>
+      <p:sp>
+        <p:nvSpPr>
+          <p:cNvPr id="298" name="Rectangle 297"/>
+          <p:cNvSpPr/>
+          <p:nvPr/>
+        </p:nvSpPr>
+        <p:spPr>
+          <a:xfrm>
+            <a:off x="7452359" y="1783080"/>
+            <a:ext cx="91440" cy="457200"/>
+          </a:xfrm>
+          <a:prstGeom prst="rect">
+            <a:avLst/>
+          </a:prstGeom>
+          <a:solidFill>
+            <a:srgbClr val="D45D35"/>
+          </a:solidFill>
+          <a:ln>
+            <a:noFill/>
+          </a:ln>
+          <a:effectLst/>
+        </p:spPr>
+        <p:style>
+          <a:lnRef idx="1">
+            <a:schemeClr val="accent1"/>
+          </a:lnRef>
+          <a:fillRef idx="3">
+            <a:schemeClr val="accent1"/>
+          </a:fillRef>
+          <a:effectRef idx="2">
+            <a:schemeClr val="accent1"/>
+          </a:effectRef>
+          <a:fontRef idx="minor">
+            <a:schemeClr val="lt1"/>
+          </a:fontRef>
+        </p:style>
+        <p:txBody>
+          <a:bodyPr rtlCol="0" anchor="ctr" wrap="square" lIns="73152" rIns="73152"/>
+          <a:lstStyle/>
+          <a:p>
+            <a:pPr algn="ctr"/>
+            <a:r>
+              <a:rPr sz="1400" b="0">
+                <a:solidFill>
+                  <a:srgbClr val="DEE2E6"/>
+                </a:solidFill>
+              </a:rPr>
+              <a:t/>
+            </a:r>
+          </a:p>
+        </p:txBody>
+      </p:sp>
+      <p:sp>
+        <p:nvSpPr>
+          <p:cNvPr id="299" name="TextBox 298"/>
+          <p:cNvSpPr txBox="1"/>
+          <p:nvPr/>
+        </p:nvSpPr>
+        <p:spPr>
+          <a:xfrm>
+            <a:off x="7040879" y="2286000"/>
+            <a:ext cx="914400" cy="274320"/>
+          </a:xfrm>
+          <a:prstGeom prst="rect">
+            <a:avLst/>
+          </a:prstGeom>
+          <a:noFill/>
+        </p:spPr>
+        <p:txBody>
+          <a:bodyPr wrap="square">
+            <a:spAutoFit/>
+          </a:bodyPr>
+          <a:lstStyle/>
+          <a:p>
+            <a:pPr algn="ctr"/>
+            <a:r>
+              <a:rPr sz="1200" b="0" i="0">
+                <a:solidFill>
+                  <a:srgbClr val="9AA3AB"/>
+                </a:solidFill>
+              </a:rPr>
+              <a:t>tick</a:t>
+            </a:r>
+          </a:p>
+        </p:txBody>
+      </p:sp>
+      <p:sp>
+        <p:nvSpPr>
+          <p:cNvPr id="300" name="Rounded Rectangle 299"/>
+          <p:cNvSpPr/>
+          <p:nvPr/>
+        </p:nvSpPr>
+        <p:spPr>
+          <a:xfrm>
+            <a:off x="2880360" y="1325880"/>
+            <a:ext cx="822960" cy="411480"/>
+          </a:xfrm>
+          <a:prstGeom prst="roundRect">
+            <a:avLst>
+              <a:gd name="adj" fmla="val 12000"/>
+            </a:avLst>
+          </a:prstGeom>
+          <a:solidFill>
+            <a:srgbClr val="2E3338"/>
+          </a:solidFill>
+          <a:ln>
+            <a:noFill/>
+          </a:ln>
+          <a:effectLst/>
+        </p:spPr>
+        <p:style>
+          <a:lnRef idx="1">
+            <a:schemeClr val="accent1"/>
+          </a:lnRef>
+          <a:fillRef idx="3">
+            <a:schemeClr val="accent1"/>
+          </a:fillRef>
+          <a:effectRef idx="2">
+            <a:schemeClr val="accent1"/>
+          </a:effectRef>
+          <a:fontRef idx="minor">
+            <a:schemeClr val="lt1"/>
+          </a:fontRef>
+        </p:style>
+        <p:txBody>
+          <a:bodyPr rtlCol="0" anchor="ctr" wrap="square" lIns="73152" rIns="73152"/>
+          <a:lstStyle/>
+          <a:p>
+            <a:pPr algn="ctr"/>
+            <a:r>
+              <a:rPr sz="1400" b="1">
+                <a:solidFill>
+                  <a:srgbClr val="DEE2E6"/>
+                </a:solidFill>
+              </a:rPr>
+              <a:t>Up</a:t>
+            </a:r>
+          </a:p>
+        </p:txBody>
+      </p:sp>
+      <p:cxnSp>
+        <p:nvCxnSpPr>
+          <p:cNvPr id="301" name="Connector 300"/>
+          <p:cNvCxnSpPr/>
+          <p:nvPr/>
+        </p:nvCxnSpPr>
+        <p:spPr>
+          <a:xfrm>
+            <a:off x="3291840" y="1755648"/>
+            <a:ext cx="0" cy="210312"/>
+          </a:xfrm>
+          <a:prstGeom prst="line">
+            <a:avLst/>
+          </a:prstGeom>
+          <a:ln w="25400">
+            <a:solidFill>
+              <a:srgbClr val="9AA3AB"/>
+            </a:solidFill>
+            <a:tailEnd type="triangle"/>
+          </a:ln>
+        </p:spPr>
+        <p:style>
+          <a:lnRef idx="2">
+            <a:schemeClr val="accent1"/>
+          </a:lnRef>
+          <a:fillRef idx="0">
+            <a:schemeClr val="accent1"/>
+          </a:fillRef>
+          <a:effectRef idx="1">
+            <a:schemeClr val="accent1"/>
+          </a:effectRef>
+          <a:fontRef idx="minor">
+            <a:schemeClr val="tx1"/>
+          </a:fontRef>
+        </p:style>
+      </p:cxnSp>
+      <p:sp>
+        <p:nvSpPr>
+          <p:cNvPr id="302" name="Rounded Rectangle 301"/>
+          <p:cNvSpPr/>
+          <p:nvPr/>
+        </p:nvSpPr>
+        <p:spPr>
+          <a:xfrm>
+            <a:off x="4709159" y="1325880"/>
+            <a:ext cx="822960" cy="411480"/>
+          </a:xfrm>
+          <a:prstGeom prst="roundRect">
+            <a:avLst>
+              <a:gd name="adj" fmla="val 12000"/>
+            </a:avLst>
+          </a:prstGeom>
+          <a:solidFill>
+            <a:srgbClr val="2E3338"/>
+          </a:solidFill>
+          <a:ln>
+            <a:noFill/>
+          </a:ln>
+          <a:effectLst/>
+        </p:spPr>
+        <p:style>
+          <a:lnRef idx="1">
+            <a:schemeClr val="accent1"/>
+          </a:lnRef>
+          <a:fillRef idx="3">
+            <a:schemeClr val="accent1"/>
+          </a:fillRef>
+          <a:effectRef idx="2">
+            <a:schemeClr val="accent1"/>
+          </a:effectRef>
+          <a:fontRef idx="minor">
+            <a:schemeClr val="lt1"/>
+          </a:fontRef>
+        </p:style>
+        <p:txBody>
+          <a:bodyPr rtlCol="0" anchor="ctr" wrap="square" lIns="73152" rIns="73152"/>
+          <a:lstStyle/>
+          <a:p>
+            <a:pPr algn="ctr"/>
+            <a:r>
+              <a:rPr sz="1400" b="1">
+                <a:solidFill>
+                  <a:srgbClr val="DEE2E6"/>
+                </a:solidFill>
+              </a:rPr>
+              <a:t>Left</a:t>
+            </a:r>
+          </a:p>
+        </p:txBody>
+      </p:sp>
+      <p:cxnSp>
+        <p:nvCxnSpPr>
+          <p:cNvPr id="303" name="Connector 302"/>
+          <p:cNvCxnSpPr/>
+          <p:nvPr/>
+        </p:nvCxnSpPr>
+        <p:spPr>
+          <a:xfrm>
+            <a:off x="5120640" y="1755648"/>
+            <a:ext cx="0" cy="210312"/>
+          </a:xfrm>
+          <a:prstGeom prst="line">
+            <a:avLst/>
+          </a:prstGeom>
+          <a:ln w="25400">
+            <a:solidFill>
+              <a:srgbClr val="9AA3AB"/>
+            </a:solidFill>
+            <a:tailEnd type="triangle"/>
+          </a:ln>
+        </p:spPr>
+        <p:style>
+          <a:lnRef idx="2">
+            <a:schemeClr val="accent1"/>
+          </a:lnRef>
+          <a:fillRef idx="0">
+            <a:schemeClr val="accent1"/>
+          </a:fillRef>
+          <a:effectRef idx="1">
+            <a:schemeClr val="accent1"/>
+          </a:effectRef>
+          <a:fontRef idx="minor">
+            <a:schemeClr val="tx1"/>
+          </a:fontRef>
+        </p:style>
+      </p:cxnSp>
+      <p:sp>
+        <p:nvSpPr>
+          <p:cNvPr id="304" name="TextBox 303"/>
+          <p:cNvSpPr txBox="1"/>
+          <p:nvPr/>
+        </p:nvSpPr>
+        <p:spPr>
+          <a:xfrm>
+            <a:off x="548640" y="2743200"/>
+            <a:ext cx="3840480" cy="822960"/>
+          </a:xfrm>
+          <a:prstGeom prst="rect">
+            <a:avLst/>
+          </a:prstGeom>
+          <a:noFill/>
+        </p:spPr>
+        <p:txBody>
+          <a:bodyPr wrap="square">
+            <a:spAutoFit/>
+          </a:bodyPr>
+          <a:lstStyle/>
+          <a:p>
+            <a:pPr algn="l"/>
+            <a:r>
+              <a:rPr sz="1500" b="1" i="0">
+                <a:solidFill>
+                  <a:srgbClr val="DEE2E6"/>
+                </a:solidFill>
+              </a:rPr>
+              <a:t>Keep only the last key:</a:t>
+            </a:r>
+          </a:p>
+          <a:p>
+            <a:pPr algn="l"/>
+            <a:r>
+              <a:rPr sz="1500" b="1" i="0">
+                <a:solidFill>
+                  <a:srgbClr val="DEE2E6"/>
+                </a:solidFill>
+              </a:rPr>
+              <a:t>Left overwrites Up, and the turn is lost.</a:t>
+            </a:r>
+          </a:p>
+        </p:txBody>
+      </p:sp>
+      <p:sp>
+        <p:nvSpPr>
+          <p:cNvPr id="305" name="TextBox 304"/>
+          <p:cNvSpPr txBox="1"/>
+          <p:nvPr/>
+        </p:nvSpPr>
+        <p:spPr>
+          <a:xfrm>
+            <a:off x="4572000" y="2743200"/>
+            <a:ext cx="4023360" cy="822960"/>
+          </a:xfrm>
+          <a:prstGeom prst="rect">
+            <a:avLst/>
+          </a:prstGeom>
+          <a:noFill/>
+        </p:spPr>
+        <p:txBody>
+          <a:bodyPr wrap="square">
+            <a:spAutoFit/>
+          </a:bodyPr>
+          <a:lstStyle/>
+          <a:p>
+            <a:pPr algn="l"/>
+            <a:r>
+              <a:rPr sz="1500" b="1" i="0">
+                <a:solidFill>
+                  <a:srgbClr val="DEE2E6"/>
+                </a:solidFill>
+              </a:rPr>
+              <a:t>Queue them (at most two):</a:t>
+            </a:r>
+          </a:p>
+          <a:p>
+            <a:pPr algn="l"/>
+            <a:r>
+              <a:rPr sz="1500" b="1" i="0">
+                <a:solidFill>
+                  <a:srgbClr val="DEE2E6"/>
+                </a:solidFill>
+              </a:rPr>
+              <a:t>Up on this tick, Left on the next.</a:t>
+            </a:r>
+          </a:p>
+        </p:txBody>
+      </p:sp>
+      <p:sp>
+        <p:nvSpPr>
+          <p:cNvPr id="306" name="TextBox 305"/>
+          <p:cNvSpPr txBox="1"/>
+          <p:nvPr/>
+        </p:nvSpPr>
+        <p:spPr>
+          <a:xfrm>
+            <a:off x="548640" y="3749039"/>
+            <a:ext cx="8046720" cy="365760"/>
+          </a:xfrm>
+          <a:prstGeom prst="rect">
+            <a:avLst/>
+          </a:prstGeom>
+          <a:noFill/>
+        </p:spPr>
+        <p:txBody>
+          <a:bodyPr wrap="square">
+            <a:spAutoFit/>
+          </a:bodyPr>
+          <a:lstStyle/>
+          <a:p>
+            <a:pPr algn="ctr"/>
+            <a:r>
+              <a:rPr sz="1300" b="0" i="0">
+                <a:solidFill>
+                  <a:srgbClr val="9AA3AB"/>
+                </a:solidFill>
+              </a:rPr>
+              <a:t>The same trick lets a jump pressed just before landing still count.</a:t>
+            </a:r>
           </a:p>
         </p:txBody>
       </p:sp>
@@ -14876,7 +15691,7 @@
         <p:spPr>
           <a:xfrm>
             <a:off x="311700" y="885950"/>
-            <a:ext cx="8520600" cy="4023300"/>
+            <a:ext cx="8520600" cy="521208"/>
           </a:xfrm>
           <a:prstGeom prst="rect">
             <a:avLst/>
@@ -14900,163 +15715,164 @@
             </a:pPr>
             <a:r>
               <a:rPr lang="en"/>
-              <a:t>No need to add basic AABB collision detection to our library</a:t>
+              <a:t>MonoGame checks rectangles for us; circles we add to GMDCore.</a:t>
             </a:r>
             <a:endParaRPr/>
           </a:p>
-          <a:p>
-            <a:pPr indent="-330200" lvl="0" marL="457200" rtl="0" algn="l">
-              <a:spcBef>
-                <a:spcPts val="0"/>
-              </a:spcBef>
-              <a:spcAft>
-                <a:spcPts val="0"/>
-              </a:spcAft>
-              <a:buSzPts val="1600"/>
-              <a:buChar char="●"/>
-            </a:pPr>
-            <a:r>
-              <a:rPr lang="en" u="sng">
-                <a:solidFill>
-                  <a:schemeClr val="hlink"/>
-                </a:solidFill>
-                <a:hlinkClick r:id="rId3"/>
-              </a:rPr>
-              <a:t>Rectangle.Intersects(Rectangle)</a:t>
-            </a:r>
-            <a:endParaRPr/>
-          </a:p>
-          <a:p>
-            <a:pPr indent="-317500" lvl="1" marL="914400" rtl="0" algn="l">
-              <a:spcBef>
-                <a:spcPts val="0"/>
-              </a:spcBef>
-              <a:spcAft>
-                <a:spcPts val="0"/>
-              </a:spcAft>
-              <a:buSzPts val="1400"/>
-              <a:buChar char="○"/>
-            </a:pPr>
-            <a:r>
-              <a:rPr lang="en"/>
-              <a:t>Provided by MonoGame</a:t>
-            </a:r>
-            <a:endParaRPr/>
-          </a:p>
-          <a:p>
-            <a:pPr indent="-304800" lvl="2" marL="1371600" rtl="0" algn="l">
-              <a:spcBef>
-                <a:spcPts val="0"/>
-              </a:spcBef>
-              <a:spcAft>
-                <a:spcPts val="0"/>
-              </a:spcAft>
-              <a:buSzPts val="1200"/>
-              <a:buChar char="■"/>
-            </a:pPr>
-            <a:r>
-              <a:rPr lang="en"/>
-              <a:t>performs an an AABB collision check for us</a:t>
-            </a:r>
-            <a:endParaRPr/>
-          </a:p>
-          <a:p>
-            <a:pPr indent="-330200" lvl="0" marL="457200" rtl="0" algn="l">
-              <a:spcBef>
-                <a:spcPts val="0"/>
-              </a:spcBef>
-              <a:spcAft>
-                <a:spcPts val="0"/>
-              </a:spcAft>
-              <a:buSzPts val="1600"/>
-              <a:buChar char="●"/>
-            </a:pPr>
-            <a:r>
-              <a:rPr lang="en" u="sng">
-                <a:solidFill>
-                  <a:schemeClr val="hlink"/>
-                </a:solidFill>
-                <a:hlinkClick r:id="rId4"/>
-              </a:rPr>
-              <a:t>Rectangle.Contains()</a:t>
-            </a:r>
-            <a:endParaRPr/>
-          </a:p>
-          <a:p>
-            <a:pPr indent="-317500" lvl="1" marL="914400" rtl="0" algn="l">
-              <a:spcBef>
-                <a:spcPts val="0"/>
-              </a:spcBef>
-              <a:spcAft>
-                <a:spcPts val="0"/>
-              </a:spcAft>
-              <a:buSzPts val="1400"/>
-              <a:buChar char="○"/>
-            </a:pPr>
-            <a:r>
-              <a:rPr lang="en"/>
-              <a:t>Checks if Rectangle/Vector2/Point is contained within the Rectangle</a:t>
-            </a:r>
-            <a:endParaRPr/>
-          </a:p>
-          <a:p>
-            <a:pPr indent="-330200" lvl="0" marL="457200" rtl="0" algn="l">
-              <a:spcBef>
-                <a:spcPts val="0"/>
-              </a:spcBef>
-              <a:spcAft>
-                <a:spcPts val="0"/>
-              </a:spcAft>
-              <a:buSzPts val="1600"/>
-              <a:buChar char="●"/>
-            </a:pPr>
-            <a:r>
-              <a:rPr lang="en"/>
-              <a:t>No Circles though</a:t>
-            </a:r>
-            <a:endParaRPr/>
-          </a:p>
-          <a:p>
-            <a:pPr indent="-317500" lvl="1" marL="914400" rtl="0" algn="l">
-              <a:spcBef>
-                <a:spcPts val="0"/>
-              </a:spcBef>
-              <a:spcAft>
-                <a:spcPts val="0"/>
-              </a:spcAft>
-              <a:buSzPts val="1400"/>
-              <a:buChar char="○"/>
-            </a:pPr>
-            <a:r>
-              <a:rPr lang="en"/>
-              <a:t>Add a Circle struct to GMDCore</a:t>
-            </a:r>
-            <a:endParaRPr/>
-          </a:p>
-          <a:p>
-            <a:pPr indent="-317500" lvl="1" marL="914400" rtl="0" algn="l">
-              <a:spcBef>
-                <a:spcPts val="0"/>
-              </a:spcBef>
-              <a:spcAft>
-                <a:spcPts val="0"/>
-              </a:spcAft>
-              <a:buSzPts val="1400"/>
-              <a:buChar char="○"/>
-            </a:pPr>
-            <a:r>
-              <a:rPr lang="en"/>
-              <a:t>Add an Intersects(Ci</a:t>
-            </a:r>
-            <a:r>
-              <a:rPr lang="en"/>
-              <a:t>rcl</a:t>
-            </a:r>
-            <a:r>
-              <a:rPr lang="en"/>
-              <a:t>e) method for other Circles</a:t>
-            </a:r>
-            <a:endParaRPr/>
+        </p:txBody>
+      </p:sp>
+      <p:sp>
+        <p:nvSpPr>
+          <p:cNvPr id="255" name="Rectangle 254"/>
+          <p:cNvSpPr/>
+          <p:nvPr/>
+        </p:nvSpPr>
+        <p:spPr>
+          <a:xfrm>
+            <a:off x="548640" y="1417320"/>
+            <a:ext cx="8046720" cy="1737360"/>
+          </a:xfrm>
+          <a:prstGeom prst="rect">
+            <a:avLst/>
+          </a:prstGeom>
+          <a:solidFill>
+            <a:srgbClr val="17191C"/>
+          </a:solidFill>
+          <a:ln>
+            <a:noFill/>
+          </a:ln>
+          <a:effectLst/>
+        </p:spPr>
+        <p:style>
+          <a:lnRef idx="1">
+            <a:schemeClr val="accent1"/>
+          </a:lnRef>
+          <a:fillRef idx="3">
+            <a:schemeClr val="accent1"/>
+          </a:fillRef>
+          <a:effectRef idx="2">
+            <a:schemeClr val="accent1"/>
+          </a:effectRef>
+          <a:fontRef idx="minor">
+            <a:schemeClr val="lt1"/>
+          </a:fontRef>
+        </p:style>
+        <p:txBody>
+          <a:bodyPr rtlCol="0" anchor="ctr" wrap="square" lIns="164592" rIns="73152"/>
+          <a:lstStyle/>
+          <a:p>
+            <a:pPr algn="l"/>
+            <a:r>
+              <a:rPr sz="1400" b="0">
+                <a:solidFill>
+                  <a:srgbClr val="DEE2E6"/>
+                </a:solidFill>
+              </a:rPr>
+              <a:t/>
+            </a:r>
+            <a:r>
+              <a:rPr sz="1200">
+                <a:solidFill>
+                  <a:srgbClr val="DEE2E6"/>
+                </a:solidFill>
+                <a:latin typeface="Consolas"/>
+              </a:rPr>
+              <a:t>bool hit = a.Intersects(b);            // Rectangle: AABB, built in</a:t>
+            </a:r>
+          </a:p>
+          <a:p>
+            <a:pPr algn="l"/>
+            <a:r>
+              <a:rPr sz="1200">
+                <a:solidFill>
+                  <a:srgbClr val="DEE2E6"/>
+                </a:solidFill>
+                <a:latin typeface="Consolas"/>
+              </a:rPr>
+              <a:t> </a:t>
+            </a:r>
+          </a:p>
+          <a:p>
+            <a:pPr algn="l"/>
+            <a:r>
+              <a:rPr sz="1200">
+                <a:solidFill>
+                  <a:srgbClr val="DEE2E6"/>
+                </a:solidFill>
+                <a:latin typeface="Consolas"/>
+              </a:rPr>
+              <a:t>public readonly record struct Circle   // GMDCore</a:t>
+            </a:r>
+          </a:p>
+          <a:p>
+            <a:pPr algn="l"/>
+            <a:r>
+              <a:rPr sz="1200">
+                <a:solidFill>
+                  <a:srgbClr val="DEE2E6"/>
+                </a:solidFill>
+                <a:latin typeface="Consolas"/>
+              </a:rPr>
+              <a:t>{</a:t>
+            </a:r>
+          </a:p>
+          <a:p>
+            <a:pPr algn="l"/>
+            <a:r>
+              <a:rPr sz="1200">
+                <a:solidFill>
+                  <a:srgbClr val="DEE2E6"/>
+                </a:solidFill>
+                <a:latin typeface="Consolas"/>
+              </a:rPr>
+              <a:t>    public bool Intersects(Circle other) =&gt; ...   // squared distances, no square root</a:t>
+            </a:r>
+          </a:p>
+          <a:p>
+            <a:pPr algn="l"/>
+            <a:r>
+              <a:rPr sz="1200">
+                <a:solidFill>
+                  <a:srgbClr val="DEE2E6"/>
+                </a:solidFill>
+                <a:latin typeface="Consolas"/>
+              </a:rPr>
+              <a:t>}</a:t>
+            </a:r>
+          </a:p>
+        </p:txBody>
+      </p:sp>
+      <p:sp>
+        <p:nvSpPr>
+          <p:cNvPr id="256" name="TextBox 255"/>
+          <p:cNvSpPr txBox="1"/>
+          <p:nvPr/>
+        </p:nvSpPr>
+        <p:spPr>
+          <a:xfrm>
+            <a:off x="457200" y="3383280"/>
+            <a:ext cx="8229600" cy="731520"/>
+          </a:xfrm>
+          <a:prstGeom prst="rect">
+            <a:avLst/>
+          </a:prstGeom>
+          <a:noFill/>
+        </p:spPr>
+        <p:txBody>
+          <a:bodyPr wrap="square">
+            <a:spAutoFit/>
+          </a:bodyPr>
+          <a:lstStyle/>
+          <a:p>
+            <a:pPr algn="ctr"/>
+            <a:r>
+              <a:rPr sz="1600" b="1" i="0">
+                <a:solidFill>
+                  <a:srgbClr val="DEE2E6"/>
+                </a:solidFill>
+              </a:rPr>
+              <a:t>Why compare squared distances?</a:t>
+            </a:r>
           </a:p>
         </p:txBody>
       </p:sp>
@@ -18842,6 +19658,179 @@
 </p:sld>
 </file>
 
+<file path=ppt/slides/slide35.xml><?xml version="1.0" encoding="utf-8"?>
+<p:sld xmlns:a="http://schemas.openxmlformats.org/drawingml/2006/main" xmlns:p="http://schemas.openxmlformats.org/presentationml/2006/main" xmlns:r="http://schemas.openxmlformats.org/officeDocument/2006/relationships">
+  <p:cSld>
+    <p:spTree>
+      <p:nvGrpSpPr>
+        <p:cNvPr id="1" name=""/>
+        <p:cNvGrpSpPr/>
+        <p:nvPr/>
+      </p:nvGrpSpPr>
+      <p:grpSpPr/>
+      <p:sp>
+        <p:nvSpPr>
+          <p:cNvPr id="2" name="Title 1"/>
+          <p:cNvSpPr>
+            <a:spLocks noGrp="1"/>
+          </p:cNvSpPr>
+          <p:nvPr>
+            <p:ph type="title"/>
+          </p:nvPr>
+        </p:nvSpPr>
+        <p:spPr/>
+        <p:txBody>
+          <a:bodyPr/>
+          <a:lstStyle/>
+          <a:p>
+            <a:pPr indent="0" lvl="0" marL="0" rtl="0" algn="l">
+              <a:spcBef>
+                <a:spcPts val="0"/>
+              </a:spcBef>
+              <a:spcAft>
+                <a:spcPts val="0"/>
+              </a:spcAft>
+              <a:buNone/>
+            </a:pPr>
+            <a:r>
+              <a:rPr lang="en"/>
+              <a:t>Check Yourself</a:t>
+            </a:r>
+            <a:endParaRPr/>
+          </a:p>
+        </p:txBody>
+      </p:sp>
+      <p:sp>
+        <p:nvSpPr>
+          <p:cNvPr id="3" name="Text Placeholder 2"/>
+          <p:cNvSpPr>
+            <a:spLocks noGrp="1"/>
+          </p:cNvSpPr>
+          <p:nvPr>
+            <p:ph type="body" idx="1"/>
+          </p:nvPr>
+        </p:nvSpPr>
+        <p:spPr>
+          <a:xfrm>
+            <a:off x="311700" y="885950"/>
+            <a:ext cx="8520600" cy="1719072"/>
+          </a:xfrm>
+        </p:spPr>
+        <p:txBody>
+          <a:bodyPr/>
+          <a:lstStyle/>
+          <a:p>
+            <a:pPr indent="-330200" lvl="0" marL="457200" rtl="0" algn="l">
+              <a:spcBef>
+                <a:spcPts val="0"/>
+              </a:spcBef>
+              <a:spcAft>
+                <a:spcPts val="0"/>
+              </a:spcAft>
+              <a:buSzPts val="1600"/>
+              <a:buChar char="●"/>
+            </a:pPr>
+            <a:r>
+              <a:rPr lang="en"/>
+              <a:t>Why prefer a texture atlas over many individual image files?</a:t>
+            </a:r>
+            <a:endParaRPr/>
+          </a:p>
+          <a:p>
+            <a:pPr indent="-330200" lvl="0" marL="457200" rtl="0" algn="l">
+              <a:spcBef>
+                <a:spcPts val="0"/>
+              </a:spcBef>
+              <a:spcAft>
+                <a:spcPts val="0"/>
+              </a:spcAft>
+              <a:buSzPts val="1600"/>
+              <a:buChar char="●"/>
+            </a:pPr>
+            <a:r>
+              <a:rPr lang="en"/>
+              <a:t>Why subtract the tick duration from the accumulator instead of resetting it?</a:t>
+            </a:r>
+            <a:endParaRPr/>
+          </a:p>
+          <a:p>
+            <a:pPr indent="-330200" lvl="0" marL="457200" rtl="0" algn="l">
+              <a:spcBef>
+                <a:spcPts val="0"/>
+              </a:spcBef>
+              <a:spcAft>
+                <a:spcPts val="0"/>
+              </a:spcAft>
+              <a:buSzPts val="1600"/>
+              <a:buChar char="●"/>
+            </a:pPr>
+            <a:r>
+              <a:rPr lang="en"/>
+              <a:t>What problems come from reading the keyboard inside gameplay code?</a:t>
+            </a:r>
+            <a:endParaRPr/>
+          </a:p>
+          <a:p>
+            <a:pPr indent="-330200" lvl="0" marL="457200" rtl="0" algn="l">
+              <a:spcBef>
+                <a:spcPts val="0"/>
+              </a:spcBef>
+              <a:spcAft>
+                <a:spcPts val="0"/>
+              </a:spcAft>
+              <a:buSzPts val="1600"/>
+              <a:buChar char="●"/>
+            </a:pPr>
+            <a:r>
+              <a:rPr lang="en"/>
+              <a:t>Why check a buffered turn against the last buffered direction?</a:t>
+            </a:r>
+            <a:endParaRPr/>
+          </a:p>
+        </p:txBody>
+      </p:sp>
+      <p:sp>
+        <p:nvSpPr>
+          <p:cNvPr id="4" name="TextBox 3"/>
+          <p:cNvSpPr txBox="1"/>
+          <p:nvPr/>
+        </p:nvSpPr>
+        <p:spPr>
+          <a:xfrm>
+            <a:off x="457200" y="3182112"/>
+            <a:ext cx="8229600" cy="457200"/>
+          </a:xfrm>
+          <a:prstGeom prst="rect">
+            <a:avLst/>
+          </a:prstGeom>
+          <a:noFill/>
+        </p:spPr>
+        <p:txBody>
+          <a:bodyPr wrap="square">
+            <a:spAutoFit/>
+          </a:bodyPr>
+          <a:lstStyle/>
+          <a:p>
+            <a:pPr algn="ctr"/>
+            <a:r>
+              <a:rPr sz="1400" b="0" i="0">
+                <a:solidFill>
+                  <a:srgbClr val="9AA3AB"/>
+                </a:solidFill>
+              </a:rPr>
+              <a:t>The answers, and more questions, are on the course site.</a:t>
+            </a:r>
+          </a:p>
+        </p:txBody>
+      </p:sp>
+    </p:spTree>
+  </p:cSld>
+  <p:clrMapOvr>
+    <a:masterClrMapping/>
+  </p:clrMapOvr>
+</p:sld>
+</file>
+
 <file path=ppt/slides/slide4.xml><?xml version="1.0" encoding="utf-8"?>
 <p:sld xmlns:a="http://schemas.openxmlformats.org/drawingml/2006/main" xmlns:r="http://schemas.openxmlformats.org/officeDocument/2006/relationships" xmlns:mc="http://schemas.openxmlformats.org/markup-compatibility/2006" xmlns:mv="urn:schemas-microsoft-com:mac:vml" xmlns:p="http://schemas.openxmlformats.org/presentationml/2006/main" xmlns:c="http://schemas.openxmlformats.org/drawingml/2006/chart" xmlns:dgm="http://schemas.openxmlformats.org/drawingml/2006/diagram" xmlns:o="urn:schemas-microsoft-com:office:office" xmlns:v="urn:schemas-microsoft-com:vml" xmlns:pvml="urn:schemas-microsoft-com:office:powerpoint" xmlns:com="http://schemas.openxmlformats.org/drawingml/2006/compatibility" xmlns:p14="http://schemas.microsoft.com/office/powerpoint/2010/main" xmlns:p15="http://schemas.microsoft.com/office/powerpoint/2012/main" xmlns:ahyp="http://schemas.microsoft.com/office/drawing/2018/hyperlinkcolor">
   <p:cSld>
@@ -18910,7 +19899,7 @@
         <p:spPr>
           <a:xfrm>
             <a:off x="311700" y="885950"/>
-            <a:ext cx="8520600" cy="4023300"/>
+            <a:ext cx="8520600" cy="1289304"/>
           </a:xfrm>
           <a:prstGeom prst="rect">
             <a:avLst/>
@@ -18934,29 +19923,7 @@
             </a:pPr>
             <a:r>
               <a:rPr lang="en"/>
-              <a:t>All Source code for today’s game can be found here:</a:t>
-            </a:r>
-            <a:endParaRPr/>
-          </a:p>
-          <a:p>
-            <a:pPr indent="-317500" lvl="1" marL="914400" rtl="0" algn="l">
-              <a:spcBef>
-                <a:spcPts val="0"/>
-              </a:spcBef>
-              <a:spcAft>
-                <a:spcPts val="0"/>
-              </a:spcAft>
-              <a:buSzPts val="1400"/>
-              <a:buChar char="○"/>
-            </a:pPr>
-            <a:r>
-              <a:rPr lang="en" u="sng">
-                <a:solidFill>
-                  <a:schemeClr val="hlink"/>
-                </a:solidFill>
-                <a:hlinkClick r:id="rId3"/>
-              </a:rPr>
-              <a:t>github.com/Metamate/gar-games (folder 03-snake)</a:t>
+              <a:t>github.com/Metamate/gar-games, folder 03-snake</a:t>
             </a:r>
             <a:endParaRPr/>
           </a:p>
@@ -18973,41 +19940,7 @@
             </a:pPr>
             <a:r>
               <a:rPr lang="en"/>
-              <a:t>The game is built up in steps: Snake0 → Snake9</a:t>
-            </a:r>
-            <a:endParaRPr/>
-          </a:p>
-          <a:p>
-            <a:pPr indent="-317500" lvl="1" marL="914400" rtl="0" algn="l">
-              <a:spcBef>
-                <a:spcPts val="0"/>
-              </a:spcBef>
-              <a:spcAft>
-                <a:spcPts val="0"/>
-              </a:spcAft>
-              <a:buSzPts val="1400"/>
-              <a:buChar char="○"/>
-            </a:pPr>
-            <a:r>
-              <a:rPr lang="en"/>
-              <a:t>Each step is a separate project that adds one concept</a:t>
-            </a:r>
-            <a:endParaRPr/>
-          </a:p>
-          <a:p>
-            <a:pPr indent="-317500" lvl="1" marL="914400" rtl="0" algn="l">
-              <a:spcBef>
-                <a:spcPts val="0"/>
-              </a:spcBef>
-              <a:spcAft>
-                <a:spcPts val="0"/>
-              </a:spcAft>
-              <a:buSzPts val="1400"/>
-              <a:buChar char="○"/>
-            </a:pPr>
-            <a:r>
-              <a:rPr lang="en"/>
-              <a:t>Compare neighbouring steps to see exactly what changed</a:t>
+              <a:t>Its README: the steps (Snake0 to Snake9), a map of the code, how to run it</a:t>
             </a:r>
             <a:endParaRPr/>
           </a:p>
@@ -19024,7 +19957,7 @@
             </a:pPr>
             <a:r>
               <a:rPr lang="en"/>
-              <a:t>Snake9 is the finished game, and the starting point for the exercises</a:t>
+              <a:t>The course site: today’s concepts in full, the exercises, and questions to check yourself</a:t>
             </a:r>
             <a:endParaRPr/>
           </a:p>
@@ -19106,7 +20039,7 @@
         <p:spPr>
           <a:xfrm>
             <a:off x="311700" y="885950"/>
-            <a:ext cx="8520600" cy="4023300"/>
+            <a:ext cx="8520600" cy="521208"/>
           </a:xfrm>
           <a:prstGeom prst="rect">
             <a:avLst/>
@@ -19130,111 +20063,413 @@
             </a:pPr>
             <a:r>
               <a:rPr lang="en"/>
-              <a:t>The same content builder as in Pong and Flappy Bird</a:t>
+              <a:t>One Content project, shared by every step. Builder.cs decides what happens to each file.</a:t>
             </a:r>
             <a:endParaRPr/>
           </a:p>
-          <a:p>
-            <a:pPr indent="-330200" lvl="0" marL="457200" rtl="0" algn="l">
-              <a:spcBef>
-                <a:spcPts val="0"/>
-              </a:spcBef>
-              <a:spcAft>
-                <a:spcPts val="0"/>
-              </a:spcAft>
-              <a:buSzPts val="1600"/>
-              <a:buChar char="●"/>
-            </a:pPr>
-            <a:r>
-              <a:rPr lang="en"/>
-              <a:t>But here, all steps share one Content project</a:t>
-            </a:r>
-            <a:endParaRPr/>
-          </a:p>
-          <a:p>
-            <a:pPr indent="-317500" lvl="1" marL="914400" rtl="0" algn="l">
-              <a:spcBef>
-                <a:spcPts val="0"/>
-              </a:spcBef>
-              <a:spcAft>
-                <a:spcPts val="0"/>
-              </a:spcAft>
-              <a:buSzPts val="1400"/>
-              <a:buChar char="○"/>
-            </a:pPr>
-            <a:r>
-              <a:rPr lang="en"/>
-              <a:t>Content/Assets: the raw images and XML definitions</a:t>
-            </a:r>
-            <a:endParaRPr/>
-          </a:p>
-          <a:p>
-            <a:pPr indent="-317500" lvl="1" marL="914400" rtl="0" algn="l">
-              <a:spcBef>
-                <a:spcPts val="0"/>
-              </a:spcBef>
-              <a:spcAft>
-                <a:spcPts val="0"/>
-              </a:spcAft>
-              <a:buSzPts val="1400"/>
-              <a:buChar char="○"/>
-            </a:pPr>
-            <a:r>
-              <a:rPr lang="en"/>
-              <a:t>Content/Builder/Builder.cs: the build rules, in C#</a:t>
-            </a:r>
-            <a:endParaRPr/>
-          </a:p>
-          <a:p>
-            <a:pPr indent="-330200" lvl="0" marL="457200" rtl="0" algn="l">
-              <a:spcBef>
-                <a:spcPts val="0"/>
-              </a:spcBef>
-              <a:spcAft>
-                <a:spcPts val="0"/>
-              </a:spcAft>
-              <a:buSzPts val="1600"/>
-              <a:buChar char="●"/>
-            </a:pPr>
-            <a:r>
-              <a:rPr lang="en"/>
-              <a:t>The rules decide how each asset is processed</a:t>
-            </a:r>
-            <a:endParaRPr/>
-          </a:p>
-          <a:p>
-            <a:pPr indent="-317500" lvl="1" marL="914400" rtl="0" algn="l">
-              <a:spcBef>
-                <a:spcPts val="0"/>
-              </a:spcBef>
-              <a:spcAft>
-                <a:spcPts val="0"/>
-              </a:spcAft>
-              <a:buSzPts val="1400"/>
-              <a:buChar char="○"/>
-            </a:pPr>
-            <a:r>
-              <a:rPr lang="en"/>
-              <a:t>PNG images are built into textures (magenta = transparent)</a:t>
-            </a:r>
-            <a:endParaRPr/>
-          </a:p>
-          <a:p>
-            <a:pPr indent="-317500" lvl="1" marL="914400" rtl="0" algn="l">
-              <a:spcBef>
-                <a:spcPts val="0"/>
-              </a:spcBef>
-              <a:spcAft>
-                <a:spcPts val="0"/>
-              </a:spcAft>
-              <a:buSzPts val="1400"/>
-              <a:buChar char="○"/>
-            </a:pPr>
-            <a:r>
-              <a:rPr lang="en"/>
-              <a:t>XML definitions are copied as they are</a:t>
-            </a:r>
-            <a:endParaRPr/>
+        </p:txBody>
+      </p:sp>
+      <p:sp>
+        <p:nvSpPr>
+          <p:cNvPr id="59" name="Rounded Rectangle 58"/>
+          <p:cNvSpPr/>
+          <p:nvPr/>
+        </p:nvSpPr>
+        <p:spPr>
+          <a:xfrm>
+            <a:off x="411480" y="1600200"/>
+            <a:ext cx="1874519" cy="868680"/>
+          </a:xfrm>
+          <a:prstGeom prst="roundRect">
+            <a:avLst>
+              <a:gd name="adj" fmla="val 12000"/>
+            </a:avLst>
+          </a:prstGeom>
+          <a:solidFill>
+            <a:srgbClr val="2E3338"/>
+          </a:solidFill>
+          <a:ln>
+            <a:noFill/>
+          </a:ln>
+          <a:effectLst/>
+        </p:spPr>
+        <p:style>
+          <a:lnRef idx="1">
+            <a:schemeClr val="accent1"/>
+          </a:lnRef>
+          <a:fillRef idx="3">
+            <a:schemeClr val="accent1"/>
+          </a:fillRef>
+          <a:effectRef idx="2">
+            <a:schemeClr val="accent1"/>
+          </a:effectRef>
+          <a:fontRef idx="minor">
+            <a:schemeClr val="lt1"/>
+          </a:fontRef>
+        </p:style>
+        <p:txBody>
+          <a:bodyPr rtlCol="0" anchor="ctr" wrap="square" lIns="73152" rIns="73152"/>
+          <a:lstStyle/>
+          <a:p>
+            <a:pPr algn="ctr"/>
+            <a:r>
+              <a:rPr sz="1400" b="1">
+                <a:solidFill>
+                  <a:srgbClr val="DEE2E6"/>
+                </a:solidFill>
+              </a:rPr>
+              <a:t>Content/Assets</a:t>
+            </a:r>
+          </a:p>
+          <a:p>
+            <a:pPr algn="ctr"/>
+            <a:r>
+              <a:rPr sz="1200" b="0">
+                <a:solidFill>
+                  <a:srgbClr val="9AA3AB"/>
+                </a:solidFill>
+              </a:rPr>
+              <a:t>images, XML</a:t>
+            </a:r>
+          </a:p>
+        </p:txBody>
+      </p:sp>
+      <p:cxnSp>
+        <p:nvCxnSpPr>
+          <p:cNvPr id="60" name="Connector 59"/>
+          <p:cNvCxnSpPr/>
+          <p:nvPr/>
+        </p:nvCxnSpPr>
+        <p:spPr>
+          <a:xfrm>
+            <a:off x="2304288" y="2034540"/>
+            <a:ext cx="237744" cy="0"/>
+          </a:xfrm>
+          <a:prstGeom prst="line">
+            <a:avLst/>
+          </a:prstGeom>
+          <a:ln w="25400">
+            <a:solidFill>
+              <a:srgbClr val="9AA3AB"/>
+            </a:solidFill>
+            <a:tailEnd type="triangle"/>
+          </a:ln>
+        </p:spPr>
+        <p:style>
+          <a:lnRef idx="2">
+            <a:schemeClr val="accent1"/>
+          </a:lnRef>
+          <a:fillRef idx="0">
+            <a:schemeClr val="accent1"/>
+          </a:fillRef>
+          <a:effectRef idx="1">
+            <a:schemeClr val="accent1"/>
+          </a:effectRef>
+          <a:fontRef idx="minor">
+            <a:schemeClr val="tx1"/>
+          </a:fontRef>
+        </p:style>
+      </p:cxnSp>
+      <p:sp>
+        <p:nvSpPr>
+          <p:cNvPr id="61" name="Rounded Rectangle 60"/>
+          <p:cNvSpPr/>
+          <p:nvPr/>
+        </p:nvSpPr>
+        <p:spPr>
+          <a:xfrm>
+            <a:off x="2560320" y="1600200"/>
+            <a:ext cx="1874519" cy="868680"/>
+          </a:xfrm>
+          <a:prstGeom prst="roundRect">
+            <a:avLst>
+              <a:gd name="adj" fmla="val 12000"/>
+            </a:avLst>
+          </a:prstGeom>
+          <a:solidFill>
+            <a:srgbClr val="2E3338"/>
+          </a:solidFill>
+          <a:ln w="25400">
+            <a:solidFill>
+              <a:srgbClr val="D45D35"/>
+            </a:solidFill>
+          </a:ln>
+          <a:effectLst/>
+        </p:spPr>
+        <p:style>
+          <a:lnRef idx="1">
+            <a:schemeClr val="accent1"/>
+          </a:lnRef>
+          <a:fillRef idx="3">
+            <a:schemeClr val="accent1"/>
+          </a:fillRef>
+          <a:effectRef idx="2">
+            <a:schemeClr val="accent1"/>
+          </a:effectRef>
+          <a:fontRef idx="minor">
+            <a:schemeClr val="lt1"/>
+          </a:fontRef>
+        </p:style>
+        <p:txBody>
+          <a:bodyPr rtlCol="0" anchor="ctr" wrap="square" lIns="73152" rIns="73152"/>
+          <a:lstStyle/>
+          <a:p>
+            <a:pPr algn="ctr"/>
+            <a:r>
+              <a:rPr sz="1400" b="1">
+                <a:solidFill>
+                  <a:srgbClr val="DEE2E6"/>
+                </a:solidFill>
+              </a:rPr>
+              <a:t>Builder.cs</a:t>
+            </a:r>
+          </a:p>
+          <a:p>
+            <a:pPr algn="ctr"/>
+            <a:r>
+              <a:rPr sz="1200" b="0">
+                <a:solidFill>
+                  <a:srgbClr val="9AA3AB"/>
+                </a:solidFill>
+              </a:rPr>
+              <a:t>rules, in C#</a:t>
+            </a:r>
+          </a:p>
+        </p:txBody>
+      </p:sp>
+      <p:cxnSp>
+        <p:nvCxnSpPr>
+          <p:cNvPr id="62" name="Connector 61"/>
+          <p:cNvCxnSpPr/>
+          <p:nvPr/>
+        </p:nvCxnSpPr>
+        <p:spPr>
+          <a:xfrm>
+            <a:off x="4453127" y="2034540"/>
+            <a:ext cx="237745" cy="0"/>
+          </a:xfrm>
+          <a:prstGeom prst="line">
+            <a:avLst/>
+          </a:prstGeom>
+          <a:ln w="25400">
+            <a:solidFill>
+              <a:srgbClr val="9AA3AB"/>
+            </a:solidFill>
+            <a:tailEnd type="triangle"/>
+          </a:ln>
+        </p:spPr>
+        <p:style>
+          <a:lnRef idx="2">
+            <a:schemeClr val="accent1"/>
+          </a:lnRef>
+          <a:fillRef idx="0">
+            <a:schemeClr val="accent1"/>
+          </a:fillRef>
+          <a:effectRef idx="1">
+            <a:schemeClr val="accent1"/>
+          </a:effectRef>
+          <a:fontRef idx="minor">
+            <a:schemeClr val="tx1"/>
+          </a:fontRef>
+        </p:style>
+      </p:cxnSp>
+      <p:sp>
+        <p:nvSpPr>
+          <p:cNvPr id="63" name="Rounded Rectangle 62"/>
+          <p:cNvSpPr/>
+          <p:nvPr/>
+        </p:nvSpPr>
+        <p:spPr>
+          <a:xfrm>
+            <a:off x="4709159" y="1600200"/>
+            <a:ext cx="1874519" cy="868680"/>
+          </a:xfrm>
+          <a:prstGeom prst="roundRect">
+            <a:avLst>
+              <a:gd name="adj" fmla="val 12000"/>
+            </a:avLst>
+          </a:prstGeom>
+          <a:solidFill>
+            <a:srgbClr val="2E3338"/>
+          </a:solidFill>
+          <a:ln>
+            <a:noFill/>
+          </a:ln>
+          <a:effectLst/>
+        </p:spPr>
+        <p:style>
+          <a:lnRef idx="1">
+            <a:schemeClr val="accent1"/>
+          </a:lnRef>
+          <a:fillRef idx="3">
+            <a:schemeClr val="accent1"/>
+          </a:fillRef>
+          <a:effectRef idx="2">
+            <a:schemeClr val="accent1"/>
+          </a:effectRef>
+          <a:fontRef idx="minor">
+            <a:schemeClr val="lt1"/>
+          </a:fontRef>
+        </p:style>
+        <p:txBody>
+          <a:bodyPr rtlCol="0" anchor="ctr" wrap="square" lIns="73152" rIns="73152"/>
+          <a:lstStyle/>
+          <a:p>
+            <a:pPr algn="ctr"/>
+            <a:r>
+              <a:rPr sz="1400" b="1">
+                <a:solidFill>
+                  <a:srgbClr val="DEE2E6"/>
+                </a:solidFill>
+              </a:rPr>
+              <a:t>The content builder</a:t>
+            </a:r>
+          </a:p>
+          <a:p>
+            <a:pPr algn="ctr"/>
+            <a:r>
+              <a:rPr sz="1200" b="0">
+                <a:solidFill>
+                  <a:srgbClr val="9AA3AB"/>
+                </a:solidFill>
+              </a:rPr>
+              <a:t>runs on build</a:t>
+            </a:r>
+          </a:p>
+        </p:txBody>
+      </p:sp>
+      <p:cxnSp>
+        <p:nvCxnSpPr>
+          <p:cNvPr id="64" name="Connector 63"/>
+          <p:cNvCxnSpPr/>
+          <p:nvPr/>
+        </p:nvCxnSpPr>
+        <p:spPr>
+          <a:xfrm>
+            <a:off x="6601967" y="2034540"/>
+            <a:ext cx="237745" cy="0"/>
+          </a:xfrm>
+          <a:prstGeom prst="line">
+            <a:avLst/>
+          </a:prstGeom>
+          <a:ln w="25400">
+            <a:solidFill>
+              <a:srgbClr val="9AA3AB"/>
+            </a:solidFill>
+            <a:tailEnd type="triangle"/>
+          </a:ln>
+        </p:spPr>
+        <p:style>
+          <a:lnRef idx="2">
+            <a:schemeClr val="accent1"/>
+          </a:lnRef>
+          <a:fillRef idx="0">
+            <a:schemeClr val="accent1"/>
+          </a:fillRef>
+          <a:effectRef idx="1">
+            <a:schemeClr val="accent1"/>
+          </a:effectRef>
+          <a:fontRef idx="minor">
+            <a:schemeClr val="tx1"/>
+          </a:fontRef>
+        </p:style>
+      </p:cxnSp>
+      <p:sp>
+        <p:nvSpPr>
+          <p:cNvPr id="65" name="Rounded Rectangle 64"/>
+          <p:cNvSpPr/>
+          <p:nvPr/>
+        </p:nvSpPr>
+        <p:spPr>
+          <a:xfrm>
+            <a:off x="6857999" y="1600200"/>
+            <a:ext cx="1874519" cy="868680"/>
+          </a:xfrm>
+          <a:prstGeom prst="roundRect">
+            <a:avLst>
+              <a:gd name="adj" fmla="val 12000"/>
+            </a:avLst>
+          </a:prstGeom>
+          <a:solidFill>
+            <a:srgbClr val="2E3338"/>
+          </a:solidFill>
+          <a:ln>
+            <a:noFill/>
+          </a:ln>
+          <a:effectLst/>
+        </p:spPr>
+        <p:style>
+          <a:lnRef idx="1">
+            <a:schemeClr val="accent1"/>
+          </a:lnRef>
+          <a:fillRef idx="3">
+            <a:schemeClr val="accent1"/>
+          </a:fillRef>
+          <a:effectRef idx="2">
+            <a:schemeClr val="accent1"/>
+          </a:effectRef>
+          <a:fontRef idx="minor">
+            <a:schemeClr val="lt1"/>
+          </a:fontRef>
+        </p:style>
+        <p:txBody>
+          <a:bodyPr rtlCol="0" anchor="ctr" wrap="square" lIns="73152" rIns="73152"/>
+          <a:lstStyle/>
+          <a:p>
+            <a:pPr algn="ctr"/>
+            <a:r>
+              <a:rPr sz="1400" b="1">
+                <a:solidFill>
+                  <a:srgbClr val="DEE2E6"/>
+                </a:solidFill>
+              </a:rPr>
+              <a:t>bin/.../Content</a:t>
+            </a:r>
+          </a:p>
+          <a:p>
+            <a:pPr algn="ctr"/>
+            <a:r>
+              <a:rPr sz="1200" b="0">
+                <a:solidFill>
+                  <a:srgbClr val="9AA3AB"/>
+                </a:solidFill>
+              </a:rPr>
+              <a:t>.xnb files, XML</a:t>
+            </a:r>
+          </a:p>
+        </p:txBody>
+      </p:sp>
+      <p:sp>
+        <p:nvSpPr>
+          <p:cNvPr id="66" name="TextBox 65"/>
+          <p:cNvSpPr txBox="1"/>
+          <p:nvPr/>
+        </p:nvSpPr>
+        <p:spPr>
+          <a:xfrm>
+            <a:off x="411480" y="2697480"/>
+            <a:ext cx="8321040" cy="548640"/>
+          </a:xfrm>
+          <a:prstGeom prst="rect">
+            <a:avLst/>
+          </a:prstGeom>
+          <a:noFill/>
+        </p:spPr>
+        <p:txBody>
+          <a:bodyPr wrap="square">
+            <a:spAutoFit/>
+          </a:bodyPr>
+          <a:lstStyle/>
+          <a:p>
+            <a:pPr algn="ctr"/>
+            <a:r>
+              <a:rPr sz="1400" b="0" i="0">
+                <a:solidFill>
+                  <a:srgbClr val="9AA3AB"/>
+                </a:solidFill>
+              </a:rPr>
+              <a:t>PNG images become textures (magenta is see-through). XML definitions are copied as they are.</a:t>
+            </a:r>
           </a:p>
         </p:txBody>
       </p:sp>
@@ -19315,7 +20550,7 @@
         <p:spPr>
           <a:xfrm>
             <a:off x="311700" y="885950"/>
-            <a:ext cx="8520600" cy="4023300"/>
+            <a:ext cx="8520600" cy="521208"/>
           </a:xfrm>
           <a:prstGeom prst="rect">
             <a:avLst/>
@@ -19339,94 +20574,278 @@
             </a:pPr>
             <a:r>
               <a:rPr lang="en"/>
-              <a:t>The XML files describe the assets</a:t>
+              <a:t>The XML describes the assets; the code only reads it.</a:t>
             </a:r>
             <a:endParaRPr/>
           </a:p>
-          <a:p>
-            <a:pPr indent="-317500" lvl="1" marL="914400" rtl="0" algn="l">
-              <a:spcBef>
-                <a:spcPts val="0"/>
-              </a:spcBef>
-              <a:spcAft>
-                <a:spcPts val="0"/>
-              </a:spcAft>
-              <a:buSzPts val="1400"/>
-              <a:buChar char="○"/>
-            </a:pPr>
-            <a:r>
-              <a:rPr lang="en"/>
-              <a:t>Which part of the image is the snake, how the bat’s animation runs, which tile goes where</a:t>
-            </a:r>
-            <a:endParaRPr/>
-          </a:p>
-          <a:p>
-            <a:pPr indent="-330200" lvl="0" marL="457200" rtl="0" algn="l">
-              <a:spcBef>
-                <a:spcPts val="0"/>
-              </a:spcBef>
-              <a:spcAft>
-                <a:spcPts val="0"/>
-              </a:spcAft>
-              <a:buSzPts val="1600"/>
-              <a:buChar char="●"/>
-            </a:pPr>
-            <a:r>
-              <a:rPr lang="en"/>
-              <a:t>Data can change without the code changing</a:t>
-            </a:r>
-            <a:endParaRPr/>
-          </a:p>
-          <a:p>
-            <a:pPr indent="-317500" lvl="1" marL="914400" rtl="0" algn="l">
-              <a:spcBef>
-                <a:spcPts val="0"/>
-              </a:spcBef>
-              <a:spcAft>
-                <a:spcPts val="0"/>
-              </a:spcAft>
-              <a:buSzPts val="1400"/>
-              <a:buChar char="○"/>
-            </a:pPr>
-            <a:r>
-              <a:rPr lang="en"/>
-              <a:t>A new frame, a faster animation or a new room: edit a file, not C#</a:t>
-            </a:r>
-            <a:endParaRPr/>
-          </a:p>
-          <a:p>
-            <a:pPr indent="-317500" lvl="1" marL="914400" rtl="0" algn="l">
-              <a:spcBef>
-                <a:spcPts val="0"/>
-              </a:spcBef>
-              <a:spcAft>
-                <a:spcPts val="0"/>
-              </a:spcAft>
-              <a:buSzPts val="1400"/>
-              <a:buChar char="○"/>
-            </a:pPr>
-            <a:r>
-              <a:rPr lang="en"/>
-              <a:t>Artists and designers can work without touching the code</a:t>
-            </a:r>
-            <a:endParaRPr/>
-          </a:p>
-          <a:p>
-            <a:pPr indent="-330200" lvl="0" marL="457200" rtl="0" algn="l">
-              <a:spcBef>
-                <a:spcPts val="0"/>
-              </a:spcBef>
-              <a:spcAft>
-                <a:spcPts val="0"/>
-              </a:spcAft>
-              <a:buSzPts val="1600"/>
-              <a:buChar char="●"/>
-            </a:pPr>
-            <a:r>
-              <a:rPr lang="en"/>
-              <a:t>The code gets smaller and more general</a:t>
-            </a:r>
-            <a:endParaRPr/>
+        </p:txBody>
+      </p:sp>
+      <p:sp>
+        <p:nvSpPr>
+          <p:cNvPr id="295" name="Rectangle 294"/>
+          <p:cNvSpPr/>
+          <p:nvPr/>
+        </p:nvSpPr>
+        <p:spPr>
+          <a:xfrm>
+            <a:off x="411480" y="1371600"/>
+            <a:ext cx="4937760" cy="2377440"/>
+          </a:xfrm>
+          <a:prstGeom prst="rect">
+            <a:avLst/>
+          </a:prstGeom>
+          <a:solidFill>
+            <a:srgbClr val="17191C"/>
+          </a:solidFill>
+          <a:ln>
+            <a:noFill/>
+          </a:ln>
+          <a:effectLst/>
+        </p:spPr>
+        <p:style>
+          <a:lnRef idx="1">
+            <a:schemeClr val="accent1"/>
+          </a:lnRef>
+          <a:fillRef idx="3">
+            <a:schemeClr val="accent1"/>
+          </a:fillRef>
+          <a:effectRef idx="2">
+            <a:schemeClr val="accent1"/>
+          </a:effectRef>
+          <a:fontRef idx="minor">
+            <a:schemeClr val="lt1"/>
+          </a:fontRef>
+        </p:style>
+        <p:txBody>
+          <a:bodyPr rtlCol="0" anchor="ctr" wrap="square" lIns="164592" rIns="73152"/>
+          <a:lstStyle/>
+          <a:p>
+            <a:pPr algn="l"/>
+            <a:r>
+              <a:rPr sz="1400" b="0">
+                <a:solidFill>
+                  <a:srgbClr val="DEE2E6"/>
+                </a:solidFill>
+              </a:rPr>
+              <a:t/>
+            </a:r>
+            <a:r>
+              <a:rPr sz="1100">
+                <a:solidFill>
+                  <a:srgbClr val="DEE2E6"/>
+                </a:solidFill>
+                <a:latin typeface="Consolas"/>
+              </a:rPr>
+              <a:t>&lt;Region name="bat-1" x="20" y="0" width="20" height="20" /&gt;</a:t>
+            </a:r>
+          </a:p>
+          <a:p>
+            <a:pPr algn="l"/>
+            <a:r>
+              <a:rPr sz="1100">
+                <a:solidFill>
+                  <a:srgbClr val="DEE2E6"/>
+                </a:solidFill>
+                <a:latin typeface="Consolas"/>
+              </a:rPr>
+              <a:t>&lt;Region name="bat-2" x="20" y="20" width="20" height="20" /&gt;</a:t>
+            </a:r>
+          </a:p>
+          <a:p>
+            <a:pPr algn="l"/>
+            <a:r>
+              <a:rPr sz="1100">
+                <a:solidFill>
+                  <a:srgbClr val="DEE2E6"/>
+                </a:solidFill>
+                <a:latin typeface="Consolas"/>
+              </a:rPr>
+              <a:t>&lt;Region name="bat-3" x="40" y="0" width="20" height="20" /&gt;</a:t>
+            </a:r>
+          </a:p>
+          <a:p>
+            <a:pPr algn="l"/>
+            <a:r>
+              <a:rPr sz="1100">
+                <a:solidFill>
+                  <a:srgbClr val="DEE2E6"/>
+                </a:solidFill>
+                <a:latin typeface="Consolas"/>
+              </a:rPr>
+              <a:t> </a:t>
+            </a:r>
+          </a:p>
+          <a:p>
+            <a:pPr algn="l"/>
+            <a:r>
+              <a:rPr sz="1100">
+                <a:solidFill>
+                  <a:srgbClr val="DEE2E6"/>
+                </a:solidFill>
+                <a:latin typeface="Consolas"/>
+              </a:rPr>
+              <a:t>&lt;Animation name="bat-animation" delay="200"&gt;</a:t>
+            </a:r>
+          </a:p>
+          <a:p>
+            <a:pPr algn="l"/>
+            <a:r>
+              <a:rPr sz="1100">
+                <a:solidFill>
+                  <a:srgbClr val="DEE2E6"/>
+                </a:solidFill>
+                <a:latin typeface="Consolas"/>
+              </a:rPr>
+              <a:t>    &lt;Frame region="bat-1" /&gt;</a:t>
+            </a:r>
+          </a:p>
+          <a:p>
+            <a:pPr algn="l"/>
+            <a:r>
+              <a:rPr sz="1100">
+                <a:solidFill>
+                  <a:srgbClr val="DEE2E6"/>
+                </a:solidFill>
+                <a:latin typeface="Consolas"/>
+              </a:rPr>
+              <a:t>    &lt;Frame region="bat-2" /&gt;</a:t>
+            </a:r>
+          </a:p>
+          <a:p>
+            <a:pPr algn="l"/>
+            <a:r>
+              <a:rPr sz="1100">
+                <a:solidFill>
+                  <a:srgbClr val="DEE2E6"/>
+                </a:solidFill>
+                <a:latin typeface="Consolas"/>
+              </a:rPr>
+              <a:t>    &lt;Frame region="bat-1" /&gt;</a:t>
+            </a:r>
+          </a:p>
+          <a:p>
+            <a:pPr algn="l"/>
+            <a:r>
+              <a:rPr sz="1100">
+                <a:solidFill>
+                  <a:srgbClr val="DEE2E6"/>
+                </a:solidFill>
+                <a:latin typeface="Consolas"/>
+              </a:rPr>
+              <a:t>    &lt;Frame region="bat-3" /&gt;</a:t>
+            </a:r>
+          </a:p>
+          <a:p>
+            <a:pPr algn="l"/>
+            <a:r>
+              <a:rPr sz="1100">
+                <a:solidFill>
+                  <a:srgbClr val="DEE2E6"/>
+                </a:solidFill>
+                <a:latin typeface="Consolas"/>
+              </a:rPr>
+              <a:t>&lt;/Animation&gt;</a:t>
+            </a:r>
+          </a:p>
+        </p:txBody>
+      </p:sp>
+      <p:sp>
+        <p:nvSpPr>
+          <p:cNvPr id="296" name="TextBox 295"/>
+          <p:cNvSpPr txBox="1"/>
+          <p:nvPr/>
+        </p:nvSpPr>
+        <p:spPr>
+          <a:xfrm>
+            <a:off x="5577840" y="1463040"/>
+            <a:ext cx="3200400" cy="2194560"/>
+          </a:xfrm>
+          <a:prstGeom prst="rect">
+            <a:avLst/>
+          </a:prstGeom>
+          <a:noFill/>
+        </p:spPr>
+        <p:txBody>
+          <a:bodyPr wrap="square">
+            <a:spAutoFit/>
+          </a:bodyPr>
+          <a:lstStyle/>
+          <a:p>
+            <a:pPr algn="l"/>
+            <a:r>
+              <a:rPr sz="1700" b="1" i="0">
+                <a:solidFill>
+                  <a:srgbClr val="DEE2E6"/>
+                </a:solidFill>
+              </a:rPr>
+              <a:t>A faster bat?</a:t>
+            </a:r>
+          </a:p>
+          <a:p>
+            <a:pPr algn="l"/>
+            <a:r>
+              <a:rPr sz="1700" b="1" i="0">
+                <a:solidFill>
+                  <a:srgbClr val="DEE2E6"/>
+                </a:solidFill>
+              </a:rPr>
+              <a:t/>
+            </a:r>
+          </a:p>
+          <a:p>
+            <a:pPr algn="l"/>
+            <a:r>
+              <a:rPr sz="1700" b="1" i="0">
+                <a:solidFill>
+                  <a:srgbClr val="DEE2E6"/>
+                </a:solidFill>
+              </a:rPr>
+              <a:t>An extra frame?</a:t>
+            </a:r>
+          </a:p>
+          <a:p>
+            <a:pPr algn="l"/>
+            <a:r>
+              <a:rPr sz="1700" b="1" i="0">
+                <a:solidFill>
+                  <a:srgbClr val="DEE2E6"/>
+                </a:solidFill>
+              </a:rPr>
+              <a:t/>
+            </a:r>
+          </a:p>
+          <a:p>
+            <a:pPr algn="l"/>
+            <a:r>
+              <a:rPr sz="1700" b="1" i="0">
+                <a:solidFill>
+                  <a:srgbClr val="DEE2E6"/>
+                </a:solidFill>
+              </a:rPr>
+              <a:t>A new room?</a:t>
+            </a:r>
+          </a:p>
+          <a:p>
+            <a:pPr algn="l"/>
+            <a:r>
+              <a:rPr sz="1700" b="1" i="0">
+                <a:solidFill>
+                  <a:srgbClr val="DEE2E6"/>
+                </a:solidFill>
+              </a:rPr>
+              <a:t/>
+            </a:r>
+          </a:p>
+          <a:p>
+            <a:pPr algn="l"/>
+            <a:r>
+              <a:rPr sz="1700" b="1" i="0">
+                <a:solidFill>
+                  <a:srgbClr val="DEE2E6"/>
+                </a:solidFill>
+              </a:rPr>
+              <a:t>Which of these need a C# change?</a:t>
+            </a:r>
           </a:p>
         </p:txBody>
       </p:sp>

</xml_diff>

<commit_message>
Session 03: exercises a student can do (the beetle is in the atlas; gamepad input through a GamePadInfo)
Co-Authored-By: Claude Opus 5.5 <noreply@anthropic.com>
Claude-Session: https://claude.ai/code/session_012sjsUQBbC7zon57rWHoo9d
</commit_message>
<xml_diff>
--- a/slides/03 Snake.pptx
+++ b/slides/03 Snake.pptx
@@ -3073,7 +3073,12 @@
           <a:lstStyle/>
           <a:p>
             <a:r>
-              <a:t>Exercise: a second enemy with its own animation, and a new room layout. Ask afterwards: how much C# did you change? Ideally none.</a:t>
+              <a:t>Exercise: the beetle is drawn in the atlas but not described. Two regions and an animation in the XML, then one line of C# (the animation name), then a new room layout.</a:t>
+            </a:r>
+          </a:p>
+          <a:p>
+            <a:r>
+              <a:t>Ask afterwards: how much C# did you change? One string. And for a beetle next to the bat? A lot: Game1 handles the bat by name (its collisions, its bounces). That is the next architecture problem, not a data one.</a:t>
             </a:r>
           </a:p>
         </p:txBody>
@@ -3163,6 +3168,11 @@
           <a:p>
             <a:r>
               <a:t>Start from Snake9. Ask for the speed-up exercise: where does that rule belong? In the snake, or in the game?</a:t>
+            </a:r>
+          </a:p>
+          <a:p>
+            <a:r>
+              <a:t>Gamepad: a press needs last frame’s state, so it goes through a GamePadInfo in GMDCore. In the game, only GameController changes. Geometry Wars has a finished GamePadInfo to compare with.</a:t>
             </a:r>
           </a:p>
         </p:txBody>
@@ -16534,7 +16544,7 @@
         <p:spPr>
           <a:xfrm>
             <a:off x="311700" y="885950"/>
-            <a:ext cx="8520600" cy="1248900"/>
+            <a:ext cx="8520600" cy="1673352"/>
           </a:xfrm>
           <a:prstGeom prst="rect">
             <a:avLst/>
@@ -16542,7 +16552,7 @@
         </p:spPr>
         <p:txBody>
           <a:bodyPr anchorCtr="0" anchor="t" bIns="91425" lIns="91425" spcFirstLastPara="1" rIns="91425" wrap="square" tIns="91425">
-            <a:normAutofit lnSpcReduction="20000"/>
+            <a:normAutofit/>
           </a:bodyPr>
           <a:lstStyle/>
           <a:p>
@@ -16558,24 +16568,7 @@
             </a:pPr>
             <a:r>
               <a:rPr lang="en"/>
-              <a:t>Add a second enemy with its own animation</a:t>
-            </a:r>
-            <a:endParaRPr/>
-          </a:p>
-          <a:p>
-            <a:pPr indent="-317500" lvl="1" marL="914400" rtl="0" algn="l">
-              <a:spcBef>
-                <a:spcPts val="0"/>
-              </a:spcBef>
-              <a:spcAft>
-                <a:spcPts val="0"/>
-              </a:spcAft>
-              <a:buSzPts val="1400"/>
-              <a:buChar char="○"/>
-            </a:pPr>
-            <a:r>
-              <a:rPr lang="en"/>
-              <a:t>New regions and an animation in atlas-definition.xml</a:t>
+              <a:t>A beetle is in the atlas image, but not in the data</a:t>
             </a:r>
             <a:endParaRPr/>
           </a:p>
@@ -16592,7 +16585,7 @@
             </a:pPr>
             <a:r>
               <a:rPr lang="en"/>
-              <a:t>Change the room layout in tilemap-definition.xml</a:t>
+              <a:t>Describe it in atlas-definition.xml: two regions, one animation</a:t>
             </a:r>
             <a:endParaRPr/>
           </a:p>
@@ -16609,42 +16602,29 @@
             </a:pPr>
             <a:r>
               <a:rPr lang="en"/>
-              <a:t>How much C# did you need to change?</a:t>
+              <a:t>Make the enemy a beetle; then change the room in tilemap-definition.xml</a:t>
+            </a:r>
+            <a:endParaRPr/>
+          </a:p>
+          <a:p>
+            <a:pPr indent="-330200" lvl="0" marL="457200" rtl="0" algn="l">
+              <a:spcBef>
+                <a:spcPts val="0"/>
+              </a:spcBef>
+              <a:spcAft>
+                <a:spcPts val="0"/>
+              </a:spcAft>
+              <a:buSzPts val="1600"/>
+              <a:buChar char="●"/>
+            </a:pPr>
+            <a:r>
+              <a:rPr lang="en"/>
+              <a:t>How much C# did you change? And for a beetle next to the bat?</a:t>
             </a:r>
             <a:endParaRPr/>
           </a:p>
         </p:txBody>
       </p:sp>
-      <p:pic>
-        <p:nvPicPr>
-          <p:cNvPr id="288" name="Google Shape;288;p44">
-            <a:hlinkClick r:id="rId3"/>
-          </p:cNvPr>
-          <p:cNvPicPr preferRelativeResize="0"/>
-          <p:nvPr/>
-        </p:nvPicPr>
-        <p:blipFill>
-          <a:blip r:embed="rId4">
-            <a:alphaModFix/>
-          </a:blip>
-          <a:stretch>
-            <a:fillRect/>
-          </a:stretch>
-        </p:blipFill>
-        <p:spPr>
-          <a:xfrm>
-            <a:off x="2004288" y="2252475"/>
-            <a:ext cx="5135416" cy="2703850"/>
-          </a:xfrm>
-          <a:prstGeom prst="rect">
-            <a:avLst/>
-          </a:prstGeom>
-          <a:noFill/>
-          <a:ln>
-            <a:noFill/>
-          </a:ln>
-        </p:spPr>
-      </p:pic>
     </p:spTree>
   </p:cSld>
   <p:clrMapOvr>
@@ -17004,7 +16984,7 @@
         <p:spPr>
           <a:xfrm>
             <a:off x="311700" y="885950"/>
-            <a:ext cx="8520600" cy="4023300"/>
+            <a:ext cx="8520600" cy="2057400"/>
           </a:xfrm>
           <a:prstGeom prst="rect">
             <a:avLst/>
@@ -17050,23 +17030,6 @@
             <a:endParaRPr/>
           </a:p>
           <a:p>
-            <a:pPr indent="-317500" lvl="1" marL="914400" rtl="0" algn="l">
-              <a:spcBef>
-                <a:spcPts val="0"/>
-              </a:spcBef>
-              <a:spcAft>
-                <a:spcPts val="0"/>
-              </a:spcAft>
-              <a:buSzPts val="1400"/>
-              <a:buChar char="○"/>
-            </a:pPr>
-            <a:r>
-              <a:rPr lang="en"/>
-              <a:t>Where does that rule belong?</a:t>
-            </a:r>
-            <a:endParaRPr/>
-          </a:p>
-          <a:p>
             <a:pPr indent="-330200" lvl="0" marL="457200" rtl="0" algn="l">
               <a:spcBef>
                 <a:spcPts val="0"/>
@@ -17079,7 +17042,24 @@
             </a:pPr>
             <a:r>
               <a:rPr lang="en"/>
-              <a:t>New input: add gamepad support by changing only GameController</a:t>
+              <a:t>Where does that rule belong?</a:t>
+            </a:r>
+            <a:endParaRPr/>
+          </a:p>
+          <a:p>
+            <a:pPr indent="-330200" lvl="0" marL="457200" rtl="0" algn="l">
+              <a:spcBef>
+                <a:spcPts val="0"/>
+              </a:spcBef>
+              <a:spcAft>
+                <a:spcPts val="0"/>
+              </a:spcAft>
+              <a:buSzPts val="1600"/>
+              <a:buChar char="●"/>
+            </a:pPr>
+            <a:r>
+              <a:rPr lang="en"/>
+              <a:t>New input: the D-pad, through a GamePadInfo in GMDCore</a:t>
             </a:r>
             <a:endParaRPr/>
           </a:p>

</xml_diff>

<commit_message>
Snake: a short task after each demo, on the step just shown (pilot); Mario's debug-drawing exercise in the deck
Co-Authored-By: Claude Opus 5.5 <noreply@anthropic.com>
Claude-Session: https://claude.ai/code/session_012sjsUQBbC7zon57rWHoo9d
</commit_message>
<xml_diff>
--- a/slides/03 Snake.pptx
+++ b/slides/03 Snake.pptx
@@ -19,18 +19,23 @@
     <p:sldId id="261" r:id="rId11"/>
     <p:sldId id="262" r:id="rId12"/>
     <p:sldId id="263" r:id="rId13"/>
+    <p:sldId id="308" r:id="rId24"/>
     <p:sldId id="264" r:id="rId14"/>
     <p:sldId id="265" r:id="rId15"/>
+    <p:sldId id="307" r:id="rId25"/>
     <p:sldId id="266" r:id="rId16"/>
     <p:sldId id="267" r:id="rId17"/>
     <p:sldId id="268" r:id="rId18"/>
+    <p:sldId id="306" r:id="rId26"/>
     <p:sldId id="288" r:id="rId38"/>
     <p:sldId id="289" r:id="rId39"/>
     <p:sldId id="290" r:id="rId40"/>
+    <p:sldId id="305" r:id="rId27"/>
     <p:sldId id="298" r:id="rId57"/>
     <p:sldId id="299" r:id="rId58"/>
     <p:sldId id="300" r:id="rId59"/>
     <p:sldId id="301" r:id="rId60"/>
+    <p:sldId id="304" r:id="rId28"/>
     <p:sldId id="281" r:id="rId31"/>
     <p:sldId id="282" r:id="rId32"/>
     <p:sldId id="283" r:id="rId33"/>
@@ -1211,6 +1216,69 @@
 </p:notes>
 </file>
 
+<file path=ppt/notesSlides/notesSlide14.xml><?xml version="1.0" encoding="utf-8"?>
+<p:notes xmlns:a="http://schemas.openxmlformats.org/drawingml/2006/main" xmlns:p="http://schemas.openxmlformats.org/presentationml/2006/main" xmlns:r="http://schemas.openxmlformats.org/officeDocument/2006/relationships">
+  <p:cSld>
+    <p:spTree>
+      <p:nvGrpSpPr>
+        <p:cNvPr id="1" name=""/>
+        <p:cNvGrpSpPr/>
+        <p:nvPr/>
+      </p:nvGrpSpPr>
+      <p:grpSpPr>
+        <a:xfrm>
+          <a:off x="0" y="0"/>
+          <a:ext cx="0" cy="0"/>
+          <a:chOff x="0" y="0"/>
+          <a:chExt cx="0" cy="0"/>
+        </a:xfrm>
+      </p:grpSpPr>
+      <p:sp>
+        <p:nvSpPr>
+          <p:cNvPr id="2" name="Slide Image Placeholder 1"/>
+          <p:cNvSpPr>
+            <a:spLocks noGrp="1"/>
+          </p:cNvSpPr>
+          <p:nvPr>
+            <p:ph type="sldImg" idx="2"/>
+          </p:nvPr>
+        </p:nvSpPr>
+        <p:spPr/>
+      </p:sp>
+      <p:sp>
+        <p:nvSpPr>
+          <p:cNvPr id="3" name="Notes Placeholder 2"/>
+          <p:cNvSpPr>
+            <a:spLocks noGrp="1"/>
+          </p:cNvSpPr>
+          <p:nvPr>
+            <p:ph type="body" idx="1"/>
+          </p:nvPr>
+        </p:nvSpPr>
+        <p:spPr/>
+        <p:txBody>
+          <a:bodyPr/>
+          <a:lstStyle/>
+          <a:p>
+            <a:r>
+              <a:t>Pairs, about 7 minutes. Speed: TickDuration in Snake. Keys: GameController only.</a:t>
+            </a:r>
+          </a:p>
+          <a:p>
+            <a:r>
+              <a:t>If there is time: press two turns within one tick in Snake6, then in Snake7, and compare.</a:t>
+            </a:r>
+          </a:p>
+        </p:txBody>
+      </p:sp>
+    </p:spTree>
+  </p:cSld>
+  <p:clrMapOvr>
+    <a:masterClrMapping/>
+  </p:clrMapOvr>
+</p:notes>
+</file>
+
 <file path=ppt/notesSlides/notesSlide15.xml><?xml version="1.0" encoding="utf-8"?>
 <p:notes xmlns:a="http://schemas.openxmlformats.org/drawingml/2006/main" xmlns:p="http://schemas.openxmlformats.org/presentationml/2006/main" xmlns:r="http://schemas.openxmlformats.org/officeDocument/2006/relationships">
   <p:cSld>
@@ -3249,6 +3317,127 @@
 </p:notes>
 </file>
 
+<file path=ppt/notesSlides/notesSlide38.xml><?xml version="1.0" encoding="utf-8"?>
+<p:notes xmlns:a="http://schemas.openxmlformats.org/drawingml/2006/main" xmlns:p="http://schemas.openxmlformats.org/presentationml/2006/main" xmlns:r="http://schemas.openxmlformats.org/officeDocument/2006/relationships">
+  <p:cSld>
+    <p:spTree>
+      <p:nvGrpSpPr>
+        <p:cNvPr id="1" name=""/>
+        <p:cNvGrpSpPr/>
+        <p:nvPr/>
+      </p:nvGrpSpPr>
+      <p:grpSpPr>
+        <a:xfrm>
+          <a:off x="0" y="0"/>
+          <a:ext cx="0" cy="0"/>
+          <a:chOff x="0" y="0"/>
+          <a:chExt cx="0" cy="0"/>
+        </a:xfrm>
+      </p:grpSpPr>
+      <p:sp>
+        <p:nvSpPr>
+          <p:cNvPr id="2" name="Slide Image Placeholder 1"/>
+          <p:cNvSpPr>
+            <a:spLocks noGrp="1"/>
+          </p:cNvSpPr>
+          <p:nvPr>
+            <p:ph type="sldImg" idx="2"/>
+          </p:nvPr>
+        </p:nvSpPr>
+        <p:spPr/>
+      </p:sp>
+      <p:sp>
+        <p:nvSpPr>
+          <p:cNvPr id="3" name="Notes Placeholder 2"/>
+          <p:cNvSpPr>
+            <a:spLocks noGrp="1"/>
+          </p:cNvSpPr>
+          <p:nvPr>
+            <p:ph type="body" idx="1"/>
+          </p:nvPr>
+        </p:nvSpPr>
+        <p:spPr/>
+        <p:txBody>
+          <a:bodyPr/>
+          <a:lstStyle/>
+          <a:p>
+            <a:r>
+              <a:t>Pairs, about 5 minutes, in Snake4.</a:t>
+            </a:r>
+          </a:p>
+          <a:p>
+            <a:r>
+              <a:t>Answer for the 20: the tileset has 16 tiles (0 to 15), so the game fails when it draws the room. Same lesson as the misspelled region: data errors appear at runtime.</a:t>
+            </a:r>
+          </a:p>
+        </p:txBody>
+      </p:sp>
+    </p:spTree>
+  </p:cSld>
+  <p:clrMapOvr>
+    <a:masterClrMapping/>
+  </p:clrMapOvr>
+</p:notes>
+</file>
+
+<file path=ppt/notesSlides/notesSlide39.xml><?xml version="1.0" encoding="utf-8"?>
+<p:notes xmlns:a="http://schemas.openxmlformats.org/drawingml/2006/main" xmlns:p="http://schemas.openxmlformats.org/presentationml/2006/main" xmlns:r="http://schemas.openxmlformats.org/officeDocument/2006/relationships">
+  <p:cSld>
+    <p:spTree>
+      <p:nvGrpSpPr>
+        <p:cNvPr id="1" name=""/>
+        <p:cNvGrpSpPr/>
+        <p:nvPr/>
+      </p:nvGrpSpPr>
+      <p:grpSpPr>
+        <a:xfrm>
+          <a:off x="0" y="0"/>
+          <a:ext cx="0" cy="0"/>
+          <a:chOff x="0" y="0"/>
+          <a:chExt cx="0" cy="0"/>
+        </a:xfrm>
+      </p:grpSpPr>
+      <p:sp>
+        <p:nvSpPr>
+          <p:cNvPr id="2" name="Slide Image Placeholder 1"/>
+          <p:cNvSpPr>
+            <a:spLocks noGrp="1"/>
+          </p:cNvSpPr>
+          <p:nvPr>
+            <p:ph type="sldImg" idx="2"/>
+          </p:nvPr>
+        </p:nvSpPr>
+        <p:spPr/>
+      </p:sp>
+      <p:sp>
+        <p:nvSpPr>
+          <p:cNvPr id="3" name="Notes Placeholder 2"/>
+          <p:cNvSpPr>
+            <a:spLocks noGrp="1"/>
+          </p:cNvSpPr>
+          <p:nvPr>
+            <p:ph type="body" idx="1"/>
+          </p:nvPr>
+        </p:nvSpPr>
+        <p:spPr/>
+        <p:txBody>
+          <a:bodyPr/>
+          <a:lstStyle/>
+          <a:p>
+            <a:r>
+              <a:t>Pairs, about 5 minutes, in Snake3. The delay attribute and one more Frame line. Ask afterwards: how much C# did you change? None.</a:t>
+            </a:r>
+          </a:p>
+        </p:txBody>
+      </p:sp>
+    </p:spTree>
+  </p:cSld>
+  <p:clrMapOvr>
+    <a:masterClrMapping/>
+  </p:clrMapOvr>
+</p:notes>
+</file>
+
 <file path=ppt/notesSlides/notesSlide4.xml><?xml version="1.0" encoding="utf-8"?>
 <p:notes xmlns:a="http://schemas.openxmlformats.org/drawingml/2006/main" xmlns:r="http://schemas.openxmlformats.org/officeDocument/2006/relationships" xmlns:mc="http://schemas.openxmlformats.org/markup-compatibility/2006" xmlns:mv="urn:schemas-microsoft-com:mac:vml" xmlns:p="http://schemas.openxmlformats.org/presentationml/2006/main" xmlns:c="http://schemas.openxmlformats.org/drawingml/2006/chart" xmlns:dgm="http://schemas.openxmlformats.org/drawingml/2006/diagram" xmlns:o="urn:schemas-microsoft-com:office:office" xmlns:v="urn:schemas-microsoft-com:vml" xmlns:pvml="urn:schemas-microsoft-com:office:powerpoint" xmlns:com="http://schemas.openxmlformats.org/drawingml/2006/compatibility" xmlns:p14="http://schemas.microsoft.com/office/powerpoint/2010/main" xmlns:p15="http://schemas.microsoft.com/office/powerpoint/2012/main" xmlns:ahyp="http://schemas.microsoft.com/office/drawing/2018/hyperlinkcolor" showMasterPhAnim="0" showMasterSp="0">
   <p:cSld>
@@ -3331,6 +3520,132 @@
           <a:p>
             <a:r>
               <a:t>Say: the site explains the ideas, the README helps you find them in the code, the slides are for today.</a:t>
+            </a:r>
+          </a:p>
+        </p:txBody>
+      </p:sp>
+    </p:spTree>
+  </p:cSld>
+  <p:clrMapOvr>
+    <a:masterClrMapping/>
+  </p:clrMapOvr>
+</p:notes>
+</file>
+
+<file path=ppt/notesSlides/notesSlide40.xml><?xml version="1.0" encoding="utf-8"?>
+<p:notes xmlns:a="http://schemas.openxmlformats.org/drawingml/2006/main" xmlns:p="http://schemas.openxmlformats.org/presentationml/2006/main" xmlns:r="http://schemas.openxmlformats.org/officeDocument/2006/relationships">
+  <p:cSld>
+    <p:spTree>
+      <p:nvGrpSpPr>
+        <p:cNvPr id="1" name=""/>
+        <p:cNvGrpSpPr/>
+        <p:nvPr/>
+      </p:nvGrpSpPr>
+      <p:grpSpPr>
+        <a:xfrm>
+          <a:off x="0" y="0"/>
+          <a:ext cx="0" cy="0"/>
+          <a:chOff x="0" y="0"/>
+          <a:chExt cx="0" cy="0"/>
+        </a:xfrm>
+      </p:grpSpPr>
+      <p:sp>
+        <p:nvSpPr>
+          <p:cNvPr id="2" name="Slide Image Placeholder 1"/>
+          <p:cNvSpPr>
+            <a:spLocks noGrp="1"/>
+          </p:cNvSpPr>
+          <p:nvPr>
+            <p:ph type="sldImg" idx="2"/>
+          </p:nvPr>
+        </p:nvSpPr>
+        <p:spPr/>
+      </p:sp>
+      <p:sp>
+        <p:nvSpPr>
+          <p:cNvPr id="3" name="Notes Placeholder 2"/>
+          <p:cNvSpPr>
+            <a:spLocks noGrp="1"/>
+          </p:cNvSpPr>
+          <p:nvPr>
+            <p:ph type="body" idx="1"/>
+          </p:nvPr>
+        </p:nvSpPr>
+        <p:spPr/>
+        <p:txBody>
+          <a:bodyPr/>
+          <a:lstStyle/>
+          <a:p>
+            <a:r>
+              <a:t>Pairs, about 5 minutes. Scale and rotation speed are at the top of Game1.</a:t>
+            </a:r>
+          </a:p>
+          <a:p>
+            <a:r>
+              <a:t>Answer: without CenterOrigin the bat spins around its top-left corner, because the origin is where rotation and scale start from.</a:t>
+            </a:r>
+          </a:p>
+        </p:txBody>
+      </p:sp>
+    </p:spTree>
+  </p:cSld>
+  <p:clrMapOvr>
+    <a:masterClrMapping/>
+  </p:clrMapOvr>
+</p:notes>
+</file>
+
+<file path=ppt/notesSlides/notesSlide41.xml><?xml version="1.0" encoding="utf-8"?>
+<p:notes xmlns:a="http://schemas.openxmlformats.org/drawingml/2006/main" xmlns:p="http://schemas.openxmlformats.org/presentationml/2006/main" xmlns:r="http://schemas.openxmlformats.org/officeDocument/2006/relationships">
+  <p:cSld>
+    <p:spTree>
+      <p:nvGrpSpPr>
+        <p:cNvPr id="1" name=""/>
+        <p:cNvGrpSpPr/>
+        <p:nvPr/>
+      </p:nvGrpSpPr>
+      <p:grpSpPr>
+        <a:xfrm>
+          <a:off x="0" y="0"/>
+          <a:ext cx="0" cy="0"/>
+          <a:chOff x="0" y="0"/>
+          <a:chExt cx="0" cy="0"/>
+        </a:xfrm>
+      </p:grpSpPr>
+      <p:sp>
+        <p:nvSpPr>
+          <p:cNvPr id="2" name="Slide Image Placeholder 1"/>
+          <p:cNvSpPr>
+            <a:spLocks noGrp="1"/>
+          </p:cNvSpPr>
+          <p:nvPr>
+            <p:ph type="sldImg" idx="2"/>
+          </p:nvPr>
+        </p:nvSpPr>
+        <p:spPr/>
+      </p:sp>
+      <p:sp>
+        <p:nvSpPr>
+          <p:cNvPr id="3" name="Notes Placeholder 2"/>
+          <p:cNvSpPr>
+            <a:spLocks noGrp="1"/>
+          </p:cNvSpPr>
+          <p:nvPr>
+            <p:ph type="body" idx="1"/>
+          </p:nvPr>
+        </p:nvSpPr>
+        <p:spPr/>
+        <p:txBody>
+          <a:bodyPr/>
+          <a:lstStyle/>
+          <a:p>
+            <a:r>
+              <a:t>Pairs, about 5 minutes, in Snake1. Moving the bat-1 rectangle is enough; no C#.</a:t>
+            </a:r>
+          </a:p>
+          <a:p>
+            <a:r>
+              <a:t>Ask about the misspelling. Answer: the game stops at start-up (the atlas looks names up in a dictionary). A mistake in data shows up when the game runs, not when it compiles.</a:t>
             </a:r>
           </a:p>
         </p:txBody>
@@ -7774,6 +8089,128 @@
 </file>
 
 <file path=ppt/slides/slide12.xml><?xml version="1.0" encoding="utf-8"?>
+<p:sld xmlns:a="http://schemas.openxmlformats.org/drawingml/2006/main" xmlns:p="http://schemas.openxmlformats.org/presentationml/2006/main" xmlns:r="http://schemas.openxmlformats.org/officeDocument/2006/relationships">
+  <p:cSld>
+    <p:spTree>
+      <p:nvGrpSpPr>
+        <p:cNvPr id="1" name=""/>
+        <p:cNvGrpSpPr/>
+        <p:nvPr/>
+      </p:nvGrpSpPr>
+      <p:grpSpPr/>
+      <p:sp>
+        <p:nvSpPr>
+          <p:cNvPr id="2" name="Title 1"/>
+          <p:cNvSpPr>
+            <a:spLocks noGrp="1"/>
+          </p:cNvSpPr>
+          <p:nvPr>
+            <p:ph type="title"/>
+          </p:nvPr>
+        </p:nvSpPr>
+        <p:spPr/>
+        <p:txBody>
+          <a:bodyPr/>
+          <a:lstStyle/>
+          <a:p>
+            <a:pPr indent="0" lvl="0" marL="0" rtl="0" algn="l">
+              <a:spcBef>
+                <a:spcPts val="0"/>
+              </a:spcBef>
+              <a:spcAft>
+                <a:spcPts val="0"/>
+              </a:spcAft>
+              <a:buNone/>
+            </a:pPr>
+            <a:r>
+              <a:rPr lang="en"/>
+              <a:t>Try It: Regions by Name</a:t>
+            </a:r>
+            <a:endParaRPr/>
+          </a:p>
+        </p:txBody>
+      </p:sp>
+      <p:sp>
+        <p:nvSpPr>
+          <p:cNvPr id="3" name="Text Placeholder 2"/>
+          <p:cNvSpPr>
+            <a:spLocks noGrp="1"/>
+          </p:cNvSpPr>
+          <p:nvPr>
+            <p:ph type="body" idx="1"/>
+          </p:nvPr>
+        </p:nvSpPr>
+        <p:spPr>
+          <a:xfrm>
+            <a:off x="311700" y="885950"/>
+            <a:ext cx="8520600" cy="1289304"/>
+          </a:xfrm>
+        </p:spPr>
+        <p:txBody>
+          <a:bodyPr/>
+          <a:lstStyle/>
+          <a:p>
+            <a:pPr indent="-330200" lvl="0" marL="457200" rtl="0" algn="l">
+              <a:spcBef>
+                <a:spcPts val="0"/>
+              </a:spcBef>
+              <a:spcAft>
+                <a:spcPts val="0"/>
+              </a:spcAft>
+              <a:buSzPts val="1600"/>
+              <a:buChar char="●"/>
+            </a:pPr>
+            <a:r>
+              <a:rPr lang="en"/>
+              <a:t>In Snake1, only atlas-definition.xml changes:</a:t>
+            </a:r>
+            <a:endParaRPr/>
+          </a:p>
+          <a:p>
+            <a:pPr indent="-330200" lvl="0" marL="457200" rtl="0" algn="l">
+              <a:spcBef>
+                <a:spcPts val="0"/>
+              </a:spcBef>
+              <a:spcAft>
+                <a:spcPts val="0"/>
+              </a:spcAft>
+              <a:buSzPts val="1600"/>
+              <a:buChar char="●"/>
+            </a:pPr>
+            <a:r>
+              <a:rPr lang="en"/>
+              <a:t>Draw the bat with its second frame (x 20, y 20)</a:t>
+            </a:r>
+            <a:endParaRPr/>
+          </a:p>
+          <a:p>
+            <a:pPr indent="-330200" lvl="0" marL="457200" rtl="0" algn="l">
+              <a:spcBef>
+                <a:spcPts val="0"/>
+              </a:spcBef>
+              <a:spcAft>
+                <a:spcPts val="0"/>
+              </a:spcAft>
+              <a:buSzPts val="1600"/>
+              <a:buChar char="●"/>
+            </a:pPr>
+            <a:r>
+              <a:rPr lang="en"/>
+              <a:t>Then misspell bat-1 in the XML. What happens, and when?</a:t>
+            </a:r>
+            <a:endParaRPr/>
+          </a:p>
+        </p:txBody>
+      </p:sp>
+    </p:spTree>
+  </p:cSld>
+  <p:clrMapOvr>
+    <a:masterClrMapping/>
+  </p:clrMapOvr>
+</p:sld>
+</file>
+
+<file path=ppt/slides/slide13.xml><?xml version="1.0" encoding="utf-8"?>
 <p:sld xmlns:a="http://schemas.openxmlformats.org/drawingml/2006/main" xmlns:r="http://schemas.openxmlformats.org/officeDocument/2006/relationships" xmlns:mc="http://schemas.openxmlformats.org/markup-compatibility/2006" xmlns:mv="urn:schemas-microsoft-com:mac:vml" xmlns:p="http://schemas.openxmlformats.org/presentationml/2006/main" xmlns:c="http://schemas.openxmlformats.org/drawingml/2006/chart" xmlns:dgm="http://schemas.openxmlformats.org/drawingml/2006/diagram" xmlns:o="urn:schemas-microsoft-com:office:office" xmlns:v="urn:schemas-microsoft-com:vml" xmlns:pvml="urn:schemas-microsoft-com:office:powerpoint" xmlns:com="http://schemas.openxmlformats.org/drawingml/2006/compatibility" xmlns:p14="http://schemas.microsoft.com/office/powerpoint/2010/main" xmlns:p15="http://schemas.microsoft.com/office/powerpoint/2012/main" xmlns:ahyp="http://schemas.microsoft.com/office/drawing/2018/hyperlinkcolor">
   <p:cSld>
     <p:spTree>
@@ -8509,7 +8946,7 @@
 </p:sld>
 </file>
 
-<file path=ppt/slides/slide13.xml><?xml version="1.0" encoding="utf-8"?>
+<file path=ppt/slides/slide14.xml><?xml version="1.0" encoding="utf-8"?>
 <p:sld xmlns:a="http://schemas.openxmlformats.org/drawingml/2006/main" xmlns:r="http://schemas.openxmlformats.org/officeDocument/2006/relationships" xmlns:mc="http://schemas.openxmlformats.org/markup-compatibility/2006" xmlns:mv="urn:schemas-microsoft-com:mac:vml" xmlns:p="http://schemas.openxmlformats.org/presentationml/2006/main" xmlns:c="http://schemas.openxmlformats.org/drawingml/2006/chart" xmlns:dgm="http://schemas.openxmlformats.org/drawingml/2006/diagram" xmlns:o="urn:schemas-microsoft-com:office:office" xmlns:v="urn:schemas-microsoft-com:vml" xmlns:pvml="urn:schemas-microsoft-com:office:powerpoint" xmlns:com="http://schemas.openxmlformats.org/drawingml/2006/compatibility" xmlns:p14="http://schemas.microsoft.com/office/powerpoint/2010/main" xmlns:p15="http://schemas.microsoft.com/office/powerpoint/2012/main" xmlns:ahyp="http://schemas.microsoft.com/office/drawing/2018/hyperlinkcolor">
   <p:cSld>
     <p:spTree>
@@ -8643,7 +9080,129 @@
 </p:sld>
 </file>
 
-<file path=ppt/slides/slide14.xml><?xml version="1.0" encoding="utf-8"?>
+<file path=ppt/slides/slide15.xml><?xml version="1.0" encoding="utf-8"?>
+<p:sld xmlns:a="http://schemas.openxmlformats.org/drawingml/2006/main" xmlns:p="http://schemas.openxmlformats.org/presentationml/2006/main" xmlns:r="http://schemas.openxmlformats.org/officeDocument/2006/relationships">
+  <p:cSld>
+    <p:spTree>
+      <p:nvGrpSpPr>
+        <p:cNvPr id="1" name=""/>
+        <p:cNvGrpSpPr/>
+        <p:nvPr/>
+      </p:nvGrpSpPr>
+      <p:grpSpPr/>
+      <p:sp>
+        <p:nvSpPr>
+          <p:cNvPr id="2" name="Title 1"/>
+          <p:cNvSpPr>
+            <a:spLocks noGrp="1"/>
+          </p:cNvSpPr>
+          <p:nvPr>
+            <p:ph type="title"/>
+          </p:nvPr>
+        </p:nvSpPr>
+        <p:spPr/>
+        <p:txBody>
+          <a:bodyPr/>
+          <a:lstStyle/>
+          <a:p>
+            <a:pPr indent="0" lvl="0" marL="0" rtl="0" algn="l">
+              <a:spcBef>
+                <a:spcPts val="0"/>
+              </a:spcBef>
+              <a:spcAft>
+                <a:spcPts val="0"/>
+              </a:spcAft>
+              <a:buNone/>
+            </a:pPr>
+            <a:r>
+              <a:rPr lang="en"/>
+              <a:t>Try It: A Sprite</a:t>
+            </a:r>
+            <a:endParaRPr/>
+          </a:p>
+        </p:txBody>
+      </p:sp>
+      <p:sp>
+        <p:nvSpPr>
+          <p:cNvPr id="3" name="Text Placeholder 2"/>
+          <p:cNvSpPr>
+            <a:spLocks noGrp="1"/>
+          </p:cNvSpPr>
+          <p:nvPr>
+            <p:ph type="body" idx="1"/>
+          </p:nvPr>
+        </p:nvSpPr>
+        <p:spPr>
+          <a:xfrm>
+            <a:off x="311700" y="885950"/>
+            <a:ext cx="8520600" cy="1289304"/>
+          </a:xfrm>
+        </p:spPr>
+        <p:txBody>
+          <a:bodyPr/>
+          <a:lstStyle/>
+          <a:p>
+            <a:pPr indent="-330200" lvl="0" marL="457200" rtl="0" algn="l">
+              <a:spcBef>
+                <a:spcPts val="0"/>
+              </a:spcBef>
+              <a:spcAft>
+                <a:spcPts val="0"/>
+              </a:spcAft>
+              <a:buSzPts val="1600"/>
+              <a:buChar char="●"/>
+            </a:pPr>
+            <a:r>
+              <a:rPr lang="en"/>
+              <a:t>In Snake2:</a:t>
+            </a:r>
+            <a:endParaRPr/>
+          </a:p>
+          <a:p>
+            <a:pPr indent="-330200" lvl="0" marL="457200" rtl="0" algn="l">
+              <a:spcBef>
+                <a:spcPts val="0"/>
+              </a:spcBef>
+              <a:spcAft>
+                <a:spcPts val="0"/>
+              </a:spcAft>
+              <a:buSzPts val="1600"/>
+              <a:buChar char="●"/>
+            </a:pPr>
+            <a:r>
+              <a:rPr lang="en"/>
+              <a:t>Make the bat bigger, and spin it the other way</a:t>
+            </a:r>
+            <a:endParaRPr/>
+          </a:p>
+          <a:p>
+            <a:pPr indent="-330200" lvl="0" marL="457200" rtl="0" algn="l">
+              <a:spcBef>
+                <a:spcPts val="0"/>
+              </a:spcBef>
+              <a:spcAft>
+                <a:spcPts val="0"/>
+              </a:spcAft>
+              <a:buSzPts val="1600"/>
+              <a:buChar char="●"/>
+            </a:pPr>
+            <a:r>
+              <a:rPr lang="en"/>
+              <a:t>Then remove CenterOrigin(). What changes, and why?</a:t>
+            </a:r>
+            <a:endParaRPr/>
+          </a:p>
+        </p:txBody>
+      </p:sp>
+    </p:spTree>
+  </p:cSld>
+  <p:clrMapOvr>
+    <a:masterClrMapping/>
+  </p:clrMapOvr>
+</p:sld>
+</file>
+
+<file path=ppt/slides/slide16.xml><?xml version="1.0" encoding="utf-8"?>
 <p:sld xmlns:a="http://schemas.openxmlformats.org/drawingml/2006/main" xmlns:r="http://schemas.openxmlformats.org/officeDocument/2006/relationships" xmlns:mc="http://schemas.openxmlformats.org/markup-compatibility/2006" xmlns:mv="urn:schemas-microsoft-com:mac:vml" xmlns:p="http://schemas.openxmlformats.org/presentationml/2006/main" xmlns:c="http://schemas.openxmlformats.org/drawingml/2006/chart" xmlns:dgm="http://schemas.openxmlformats.org/drawingml/2006/diagram" xmlns:o="urn:schemas-microsoft-com:office:office" xmlns:v="urn:schemas-microsoft-com:vml" xmlns:pvml="urn:schemas-microsoft-com:office:powerpoint" xmlns:com="http://schemas.openxmlformats.org/drawingml/2006/compatibility" xmlns:p14="http://schemas.microsoft.com/office/powerpoint/2010/main" xmlns:p15="http://schemas.microsoft.com/office/powerpoint/2012/main" xmlns:ahyp="http://schemas.microsoft.com/office/drawing/2018/hyperlinkcolor">
   <p:cSld>
     <p:spTree>
@@ -8736,7 +9295,7 @@
 </p:sld>
 </file>
 
-<file path=ppt/slides/slide15.xml><?xml version="1.0" encoding="utf-8"?>
+<file path=ppt/slides/slide17.xml><?xml version="1.0" encoding="utf-8"?>
 <p:sld xmlns:a="http://schemas.openxmlformats.org/drawingml/2006/main" xmlns:r="http://schemas.openxmlformats.org/officeDocument/2006/relationships" xmlns:mc="http://schemas.openxmlformats.org/markup-compatibility/2006" xmlns:mv="urn:schemas-microsoft-com:mac:vml" xmlns:p="http://schemas.openxmlformats.org/presentationml/2006/main" xmlns:c="http://schemas.openxmlformats.org/drawingml/2006/chart" xmlns:dgm="http://schemas.openxmlformats.org/drawingml/2006/diagram" xmlns:o="urn:schemas-microsoft-com:office:office" xmlns:v="urn:schemas-microsoft-com:vml" xmlns:pvml="urn:schemas-microsoft-com:office:powerpoint" xmlns:com="http://schemas.openxmlformats.org/drawingml/2006/compatibility" xmlns:p14="http://schemas.microsoft.com/office/powerpoint/2010/main" xmlns:p15="http://schemas.microsoft.com/office/powerpoint/2012/main" xmlns:ahyp="http://schemas.microsoft.com/office/drawing/2018/hyperlinkcolor">
   <p:cSld>
     <p:spTree>
@@ -8900,7 +9459,7 @@
 </p:sld>
 </file>
 
-<file path=ppt/slides/slide16.xml><?xml version="1.0" encoding="utf-8"?>
+<file path=ppt/slides/slide18.xml><?xml version="1.0" encoding="utf-8"?>
 <p:sld xmlns:a="http://schemas.openxmlformats.org/drawingml/2006/main" xmlns:r="http://schemas.openxmlformats.org/officeDocument/2006/relationships" xmlns:mc="http://schemas.openxmlformats.org/markup-compatibility/2006" xmlns:mv="urn:schemas-microsoft-com:mac:vml" xmlns:p="http://schemas.openxmlformats.org/presentationml/2006/main" xmlns:c="http://schemas.openxmlformats.org/drawingml/2006/chart" xmlns:dgm="http://schemas.openxmlformats.org/drawingml/2006/diagram" xmlns:o="urn:schemas-microsoft-com:office:office" xmlns:v="urn:schemas-microsoft-com:vml" xmlns:pvml="urn:schemas-microsoft-com:office:powerpoint" xmlns:com="http://schemas.openxmlformats.org/drawingml/2006/compatibility" xmlns:p14="http://schemas.microsoft.com/office/powerpoint/2010/main" xmlns:p15="http://schemas.microsoft.com/office/powerpoint/2012/main" xmlns:ahyp="http://schemas.microsoft.com/office/drawing/2018/hyperlinkcolor">
   <p:cSld>
     <p:spTree>
@@ -9034,7 +9593,242 @@
 </p:sld>
 </file>
 
-<file path=ppt/slides/slide17.xml><?xml version="1.0" encoding="utf-8"?>
+<file path=ppt/slides/slide19.xml><?xml version="1.0" encoding="utf-8"?>
+<p:sld xmlns:a="http://schemas.openxmlformats.org/drawingml/2006/main" xmlns:p="http://schemas.openxmlformats.org/presentationml/2006/main" xmlns:r="http://schemas.openxmlformats.org/officeDocument/2006/relationships">
+  <p:cSld>
+    <p:spTree>
+      <p:nvGrpSpPr>
+        <p:cNvPr id="1" name=""/>
+        <p:cNvGrpSpPr/>
+        <p:nvPr/>
+      </p:nvGrpSpPr>
+      <p:grpSpPr/>
+      <p:sp>
+        <p:nvSpPr>
+          <p:cNvPr id="2" name="Title 1"/>
+          <p:cNvSpPr>
+            <a:spLocks noGrp="1"/>
+          </p:cNvSpPr>
+          <p:nvPr>
+            <p:ph type="title"/>
+          </p:nvPr>
+        </p:nvSpPr>
+        <p:spPr/>
+        <p:txBody>
+          <a:bodyPr/>
+          <a:lstStyle/>
+          <a:p>
+            <a:pPr indent="0" lvl="0" marL="0" rtl="0" algn="l">
+              <a:spcBef>
+                <a:spcPts val="0"/>
+              </a:spcBef>
+              <a:spcAft>
+                <a:spcPts val="0"/>
+              </a:spcAft>
+              <a:buNone/>
+            </a:pPr>
+            <a:r>
+              <a:rPr lang="en"/>
+              <a:t>Try It: Animation Speed</a:t>
+            </a:r>
+            <a:endParaRPr/>
+          </a:p>
+        </p:txBody>
+      </p:sp>
+      <p:sp>
+        <p:nvSpPr>
+          <p:cNvPr id="3" name="Text Placeholder 2"/>
+          <p:cNvSpPr>
+            <a:spLocks noGrp="1"/>
+          </p:cNvSpPr>
+          <p:nvPr>
+            <p:ph type="body" idx="1"/>
+          </p:nvPr>
+        </p:nvSpPr>
+        <p:spPr>
+          <a:xfrm>
+            <a:off x="311700" y="885950"/>
+            <a:ext cx="8520600" cy="1289304"/>
+          </a:xfrm>
+        </p:spPr>
+        <p:txBody>
+          <a:bodyPr/>
+          <a:lstStyle/>
+          <a:p>
+            <a:pPr indent="-330200" lvl="0" marL="457200" rtl="0" algn="l">
+              <a:spcBef>
+                <a:spcPts val="0"/>
+              </a:spcBef>
+              <a:spcAft>
+                <a:spcPts val="0"/>
+              </a:spcAft>
+              <a:buSzPts val="1600"/>
+              <a:buChar char="●"/>
+            </a:pPr>
+            <a:r>
+              <a:rPr lang="en"/>
+              <a:t>In the XML only:</a:t>
+            </a:r>
+            <a:endParaRPr/>
+          </a:p>
+          <a:p>
+            <a:pPr indent="-330200" lvl="0" marL="457200" rtl="0" algn="l">
+              <a:spcBef>
+                <a:spcPts val="0"/>
+              </a:spcBef>
+              <a:spcAft>
+                <a:spcPts val="0"/>
+              </a:spcAft>
+              <a:buSzPts val="1600"/>
+              <a:buChar char="●"/>
+            </a:pPr>
+            <a:r>
+              <a:rPr lang="en"/>
+              <a:t>Make the bat flap twice as fast, and the snake breathe slower</a:t>
+            </a:r>
+            <a:endParaRPr/>
+          </a:p>
+          <a:p>
+            <a:pPr indent="-330200" lvl="0" marL="457200" rtl="0" algn="l">
+              <a:spcBef>
+                <a:spcPts val="0"/>
+              </a:spcBef>
+              <a:spcAft>
+                <a:spcPts val="0"/>
+              </a:spcAft>
+              <a:buSzPts val="1600"/>
+              <a:buChar char="●"/>
+            </a:pPr>
+            <a:r>
+              <a:rPr lang="en"/>
+              <a:t>Give the bat’s animation one more frame</a:t>
+            </a:r>
+            <a:endParaRPr/>
+          </a:p>
+        </p:txBody>
+      </p:sp>
+    </p:spTree>
+  </p:cSld>
+  <p:clrMapOvr>
+    <a:masterClrMapping/>
+  </p:clrMapOvr>
+</p:sld>
+</file>
+
+<file path=ppt/slides/slide2.xml><?xml version="1.0" encoding="utf-8"?>
+<p:sld xmlns:a="http://schemas.openxmlformats.org/drawingml/2006/main" xmlns:p="http://schemas.openxmlformats.org/presentationml/2006/main" xmlns:r="http://schemas.openxmlformats.org/officeDocument/2006/relationships">
+  <p:cSld>
+    <p:spTree>
+      <p:nvGrpSpPr>
+        <p:cNvPr id="1" name=""/>
+        <p:cNvGrpSpPr/>
+        <p:nvPr/>
+      </p:nvGrpSpPr>
+      <p:grpSpPr/>
+      <p:sp>
+        <p:nvSpPr>
+          <p:cNvPr id="2" name="Title 1"/>
+          <p:cNvSpPr>
+            <a:spLocks noGrp="1"/>
+          </p:cNvSpPr>
+          <p:nvPr>
+            <p:ph type="title"/>
+          </p:nvPr>
+        </p:nvSpPr>
+        <p:spPr>
+          <a:xfrm>
+            <a:off x="311700" y="195615"/>
+            <a:ext cx="8520600" cy="572700"/>
+          </a:xfrm>
+        </p:spPr>
+        <p:txBody>
+          <a:bodyPr/>
+          <a:lstStyle/>
+          <a:p>
+            <a:pPr indent="0" lvl="0" marL="0" rtl="0" algn="l">
+              <a:spcBef>
+                <a:spcPts val="0"/>
+              </a:spcBef>
+              <a:spcAft>
+                <a:spcPts val="0"/>
+              </a:spcAft>
+              <a:buNone/>
+            </a:pPr>
+            <a:r>
+              <a:rPr lang="en"/>
+              <a:t>Snake</a:t>
+            </a:r>
+            <a:endParaRPr/>
+          </a:p>
+        </p:txBody>
+      </p:sp>
+      <p:pic>
+        <p:nvPicPr>
+          <p:cNvPr id="3" name="Picture 2" descr="snake.gif"/>
+          <p:cNvPicPr>
+            <a:picLocks noChangeAspect="1"/>
+          </p:cNvPicPr>
+          <p:nvPr/>
+        </p:nvPicPr>
+        <p:blipFill>
+          <a:blip r:embed="rId2"/>
+          <a:stretch>
+            <a:fillRect/>
+          </a:stretch>
+        </p:blipFill>
+        <p:spPr>
+          <a:xfrm>
+            <a:off x="2743200" y="960120"/>
+            <a:ext cx="3657600" cy="3657600"/>
+          </a:xfrm>
+          <a:prstGeom prst="rect">
+            <a:avLst/>
+          </a:prstGeom>
+        </p:spPr>
+      </p:pic>
+      <p:sp>
+        <p:nvSpPr>
+          <p:cNvPr id="4" name="TextBox 3"/>
+          <p:cNvSpPr txBox="1"/>
+          <p:nvPr/>
+        </p:nvSpPr>
+        <p:spPr>
+          <a:xfrm>
+            <a:off x="457200" y="4736592"/>
+            <a:ext cx="8229600" cy="274320"/>
+          </a:xfrm>
+          <a:prstGeom prst="rect">
+            <a:avLst/>
+          </a:prstGeom>
+          <a:noFill/>
+        </p:spPr>
+        <p:txBody>
+          <a:bodyPr wrap="square">
+            <a:spAutoFit/>
+          </a:bodyPr>
+          <a:lstStyle/>
+          <a:p>
+            <a:pPr algn="ctr"/>
+            <a:r>
+              <a:rPr sz="900" b="0" i="0">
+                <a:solidFill>
+                  <a:srgbClr val="9AA3AB"/>
+                </a:solidFill>
+              </a:rPr>
+              <a:t>Snake goes back to Blockade (Gremlin, 1976). Image: Ustone07, CC BY-SA 3.0, via Wikimedia Commons.</a:t>
+            </a:r>
+          </a:p>
+        </p:txBody>
+      </p:sp>
+    </p:spTree>
+  </p:cSld>
+  <p:clrMapOvr>
+    <a:masterClrMapping/>
+  </p:clrMapOvr>
+</p:sld>
+</file>
+
+<file path=ppt/slides/slide20.xml><?xml version="1.0" encoding="utf-8"?>
 <p:sld xmlns:a="http://schemas.openxmlformats.org/drawingml/2006/main" xmlns:r="http://schemas.openxmlformats.org/officeDocument/2006/relationships" xmlns:mc="http://schemas.openxmlformats.org/markup-compatibility/2006" xmlns:mv="urn:schemas-microsoft-com:mac:vml" xmlns:p="http://schemas.openxmlformats.org/presentationml/2006/main" xmlns:c="http://schemas.openxmlformats.org/drawingml/2006/chart" xmlns:dgm="http://schemas.openxmlformats.org/drawingml/2006/diagram" xmlns:o="urn:schemas-microsoft-com:office:office" xmlns:v="urn:schemas-microsoft-com:vml" xmlns:pvml="urn:schemas-microsoft-com:office:powerpoint" xmlns:com="http://schemas.openxmlformats.org/drawingml/2006/compatibility" xmlns:p14="http://schemas.microsoft.com/office/powerpoint/2010/main" xmlns:p15="http://schemas.microsoft.com/office/powerpoint/2012/main" xmlns:ahyp="http://schemas.microsoft.com/office/drawing/2018/hyperlinkcolor">
   <p:cSld>
     <p:spTree>
@@ -9267,7 +10061,7 @@
 </p:sld>
 </file>
 
-<file path=ppt/slides/slide18.xml><?xml version="1.0" encoding="utf-8"?>
+<file path=ppt/slides/slide21.xml><?xml version="1.0" encoding="utf-8"?>
 <p:sld xmlns:a="http://schemas.openxmlformats.org/drawingml/2006/main" xmlns:r="http://schemas.openxmlformats.org/officeDocument/2006/relationships" xmlns:mc="http://schemas.openxmlformats.org/markup-compatibility/2006" xmlns:mv="urn:schemas-microsoft-com:mac:vml" xmlns:p="http://schemas.openxmlformats.org/presentationml/2006/main" xmlns:c="http://schemas.openxmlformats.org/drawingml/2006/chart" xmlns:dgm="http://schemas.openxmlformats.org/drawingml/2006/diagram" xmlns:o="urn:schemas-microsoft-com:office:office" xmlns:v="urn:schemas-microsoft-com:vml" xmlns:pvml="urn:schemas-microsoft-com:office:powerpoint" xmlns:com="http://schemas.openxmlformats.org/drawingml/2006/compatibility" xmlns:p14="http://schemas.microsoft.com/office/powerpoint/2010/main" xmlns:p15="http://schemas.microsoft.com/office/powerpoint/2012/main" xmlns:ahyp="http://schemas.microsoft.com/office/drawing/2018/hyperlinkcolor">
   <p:cSld>
     <p:spTree>
@@ -10366,7 +11160,7 @@
 </p:sld>
 </file>
 
-<file path=ppt/slides/slide19.xml><?xml version="1.0" encoding="utf-8"?>
+<file path=ppt/slides/slide22.xml><?xml version="1.0" encoding="utf-8"?>
 <p:sld xmlns:a="http://schemas.openxmlformats.org/drawingml/2006/main" xmlns:r="http://schemas.openxmlformats.org/officeDocument/2006/relationships" xmlns:mc="http://schemas.openxmlformats.org/markup-compatibility/2006" xmlns:mv="urn:schemas-microsoft-com:mac:vml" xmlns:p="http://schemas.openxmlformats.org/presentationml/2006/main" xmlns:c="http://schemas.openxmlformats.org/drawingml/2006/chart" xmlns:dgm="http://schemas.openxmlformats.org/drawingml/2006/diagram" xmlns:o="urn:schemas-microsoft-com:office:office" xmlns:v="urn:schemas-microsoft-com:vml" xmlns:pvml="urn:schemas-microsoft-com:office:powerpoint" xmlns:com="http://schemas.openxmlformats.org/drawingml/2006/compatibility" xmlns:p14="http://schemas.microsoft.com/office/powerpoint/2010/main" xmlns:p15="http://schemas.microsoft.com/office/powerpoint/2012/main" xmlns:ahyp="http://schemas.microsoft.com/office/drawing/2018/hyperlinkcolor">
   <p:cSld>
     <p:spTree>
@@ -10500,7 +11294,7 @@
 </p:sld>
 </file>
 
-<file path=ppt/slides/slide2.xml><?xml version="1.0" encoding="utf-8"?>
+<file path=ppt/slides/slide23.xml><?xml version="1.0" encoding="utf-8"?>
 <p:sld xmlns:a="http://schemas.openxmlformats.org/drawingml/2006/main" xmlns:p="http://schemas.openxmlformats.org/presentationml/2006/main" xmlns:r="http://schemas.openxmlformats.org/officeDocument/2006/relationships">
   <p:cSld>
     <p:spTree>
@@ -10520,88 +11314,97 @@
             <p:ph type="title"/>
           </p:nvPr>
         </p:nvSpPr>
+        <p:spPr/>
+        <p:txBody>
+          <a:bodyPr/>
+          <a:lstStyle/>
+          <a:p>
+            <a:pPr indent="0" lvl="0" marL="0" rtl="0" algn="l">
+              <a:spcBef>
+                <a:spcPts val="0"/>
+              </a:spcBef>
+              <a:spcAft>
+                <a:spcPts val="0"/>
+              </a:spcAft>
+              <a:buNone/>
+            </a:pPr>
+            <a:r>
+              <a:rPr lang="en"/>
+              <a:t>Try It: A New Room</a:t>
+            </a:r>
+            <a:endParaRPr/>
+          </a:p>
+        </p:txBody>
+      </p:sp>
+      <p:sp>
+        <p:nvSpPr>
+          <p:cNvPr id="3" name="Text Placeholder 2"/>
+          <p:cNvSpPr>
+            <a:spLocks noGrp="1"/>
+          </p:cNvSpPr>
+          <p:nvPr>
+            <p:ph type="body" idx="1"/>
+          </p:nvPr>
+        </p:nvSpPr>
         <p:spPr>
           <a:xfrm>
-            <a:off x="311700" y="195615"/>
-            <a:ext cx="8520600" cy="572700"/>
+            <a:off x="311700" y="885950"/>
+            <a:ext cx="8520600" cy="1289304"/>
           </a:xfrm>
         </p:spPr>
         <p:txBody>
           <a:bodyPr/>
           <a:lstStyle/>
           <a:p>
-            <a:pPr indent="0" lvl="0" marL="0" rtl="0" algn="l">
-              <a:spcBef>
-                <a:spcPts val="0"/>
-              </a:spcBef>
-              <a:spcAft>
-                <a:spcPts val="0"/>
-              </a:spcAft>
-              <a:buNone/>
+            <a:pPr indent="-330200" lvl="0" marL="457200" rtl="0" algn="l">
+              <a:spcBef>
+                <a:spcPts val="0"/>
+              </a:spcBef>
+              <a:spcAft>
+                <a:spcPts val="0"/>
+              </a:spcAft>
+              <a:buSzPts val="1600"/>
+              <a:buChar char="●"/>
             </a:pPr>
             <a:r>
               <a:rPr lang="en"/>
-              <a:t>Snake</a:t>
+              <a:t>In tilemap-definition.xml:</a:t>
             </a:r>
             <a:endParaRPr/>
           </a:p>
-        </p:txBody>
-      </p:sp>
-      <p:pic>
-        <p:nvPicPr>
-          <p:cNvPr id="3" name="Picture 2" descr="snake.gif"/>
-          <p:cNvPicPr>
-            <a:picLocks noChangeAspect="1"/>
-          </p:cNvPicPr>
-          <p:nvPr/>
-        </p:nvPicPr>
-        <p:blipFill>
-          <a:blip r:embed="rId2"/>
-          <a:stretch>
-            <a:fillRect/>
-          </a:stretch>
-        </p:blipFill>
-        <p:spPr>
-          <a:xfrm>
-            <a:off x="2743200" y="960120"/>
-            <a:ext cx="3657600" cy="3657600"/>
-          </a:xfrm>
-          <a:prstGeom prst="rect">
-            <a:avLst/>
-          </a:prstGeom>
-        </p:spPr>
-      </p:pic>
-      <p:sp>
-        <p:nvSpPr>
-          <p:cNvPr id="4" name="TextBox 3"/>
-          <p:cNvSpPr txBox="1"/>
-          <p:nvPr/>
-        </p:nvSpPr>
-        <p:spPr>
-          <a:xfrm>
-            <a:off x="457200" y="4736592"/>
-            <a:ext cx="8229600" cy="274320"/>
-          </a:xfrm>
-          <a:prstGeom prst="rect">
-            <a:avLst/>
-          </a:prstGeom>
-          <a:noFill/>
-        </p:spPr>
-        <p:txBody>
-          <a:bodyPr wrap="square">
-            <a:spAutoFit/>
-          </a:bodyPr>
-          <a:lstStyle/>
-          <a:p>
-            <a:pPr algn="ctr"/>
-            <a:r>
-              <a:rPr sz="900" b="0" i="0">
-                <a:solidFill>
-                  <a:srgbClr val="9AA3AB"/>
-                </a:solidFill>
-              </a:rPr>
-              <a:t>Snake goes back to Blockade (Gremlin, 1976). Image: Ustone07, CC BY-SA 3.0, via Wikimedia Commons.</a:t>
-            </a:r>
+          <a:p>
+            <a:pPr indent="-330200" lvl="0" marL="457200" rtl="0" algn="l">
+              <a:spcBef>
+                <a:spcPts val="0"/>
+              </a:spcBef>
+              <a:spcAft>
+                <a:spcPts val="0"/>
+              </a:spcAft>
+              <a:buSzPts val="1600"/>
+              <a:buChar char="●"/>
+            </a:pPr>
+            <a:r>
+              <a:rPr lang="en"/>
+              <a:t>Rearrange the room: move the torches, add cracks</a:t>
+            </a:r>
+            <a:endParaRPr/>
+          </a:p>
+          <a:p>
+            <a:pPr indent="-330200" lvl="0" marL="457200" rtl="0" algn="l">
+              <a:spcBef>
+                <a:spcPts val="0"/>
+              </a:spcBef>
+              <a:spcAft>
+                <a:spcPts val="0"/>
+              </a:spcAft>
+              <a:buSzPts val="1600"/>
+              <a:buChar char="●"/>
+            </a:pPr>
+            <a:r>
+              <a:rPr lang="en"/>
+              <a:t>Then put a 20 in it. What happens, and when?</a:t>
+            </a:r>
+            <a:endParaRPr/>
           </a:p>
         </p:txBody>
       </p:sp>
@@ -10613,7 +11416,7 @@
 </p:sld>
 </file>
 
-<file path=ppt/slides/slide20.xml><?xml version="1.0" encoding="utf-8"?>
+<file path=ppt/slides/slide24.xml><?xml version="1.0" encoding="utf-8"?>
 <p:sld xmlns:a="http://schemas.openxmlformats.org/drawingml/2006/main" xmlns:p="http://schemas.openxmlformats.org/presentationml/2006/main" xmlns:r="http://schemas.openxmlformats.org/officeDocument/2006/relationships">
   <p:cSld>
     <p:spTree>
@@ -11295,7 +12098,7 @@
 </p:sld>
 </file>
 
-<file path=ppt/slides/slide21.xml><?xml version="1.0" encoding="utf-8"?>
+<file path=ppt/slides/slide25.xml><?xml version="1.0" encoding="utf-8"?>
 <p:sld xmlns:a="http://schemas.openxmlformats.org/drawingml/2006/main" xmlns:p="http://schemas.openxmlformats.org/presentationml/2006/main" xmlns:r="http://schemas.openxmlformats.org/officeDocument/2006/relationships">
   <p:cSld>
     <p:spTree>
@@ -11963,7 +12766,7 @@
 </p:sld>
 </file>
 
-<file path=ppt/slides/slide22.xml><?xml version="1.0" encoding="utf-8"?>
+<file path=ppt/slides/slide26.xml><?xml version="1.0" encoding="utf-8"?>
 <p:sld xmlns:a="http://schemas.openxmlformats.org/drawingml/2006/main" xmlns:p="http://schemas.openxmlformats.org/presentationml/2006/main" xmlns:r="http://schemas.openxmlformats.org/officeDocument/2006/relationships">
   <p:cSld>
     <p:spTree>
@@ -12582,7 +13385,7 @@
 </p:sld>
 </file>
 
-<file path=ppt/slides/slide23.xml><?xml version="1.0" encoding="utf-8"?>
+<file path=ppt/slides/slide27.xml><?xml version="1.0" encoding="utf-8"?>
 <p:sld xmlns:a="http://schemas.openxmlformats.org/drawingml/2006/main" xmlns:p="http://schemas.openxmlformats.org/presentationml/2006/main" xmlns:r="http://schemas.openxmlformats.org/officeDocument/2006/relationships">
   <p:cSld>
     <p:spTree>
@@ -12709,7 +13512,146 @@
 </p:sld>
 </file>
 
-<file path=ppt/slides/slide24.xml><?xml version="1.0" encoding="utf-8"?>
+<file path=ppt/slides/slide28.xml><?xml version="1.0" encoding="utf-8"?>
+<p:sld xmlns:a="http://schemas.openxmlformats.org/drawingml/2006/main" xmlns:p="http://schemas.openxmlformats.org/presentationml/2006/main" xmlns:r="http://schemas.openxmlformats.org/officeDocument/2006/relationships">
+  <p:cSld>
+    <p:spTree>
+      <p:nvGrpSpPr>
+        <p:cNvPr id="1" name=""/>
+        <p:cNvGrpSpPr/>
+        <p:nvPr/>
+      </p:nvGrpSpPr>
+      <p:grpSpPr/>
+      <p:sp>
+        <p:nvSpPr>
+          <p:cNvPr id="2" name="Title 1"/>
+          <p:cNvSpPr>
+            <a:spLocks noGrp="1"/>
+          </p:cNvSpPr>
+          <p:nvPr>
+            <p:ph type="title"/>
+          </p:nvPr>
+        </p:nvSpPr>
+        <p:spPr/>
+        <p:txBody>
+          <a:bodyPr/>
+          <a:lstStyle/>
+          <a:p>
+            <a:pPr indent="0" lvl="0" marL="0" rtl="0" algn="l">
+              <a:spcBef>
+                <a:spcPts val="0"/>
+              </a:spcBef>
+              <a:spcAft>
+                <a:spcPts val="0"/>
+              </a:spcAft>
+              <a:buNone/>
+            </a:pPr>
+            <a:r>
+              <a:rPr lang="en"/>
+              <a:t>Try It: Ticks and Keys</a:t>
+            </a:r>
+            <a:endParaRPr/>
+          </a:p>
+        </p:txBody>
+      </p:sp>
+      <p:sp>
+        <p:nvSpPr>
+          <p:cNvPr id="3" name="Text Placeholder 2"/>
+          <p:cNvSpPr>
+            <a:spLocks noGrp="1"/>
+          </p:cNvSpPr>
+          <p:nvPr>
+            <p:ph type="body" idx="1"/>
+          </p:nvPr>
+        </p:nvSpPr>
+        <p:spPr>
+          <a:xfrm>
+            <a:off x="311700" y="885950"/>
+            <a:ext cx="8520600" cy="1673352"/>
+          </a:xfrm>
+        </p:spPr>
+        <p:txBody>
+          <a:bodyPr/>
+          <a:lstStyle/>
+          <a:p>
+            <a:pPr indent="-330200" lvl="0" marL="457200" rtl="0" algn="l">
+              <a:spcBef>
+                <a:spcPts val="0"/>
+              </a:spcBef>
+              <a:spcAft>
+                <a:spcPts val="0"/>
+              </a:spcAft>
+              <a:buSzPts val="1600"/>
+              <a:buChar char="●"/>
+            </a:pPr>
+            <a:r>
+              <a:rPr lang="en"/>
+              <a:t>In Snake7:</a:t>
+            </a:r>
+            <a:endParaRPr/>
+          </a:p>
+          <a:p>
+            <a:pPr indent="-330200" lvl="0" marL="457200" rtl="0" algn="l">
+              <a:spcBef>
+                <a:spcPts val="0"/>
+              </a:spcBef>
+              <a:spcAft>
+                <a:spcPts val="0"/>
+              </a:spcAft>
+              <a:buSzPts val="1600"/>
+              <a:buChar char="●"/>
+            </a:pPr>
+            <a:r>
+              <a:rPr lang="en"/>
+              <a:t>Make the snake twice as fast</a:t>
+            </a:r>
+            <a:endParaRPr/>
+          </a:p>
+          <a:p>
+            <a:pPr indent="-330200" lvl="0" marL="457200" rtl="0" algn="l">
+              <a:spcBef>
+                <a:spcPts val="0"/>
+              </a:spcBef>
+              <a:spcAft>
+                <a:spcPts val="0"/>
+              </a:spcAft>
+              <a:buSzPts val="1600"/>
+              <a:buChar char="●"/>
+            </a:pPr>
+            <a:r>
+              <a:rPr lang="en"/>
+              <a:t>Add I, J, K and L as a third set of keys</a:t>
+            </a:r>
+            <a:endParaRPr/>
+          </a:p>
+          <a:p>
+            <a:pPr indent="-330200" lvl="0" marL="457200" rtl="0" algn="l">
+              <a:spcBef>
+                <a:spcPts val="0"/>
+              </a:spcBef>
+              <a:spcAft>
+                <a:spcPts val="0"/>
+              </a:spcAft>
+              <a:buSzPts val="1600"/>
+              <a:buChar char="●"/>
+            </a:pPr>
+            <a:r>
+              <a:rPr lang="en"/>
+              <a:t>Which file did each change need?</a:t>
+            </a:r>
+            <a:endParaRPr/>
+          </a:p>
+        </p:txBody>
+      </p:sp>
+    </p:spTree>
+  </p:cSld>
+  <p:clrMapOvr>
+    <a:masterClrMapping/>
+  </p:clrMapOvr>
+</p:sld>
+</file>
+
+<file path=ppt/slides/slide29.xml><?xml version="1.0" encoding="utf-8"?>
 <p:sld xmlns:a="http://schemas.openxmlformats.org/drawingml/2006/main" xmlns:r="http://schemas.openxmlformats.org/officeDocument/2006/relationships" xmlns:mc="http://schemas.openxmlformats.org/markup-compatibility/2006" xmlns:mv="urn:schemas-microsoft-com:mac:vml" xmlns:p="http://schemas.openxmlformats.org/presentationml/2006/main" xmlns:c="http://schemas.openxmlformats.org/drawingml/2006/chart" xmlns:dgm="http://schemas.openxmlformats.org/drawingml/2006/diagram" xmlns:o="urn:schemas-microsoft-com:office:office" xmlns:v="urn:schemas-microsoft-com:vml" xmlns:pvml="urn:schemas-microsoft-com:office:powerpoint" xmlns:com="http://schemas.openxmlformats.org/drawingml/2006/compatibility" xmlns:p14="http://schemas.microsoft.com/office/powerpoint/2010/main" xmlns:p15="http://schemas.microsoft.com/office/powerpoint/2012/main" xmlns:ahyp="http://schemas.microsoft.com/office/drawing/2018/hyperlinkcolor">
   <p:cSld>
     <p:spTree>
@@ -13165,7 +14107,96 @@
 </p:sld>
 </file>
 
-<file path=ppt/slides/slide25.xml><?xml version="1.0" encoding="utf-8"?>
+<file path=ppt/slides/slide3.xml><?xml version="1.0" encoding="utf-8"?>
+<p:sld xmlns:a="http://schemas.openxmlformats.org/drawingml/2006/main" xmlns:r="http://schemas.openxmlformats.org/officeDocument/2006/relationships" xmlns:mc="http://schemas.openxmlformats.org/markup-compatibility/2006" xmlns:mv="urn:schemas-microsoft-com:mac:vml" xmlns:p="http://schemas.openxmlformats.org/presentationml/2006/main" xmlns:c="http://schemas.openxmlformats.org/drawingml/2006/chart" xmlns:dgm="http://schemas.openxmlformats.org/drawingml/2006/diagram" xmlns:o="urn:schemas-microsoft-com:office:office" xmlns:v="urn:schemas-microsoft-com:vml" xmlns:pvml="urn:schemas-microsoft-com:office:powerpoint" xmlns:com="http://schemas.openxmlformats.org/drawingml/2006/compatibility" xmlns:p14="http://schemas.microsoft.com/office/powerpoint/2010/main" xmlns:p15="http://schemas.microsoft.com/office/powerpoint/2012/main" xmlns:ahyp="http://schemas.microsoft.com/office/drawing/2018/hyperlinkcolor">
+  <p:cSld>
+    <p:spTree>
+      <p:nvGrpSpPr>
+        <p:cNvPr id="44" name="Shape 44"/>
+        <p:cNvGrpSpPr/>
+        <p:nvPr/>
+      </p:nvGrpSpPr>
+      <p:grpSpPr>
+        <a:xfrm>
+          <a:off x="0" y="0"/>
+          <a:ext cx="0" cy="0"/>
+          <a:chOff x="0" y="0"/>
+          <a:chExt cx="0" cy="0"/>
+        </a:xfrm>
+      </p:grpSpPr>
+      <p:sp>
+        <p:nvSpPr>
+          <p:cNvPr id="45" name="Google Shape;45;p10"/>
+          <p:cNvSpPr txBox="1"/>
+          <p:nvPr>
+            <p:ph type="title"/>
+          </p:nvPr>
+        </p:nvSpPr>
+        <p:spPr>
+          <a:xfrm>
+            <a:off x="311700" y="195615"/>
+            <a:ext cx="8520600" cy="572700"/>
+          </a:xfrm>
+          <a:prstGeom prst="rect">
+            <a:avLst/>
+          </a:prstGeom>
+        </p:spPr>
+        <p:txBody>
+          <a:bodyPr anchorCtr="0" anchor="t" bIns="91425" lIns="91425" spcFirstLastPara="1" rIns="91425" wrap="square" tIns="91425">
+            <a:normAutofit fontScale="90000"/>
+          </a:bodyPr>
+          <a:lstStyle/>
+          <a:p>
+            <a:pPr indent="0" lvl="0" marL="0" rtl="0" algn="l">
+              <a:spcBef>
+                <a:spcPts val="0"/>
+              </a:spcBef>
+              <a:spcAft>
+                <a:spcPts val="0"/>
+              </a:spcAft>
+              <a:buNone/>
+            </a:pPr>
+            <a:r>
+              <a:rPr lang="en"/>
+              <a:t>Today’s Goal</a:t>
+            </a:r>
+            <a:endParaRPr/>
+          </a:p>
+        </p:txBody>
+      </p:sp>
+      <p:pic>
+        <p:nvPicPr>
+          <p:cNvPr id="46" name="Picture 46" descr="snake9.png"/>
+          <p:cNvPicPr>
+            <a:picLocks noChangeAspect="1"/>
+          </p:cNvPicPr>
+          <p:nvPr/>
+        </p:nvPicPr>
+        <p:blipFill>
+          <a:blip r:embed="rId4"/>
+          <a:stretch>
+            <a:fillRect/>
+          </a:stretch>
+        </p:blipFill>
+        <p:spPr>
+          <a:xfrm>
+            <a:off x="1846087" y="1626274"/>
+            <a:ext cx="5451825" cy="3066651"/>
+          </a:xfrm>
+          <a:prstGeom prst="rect">
+            <a:avLst/>
+          </a:prstGeom>
+        </p:spPr>
+      </p:pic>
+    </p:spTree>
+  </p:cSld>
+  <p:clrMapOvr>
+    <a:masterClrMapping/>
+  </p:clrMapOvr>
+</p:sld>
+</file>
+
+<file path=ppt/slides/slide30.xml><?xml version="1.0" encoding="utf-8"?>
 <p:sld xmlns:a="http://schemas.openxmlformats.org/drawingml/2006/main" xmlns:r="http://schemas.openxmlformats.org/officeDocument/2006/relationships" xmlns:mc="http://schemas.openxmlformats.org/markup-compatibility/2006" xmlns:mv="urn:schemas-microsoft-com:mac:vml" xmlns:p="http://schemas.openxmlformats.org/presentationml/2006/main" xmlns:c="http://schemas.openxmlformats.org/drawingml/2006/chart" xmlns:dgm="http://schemas.openxmlformats.org/drawingml/2006/diagram" xmlns:o="urn:schemas-microsoft-com:office:office" xmlns:v="urn:schemas-microsoft-com:vml" xmlns:pvml="urn:schemas-microsoft-com:office:powerpoint" xmlns:com="http://schemas.openxmlformats.org/drawingml/2006/compatibility" xmlns:p14="http://schemas.microsoft.com/office/powerpoint/2010/main" xmlns:p15="http://schemas.microsoft.com/office/powerpoint/2012/main" xmlns:ahyp="http://schemas.microsoft.com/office/drawing/2018/hyperlinkcolor">
   <p:cSld>
     <p:spTree>
@@ -15217,7 +16248,7 @@
 </p:sld>
 </file>
 
-<file path=ppt/slides/slide26.xml><?xml version="1.0" encoding="utf-8"?>
+<file path=ppt/slides/slide31.xml><?xml version="1.0" encoding="utf-8"?>
 <p:sld xmlns:a="http://schemas.openxmlformats.org/drawingml/2006/main" xmlns:r="http://schemas.openxmlformats.org/officeDocument/2006/relationships" xmlns:mc="http://schemas.openxmlformats.org/markup-compatibility/2006" xmlns:mv="urn:schemas-microsoft-com:mac:vml" xmlns:p="http://schemas.openxmlformats.org/presentationml/2006/main" xmlns:c="http://schemas.openxmlformats.org/drawingml/2006/chart" xmlns:dgm="http://schemas.openxmlformats.org/drawingml/2006/diagram" xmlns:o="urn:schemas-microsoft-com:office:office" xmlns:v="urn:schemas-microsoft-com:vml" xmlns:pvml="urn:schemas-microsoft-com:office:powerpoint" xmlns:com="http://schemas.openxmlformats.org/drawingml/2006/compatibility" xmlns:p14="http://schemas.microsoft.com/office/powerpoint/2010/main" xmlns:p15="http://schemas.microsoft.com/office/powerpoint/2012/main" xmlns:ahyp="http://schemas.microsoft.com/office/drawing/2018/hyperlinkcolor">
   <p:cSld>
     <p:spTree>
@@ -15392,7 +16423,7 @@
 </p:sld>
 </file>
 
-<file path=ppt/slides/slide27.xml><?xml version="1.0" encoding="utf-8"?>
+<file path=ppt/slides/slide32.xml><?xml version="1.0" encoding="utf-8"?>
 <p:sld xmlns:a="http://schemas.openxmlformats.org/drawingml/2006/main" xmlns:r="http://schemas.openxmlformats.org/officeDocument/2006/relationships" xmlns:mc="http://schemas.openxmlformats.org/markup-compatibility/2006" xmlns:mv="urn:schemas-microsoft-com:mac:vml" xmlns:p="http://schemas.openxmlformats.org/presentationml/2006/main" xmlns:c="http://schemas.openxmlformats.org/drawingml/2006/chart" xmlns:dgm="http://schemas.openxmlformats.org/drawingml/2006/diagram" xmlns:o="urn:schemas-microsoft-com:office:office" xmlns:v="urn:schemas-microsoft-com:vml" xmlns:pvml="urn:schemas-microsoft-com:office:powerpoint" xmlns:com="http://schemas.openxmlformats.org/drawingml/2006/compatibility" xmlns:p14="http://schemas.microsoft.com/office/powerpoint/2010/main" xmlns:p15="http://schemas.microsoft.com/office/powerpoint/2012/main" xmlns:ahyp="http://schemas.microsoft.com/office/drawing/2018/hyperlinkcolor">
   <p:cSld>
     <p:spTree>
@@ -15625,7 +16656,7 @@
 </p:sld>
 </file>
 
-<file path=ppt/slides/slide28.xml><?xml version="1.0" encoding="utf-8"?>
+<file path=ppt/slides/slide33.xml><?xml version="1.0" encoding="utf-8"?>
 <p:sld xmlns:a="http://schemas.openxmlformats.org/drawingml/2006/main" xmlns:r="http://schemas.openxmlformats.org/officeDocument/2006/relationships" xmlns:mc="http://schemas.openxmlformats.org/markup-compatibility/2006" xmlns:mv="urn:schemas-microsoft-com:mac:vml" xmlns:p="http://schemas.openxmlformats.org/presentationml/2006/main" xmlns:c="http://schemas.openxmlformats.org/drawingml/2006/chart" xmlns:dgm="http://schemas.openxmlformats.org/drawingml/2006/diagram" xmlns:o="urn:schemas-microsoft-com:office:office" xmlns:v="urn:schemas-microsoft-com:vml" xmlns:pvml="urn:schemas-microsoft-com:office:powerpoint" xmlns:com="http://schemas.openxmlformats.org/drawingml/2006/compatibility" xmlns:p14="http://schemas.microsoft.com/office/powerpoint/2010/main" xmlns:p15="http://schemas.microsoft.com/office/powerpoint/2012/main" xmlns:ahyp="http://schemas.microsoft.com/office/drawing/2018/hyperlinkcolor">
   <p:cSld>
     <p:spTree>
@@ -15874,7 +16905,7 @@
 </p:sld>
 </file>
 
-<file path=ppt/slides/slide29.xml><?xml version="1.0" encoding="utf-8"?>
+<file path=ppt/slides/slide34.xml><?xml version="1.0" encoding="utf-8"?>
 <p:sld xmlns:a="http://schemas.openxmlformats.org/drawingml/2006/main" xmlns:r="http://schemas.openxmlformats.org/officeDocument/2006/relationships" xmlns:mc="http://schemas.openxmlformats.org/markup-compatibility/2006" xmlns:mv="urn:schemas-microsoft-com:mac:vml" xmlns:p="http://schemas.openxmlformats.org/presentationml/2006/main" xmlns:c="http://schemas.openxmlformats.org/drawingml/2006/chart" xmlns:dgm="http://schemas.openxmlformats.org/drawingml/2006/diagram" xmlns:o="urn:schemas-microsoft-com:office:office" xmlns:v="urn:schemas-microsoft-com:vml" xmlns:pvml="urn:schemas-microsoft-com:office:powerpoint" xmlns:com="http://schemas.openxmlformats.org/drawingml/2006/compatibility" xmlns:p14="http://schemas.microsoft.com/office/powerpoint/2010/main" xmlns:p15="http://schemas.microsoft.com/office/powerpoint/2012/main" xmlns:ahyp="http://schemas.microsoft.com/office/drawing/2018/hyperlinkcolor">
   <p:cSld>
     <p:spTree>
@@ -16143,96 +17174,7 @@
 </p:sld>
 </file>
 
-<file path=ppt/slides/slide3.xml><?xml version="1.0" encoding="utf-8"?>
-<p:sld xmlns:a="http://schemas.openxmlformats.org/drawingml/2006/main" xmlns:r="http://schemas.openxmlformats.org/officeDocument/2006/relationships" xmlns:mc="http://schemas.openxmlformats.org/markup-compatibility/2006" xmlns:mv="urn:schemas-microsoft-com:mac:vml" xmlns:p="http://schemas.openxmlformats.org/presentationml/2006/main" xmlns:c="http://schemas.openxmlformats.org/drawingml/2006/chart" xmlns:dgm="http://schemas.openxmlformats.org/drawingml/2006/diagram" xmlns:o="urn:schemas-microsoft-com:office:office" xmlns:v="urn:schemas-microsoft-com:vml" xmlns:pvml="urn:schemas-microsoft-com:office:powerpoint" xmlns:com="http://schemas.openxmlformats.org/drawingml/2006/compatibility" xmlns:p14="http://schemas.microsoft.com/office/powerpoint/2010/main" xmlns:p15="http://schemas.microsoft.com/office/powerpoint/2012/main" xmlns:ahyp="http://schemas.microsoft.com/office/drawing/2018/hyperlinkcolor">
-  <p:cSld>
-    <p:spTree>
-      <p:nvGrpSpPr>
-        <p:cNvPr id="44" name="Shape 44"/>
-        <p:cNvGrpSpPr/>
-        <p:nvPr/>
-      </p:nvGrpSpPr>
-      <p:grpSpPr>
-        <a:xfrm>
-          <a:off x="0" y="0"/>
-          <a:ext cx="0" cy="0"/>
-          <a:chOff x="0" y="0"/>
-          <a:chExt cx="0" cy="0"/>
-        </a:xfrm>
-      </p:grpSpPr>
-      <p:sp>
-        <p:nvSpPr>
-          <p:cNvPr id="45" name="Google Shape;45;p10"/>
-          <p:cNvSpPr txBox="1"/>
-          <p:nvPr>
-            <p:ph type="title"/>
-          </p:nvPr>
-        </p:nvSpPr>
-        <p:spPr>
-          <a:xfrm>
-            <a:off x="311700" y="195615"/>
-            <a:ext cx="8520600" cy="572700"/>
-          </a:xfrm>
-          <a:prstGeom prst="rect">
-            <a:avLst/>
-          </a:prstGeom>
-        </p:spPr>
-        <p:txBody>
-          <a:bodyPr anchorCtr="0" anchor="t" bIns="91425" lIns="91425" spcFirstLastPara="1" rIns="91425" wrap="square" tIns="91425">
-            <a:normAutofit fontScale="90000"/>
-          </a:bodyPr>
-          <a:lstStyle/>
-          <a:p>
-            <a:pPr indent="0" lvl="0" marL="0" rtl="0" algn="l">
-              <a:spcBef>
-                <a:spcPts val="0"/>
-              </a:spcBef>
-              <a:spcAft>
-                <a:spcPts val="0"/>
-              </a:spcAft>
-              <a:buNone/>
-            </a:pPr>
-            <a:r>
-              <a:rPr lang="en"/>
-              <a:t>Today’s Goal</a:t>
-            </a:r>
-            <a:endParaRPr/>
-          </a:p>
-        </p:txBody>
-      </p:sp>
-      <p:pic>
-        <p:nvPicPr>
-          <p:cNvPr id="46" name="Picture 46" descr="snake9.png"/>
-          <p:cNvPicPr>
-            <a:picLocks noChangeAspect="1"/>
-          </p:cNvPicPr>
-          <p:nvPr/>
-        </p:nvPicPr>
-        <p:blipFill>
-          <a:blip r:embed="rId4"/>
-          <a:stretch>
-            <a:fillRect/>
-          </a:stretch>
-        </p:blipFill>
-        <p:spPr>
-          <a:xfrm>
-            <a:off x="1846087" y="1626274"/>
-            <a:ext cx="5451825" cy="3066651"/>
-          </a:xfrm>
-          <a:prstGeom prst="rect">
-            <a:avLst/>
-          </a:prstGeom>
-        </p:spPr>
-      </p:pic>
-    </p:spTree>
-  </p:cSld>
-  <p:clrMapOvr>
-    <a:masterClrMapping/>
-  </p:clrMapOvr>
-</p:sld>
-</file>
-
-<file path=ppt/slides/slide30.xml><?xml version="1.0" encoding="utf-8"?>
+<file path=ppt/slides/slide35.xml><?xml version="1.0" encoding="utf-8"?>
 <p:sld xmlns:a="http://schemas.openxmlformats.org/drawingml/2006/main" xmlns:r="http://schemas.openxmlformats.org/officeDocument/2006/relationships" xmlns:mc="http://schemas.openxmlformats.org/markup-compatibility/2006" xmlns:mv="urn:schemas-microsoft-com:mac:vml" xmlns:p="http://schemas.openxmlformats.org/presentationml/2006/main" xmlns:c="http://schemas.openxmlformats.org/drawingml/2006/chart" xmlns:dgm="http://schemas.openxmlformats.org/drawingml/2006/diagram" xmlns:o="urn:schemas-microsoft-com:office:office" xmlns:v="urn:schemas-microsoft-com:vml" xmlns:pvml="urn:schemas-microsoft-com:office:powerpoint" xmlns:com="http://schemas.openxmlformats.org/drawingml/2006/compatibility" xmlns:p14="http://schemas.microsoft.com/office/powerpoint/2010/main" xmlns:p15="http://schemas.microsoft.com/office/powerpoint/2012/main" xmlns:ahyp="http://schemas.microsoft.com/office/drawing/2018/hyperlinkcolor">
   <p:cSld>
     <p:spTree>
@@ -16366,7 +17308,7 @@
 </p:sld>
 </file>
 
-<file path=ppt/slides/slide31.xml><?xml version="1.0" encoding="utf-8"?>
+<file path=ppt/slides/slide36.xml><?xml version="1.0" encoding="utf-8"?>
 <p:sld xmlns:a="http://schemas.openxmlformats.org/drawingml/2006/main" xmlns:r="http://schemas.openxmlformats.org/officeDocument/2006/relationships" xmlns:mc="http://schemas.openxmlformats.org/markup-compatibility/2006" xmlns:mv="urn:schemas-microsoft-com:mac:vml" xmlns:p="http://schemas.openxmlformats.org/presentationml/2006/main" xmlns:c="http://schemas.openxmlformats.org/drawingml/2006/chart" xmlns:dgm="http://schemas.openxmlformats.org/drawingml/2006/diagram" xmlns:o="urn:schemas-microsoft-com:office:office" xmlns:v="urn:schemas-microsoft-com:vml" xmlns:pvml="urn:schemas-microsoft-com:office:powerpoint" xmlns:com="http://schemas.openxmlformats.org/drawingml/2006/compatibility" xmlns:p14="http://schemas.microsoft.com/office/powerpoint/2010/main" xmlns:p15="http://schemas.microsoft.com/office/powerpoint/2012/main" xmlns:ahyp="http://schemas.microsoft.com/office/drawing/2018/hyperlinkcolor">
   <p:cSld>
     <p:spTree>
@@ -16806,7 +17748,7 @@
 </p:sld>
 </file>
 
-<file path=ppt/slides/slide32.xml><?xml version="1.0" encoding="utf-8"?>
+<file path=ppt/slides/slide37.xml><?xml version="1.0" encoding="utf-8"?>
 <p:sld xmlns:a="http://schemas.openxmlformats.org/drawingml/2006/main" xmlns:r="http://schemas.openxmlformats.org/officeDocument/2006/relationships" xmlns:mc="http://schemas.openxmlformats.org/markup-compatibility/2006" xmlns:mv="urn:schemas-microsoft-com:mac:vml" xmlns:p="http://schemas.openxmlformats.org/presentationml/2006/main" xmlns:c="http://schemas.openxmlformats.org/drawingml/2006/chart" xmlns:dgm="http://schemas.openxmlformats.org/drawingml/2006/diagram" xmlns:o="urn:schemas-microsoft-com:office:office" xmlns:v="urn:schemas-microsoft-com:vml" xmlns:pvml="urn:schemas-microsoft-com:office:powerpoint" xmlns:com="http://schemas.openxmlformats.org/drawingml/2006/compatibility" xmlns:p14="http://schemas.microsoft.com/office/powerpoint/2010/main" xmlns:p15="http://schemas.microsoft.com/office/powerpoint/2012/main" xmlns:ahyp="http://schemas.microsoft.com/office/drawing/2018/hyperlinkcolor">
   <p:cSld>
     <p:spTree>
@@ -17655,7 +18597,7 @@
 </p:sld>
 </file>
 
-<file path=ppt/slides/slide33.xml><?xml version="1.0" encoding="utf-8"?>
+<file path=ppt/slides/slide38.xml><?xml version="1.0" encoding="utf-8"?>
 <p:sld xmlns:a="http://schemas.openxmlformats.org/drawingml/2006/main" xmlns:r="http://schemas.openxmlformats.org/officeDocument/2006/relationships" xmlns:mc="http://schemas.openxmlformats.org/markup-compatibility/2006" xmlns:mv="urn:schemas-microsoft-com:mac:vml" xmlns:p="http://schemas.openxmlformats.org/presentationml/2006/main" xmlns:c="http://schemas.openxmlformats.org/drawingml/2006/chart" xmlns:dgm="http://schemas.openxmlformats.org/drawingml/2006/diagram" xmlns:o="urn:schemas-microsoft-com:office:office" xmlns:v="urn:schemas-microsoft-com:vml" xmlns:pvml="urn:schemas-microsoft-com:office:powerpoint" xmlns:com="http://schemas.openxmlformats.org/drawingml/2006/compatibility" xmlns:p14="http://schemas.microsoft.com/office/powerpoint/2010/main" xmlns:p15="http://schemas.microsoft.com/office/powerpoint/2012/main" xmlns:ahyp="http://schemas.microsoft.com/office/drawing/2018/hyperlinkcolor">
   <p:cSld>
     <p:spTree>
@@ -18487,7 +19429,7 @@
 </p:sld>
 </file>
 
-<file path=ppt/slides/slide34.xml><?xml version="1.0" encoding="utf-8"?>
+<file path=ppt/slides/slide39.xml><?xml version="1.0" encoding="utf-8"?>
 <p:sld xmlns:a="http://schemas.openxmlformats.org/drawingml/2006/main" xmlns:p="http://schemas.openxmlformats.org/presentationml/2006/main" xmlns:r="http://schemas.openxmlformats.org/officeDocument/2006/relationships">
   <p:cSld>
     <p:spTree>
@@ -18660,7 +19602,456 @@
 </p:sld>
 </file>
 
-<file path=ppt/slides/slide35.xml><?xml version="1.0" encoding="utf-8"?>
+<file path=ppt/slides/slide4.xml><?xml version="1.0" encoding="utf-8"?>
+<p:sld xmlns:a="http://schemas.openxmlformats.org/drawingml/2006/main" xmlns:r="http://schemas.openxmlformats.org/officeDocument/2006/relationships" xmlns:mc="http://schemas.openxmlformats.org/markup-compatibility/2006" xmlns:mv="urn:schemas-microsoft-com:mac:vml" xmlns:p="http://schemas.openxmlformats.org/presentationml/2006/main" xmlns:c="http://schemas.openxmlformats.org/drawingml/2006/chart" xmlns:dgm="http://schemas.openxmlformats.org/drawingml/2006/diagram" xmlns:o="urn:schemas-microsoft-com:office:office" xmlns:v="urn:schemas-microsoft-com:vml" xmlns:pvml="urn:schemas-microsoft-com:office:powerpoint" xmlns:com="http://schemas.openxmlformats.org/drawingml/2006/compatibility" xmlns:p14="http://schemas.microsoft.com/office/powerpoint/2010/main" xmlns:p15="http://schemas.microsoft.com/office/powerpoint/2012/main" xmlns:ahyp="http://schemas.microsoft.com/office/drawing/2018/hyperlinkcolor">
+  <p:cSld>
+    <p:spTree>
+      <p:nvGrpSpPr>
+        <p:cNvPr id="50" name="Shape 50"/>
+        <p:cNvGrpSpPr/>
+        <p:nvPr/>
+      </p:nvGrpSpPr>
+      <p:grpSpPr>
+        <a:xfrm>
+          <a:off x="0" y="0"/>
+          <a:ext cx="0" cy="0"/>
+          <a:chOff x="0" y="0"/>
+          <a:chExt cx="0" cy="0"/>
+        </a:xfrm>
+      </p:grpSpPr>
+      <p:sp>
+        <p:nvSpPr>
+          <p:cNvPr id="51" name="Google Shape;51;p11"/>
+          <p:cNvSpPr txBox="1"/>
+          <p:nvPr>
+            <p:ph type="title"/>
+          </p:nvPr>
+        </p:nvSpPr>
+        <p:spPr>
+          <a:xfrm>
+            <a:off x="311700" y="195615"/>
+            <a:ext cx="8520600" cy="572700"/>
+          </a:xfrm>
+          <a:prstGeom prst="rect">
+            <a:avLst/>
+          </a:prstGeom>
+        </p:spPr>
+        <p:txBody>
+          <a:bodyPr anchorCtr="0" anchor="t" bIns="91425" lIns="91425" spcFirstLastPara="1" rIns="91425" wrap="square" tIns="91425">
+            <a:normAutofit fontScale="90000"/>
+          </a:bodyPr>
+          <a:lstStyle/>
+          <a:p>
+            <a:pPr indent="0" lvl="0" marL="0" rtl="0" algn="l">
+              <a:spcBef>
+                <a:spcPts val="0"/>
+              </a:spcBef>
+              <a:spcAft>
+                <a:spcPts val="0"/>
+              </a:spcAft>
+              <a:buNone/>
+            </a:pPr>
+            <a:r>
+              <a:rPr lang="en"/>
+              <a:t>Today’s Topics</a:t>
+            </a:r>
+            <a:endParaRPr/>
+          </a:p>
+        </p:txBody>
+      </p:sp>
+      <p:sp>
+        <p:nvSpPr>
+          <p:cNvPr id="52" name="Google Shape;52;p11"/>
+          <p:cNvSpPr txBox="1"/>
+          <p:nvPr>
+            <p:ph idx="1" type="body"/>
+          </p:nvPr>
+        </p:nvSpPr>
+        <p:spPr>
+          <a:xfrm>
+            <a:off x="311700" y="885950"/>
+            <a:ext cx="8520600" cy="4023300"/>
+          </a:xfrm>
+          <a:prstGeom prst="rect">
+            <a:avLst/>
+          </a:prstGeom>
+        </p:spPr>
+        <p:txBody>
+          <a:bodyPr anchorCtr="0" anchor="t" bIns="91425" lIns="91425" spcFirstLastPara="1" rIns="91425" wrap="square" tIns="91425">
+            <a:normAutofit/>
+          </a:bodyPr>
+          <a:lstStyle/>
+          <a:p>
+            <a:pPr indent="-330200" lvl="0" marL="457200" rtl="0" algn="l">
+              <a:spcBef>
+                <a:spcPts val="0"/>
+              </a:spcBef>
+              <a:spcAft>
+                <a:spcPts val="0"/>
+              </a:spcAft>
+              <a:buSzPts val="1600"/>
+              <a:buChar char="●"/>
+            </a:pPr>
+            <a:r>
+              <a:rPr lang="en"/>
+              <a:t>Assets as Data</a:t>
+            </a:r>
+            <a:endParaRPr/>
+          </a:p>
+          <a:p>
+            <a:pPr indent="-330200" lvl="0" marL="457200" rtl="0" algn="l">
+              <a:spcBef>
+                <a:spcPts val="0"/>
+              </a:spcBef>
+              <a:spcAft>
+                <a:spcPts val="0"/>
+              </a:spcAft>
+              <a:buSzPts val="1600"/>
+              <a:buChar char="●"/>
+            </a:pPr>
+            <a:r>
+              <a:rPr lang="en"/>
+              <a:t>Texture Atlases</a:t>
+            </a:r>
+            <a:endParaRPr/>
+          </a:p>
+          <a:p>
+            <a:pPr indent="-330200" lvl="0" marL="457200" rtl="0" algn="l">
+              <a:spcBef>
+                <a:spcPts val="0"/>
+              </a:spcBef>
+              <a:spcAft>
+                <a:spcPts val="0"/>
+              </a:spcAft>
+              <a:buSzPts val="1600"/>
+              <a:buChar char="●"/>
+            </a:pPr>
+            <a:r>
+              <a:rPr lang="en"/>
+              <a:t>Sprites &amp; Animation</a:t>
+            </a:r>
+            <a:endParaRPr/>
+          </a:p>
+          <a:p>
+            <a:pPr indent="-330200" lvl="0" marL="457200" rtl="0" algn="l">
+              <a:spcBef>
+                <a:spcPts val="0"/>
+              </a:spcBef>
+              <a:spcAft>
+                <a:spcPts val="0"/>
+              </a:spcAft>
+              <a:buSzPts val="1600"/>
+              <a:buChar char="●"/>
+            </a:pPr>
+            <a:r>
+              <a:rPr lang="en"/>
+              <a:t>Fixed-Tick Movement</a:t>
+            </a:r>
+            <a:endParaRPr/>
+          </a:p>
+          <a:p>
+            <a:pPr indent="-330200" lvl="0" marL="457200" rtl="0" algn="l">
+              <a:spcBef>
+                <a:spcPts val="0"/>
+              </a:spcBef>
+              <a:spcAft>
+                <a:spcPts val="0"/>
+              </a:spcAft>
+              <a:buSzPts val="1600"/>
+              <a:buChar char="●"/>
+            </a:pPr>
+            <a:r>
+              <a:rPr lang="en"/>
+              <a:t>Input as Actions &amp; Buffering</a:t>
+            </a:r>
+            <a:endParaRPr/>
+          </a:p>
+        </p:txBody>
+      </p:sp>
+    </p:spTree>
+  </p:cSld>
+  <p:clrMapOvr>
+    <a:masterClrMapping/>
+  </p:clrMapOvr>
+  <p:timing>
+    <p:tnLst>
+      <p:par>
+        <p:cTn dur="indefinite" nodeType="tmRoot" restart="never">
+          <p:childTnLst>
+            <p:seq concurrent="1" nextAc="seek">
+              <p:cTn dur="indefinite" id="2" nodeType="mainSeq">
+                <p:childTnLst>
+                  <p:par>
+                    <p:cTn fill="hold">
+                      <p:stCondLst>
+                        <p:cond delay="indefinite"/>
+                      </p:stCondLst>
+                      <p:childTnLst>
+                        <p:par>
+                          <p:cTn fill="hold">
+                            <p:stCondLst>
+                              <p:cond delay="0"/>
+                            </p:stCondLst>
+                            <p:childTnLst>
+                              <p:par>
+                                <p:cTn fill="hold" nodeType="clickEffect" presetClass="entr" presetID="1" presetSubtype="0">
+                                  <p:stCondLst>
+                                    <p:cond delay="0"/>
+                                  </p:stCondLst>
+                                  <p:childTnLst>
+                                    <p:set>
+                                      <p:cBhvr>
+                                        <p:cTn dur="1" fill="hold">
+                                          <p:stCondLst>
+                                            <p:cond delay="0"/>
+                                          </p:stCondLst>
+                                        </p:cTn>
+                                        <p:tgtEl>
+                                          <p:spTgt spid="52">
+                                            <p:txEl>
+                                              <p:pRg end="0" st="0"/>
+                                            </p:txEl>
+                                          </p:spTgt>
+                                        </p:tgtEl>
+                                        <p:attrNameLst>
+                                          <p:attrName>style.visibility</p:attrName>
+                                        </p:attrNameLst>
+                                      </p:cBhvr>
+                                      <p:to>
+                                        <p:strVal val="visible"/>
+                                      </p:to>
+                                    </p:set>
+                                  </p:childTnLst>
+                                </p:cTn>
+                              </p:par>
+                            </p:childTnLst>
+                          </p:cTn>
+                        </p:par>
+                      </p:childTnLst>
+                    </p:cTn>
+                  </p:par>
+                  <p:par>
+                    <p:cTn fill="hold">
+                      <p:stCondLst>
+                        <p:cond delay="indefinite"/>
+                      </p:stCondLst>
+                      <p:childTnLst>
+                        <p:par>
+                          <p:cTn fill="hold">
+                            <p:stCondLst>
+                              <p:cond delay="0"/>
+                            </p:stCondLst>
+                            <p:childTnLst>
+                              <p:par>
+                                <p:cTn fill="hold" nodeType="clickEffect" presetClass="entr" presetID="1" presetSubtype="0">
+                                  <p:stCondLst>
+                                    <p:cond delay="0"/>
+                                  </p:stCondLst>
+                                  <p:childTnLst>
+                                    <p:set>
+                                      <p:cBhvr>
+                                        <p:cTn dur="1" fill="hold">
+                                          <p:stCondLst>
+                                            <p:cond delay="0"/>
+                                          </p:stCondLst>
+                                        </p:cTn>
+                                        <p:tgtEl>
+                                          <p:spTgt spid="52">
+                                            <p:txEl>
+                                              <p:pRg end="1" st="1"/>
+                                            </p:txEl>
+                                          </p:spTgt>
+                                        </p:tgtEl>
+                                        <p:attrNameLst>
+                                          <p:attrName>style.visibility</p:attrName>
+                                        </p:attrNameLst>
+                                      </p:cBhvr>
+                                      <p:to>
+                                        <p:strVal val="visible"/>
+                                      </p:to>
+                                    </p:set>
+                                  </p:childTnLst>
+                                </p:cTn>
+                              </p:par>
+                            </p:childTnLst>
+                          </p:cTn>
+                        </p:par>
+                      </p:childTnLst>
+                    </p:cTn>
+                  </p:par>
+                  <p:par>
+                    <p:cTn fill="hold">
+                      <p:stCondLst>
+                        <p:cond delay="indefinite"/>
+                      </p:stCondLst>
+                      <p:childTnLst>
+                        <p:par>
+                          <p:cTn fill="hold">
+                            <p:stCondLst>
+                              <p:cond delay="0"/>
+                            </p:stCondLst>
+                            <p:childTnLst>
+                              <p:par>
+                                <p:cTn fill="hold" nodeType="clickEffect" presetClass="entr" presetID="1" presetSubtype="0">
+                                  <p:stCondLst>
+                                    <p:cond delay="0"/>
+                                  </p:stCondLst>
+                                  <p:childTnLst>
+                                    <p:set>
+                                      <p:cBhvr>
+                                        <p:cTn dur="1" fill="hold">
+                                          <p:stCondLst>
+                                            <p:cond delay="0"/>
+                                          </p:stCondLst>
+                                        </p:cTn>
+                                        <p:tgtEl>
+                                          <p:spTgt spid="52">
+                                            <p:txEl>
+                                              <p:pRg end="2" st="2"/>
+                                            </p:txEl>
+                                          </p:spTgt>
+                                        </p:tgtEl>
+                                        <p:attrNameLst>
+                                          <p:attrName>style.visibility</p:attrName>
+                                        </p:attrNameLst>
+                                      </p:cBhvr>
+                                      <p:to>
+                                        <p:strVal val="visible"/>
+                                      </p:to>
+                                    </p:set>
+                                  </p:childTnLst>
+                                </p:cTn>
+                              </p:par>
+                            </p:childTnLst>
+                          </p:cTn>
+                        </p:par>
+                      </p:childTnLst>
+                    </p:cTn>
+                  </p:par>
+                  <p:par>
+                    <p:cTn fill="hold">
+                      <p:stCondLst>
+                        <p:cond delay="indefinite"/>
+                      </p:stCondLst>
+                      <p:childTnLst>
+                        <p:par>
+                          <p:cTn fill="hold">
+                            <p:stCondLst>
+                              <p:cond delay="0"/>
+                            </p:stCondLst>
+                            <p:childTnLst>
+                              <p:par>
+                                <p:cTn fill="hold" nodeType="clickEffect" presetClass="entr" presetID="1" presetSubtype="0">
+                                  <p:stCondLst>
+                                    <p:cond delay="0"/>
+                                  </p:stCondLst>
+                                  <p:childTnLst>
+                                    <p:set>
+                                      <p:cBhvr>
+                                        <p:cTn dur="1" fill="hold">
+                                          <p:stCondLst>
+                                            <p:cond delay="0"/>
+                                          </p:stCondLst>
+                                        </p:cTn>
+                                        <p:tgtEl>
+                                          <p:spTgt spid="52">
+                                            <p:txEl>
+                                              <p:pRg end="3" st="3"/>
+                                            </p:txEl>
+                                          </p:spTgt>
+                                        </p:tgtEl>
+                                        <p:attrNameLst>
+                                          <p:attrName>style.visibility</p:attrName>
+                                        </p:attrNameLst>
+                                      </p:cBhvr>
+                                      <p:to>
+                                        <p:strVal val="visible"/>
+                                      </p:to>
+                                    </p:set>
+                                  </p:childTnLst>
+                                </p:cTn>
+                              </p:par>
+                            </p:childTnLst>
+                          </p:cTn>
+                        </p:par>
+                      </p:childTnLst>
+                    </p:cTn>
+                  </p:par>
+                  <p:par>
+                    <p:cTn fill="hold">
+                      <p:stCondLst>
+                        <p:cond delay="indefinite"/>
+                      </p:stCondLst>
+                      <p:childTnLst>
+                        <p:par>
+                          <p:cTn fill="hold">
+                            <p:stCondLst>
+                              <p:cond delay="0"/>
+                            </p:stCondLst>
+                            <p:childTnLst>
+                              <p:par>
+                                <p:cTn fill="hold" nodeType="clickEffect" presetClass="entr" presetID="1" presetSubtype="0">
+                                  <p:stCondLst>
+                                    <p:cond delay="0"/>
+                                  </p:stCondLst>
+                                  <p:childTnLst>
+                                    <p:set>
+                                      <p:cBhvr>
+                                        <p:cTn dur="1" fill="hold">
+                                          <p:stCondLst>
+                                            <p:cond delay="0"/>
+                                          </p:stCondLst>
+                                        </p:cTn>
+                                        <p:tgtEl>
+                                          <p:spTgt spid="52">
+                                            <p:txEl>
+                                              <p:pRg end="4" st="4"/>
+                                            </p:txEl>
+                                          </p:spTgt>
+                                        </p:tgtEl>
+                                        <p:attrNameLst>
+                                          <p:attrName>style.visibility</p:attrName>
+                                        </p:attrNameLst>
+                                      </p:cBhvr>
+                                      <p:to>
+                                        <p:strVal val="visible"/>
+                                      </p:to>
+                                    </p:set>
+                                  </p:childTnLst>
+                                </p:cTn>
+                              </p:par>
+                            </p:childTnLst>
+                          </p:cTn>
+                        </p:par>
+                      </p:childTnLst>
+                    </p:cTn>
+                  </p:par>
+                </p:childTnLst>
+              </p:cTn>
+              <p:prevCondLst>
+                <p:cond evt="onPrev">
+                  <p:tgtEl>
+                    <p:sldTgt/>
+                  </p:tgtEl>
+                </p:cond>
+              </p:prevCondLst>
+              <p:nextCondLst>
+                <p:cond evt="onNext">
+                  <p:tgtEl>
+                    <p:sldTgt/>
+                  </p:tgtEl>
+                </p:cond>
+              </p:nextCondLst>
+            </p:seq>
+          </p:childTnLst>
+        </p:cTn>
+      </p:par>
+    </p:tnLst>
+  </p:timing>
+</p:sld>
+</file>
+
+<file path=ppt/slides/slide40.xml><?xml version="1.0" encoding="utf-8"?>
 <p:sld xmlns:a="http://schemas.openxmlformats.org/drawingml/2006/main" xmlns:r="http://schemas.openxmlformats.org/officeDocument/2006/relationships" xmlns:mc="http://schemas.openxmlformats.org/markup-compatibility/2006" xmlns:mv="urn:schemas-microsoft-com:mac:vml" xmlns:p="http://schemas.openxmlformats.org/presentationml/2006/main" xmlns:c="http://schemas.openxmlformats.org/drawingml/2006/chart" xmlns:dgm="http://schemas.openxmlformats.org/drawingml/2006/diagram" xmlns:o="urn:schemas-microsoft-com:office:office" xmlns:v="urn:schemas-microsoft-com:vml" xmlns:pvml="urn:schemas-microsoft-com:office:powerpoint" xmlns:com="http://schemas.openxmlformats.org/drawingml/2006/compatibility" xmlns:p14="http://schemas.microsoft.com/office/powerpoint/2010/main" xmlns:p15="http://schemas.microsoft.com/office/powerpoint/2012/main" xmlns:ahyp="http://schemas.microsoft.com/office/drawing/2018/hyperlinkcolor">
   <p:cSld>
     <p:spTree>
@@ -19492,7 +20883,7 @@
 </p:sld>
 </file>
 
-<file path=ppt/slides/slide36.xml><?xml version="1.0" encoding="utf-8"?>
+<file path=ppt/slides/slide41.xml><?xml version="1.0" encoding="utf-8"?>
 <p:sld xmlns:a="http://schemas.openxmlformats.org/drawingml/2006/main" xmlns:r="http://schemas.openxmlformats.org/officeDocument/2006/relationships" xmlns:mc="http://schemas.openxmlformats.org/markup-compatibility/2006" xmlns:mv="urn:schemas-microsoft-com:mac:vml" xmlns:p="http://schemas.openxmlformats.org/presentationml/2006/main" xmlns:c="http://schemas.openxmlformats.org/drawingml/2006/chart" xmlns:dgm="http://schemas.openxmlformats.org/drawingml/2006/diagram" xmlns:o="urn:schemas-microsoft-com:office:office" xmlns:v="urn:schemas-microsoft-com:vml" xmlns:pvml="urn:schemas-microsoft-com:office:powerpoint" xmlns:com="http://schemas.openxmlformats.org/drawingml/2006/compatibility" xmlns:p14="http://schemas.microsoft.com/office/powerpoint/2010/main" xmlns:p15="http://schemas.microsoft.com/office/powerpoint/2012/main" xmlns:ahyp="http://schemas.microsoft.com/office/drawing/2018/hyperlinkcolor">
   <p:cSld>
     <p:spTree>
@@ -19697,455 +21088,6 @@
   <p:clrMapOvr>
     <a:masterClrMapping/>
   </p:clrMapOvr>
-</p:sld>
-</file>
-
-<file path=ppt/slides/slide4.xml><?xml version="1.0" encoding="utf-8"?>
-<p:sld xmlns:a="http://schemas.openxmlformats.org/drawingml/2006/main" xmlns:r="http://schemas.openxmlformats.org/officeDocument/2006/relationships" xmlns:mc="http://schemas.openxmlformats.org/markup-compatibility/2006" xmlns:mv="urn:schemas-microsoft-com:mac:vml" xmlns:p="http://schemas.openxmlformats.org/presentationml/2006/main" xmlns:c="http://schemas.openxmlformats.org/drawingml/2006/chart" xmlns:dgm="http://schemas.openxmlformats.org/drawingml/2006/diagram" xmlns:o="urn:schemas-microsoft-com:office:office" xmlns:v="urn:schemas-microsoft-com:vml" xmlns:pvml="urn:schemas-microsoft-com:office:powerpoint" xmlns:com="http://schemas.openxmlformats.org/drawingml/2006/compatibility" xmlns:p14="http://schemas.microsoft.com/office/powerpoint/2010/main" xmlns:p15="http://schemas.microsoft.com/office/powerpoint/2012/main" xmlns:ahyp="http://schemas.microsoft.com/office/drawing/2018/hyperlinkcolor">
-  <p:cSld>
-    <p:spTree>
-      <p:nvGrpSpPr>
-        <p:cNvPr id="50" name="Shape 50"/>
-        <p:cNvGrpSpPr/>
-        <p:nvPr/>
-      </p:nvGrpSpPr>
-      <p:grpSpPr>
-        <a:xfrm>
-          <a:off x="0" y="0"/>
-          <a:ext cx="0" cy="0"/>
-          <a:chOff x="0" y="0"/>
-          <a:chExt cx="0" cy="0"/>
-        </a:xfrm>
-      </p:grpSpPr>
-      <p:sp>
-        <p:nvSpPr>
-          <p:cNvPr id="51" name="Google Shape;51;p11"/>
-          <p:cNvSpPr txBox="1"/>
-          <p:nvPr>
-            <p:ph type="title"/>
-          </p:nvPr>
-        </p:nvSpPr>
-        <p:spPr>
-          <a:xfrm>
-            <a:off x="311700" y="195615"/>
-            <a:ext cx="8520600" cy="572700"/>
-          </a:xfrm>
-          <a:prstGeom prst="rect">
-            <a:avLst/>
-          </a:prstGeom>
-        </p:spPr>
-        <p:txBody>
-          <a:bodyPr anchorCtr="0" anchor="t" bIns="91425" lIns="91425" spcFirstLastPara="1" rIns="91425" wrap="square" tIns="91425">
-            <a:normAutofit fontScale="90000"/>
-          </a:bodyPr>
-          <a:lstStyle/>
-          <a:p>
-            <a:pPr indent="0" lvl="0" marL="0" rtl="0" algn="l">
-              <a:spcBef>
-                <a:spcPts val="0"/>
-              </a:spcBef>
-              <a:spcAft>
-                <a:spcPts val="0"/>
-              </a:spcAft>
-              <a:buNone/>
-            </a:pPr>
-            <a:r>
-              <a:rPr lang="en"/>
-              <a:t>Today’s Topics</a:t>
-            </a:r>
-            <a:endParaRPr/>
-          </a:p>
-        </p:txBody>
-      </p:sp>
-      <p:sp>
-        <p:nvSpPr>
-          <p:cNvPr id="52" name="Google Shape;52;p11"/>
-          <p:cNvSpPr txBox="1"/>
-          <p:nvPr>
-            <p:ph idx="1" type="body"/>
-          </p:nvPr>
-        </p:nvSpPr>
-        <p:spPr>
-          <a:xfrm>
-            <a:off x="311700" y="885950"/>
-            <a:ext cx="8520600" cy="4023300"/>
-          </a:xfrm>
-          <a:prstGeom prst="rect">
-            <a:avLst/>
-          </a:prstGeom>
-        </p:spPr>
-        <p:txBody>
-          <a:bodyPr anchorCtr="0" anchor="t" bIns="91425" lIns="91425" spcFirstLastPara="1" rIns="91425" wrap="square" tIns="91425">
-            <a:normAutofit/>
-          </a:bodyPr>
-          <a:lstStyle/>
-          <a:p>
-            <a:pPr indent="-330200" lvl="0" marL="457200" rtl="0" algn="l">
-              <a:spcBef>
-                <a:spcPts val="0"/>
-              </a:spcBef>
-              <a:spcAft>
-                <a:spcPts val="0"/>
-              </a:spcAft>
-              <a:buSzPts val="1600"/>
-              <a:buChar char="●"/>
-            </a:pPr>
-            <a:r>
-              <a:rPr lang="en"/>
-              <a:t>Assets as Data</a:t>
-            </a:r>
-            <a:endParaRPr/>
-          </a:p>
-          <a:p>
-            <a:pPr indent="-330200" lvl="0" marL="457200" rtl="0" algn="l">
-              <a:spcBef>
-                <a:spcPts val="0"/>
-              </a:spcBef>
-              <a:spcAft>
-                <a:spcPts val="0"/>
-              </a:spcAft>
-              <a:buSzPts val="1600"/>
-              <a:buChar char="●"/>
-            </a:pPr>
-            <a:r>
-              <a:rPr lang="en"/>
-              <a:t>Texture Atlases</a:t>
-            </a:r>
-            <a:endParaRPr/>
-          </a:p>
-          <a:p>
-            <a:pPr indent="-330200" lvl="0" marL="457200" rtl="0" algn="l">
-              <a:spcBef>
-                <a:spcPts val="0"/>
-              </a:spcBef>
-              <a:spcAft>
-                <a:spcPts val="0"/>
-              </a:spcAft>
-              <a:buSzPts val="1600"/>
-              <a:buChar char="●"/>
-            </a:pPr>
-            <a:r>
-              <a:rPr lang="en"/>
-              <a:t>Sprites &amp; Animation</a:t>
-            </a:r>
-            <a:endParaRPr/>
-          </a:p>
-          <a:p>
-            <a:pPr indent="-330200" lvl="0" marL="457200" rtl="0" algn="l">
-              <a:spcBef>
-                <a:spcPts val="0"/>
-              </a:spcBef>
-              <a:spcAft>
-                <a:spcPts val="0"/>
-              </a:spcAft>
-              <a:buSzPts val="1600"/>
-              <a:buChar char="●"/>
-            </a:pPr>
-            <a:r>
-              <a:rPr lang="en"/>
-              <a:t>Fixed-Tick Movement</a:t>
-            </a:r>
-            <a:endParaRPr/>
-          </a:p>
-          <a:p>
-            <a:pPr indent="-330200" lvl="0" marL="457200" rtl="0" algn="l">
-              <a:spcBef>
-                <a:spcPts val="0"/>
-              </a:spcBef>
-              <a:spcAft>
-                <a:spcPts val="0"/>
-              </a:spcAft>
-              <a:buSzPts val="1600"/>
-              <a:buChar char="●"/>
-            </a:pPr>
-            <a:r>
-              <a:rPr lang="en"/>
-              <a:t>Input as Actions &amp; Buffering</a:t>
-            </a:r>
-            <a:endParaRPr/>
-          </a:p>
-        </p:txBody>
-      </p:sp>
-    </p:spTree>
-  </p:cSld>
-  <p:clrMapOvr>
-    <a:masterClrMapping/>
-  </p:clrMapOvr>
-  <p:timing>
-    <p:tnLst>
-      <p:par>
-        <p:cTn dur="indefinite" nodeType="tmRoot" restart="never">
-          <p:childTnLst>
-            <p:seq concurrent="1" nextAc="seek">
-              <p:cTn dur="indefinite" id="2" nodeType="mainSeq">
-                <p:childTnLst>
-                  <p:par>
-                    <p:cTn fill="hold">
-                      <p:stCondLst>
-                        <p:cond delay="indefinite"/>
-                      </p:stCondLst>
-                      <p:childTnLst>
-                        <p:par>
-                          <p:cTn fill="hold">
-                            <p:stCondLst>
-                              <p:cond delay="0"/>
-                            </p:stCondLst>
-                            <p:childTnLst>
-                              <p:par>
-                                <p:cTn fill="hold" nodeType="clickEffect" presetClass="entr" presetID="1" presetSubtype="0">
-                                  <p:stCondLst>
-                                    <p:cond delay="0"/>
-                                  </p:stCondLst>
-                                  <p:childTnLst>
-                                    <p:set>
-                                      <p:cBhvr>
-                                        <p:cTn dur="1" fill="hold">
-                                          <p:stCondLst>
-                                            <p:cond delay="0"/>
-                                          </p:stCondLst>
-                                        </p:cTn>
-                                        <p:tgtEl>
-                                          <p:spTgt spid="52">
-                                            <p:txEl>
-                                              <p:pRg end="0" st="0"/>
-                                            </p:txEl>
-                                          </p:spTgt>
-                                        </p:tgtEl>
-                                        <p:attrNameLst>
-                                          <p:attrName>style.visibility</p:attrName>
-                                        </p:attrNameLst>
-                                      </p:cBhvr>
-                                      <p:to>
-                                        <p:strVal val="visible"/>
-                                      </p:to>
-                                    </p:set>
-                                  </p:childTnLst>
-                                </p:cTn>
-                              </p:par>
-                            </p:childTnLst>
-                          </p:cTn>
-                        </p:par>
-                      </p:childTnLst>
-                    </p:cTn>
-                  </p:par>
-                  <p:par>
-                    <p:cTn fill="hold">
-                      <p:stCondLst>
-                        <p:cond delay="indefinite"/>
-                      </p:stCondLst>
-                      <p:childTnLst>
-                        <p:par>
-                          <p:cTn fill="hold">
-                            <p:stCondLst>
-                              <p:cond delay="0"/>
-                            </p:stCondLst>
-                            <p:childTnLst>
-                              <p:par>
-                                <p:cTn fill="hold" nodeType="clickEffect" presetClass="entr" presetID="1" presetSubtype="0">
-                                  <p:stCondLst>
-                                    <p:cond delay="0"/>
-                                  </p:stCondLst>
-                                  <p:childTnLst>
-                                    <p:set>
-                                      <p:cBhvr>
-                                        <p:cTn dur="1" fill="hold">
-                                          <p:stCondLst>
-                                            <p:cond delay="0"/>
-                                          </p:stCondLst>
-                                        </p:cTn>
-                                        <p:tgtEl>
-                                          <p:spTgt spid="52">
-                                            <p:txEl>
-                                              <p:pRg end="1" st="1"/>
-                                            </p:txEl>
-                                          </p:spTgt>
-                                        </p:tgtEl>
-                                        <p:attrNameLst>
-                                          <p:attrName>style.visibility</p:attrName>
-                                        </p:attrNameLst>
-                                      </p:cBhvr>
-                                      <p:to>
-                                        <p:strVal val="visible"/>
-                                      </p:to>
-                                    </p:set>
-                                  </p:childTnLst>
-                                </p:cTn>
-                              </p:par>
-                            </p:childTnLst>
-                          </p:cTn>
-                        </p:par>
-                      </p:childTnLst>
-                    </p:cTn>
-                  </p:par>
-                  <p:par>
-                    <p:cTn fill="hold">
-                      <p:stCondLst>
-                        <p:cond delay="indefinite"/>
-                      </p:stCondLst>
-                      <p:childTnLst>
-                        <p:par>
-                          <p:cTn fill="hold">
-                            <p:stCondLst>
-                              <p:cond delay="0"/>
-                            </p:stCondLst>
-                            <p:childTnLst>
-                              <p:par>
-                                <p:cTn fill="hold" nodeType="clickEffect" presetClass="entr" presetID="1" presetSubtype="0">
-                                  <p:stCondLst>
-                                    <p:cond delay="0"/>
-                                  </p:stCondLst>
-                                  <p:childTnLst>
-                                    <p:set>
-                                      <p:cBhvr>
-                                        <p:cTn dur="1" fill="hold">
-                                          <p:stCondLst>
-                                            <p:cond delay="0"/>
-                                          </p:stCondLst>
-                                        </p:cTn>
-                                        <p:tgtEl>
-                                          <p:spTgt spid="52">
-                                            <p:txEl>
-                                              <p:pRg end="2" st="2"/>
-                                            </p:txEl>
-                                          </p:spTgt>
-                                        </p:tgtEl>
-                                        <p:attrNameLst>
-                                          <p:attrName>style.visibility</p:attrName>
-                                        </p:attrNameLst>
-                                      </p:cBhvr>
-                                      <p:to>
-                                        <p:strVal val="visible"/>
-                                      </p:to>
-                                    </p:set>
-                                  </p:childTnLst>
-                                </p:cTn>
-                              </p:par>
-                            </p:childTnLst>
-                          </p:cTn>
-                        </p:par>
-                      </p:childTnLst>
-                    </p:cTn>
-                  </p:par>
-                  <p:par>
-                    <p:cTn fill="hold">
-                      <p:stCondLst>
-                        <p:cond delay="indefinite"/>
-                      </p:stCondLst>
-                      <p:childTnLst>
-                        <p:par>
-                          <p:cTn fill="hold">
-                            <p:stCondLst>
-                              <p:cond delay="0"/>
-                            </p:stCondLst>
-                            <p:childTnLst>
-                              <p:par>
-                                <p:cTn fill="hold" nodeType="clickEffect" presetClass="entr" presetID="1" presetSubtype="0">
-                                  <p:stCondLst>
-                                    <p:cond delay="0"/>
-                                  </p:stCondLst>
-                                  <p:childTnLst>
-                                    <p:set>
-                                      <p:cBhvr>
-                                        <p:cTn dur="1" fill="hold">
-                                          <p:stCondLst>
-                                            <p:cond delay="0"/>
-                                          </p:stCondLst>
-                                        </p:cTn>
-                                        <p:tgtEl>
-                                          <p:spTgt spid="52">
-                                            <p:txEl>
-                                              <p:pRg end="3" st="3"/>
-                                            </p:txEl>
-                                          </p:spTgt>
-                                        </p:tgtEl>
-                                        <p:attrNameLst>
-                                          <p:attrName>style.visibility</p:attrName>
-                                        </p:attrNameLst>
-                                      </p:cBhvr>
-                                      <p:to>
-                                        <p:strVal val="visible"/>
-                                      </p:to>
-                                    </p:set>
-                                  </p:childTnLst>
-                                </p:cTn>
-                              </p:par>
-                            </p:childTnLst>
-                          </p:cTn>
-                        </p:par>
-                      </p:childTnLst>
-                    </p:cTn>
-                  </p:par>
-                  <p:par>
-                    <p:cTn fill="hold">
-                      <p:stCondLst>
-                        <p:cond delay="indefinite"/>
-                      </p:stCondLst>
-                      <p:childTnLst>
-                        <p:par>
-                          <p:cTn fill="hold">
-                            <p:stCondLst>
-                              <p:cond delay="0"/>
-                            </p:stCondLst>
-                            <p:childTnLst>
-                              <p:par>
-                                <p:cTn fill="hold" nodeType="clickEffect" presetClass="entr" presetID="1" presetSubtype="0">
-                                  <p:stCondLst>
-                                    <p:cond delay="0"/>
-                                  </p:stCondLst>
-                                  <p:childTnLst>
-                                    <p:set>
-                                      <p:cBhvr>
-                                        <p:cTn dur="1" fill="hold">
-                                          <p:stCondLst>
-                                            <p:cond delay="0"/>
-                                          </p:stCondLst>
-                                        </p:cTn>
-                                        <p:tgtEl>
-                                          <p:spTgt spid="52">
-                                            <p:txEl>
-                                              <p:pRg end="4" st="4"/>
-                                            </p:txEl>
-                                          </p:spTgt>
-                                        </p:tgtEl>
-                                        <p:attrNameLst>
-                                          <p:attrName>style.visibility</p:attrName>
-                                        </p:attrNameLst>
-                                      </p:cBhvr>
-                                      <p:to>
-                                        <p:strVal val="visible"/>
-                                      </p:to>
-                                    </p:set>
-                                  </p:childTnLst>
-                                </p:cTn>
-                              </p:par>
-                            </p:childTnLst>
-                          </p:cTn>
-                        </p:par>
-                      </p:childTnLst>
-                    </p:cTn>
-                  </p:par>
-                </p:childTnLst>
-              </p:cTn>
-              <p:prevCondLst>
-                <p:cond evt="onPrev">
-                  <p:tgtEl>
-                    <p:sldTgt/>
-                  </p:tgtEl>
-                </p:cond>
-              </p:prevCondLst>
-              <p:nextCondLst>
-                <p:cond evt="onNext">
-                  <p:tgtEl>
-                    <p:sldTgt/>
-                  </p:tgtEl>
-                </p:cond>
-              </p:nextCondLst>
-            </p:seq>
-          </p:childTnLst>
-        </p:cTn>
-      </p:par>
-    </p:tnLst>
-  </p:timing>
 </p:sld>
 </file>
 

</xml_diff>

<commit_message>
Exam coverage: batching, the problems of each timestep, the costs of Update Method, how a tilemap is stored and drawn, choosing a collision shape. End exercises build on the new in-class tasks instead of repeating them
Co-Authored-By: Claude Opus 5.5 <noreply@anthropic.com>
Claude-Session: https://claude.ai/code/session_012sjsUQBbC7zon57rWHoo9d
</commit_message>
<xml_diff>
--- a/slides/03 Snake.pptx
+++ b/slides/03 Snake.pptx
@@ -3205,7 +3205,7 @@
           <a:lstStyle/>
           <a:p>
             <a:r>
-              <a:t>Exercise: the beetle is drawn in the atlas but not described. Two regions and an animation in the XML, then one line of C# (the animation name), then a new room layout.</a:t>
+              <a:t>Exercise: the beetle is drawn in the atlas but not described. Two regions and an animation in the XML, then one line of C# (the animation name).</a:t>
             </a:r>
           </a:p>
           <a:p>
@@ -17442,7 +17442,7 @@
             </a:pPr>
             <a:r>
               <a:rPr lang="en"/>
-              <a:t>Make the enemy a beetle; then change the room in tilemap-definition.xml</a:t>
+              <a:t>Make the enemy a beetle: which line of C# changes?</a:t>
             </a:r>
             <a:endParaRPr/>
           </a:p>

</xml_diff>

<commit_message>
Snake: an animated clip, played by a small bot that reads the screen and steers towards the bat
Co-Authored-By: Claude Opus 5.5 <noreply@anthropic.com>
Claude-Session: https://claude.ai/code/session_012sjsUQBbC7zon57rWHoo9d
</commit_message>
<xml_diff>
--- a/slides/03 Snake.pptx
+++ b/slides/03 Snake.pptx
@@ -14166,14 +14166,14 @@
       </p:sp>
       <p:pic>
         <p:nvPicPr>
-          <p:cNvPr id="46" name="Picture 46" descr="snake9.png"/>
+          <p:cNvPr id="46" name="Picture 46" descr="snake.gif"/>
           <p:cNvPicPr>
             <a:picLocks noChangeAspect="1"/>
           </p:cNvPicPr>
           <p:nvPr/>
         </p:nvPicPr>
         <p:blipFill>
-          <a:blip r:embed="rId4"/>
+          <a:blip r:embed="rId3"/>
           <a:stretch>
             <a:fillRect/>
           </a:stretch>
@@ -14181,7 +14181,7 @@
         <p:spPr>
           <a:xfrm>
             <a:off x="1846087" y="1626274"/>
-            <a:ext cx="5451825" cy="3066651"/>
+            <a:ext cx="5451824" cy="3066651"/>
           </a:xfrm>
           <a:prstGeom prst="rect">
             <a:avLst/>

</xml_diff>

<commit_message>
Our own characters in the originals' settings on the site and in the decks: Mario's builder and moles, Snake's mouse, Zelda's hero in green
The recording recipes cover Mario and Zelda too; the Snake bot looks for the mouse.

Co-Authored-By: Claude Opus 5.5 <noreply@anthropic.com>
Claude-Session: https://claude.ai/code/session_012sjsUQBbC7zon57rWHoo9d
</commit_message>
<xml_diff>
--- a/slides/03 Snake.pptx
+++ b/slides/03 Snake.pptx
@@ -1103,7 +1103,7 @@
           <a:lstStyle/>
           <a:p>
             <a:r>
-              <a:t>An animation: a list of regions and a delay. The bottom bat cycles through the three above.</a:t>
+              <a:t>An animation: a list of regions and a delay. The bottom mouse cycles through the three above.</a:t>
             </a:r>
           </a:p>
         </p:txBody>
@@ -1975,7 +1975,7 @@
           </a:p>
           <a:p>
             <a:r>
-              <a:t>Answer: none of them need C#. A faster bat is a delay, an extra frame is a Frame line, a new room is the tilemap file.</a:t>
+              <a:t>Answer: none of them need C#. A faster mouse is a delay, an extra frame is a Frame line, a new room is the tilemap file.</a:t>
             </a:r>
           </a:p>
         </p:txBody>
@@ -2770,7 +2770,7 @@
           </a:p>
           <a:p>
             <a:r>
-              <a:t>- eating the bat grows the snake</a:t>
+              <a:t>- eating the mouse grows the snake</a:t>
             </a:r>
           </a:p>
           <a:p>
@@ -3151,7 +3151,7 @@
           </a:p>
           <a:p>
             <a:r>
-              <a:t>Ask afterwards: how much C# did you change? One string. And for a beetle next to the bat? A lot: Game1 handles the bat by name (its collisions, its bounces). That is the next architecture problem, not a data one.</a:t>
+              <a:t>Ask afterwards: how much C# did you change? One string. And for a beetle next to the mouse? A lot: Game1 handles the mouse by name (its collisions, its bounces). That is the next architecture problem, not a data one.</a:t>
             </a:r>
           </a:p>
         </p:txBody>
@@ -3523,7 +3523,7 @@
           </a:p>
           <a:p>
             <a:r>
-              <a:t>Answer: without CenterOrigin the bat spins around its top-left corner, because the origin is where rotation and scale start from.</a:t>
+              <a:t>Answer: without CenterOrigin the mouse spins around its top-left corner, because the origin is where rotation and scale start from.</a:t>
             </a:r>
           </a:p>
         </p:txBody>
@@ -3581,7 +3581,7 @@
           <a:lstStyle/>
           <a:p>
             <a:r>
-              <a:t>Pairs, about 5 minutes, in Snake1. Moving the bat-1 rectangle is enough; no C#.</a:t>
+              <a:t>Pairs, about 5 minutes, in Snake1. Moving the mouse-1 rectangle is enough; no C#.</a:t>
             </a:r>
           </a:p>
           <a:p>
@@ -7779,14 +7779,14 @@
       </p:sp>
       <p:pic>
         <p:nvPicPr>
-          <p:cNvPr id="85" name="Picture 87" descr="snake_atlas.png"/>
+          <p:cNvPr id="85" name="Picture 87" descr="atlas_region.png"/>
           <p:cNvPicPr>
             <a:picLocks noChangeAspect="1"/>
           </p:cNvPicPr>
           <p:nvPr/>
         </p:nvPicPr>
         <p:blipFill>
-          <a:blip r:embed="rId4"/>
+          <a:blip r:embed="rId3"/>
           <a:stretch>
             <a:fillRect/>
           </a:stretch>
@@ -8120,7 +8120,7 @@
             </a:pPr>
             <a:r>
               <a:rPr lang="en"/>
-              <a:t>Draw the bat with its second frame (x 20, y 20)</a:t>
+              <a:t>Draw the mouse with its second frame (x 20, y 20)</a:t>
             </a:r>
             <a:endParaRPr/>
           </a:p>
@@ -8137,7 +8137,7 @@
             </a:pPr>
             <a:r>
               <a:rPr lang="en"/>
-              <a:t>Then misspell bat-1 in the XML. What happens, and when?</a:t>
+              <a:t>Then misspell mouse-1 in the XML. What happens, and when?</a:t>
             </a:r>
             <a:endParaRPr/>
           </a:p>
@@ -8396,20 +8396,20 @@
       </p:sp>
       <p:pic>
         <p:nvPicPr>
-          <p:cNvPr id="100" name="Picture 105" descr="snake_sprite.png"/>
+          <p:cNvPr id="100" name="Picture 105" descr="sprite.png"/>
           <p:cNvPicPr>
             <a:picLocks noChangeAspect="1"/>
           </p:cNvPicPr>
           <p:nvPr/>
         </p:nvPicPr>
         <p:blipFill>
-          <a:blip r:embed="rId4"/>
+          <a:blip r:embed="rId3"/>
           <a:stretch>
             <a:fillRect/>
           </a:stretch>
         </p:blipFill>
         <p:spPr>
-          <a:xfrm rot="20408050">
+          <a:xfrm>
             <a:off x="3478224" y="1282475"/>
             <a:ext cx="2187550" cy="2187550"/>
           </a:xfrm>
@@ -9112,7 +9112,7 @@
             </a:pPr>
             <a:r>
               <a:rPr lang="en"/>
-              <a:t>Make the bat bigger, and spin it the other way</a:t>
+              <a:t>Make the mouse bigger, and spin it the other way</a:t>
             </a:r>
             <a:endParaRPr/>
           </a:p>
@@ -9295,14 +9295,14 @@
       </p:sp>
       <p:pic>
         <p:nvPicPr>
-          <p:cNvPr id="123" name="Picture 123" descr="bat_animation.gif"/>
+          <p:cNvPr id="123" name="Picture 123" descr="animation.gif"/>
           <p:cNvPicPr>
             <a:picLocks noChangeAspect="1"/>
           </p:cNvPicPr>
           <p:nvPr/>
         </p:nvPicPr>
         <p:blipFill>
-          <a:blip r:embed="rId4"/>
+          <a:blip r:embed="rId3"/>
           <a:stretch>
             <a:fillRect/>
           </a:stretch>
@@ -9625,7 +9625,7 @@
             </a:pPr>
             <a:r>
               <a:rPr lang="en"/>
-              <a:t>Make the bat flap twice as fast, and the snake breathe slower</a:t>
+              <a:t>Make the mouse’s tail wiggle twice as fast, and the snake breathe slower</a:t>
             </a:r>
             <a:endParaRPr/>
           </a:p>
@@ -9642,7 +9642,7 @@
             </a:pPr>
             <a:r>
               <a:rPr lang="en"/>
-              <a:t>Give the bat’s animation one more frame</a:t>
+              <a:t>Give the mouse’s animation one more frame</a:t>
             </a:r>
             <a:endParaRPr/>
           </a:p>
@@ -9828,14 +9828,14 @@
       </p:sp>
       <p:pic>
         <p:nvPicPr>
-          <p:cNvPr id="266" name="Picture 267" descr="snake_tileset.png"/>
+          <p:cNvPr id="266" name="Picture 267" descr="tileset.png"/>
           <p:cNvPicPr>
             <a:picLocks noChangeAspect="1"/>
           </p:cNvPicPr>
           <p:nvPr/>
         </p:nvPicPr>
         <p:blipFill>
-          <a:blip r:embed="rId4"/>
+          <a:blip r:embed="rId3"/>
           <a:stretch>
             <a:fillRect/>
           </a:stretch>
@@ -9852,14 +9852,14 @@
       </p:pic>
       <p:pic>
         <p:nvPicPr>
-          <p:cNvPr id="267" name="Picture 267" descr="snake_tileset_labelled.png"/>
+          <p:cNvPr id="267" name="Picture 267" descr="tileset_numbers.png"/>
           <p:cNvPicPr>
             <a:picLocks noChangeAspect="1"/>
           </p:cNvPicPr>
           <p:nvPr/>
         </p:nvPicPr>
         <p:blipFill>
-          <a:blip r:embed="rId5"/>
+          <a:blip r:embed="rId6"/>
           <a:stretch>
             <a:fillRect/>
           </a:stretch>
@@ -10061,14 +10061,14 @@
       </p:sp>
       <p:pic>
         <p:nvPicPr>
-          <p:cNvPr id="273" name="Picture 275" descr="snake_tileset_labelled.png"/>
+          <p:cNvPr id="273" name="Picture 275" descr="tileset_numbers.png"/>
           <p:cNvPicPr>
             <a:picLocks noChangeAspect="1"/>
           </p:cNvPicPr>
           <p:nvPr/>
         </p:nvPicPr>
         <p:blipFill>
-          <a:blip r:embed="rId4"/>
+          <a:blip r:embed="rId3"/>
           <a:stretch>
             <a:fillRect/>
           </a:stretch>
@@ -10906,14 +10906,14 @@
       </p:sp>
       <p:pic>
         <p:nvPicPr>
-          <p:cNvPr id="275" name="Picture 275" descr="snake_room.png"/>
+          <p:cNvPr id="275" name="Picture 275" descr="room_tiles.png"/>
           <p:cNvPicPr>
             <a:picLocks noChangeAspect="1"/>
           </p:cNvPicPr>
           <p:nvPr/>
         </p:nvPicPr>
         <p:blipFill>
-          <a:blip r:embed="rId5"/>
+          <a:blip r:embed="rId6"/>
           <a:stretch>
             <a:fillRect/>
           </a:stretch>
@@ -14114,7 +14114,7 @@
           <p:nvPr/>
         </p:nvPicPr>
         <p:blipFill>
-          <a:blip r:embed="rId3"/>
+          <a:blip r:embed="rId4"/>
           <a:stretch>
             <a:fillRect/>
           </a:stretch>
@@ -17400,7 +17400,7 @@
             </a:pPr>
             <a:r>
               <a:rPr lang="en"/>
-              <a:t>How much C# did you change? And for a beetle next to the bat?</a:t>
+              <a:t>How much C# did you change? And for a beetle next to the mouse?</a:t>
             </a:r>
             <a:endParaRPr/>
           </a:p>
@@ -21615,7 +21615,7 @@
           <a:p>
             <a:pPr algn="l"/>
             <a:r>
-              <a:rPr sz="1400" b="0">
+              <a:rPr sz="1300" b="0">
                 <a:solidFill>
                   <a:srgbClr val="DEE2E6"/>
                 </a:solidFill>
@@ -21623,43 +21623,43 @@
               <a:t/>
             </a:r>
             <a:r>
-              <a:rPr sz="1100">
+              <a:rPr sz="1000">
                 <a:solidFill>
                   <a:srgbClr val="DEE2E6"/>
                 </a:solidFill>
                 <a:latin typeface="Consolas"/>
               </a:rPr>
-              <a:t>&lt;Region name="bat-1" x="20" y="0" width="20" height="20" /&gt;</a:t>
+              <a:t>&lt;Region name="mouse-1" x="20" y="0" width="20" height="20" /&gt;</a:t>
             </a:r>
           </a:p>
           <a:p>
             <a:pPr algn="l"/>
             <a:r>
-              <a:rPr sz="1100">
+              <a:rPr sz="1000">
                 <a:solidFill>
                   <a:srgbClr val="DEE2E6"/>
                 </a:solidFill>
                 <a:latin typeface="Consolas"/>
               </a:rPr>
-              <a:t>&lt;Region name="bat-2" x="20" y="20" width="20" height="20" /&gt;</a:t>
+              <a:t>&lt;Region name="mouse-2" x="20" y="20" width="20" height="20" /&gt;</a:t>
             </a:r>
           </a:p>
           <a:p>
             <a:pPr algn="l"/>
             <a:r>
-              <a:rPr sz="1100">
+              <a:rPr sz="1000">
                 <a:solidFill>
                   <a:srgbClr val="DEE2E6"/>
                 </a:solidFill>
                 <a:latin typeface="Consolas"/>
               </a:rPr>
-              <a:t>&lt;Region name="bat-3" x="40" y="0" width="20" height="20" /&gt;</a:t>
+              <a:t>&lt;Region name="mouse-3" x="40" y="0" width="20" height="20" /&gt;</a:t>
             </a:r>
           </a:p>
           <a:p>
             <a:pPr algn="l"/>
             <a:r>
-              <a:rPr sz="1100">
+              <a:rPr sz="1000">
                 <a:solidFill>
                   <a:srgbClr val="DEE2E6"/>
                 </a:solidFill>
@@ -21671,67 +21671,67 @@
           <a:p>
             <a:pPr algn="l"/>
             <a:r>
-              <a:rPr sz="1100">
+              <a:rPr sz="1000">
                 <a:solidFill>
                   <a:srgbClr val="DEE2E6"/>
                 </a:solidFill>
                 <a:latin typeface="Consolas"/>
               </a:rPr>
-              <a:t>&lt;Animation name="bat-animation" delay="200"&gt;</a:t>
+              <a:t>&lt;Animation name="mouse-animation" delay="200"&gt;</a:t>
             </a:r>
           </a:p>
           <a:p>
             <a:pPr algn="l"/>
             <a:r>
-              <a:rPr sz="1100">
+              <a:rPr sz="1000">
                 <a:solidFill>
                   <a:srgbClr val="DEE2E6"/>
                 </a:solidFill>
                 <a:latin typeface="Consolas"/>
               </a:rPr>
-              <a:t>    &lt;Frame region="bat-1" /&gt;</a:t>
+              <a:t>    &lt;Frame region="mouse-1" /&gt;</a:t>
             </a:r>
           </a:p>
           <a:p>
             <a:pPr algn="l"/>
             <a:r>
-              <a:rPr sz="1100">
+              <a:rPr sz="1000">
                 <a:solidFill>
                   <a:srgbClr val="DEE2E6"/>
                 </a:solidFill>
                 <a:latin typeface="Consolas"/>
               </a:rPr>
-              <a:t>    &lt;Frame region="bat-2" /&gt;</a:t>
+              <a:t>    &lt;Frame region="mouse-2" /&gt;</a:t>
             </a:r>
           </a:p>
           <a:p>
             <a:pPr algn="l"/>
             <a:r>
-              <a:rPr sz="1100">
+              <a:rPr sz="1000">
                 <a:solidFill>
                   <a:srgbClr val="DEE2E6"/>
                 </a:solidFill>
                 <a:latin typeface="Consolas"/>
               </a:rPr>
-              <a:t>    &lt;Frame region="bat-1" /&gt;</a:t>
+              <a:t>    &lt;Frame region="mouse-1" /&gt;</a:t>
             </a:r>
           </a:p>
           <a:p>
             <a:pPr algn="l"/>
             <a:r>
-              <a:rPr sz="1100">
+              <a:rPr sz="1000">
                 <a:solidFill>
                   <a:srgbClr val="DEE2E6"/>
                 </a:solidFill>
                 <a:latin typeface="Consolas"/>
               </a:rPr>
-              <a:t>    &lt;Frame region="bat-3" /&gt;</a:t>
+              <a:t>    &lt;Frame region="mouse-3" /&gt;</a:t>
             </a:r>
           </a:p>
           <a:p>
             <a:pPr algn="l"/>
             <a:r>
-              <a:rPr sz="1100">
+              <a:rPr sz="1000">
                 <a:solidFill>
                   <a:srgbClr val="DEE2E6"/>
                 </a:solidFill>
@@ -21771,7 +21771,7 @@
                   <a:srgbClr val="DEE2E6"/>
                 </a:solidFill>
               </a:rPr>
-              <a:t>A faster bat?</a:t>
+              <a:t>A faster mouse?</a:t>
             </a:r>
           </a:p>
           <a:p>
@@ -21909,14 +21909,14 @@
       </p:sp>
       <p:pic>
         <p:nvPicPr>
-          <p:cNvPr id="64" name="Picture 73" descr="bat1.png"/>
+          <p:cNvPr id="64" name="Picture 73" descr="mouse1.png"/>
           <p:cNvPicPr>
             <a:picLocks noChangeAspect="1"/>
           </p:cNvPicPr>
           <p:nvPr/>
         </p:nvPicPr>
         <p:blipFill>
-          <a:blip r:embed="rId6"/>
+          <a:blip r:embed="rId3"/>
           <a:stretch>
             <a:fillRect/>
           </a:stretch>
@@ -21933,7 +21933,7 @@
       </p:pic>
       <p:pic>
         <p:nvPicPr>
-          <p:cNvPr id="65" name="Picture 73" descr="snake1.png"/>
+          <p:cNvPr id="65" name="Picture 73" descr="image.png"/>
           <p:cNvPicPr>
             <a:picLocks noChangeAspect="1"/>
           </p:cNvPicPr>
@@ -21957,7 +21957,7 @@
       </p:pic>
       <p:pic>
         <p:nvPicPr>
-          <p:cNvPr id="66" name="Picture 73" descr="snake2.png"/>
+          <p:cNvPr id="66" name="Picture 73" descr="image.png"/>
           <p:cNvPicPr>
             <a:picLocks noChangeAspect="1"/>
           </p:cNvPicPr>
@@ -21981,14 +21981,14 @@
       </p:pic>
       <p:pic>
         <p:nvPicPr>
-          <p:cNvPr id="67" name="Picture 73" descr="snake_atlas.png"/>
+          <p:cNvPr id="67" name="Picture 73" descr="atlas.png"/>
           <p:cNvPicPr>
             <a:picLocks noChangeAspect="1"/>
           </p:cNvPicPr>
           <p:nvPr/>
         </p:nvPicPr>
         <p:blipFill>
-          <a:blip r:embed="rId8"/>
+          <a:blip r:embed="rId10"/>
           <a:stretch>
             <a:fillRect/>
           </a:stretch>
@@ -22005,14 +22005,14 @@
       </p:pic>
       <p:pic>
         <p:nvPicPr>
-          <p:cNvPr id="68" name="Picture 73" descr="floor.png"/>
+          <p:cNvPr id="68" name="Picture 73" descr="grass.png"/>
           <p:cNvPicPr>
             <a:picLocks noChangeAspect="1"/>
           </p:cNvPicPr>
           <p:nvPr/>
         </p:nvPicPr>
         <p:blipFill>
-          <a:blip r:embed="rId7"/>
+          <a:blip r:embed="rId9"/>
           <a:stretch>
             <a:fillRect/>
           </a:stretch>
@@ -22187,7 +22187,7 @@
                 <a:cs typeface="VT323"/>
                 <a:sym typeface="VT323"/>
               </a:rPr>
-              <a:t>bat1.png</a:t>
+              <a:t>mouse1.png</a:t>
             </a:r>
             <a:endParaRPr sz="900">
               <a:solidFill>
@@ -22245,7 +22245,7 @@
                 <a:cs typeface="VT323"/>
                 <a:sym typeface="VT323"/>
               </a:rPr>
-              <a:t>floor.png</a:t>
+              <a:t>grass.png</a:t>
             </a:r>
             <a:endParaRPr sz="900">
               <a:solidFill>
@@ -22786,14 +22786,14 @@
       </p:sp>
       <p:pic>
         <p:nvPicPr>
-          <p:cNvPr id="79" name="Picture 79" descr="snake_atlas.png"/>
+          <p:cNvPr id="79" name="Picture 79" descr="atlas.png"/>
           <p:cNvPicPr>
             <a:picLocks noChangeAspect="1"/>
           </p:cNvPicPr>
           <p:nvPr/>
         </p:nvPicPr>
         <p:blipFill>
-          <a:blip r:embed="rId4"/>
+          <a:blip r:embed="rId3"/>
           <a:stretch>
             <a:fillRect/>
           </a:stretch>

</xml_diff>

<commit_message>
Snake: an apple instead of the mouse, on the page, the deck and the recording bot
Co-Authored-By: Claude Opus 5.5 <noreply@anthropic.com>
Claude-Session: https://claude.ai/code/session_012sjsUQBbC7zon57rWHoo9d
</commit_message>
<xml_diff>
--- a/slides/03 Snake.pptx
+++ b/slides/03 Snake.pptx
@@ -1103,7 +1103,7 @@
           <a:lstStyle/>
           <a:p>
             <a:r>
-              <a:t>An animation: a list of regions and a delay. The bottom mouse cycles through the three above.</a:t>
+              <a:t>An animation: a list of regions and a delay. The bottom apple cycles through the three above.</a:t>
             </a:r>
           </a:p>
         </p:txBody>
@@ -1975,7 +1975,7 @@
           </a:p>
           <a:p>
             <a:r>
-              <a:t>Answer: none of them need C#. A faster mouse is a delay, an extra frame is a Frame line, a new room is the tilemap file.</a:t>
+              <a:t>Answer: none of them need C#. A faster animation is a delay, an extra frame is a Frame line, a new room is the tilemap file.</a:t>
             </a:r>
           </a:p>
         </p:txBody>
@@ -2770,7 +2770,7 @@
           </a:p>
           <a:p>
             <a:r>
-              <a:t>- eating the mouse grows the snake</a:t>
+              <a:t>- eating the apple grows the snake</a:t>
             </a:r>
           </a:p>
           <a:p>
@@ -3151,7 +3151,7 @@
           </a:p>
           <a:p>
             <a:r>
-              <a:t>Ask afterwards: how much C# did you change? One string. And for a beetle next to the mouse? A lot: Game1 handles the mouse by name (its collisions, its bounces). Data can’t fix that; it’s the next architecture problem.</a:t>
+              <a:t>Ask afterwards: how much C# did you change? One string. And for a beetle next to the apple? A lot: Game1 handles the apple by name (its field, its respawn, its collision). Data can’t fix that; it’s the next architecture problem.</a:t>
             </a:r>
           </a:p>
         </p:txBody>
@@ -3523,7 +3523,7 @@
           </a:p>
           <a:p>
             <a:r>
-              <a:t>Answer: without CenterOrigin the mouse spins around its top-left corner, because the origin is where rotation and scale start from.</a:t>
+              <a:t>Answer: without CenterOrigin the apple spins around its top-left corner, because the origin is where rotation and scale start from.</a:t>
             </a:r>
           </a:p>
         </p:txBody>
@@ -3581,7 +3581,7 @@
           <a:lstStyle/>
           <a:p>
             <a:r>
-              <a:t>Pairs, about 5 minutes, in Snake1. Moving the mouse-1 rectangle is enough; no C#.</a:t>
+              <a:t>Pairs, about 5 minutes, in Snake1. Moving the apple-1 rectangle is enough; no C#.</a:t>
             </a:r>
           </a:p>
           <a:p>
@@ -8120,7 +8120,7 @@
             </a:pPr>
             <a:r>
               <a:rPr lang="en"/>
-              <a:t>Draw the mouse with its second frame (x 20, y 20)</a:t>
+              <a:t>Draw the apple with its second frame (x 20, y 20)</a:t>
             </a:r>
             <a:endParaRPr/>
           </a:p>
@@ -8137,7 +8137,7 @@
             </a:pPr>
             <a:r>
               <a:rPr lang="en"/>
-              <a:t>Then misspell mouse-1 in the XML. What happens, and when?</a:t>
+              <a:t>Then misspell apple-1 in the XML. What happens, and when?</a:t>
             </a:r>
             <a:endParaRPr/>
           </a:p>
@@ -9112,7 +9112,7 @@
             </a:pPr>
             <a:r>
               <a:rPr lang="en"/>
-              <a:t>Make the mouse bigger, and spin it the other way</a:t>
+              <a:t>Make the apple bigger, and spin it the other way</a:t>
             </a:r>
             <a:endParaRPr/>
           </a:p>
@@ -9625,7 +9625,7 @@
             </a:pPr>
             <a:r>
               <a:rPr lang="en"/>
-              <a:t>Make the mouse’s tail wiggle twice as fast, and the snake breathe slower</a:t>
+              <a:t>Make the apple’s leaf sway twice as fast, and the snake breathe slower</a:t>
             </a:r>
             <a:endParaRPr/>
           </a:p>
@@ -9642,7 +9642,7 @@
             </a:pPr>
             <a:r>
               <a:rPr lang="en"/>
-              <a:t>Give the mouse’s animation one more frame</a:t>
+              <a:t>Give the apple’s animation one more frame</a:t>
             </a:r>
             <a:endParaRPr/>
           </a:p>
@@ -17400,7 +17400,7 @@
             </a:pPr>
             <a:r>
               <a:rPr lang="en"/>
-              <a:t>How much C# did you change? And for a beetle next to the mouse?</a:t>
+              <a:t>How much C# did you change? And for a beetle next to the apple?</a:t>
             </a:r>
             <a:endParaRPr/>
           </a:p>
@@ -21646,7 +21646,7 @@
                 </a:solidFill>
                 <a:latin typeface="Consolas"/>
               </a:rPr>
-              <a:t>&lt;Region name="mouse-1" x="20" y="0" width="20" height="20" /&gt;</a:t>
+              <a:t>&lt;Region name="apple-1" x="20" y="0" width="20" height="20" /&gt;</a:t>
             </a:r>
           </a:p>
           <a:p>
@@ -21658,7 +21658,7 @@
                 </a:solidFill>
                 <a:latin typeface="Consolas"/>
               </a:rPr>
-              <a:t>&lt;Region name="mouse-2" x="20" y="20" width="20" height="20" /&gt;</a:t>
+              <a:t>&lt;Region name="apple-2" x="20" y="20" width="20" height="20" /&gt;</a:t>
             </a:r>
           </a:p>
           <a:p>
@@ -21670,7 +21670,7 @@
                 </a:solidFill>
                 <a:latin typeface="Consolas"/>
               </a:rPr>
-              <a:t>&lt;Region name="mouse-3" x="40" y="0" width="20" height="20" /&gt;</a:t>
+              <a:t>&lt;Region name="apple-3" x="40" y="0" width="20" height="20" /&gt;</a:t>
             </a:r>
           </a:p>
           <a:p>
@@ -21694,7 +21694,7 @@
                 </a:solidFill>
                 <a:latin typeface="Consolas"/>
               </a:rPr>
-              <a:t>&lt;Animation name="mouse-animation" delay="200"&gt;</a:t>
+              <a:t>&lt;Animation name="apple-animation" delay="200"&gt;</a:t>
             </a:r>
           </a:p>
           <a:p>
@@ -21706,7 +21706,7 @@
                 </a:solidFill>
                 <a:latin typeface="Consolas"/>
               </a:rPr>
-              <a:t>    &lt;Frame region="mouse-1" /&gt;</a:t>
+              <a:t>    &lt;Frame region="apple-1" /&gt;</a:t>
             </a:r>
           </a:p>
           <a:p>
@@ -21718,7 +21718,7 @@
                 </a:solidFill>
                 <a:latin typeface="Consolas"/>
               </a:rPr>
-              <a:t>    &lt;Frame region="mouse-2" /&gt;</a:t>
+              <a:t>    &lt;Frame region="apple-2" /&gt;</a:t>
             </a:r>
           </a:p>
           <a:p>
@@ -21730,7 +21730,7 @@
                 </a:solidFill>
                 <a:latin typeface="Consolas"/>
               </a:rPr>
-              <a:t>    &lt;Frame region="mouse-1" /&gt;</a:t>
+              <a:t>    &lt;Frame region="apple-1" /&gt;</a:t>
             </a:r>
           </a:p>
           <a:p>
@@ -21742,7 +21742,7 @@
                 </a:solidFill>
                 <a:latin typeface="Consolas"/>
               </a:rPr>
-              <a:t>    &lt;Frame region="mouse-3" /&gt;</a:t>
+              <a:t>    &lt;Frame region="apple-3" /&gt;</a:t>
             </a:r>
           </a:p>
           <a:p>
@@ -21788,7 +21788,7 @@
                   <a:srgbClr val="DEE2E6"/>
                 </a:solidFill>
               </a:rPr>
-              <a:t>A faster mouse?</a:t>
+              <a:t>A faster animation?</a:t>
             </a:r>
           </a:p>
           <a:p>
@@ -22204,7 +22204,7 @@
                 <a:cs typeface="VT323"/>
                 <a:sym typeface="VT323"/>
               </a:rPr>
-              <a:t>mouse1.png</a:t>
+              <a:t>apple1.png</a:t>
             </a:r>
             <a:endParaRPr sz="900">
               <a:solidFill>

</xml_diff>

<commit_message>
Snake in lit dots: page, deck diagrams, course notes and the recording bot
The page and deck follow the new atlas: the head's regions and blinking animation,
the nine-tile frame, the food, the score's digit regions and the bug exercise. The
deck's atlas, sprite, animation and tileset pictures are drawn from the new atlas.
The course notes drop the shared outline style: each game has its own look. The
bot finds the snake and the food by their dots.

Co-Authored-By: Claude Opus 5.5 <noreply@anthropic.com>
Claude-Session: https://claude.ai/code/session_012sjsUQBbC7zon57rWHoo9d
</commit_message>
<xml_diff>
--- a/slides/03 Snake.pptx
+++ b/slides/03 Snake.pptx
@@ -1103,7 +1103,7 @@
           <a:lstStyle/>
           <a:p>
             <a:r>
-              <a:t>An animation: a list of regions and a delay. The bottom apple cycles through the three above.</a:t>
+              <a:t>An animation: a list of regions and a delay. The head at the bottom plays the frames above: five with its eyes open, one with them closed, so it blinks.</a:t>
             </a:r>
           </a:p>
         </p:txBody>
@@ -2770,7 +2770,7 @@
           </a:p>
           <a:p>
             <a:r>
-              <a:t>- eating the apple grows the snake</a:t>
+              <a:t>- eating the food grows the snake and adds a point</a:t>
             </a:r>
           </a:p>
           <a:p>
@@ -2953,7 +2953,7 @@
           <a:lstStyle/>
           <a:p>
             <a:r>
-              <a:t>The numbers in the middle are the room. Find tile 6 (the torch) and tile 9 (the floor) together.</a:t>
+              <a:t>The numbers in the middle are the room. Find tile 4 (the floor) and the four corners together.</a:t>
             </a:r>
           </a:p>
         </p:txBody>
@@ -3146,12 +3146,12 @@
           <a:lstStyle/>
           <a:p>
             <a:r>
-              <a:t>Exercise: the beetle is drawn in the atlas but not described. Two regions and an animation in the XML, then one line of C# (the animation name).</a:t>
-            </a:r>
-          </a:p>
-          <a:p>
-            <a:r>
-              <a:t>Ask afterwards: how much C# did you change? One string. And for a beetle next to the apple? A lot: Game1 handles the apple by name (its field, its respawn, its collision). Data can’t fix that; it’s the next architecture problem.</a:t>
+              <a:t>Exercise: the bug is drawn in the atlas but not described. Two regions and an animation in the XML, then one line of C# (the animation name).</a:t>
+            </a:r>
+          </a:p>
+          <a:p>
+            <a:r>
+              <a:t>Ask afterwards: how much C# did you change? One string. And for a bug next to the food? A lot: Game1 handles the food by name (its field, its respawn, its collision). Data can’t fix that; it’s the next architecture problem.</a:t>
             </a:r>
           </a:p>
         </p:txBody>
@@ -3308,7 +3308,7 @@
           </a:p>
           <a:p>
             <a:r>
-              <a:t>Answer for the 20: the tileset has 16 tiles (0 to 15), so the game fails when it draws the room. Same lesson as the misspelled region: data errors appear at runtime.</a:t>
+              <a:t>The new wall doesn’t stop the snake: the tilemap is only a picture, and the room’s Rectangle decides. Answer for the 9: the tileset has 9 tiles (0 to 8), so the game fails when it draws the room. Same lesson as the misspelled region: data errors appear at runtime.</a:t>
             </a:r>
           </a:p>
         </p:txBody>
@@ -3523,7 +3523,7 @@
           </a:p>
           <a:p>
             <a:r>
-              <a:t>Answer: without CenterOrigin the apple spins around its top-left corner, because the origin is where rotation and scale start from.</a:t>
+              <a:t>Answer: without CenterOrigin the head spins around its top-left corner, because the origin is where rotation and scale start from.</a:t>
             </a:r>
           </a:p>
         </p:txBody>
@@ -3581,7 +3581,7 @@
           <a:lstStyle/>
           <a:p>
             <a:r>
-              <a:t>Pairs, about 5 minutes, in Snake1. Moving the apple-1 rectangle is enough; no C#.</a:t>
+              <a:t>Pairs, about 5 minutes, in Snake1. Moving the food-1 rectangle is enough; no C#.</a:t>
             </a:r>
           </a:p>
           <a:p>
@@ -7779,22 +7779,22 @@
       </p:sp>
       <p:pic>
         <p:nvPicPr>
-          <p:cNvPr id="85" name="Picture 87" descr="atlas_region.png"/>
+          <p:cNvPr id="85" name="Picture 87" descr="atlas.png"/>
           <p:cNvPicPr>
             <a:picLocks noChangeAspect="1"/>
           </p:cNvPicPr>
           <p:nvPr/>
         </p:nvPicPr>
         <p:blipFill>
-          <a:blip r:embed="rId4"/>
+          <a:blip r:embed="rId3"/>
           <a:stretch>
             <a:fillRect/>
           </a:stretch>
         </p:blipFill>
         <p:spPr>
           <a:xfrm>
-            <a:off x="3897617" y="1560179"/>
-            <a:ext cx="1348766" cy="2023149"/>
+            <a:off x="2743200" y="1325880"/>
+            <a:ext cx="3657600" cy="2286000"/>
           </a:xfrm>
           <a:prstGeom prst="rect">
             <a:avLst/>
@@ -7809,8 +7809,8 @@
         </p:nvSpPr>
         <p:spPr>
           <a:xfrm>
-            <a:off x="3872328" y="1534890"/>
-            <a:ext cx="387769" cy="387769"/>
+            <a:off x="3172968" y="1298448"/>
+            <a:ext cx="454914" cy="454914"/>
           </a:xfrm>
           <a:prstGeom prst="rect">
             <a:avLst/>
@@ -7864,7 +7864,7 @@
         </p:nvCxnSpPr>
         <p:spPr>
           <a:xfrm>
-            <a:off x="3571128" y="1084290"/>
+            <a:off x="2737668" y="847848"/>
             <a:ext cx="435300" cy="450600"/>
           </a:xfrm>
           <a:prstGeom prst="straightConnector1">
@@ -8120,7 +8120,7 @@
             </a:pPr>
             <a:r>
               <a:rPr lang="en"/>
-              <a:t>Draw the apple with its second frame (x 20, y 20)</a:t>
+              <a:t>Draw the food with its second frame (x 32, y 0)</a:t>
             </a:r>
             <a:endParaRPr/>
           </a:p>
@@ -8137,7 +8137,7 @@
             </a:pPr>
             <a:r>
               <a:rPr lang="en"/>
-              <a:t>Then misspell apple-1 in the XML. What happens, and when?</a:t>
+              <a:t>Then misspell food-1 in the XML. What happens, and when?</a:t>
             </a:r>
             <a:endParaRPr/>
           </a:p>
@@ -8403,7 +8403,7 @@
           <p:nvPr/>
         </p:nvPicPr>
         <p:blipFill>
-          <a:blip r:embed="rId4"/>
+          <a:blip r:embed="rId3"/>
           <a:stretch>
             <a:fillRect/>
           </a:stretch>
@@ -9112,7 +9112,7 @@
             </a:pPr>
             <a:r>
               <a:rPr lang="en"/>
-              <a:t>Make the apple bigger, and spin it the other way</a:t>
+              <a:t>Make the head bigger, and spin it the other way</a:t>
             </a:r>
             <a:endParaRPr/>
           </a:p>
@@ -9295,14 +9295,14 @@
       </p:sp>
       <p:pic>
         <p:nvPicPr>
-          <p:cNvPr id="123" name="Picture 123" descr="animation.gif"/>
+          <p:cNvPr id="123" name="Picture 123" descr="animation.png"/>
           <p:cNvPicPr>
             <a:picLocks noChangeAspect="1"/>
           </p:cNvPicPr>
           <p:nvPr/>
         </p:nvPicPr>
         <p:blipFill>
-          <a:blip r:embed="rId4"/>
+          <a:blip r:embed="rId3"/>
           <a:stretch>
             <a:fillRect/>
           </a:stretch>
@@ -9625,7 +9625,7 @@
             </a:pPr>
             <a:r>
               <a:rPr lang="en"/>
-              <a:t>Make the apple’s leaf sway twice as fast, and the snake breathe slower</a:t>
+              <a:t>Make the food pulse twice as fast, and the head blink less often</a:t>
             </a:r>
             <a:endParaRPr/>
           </a:p>
@@ -9642,7 +9642,7 @@
             </a:pPr>
             <a:r>
               <a:rPr lang="en"/>
-              <a:t>Give the apple’s animation one more frame</a:t>
+              <a:t>Give the food’s animation one more frame</a:t>
             </a:r>
             <a:endParaRPr/>
           </a:p>
@@ -9835,7 +9835,7 @@
           <p:nvPr/>
         </p:nvPicPr>
         <p:blipFill>
-          <a:blip r:embed="rId3"/>
+          <a:blip r:embed="rId5"/>
           <a:stretch>
             <a:fillRect/>
           </a:stretch>
@@ -9852,14 +9852,14 @@
       </p:pic>
       <p:pic>
         <p:nvPicPr>
-          <p:cNvPr id="267" name="Picture 267" descr="tileset_numbers.png"/>
+          <p:cNvPr id="267" name="Picture 267" descr="tileset_numbered.png"/>
           <p:cNvPicPr>
             <a:picLocks noChangeAspect="1"/>
           </p:cNvPicPr>
           <p:nvPr/>
         </p:nvPicPr>
         <p:blipFill>
-          <a:blip r:embed="rId6"/>
+          <a:blip r:embed="rId4"/>
           <a:stretch>
             <a:fillRect/>
           </a:stretch>
@@ -10061,14 +10061,14 @@
       </p:sp>
       <p:pic>
         <p:nvPicPr>
-          <p:cNvPr id="273" name="Picture 275" descr="tileset_numbers.png"/>
+          <p:cNvPr id="273" name="Picture 275" descr="tileset_numbered.png"/>
           <p:cNvPicPr>
             <a:picLocks noChangeAspect="1"/>
           </p:cNvPicPr>
           <p:nvPr/>
         </p:nvPicPr>
         <p:blipFill>
-          <a:blip r:embed="rId3"/>
+          <a:blip r:embed="rId5"/>
           <a:stretch>
             <a:fillRect/>
           </a:stretch>
@@ -10134,23 +10134,34 @@
                 <a:cs typeface="Consolas"/>
                 <a:sym typeface="Consolas"/>
               </a:rPr>
-              <a:t>00</a:t>
-            </a:r>
-            <a:r>
-              <a:rPr lang="en" sz="1000">
-                <a:solidFill>
-                  <a:srgbClr val="CCCCCC"/>
-                </a:solidFill>
-                <a:highlight>
-                  <a:srgbClr val="1F1F1F"/>
-                </a:highlight>
-                <a:latin typeface="Consolas"/>
-                <a:ea typeface="Consolas"/>
-                <a:cs typeface="Consolas"/>
-                <a:sym typeface="Consolas"/>
-              </a:rPr>
-              <a:t> </a:t>
-            </a:r>
+              <a:t>00 01 01 01 02</a:t>
+            </a:r>
+            <a:endParaRPr sz="1000">
+              <a:solidFill>
+                <a:srgbClr val="B5CEA8"/>
+              </a:solidFill>
+              <a:highlight>
+                <a:srgbClr val="1F1F1F"/>
+              </a:highlight>
+              <a:latin typeface="Consolas"/>
+              <a:ea typeface="Consolas"/>
+              <a:cs typeface="Consolas"/>
+              <a:sym typeface="Consolas"/>
+            </a:endParaRPr>
+          </a:p>
+          <a:p>
+            <a:pPr indent="0" lvl="0" marL="0" rtl="0" algn="l">
+              <a:lnSpc>
+                <a:spcPct val="157500"/>
+              </a:lnSpc>
+              <a:spcBef>
+                <a:spcPts val="0"/>
+              </a:spcBef>
+              <a:spcAft>
+                <a:spcPts val="0"/>
+              </a:spcAft>
+              <a:buNone/>
+            </a:pPr>
             <a:r>
               <a:rPr lang="en" sz="1000">
                 <a:solidFill>
@@ -10164,23 +10175,34 @@
                 <a:cs typeface="Consolas"/>
                 <a:sym typeface="Consolas"/>
               </a:rPr>
-              <a:t>01</a:t>
-            </a:r>
-            <a:r>
-              <a:rPr lang="en" sz="1000">
-                <a:solidFill>
-                  <a:srgbClr val="CCCCCC"/>
-                </a:solidFill>
-                <a:highlight>
-                  <a:srgbClr val="1F1F1F"/>
-                </a:highlight>
-                <a:latin typeface="Consolas"/>
-                <a:ea typeface="Consolas"/>
-                <a:cs typeface="Consolas"/>
-                <a:sym typeface="Consolas"/>
-              </a:rPr>
-              <a:t> </a:t>
-            </a:r>
+              <a:t>03 04 04 04 05</a:t>
+            </a:r>
+            <a:endParaRPr sz="1000">
+              <a:solidFill>
+                <a:srgbClr val="B5CEA8"/>
+              </a:solidFill>
+              <a:highlight>
+                <a:srgbClr val="1F1F1F"/>
+              </a:highlight>
+              <a:latin typeface="Consolas"/>
+              <a:ea typeface="Consolas"/>
+              <a:cs typeface="Consolas"/>
+              <a:sym typeface="Consolas"/>
+            </a:endParaRPr>
+          </a:p>
+          <a:p>
+            <a:pPr indent="0" lvl="0" marL="0" rtl="0" algn="l">
+              <a:lnSpc>
+                <a:spcPct val="157500"/>
+              </a:lnSpc>
+              <a:spcBef>
+                <a:spcPts val="0"/>
+              </a:spcBef>
+              <a:spcAft>
+                <a:spcPts val="0"/>
+              </a:spcAft>
+              <a:buNone/>
+            </a:pPr>
             <a:r>
               <a:rPr lang="en" sz="1000">
                 <a:solidFill>
@@ -10194,23 +10216,34 @@
                 <a:cs typeface="Consolas"/>
                 <a:sym typeface="Consolas"/>
               </a:rPr>
-              <a:t>02</a:t>
-            </a:r>
-            <a:r>
-              <a:rPr lang="en" sz="1000">
-                <a:solidFill>
-                  <a:srgbClr val="CCCCCC"/>
-                </a:solidFill>
-                <a:highlight>
-                  <a:srgbClr val="1F1F1F"/>
-                </a:highlight>
-                <a:latin typeface="Consolas"/>
-                <a:ea typeface="Consolas"/>
-                <a:cs typeface="Consolas"/>
-                <a:sym typeface="Consolas"/>
-              </a:rPr>
-              <a:t> </a:t>
-            </a:r>
+              <a:t>03 04 04 04 05</a:t>
+            </a:r>
+            <a:endParaRPr sz="1000">
+              <a:solidFill>
+                <a:srgbClr val="B5CEA8"/>
+              </a:solidFill>
+              <a:highlight>
+                <a:srgbClr val="1F1F1F"/>
+              </a:highlight>
+              <a:latin typeface="Consolas"/>
+              <a:ea typeface="Consolas"/>
+              <a:cs typeface="Consolas"/>
+              <a:sym typeface="Consolas"/>
+            </a:endParaRPr>
+          </a:p>
+          <a:p>
+            <a:pPr indent="0" lvl="0" marL="0" rtl="0" algn="l">
+              <a:lnSpc>
+                <a:spcPct val="157500"/>
+              </a:lnSpc>
+              <a:spcBef>
+                <a:spcPts val="0"/>
+              </a:spcBef>
+              <a:spcAft>
+                <a:spcPts val="0"/>
+              </a:spcAft>
+              <a:buNone/>
+            </a:pPr>
             <a:r>
               <a:rPr lang="en" sz="1000">
                 <a:solidFill>
@@ -10224,37 +10257,7 @@
                 <a:cs typeface="Consolas"/>
                 <a:sym typeface="Consolas"/>
               </a:rPr>
-              <a:t>01</a:t>
-            </a:r>
-            <a:r>
-              <a:rPr lang="en" sz="1000">
-                <a:solidFill>
-                  <a:srgbClr val="CCCCCC"/>
-                </a:solidFill>
-                <a:highlight>
-                  <a:srgbClr val="1F1F1F"/>
-                </a:highlight>
-                <a:latin typeface="Consolas"/>
-                <a:ea typeface="Consolas"/>
-                <a:cs typeface="Consolas"/>
-                <a:sym typeface="Consolas"/>
-              </a:rPr>
-              <a:t> </a:t>
-            </a:r>
-            <a:r>
-              <a:rPr lang="en" sz="1000">
-                <a:solidFill>
-                  <a:srgbClr val="B5CEA8"/>
-                </a:solidFill>
-                <a:highlight>
-                  <a:srgbClr val="1F1F1F"/>
-                </a:highlight>
-                <a:latin typeface="Consolas"/>
-                <a:ea typeface="Consolas"/>
-                <a:cs typeface="Consolas"/>
-                <a:sym typeface="Consolas"/>
-              </a:rPr>
-              <a:t>03</a:t>
+              <a:t>06 07 07 07 08</a:t>
             </a:r>
             <a:endParaRPr sz="1000">
               <a:solidFill>
@@ -10269,659 +10272,26 @@
               <a:sym typeface="Consolas"/>
             </a:endParaRPr>
           </a:p>
-          <a:p>
-            <a:pPr indent="0" lvl="0" marL="0" rtl="0" algn="l">
-              <a:lnSpc>
-                <a:spcPct val="157500"/>
-              </a:lnSpc>
-              <a:spcBef>
-                <a:spcPts val="0"/>
-              </a:spcBef>
-              <a:spcAft>
-                <a:spcPts val="0"/>
-              </a:spcAft>
-              <a:buNone/>
-            </a:pPr>
-            <a:r>
-              <a:rPr lang="en" sz="1000">
-                <a:solidFill>
-                  <a:srgbClr val="B5CEA8"/>
-                </a:solidFill>
-                <a:highlight>
-                  <a:srgbClr val="1F1F1F"/>
-                </a:highlight>
-                <a:latin typeface="Consolas"/>
-                <a:ea typeface="Consolas"/>
-                <a:cs typeface="Consolas"/>
-                <a:sym typeface="Consolas"/>
-              </a:rPr>
-              <a:t>04</a:t>
-            </a:r>
-            <a:r>
-              <a:rPr lang="en" sz="1000">
-                <a:solidFill>
-                  <a:srgbClr val="CCCCCC"/>
-                </a:solidFill>
-                <a:highlight>
-                  <a:srgbClr val="1F1F1F"/>
-                </a:highlight>
-                <a:latin typeface="Consolas"/>
-                <a:ea typeface="Consolas"/>
-                <a:cs typeface="Consolas"/>
-                <a:sym typeface="Consolas"/>
-              </a:rPr>
-              <a:t> </a:t>
-            </a:r>
-            <a:r>
-              <a:rPr lang="en" sz="1000">
-                <a:solidFill>
-                  <a:srgbClr val="B5CEA8"/>
-                </a:solidFill>
-                <a:highlight>
-                  <a:srgbClr val="1F1F1F"/>
-                </a:highlight>
-                <a:latin typeface="Consolas"/>
-                <a:ea typeface="Consolas"/>
-                <a:cs typeface="Consolas"/>
-                <a:sym typeface="Consolas"/>
-              </a:rPr>
-              <a:t>05</a:t>
-            </a:r>
-            <a:r>
-              <a:rPr lang="en" sz="1000">
-                <a:solidFill>
-                  <a:srgbClr val="CCCCCC"/>
-                </a:solidFill>
-                <a:highlight>
-                  <a:srgbClr val="1F1F1F"/>
-                </a:highlight>
-                <a:latin typeface="Consolas"/>
-                <a:ea typeface="Consolas"/>
-                <a:cs typeface="Consolas"/>
-                <a:sym typeface="Consolas"/>
-              </a:rPr>
-              <a:t> </a:t>
-            </a:r>
-            <a:r>
-              <a:rPr lang="en" sz="1000">
-                <a:solidFill>
-                  <a:srgbClr val="B5CEA8"/>
-                </a:solidFill>
-                <a:highlight>
-                  <a:srgbClr val="1F1F1F"/>
-                </a:highlight>
-                <a:latin typeface="Consolas"/>
-                <a:ea typeface="Consolas"/>
-                <a:cs typeface="Consolas"/>
-                <a:sym typeface="Consolas"/>
-              </a:rPr>
-              <a:t>06</a:t>
-            </a:r>
-            <a:r>
-              <a:rPr lang="en" sz="1000">
-                <a:solidFill>
-                  <a:srgbClr val="CCCCCC"/>
-                </a:solidFill>
-                <a:highlight>
-                  <a:srgbClr val="1F1F1F"/>
-                </a:highlight>
-                <a:latin typeface="Consolas"/>
-                <a:ea typeface="Consolas"/>
-                <a:cs typeface="Consolas"/>
-                <a:sym typeface="Consolas"/>
-              </a:rPr>
-              <a:t> </a:t>
-            </a:r>
-            <a:r>
-              <a:rPr lang="en" sz="1000">
-                <a:solidFill>
-                  <a:srgbClr val="B5CEA8"/>
-                </a:solidFill>
-                <a:highlight>
-                  <a:srgbClr val="1F1F1F"/>
-                </a:highlight>
-                <a:latin typeface="Consolas"/>
-                <a:ea typeface="Consolas"/>
-                <a:cs typeface="Consolas"/>
-                <a:sym typeface="Consolas"/>
-              </a:rPr>
-              <a:t>05</a:t>
-            </a:r>
-            <a:r>
-              <a:rPr lang="en" sz="1000">
-                <a:solidFill>
-                  <a:srgbClr val="CCCCCC"/>
-                </a:solidFill>
-                <a:highlight>
-                  <a:srgbClr val="1F1F1F"/>
-                </a:highlight>
-                <a:latin typeface="Consolas"/>
-                <a:ea typeface="Consolas"/>
-                <a:cs typeface="Consolas"/>
-                <a:sym typeface="Consolas"/>
-              </a:rPr>
-              <a:t> </a:t>
-            </a:r>
-            <a:r>
-              <a:rPr lang="en" sz="1000">
-                <a:solidFill>
-                  <a:srgbClr val="B5CEA8"/>
-                </a:solidFill>
-                <a:highlight>
-                  <a:srgbClr val="1F1F1F"/>
-                </a:highlight>
-                <a:latin typeface="Consolas"/>
-                <a:ea typeface="Consolas"/>
-                <a:cs typeface="Consolas"/>
-                <a:sym typeface="Consolas"/>
-              </a:rPr>
-              <a:t>07</a:t>
-            </a:r>
-            <a:endParaRPr sz="1000">
-              <a:solidFill>
-                <a:srgbClr val="B5CEA8"/>
-              </a:solidFill>
-              <a:highlight>
-                <a:srgbClr val="1F1F1F"/>
-              </a:highlight>
-              <a:latin typeface="Consolas"/>
-              <a:ea typeface="Consolas"/>
-              <a:cs typeface="Consolas"/>
-              <a:sym typeface="Consolas"/>
-            </a:endParaRPr>
-          </a:p>
-          <a:p>
-            <a:pPr indent="0" lvl="0" marL="0" rtl="0" algn="l">
-              <a:lnSpc>
-                <a:spcPct val="157500"/>
-              </a:lnSpc>
-              <a:spcBef>
-                <a:spcPts val="0"/>
-              </a:spcBef>
-              <a:spcAft>
-                <a:spcPts val="0"/>
-              </a:spcAft>
-              <a:buNone/>
-            </a:pPr>
-            <a:r>
-              <a:rPr lang="en" sz="1000">
-                <a:solidFill>
-                  <a:srgbClr val="B5CEA8"/>
-                </a:solidFill>
-                <a:highlight>
-                  <a:srgbClr val="1F1F1F"/>
-                </a:highlight>
-                <a:latin typeface="Consolas"/>
-                <a:ea typeface="Consolas"/>
-                <a:cs typeface="Consolas"/>
-                <a:sym typeface="Consolas"/>
-              </a:rPr>
-              <a:t>08</a:t>
-            </a:r>
-            <a:r>
-              <a:rPr lang="en" sz="1000">
-                <a:solidFill>
-                  <a:srgbClr val="CCCCCC"/>
-                </a:solidFill>
-                <a:highlight>
-                  <a:srgbClr val="1F1F1F"/>
-                </a:highlight>
-                <a:latin typeface="Consolas"/>
-                <a:ea typeface="Consolas"/>
-                <a:cs typeface="Consolas"/>
-                <a:sym typeface="Consolas"/>
-              </a:rPr>
-              <a:t> </a:t>
-            </a:r>
-            <a:r>
-              <a:rPr lang="en" sz="1000">
-                <a:solidFill>
-                  <a:srgbClr val="B5CEA8"/>
-                </a:solidFill>
-                <a:highlight>
-                  <a:srgbClr val="1F1F1F"/>
-                </a:highlight>
-                <a:latin typeface="Consolas"/>
-                <a:ea typeface="Consolas"/>
-                <a:cs typeface="Consolas"/>
-                <a:sym typeface="Consolas"/>
-              </a:rPr>
-              <a:t>09</a:t>
-            </a:r>
-            <a:r>
-              <a:rPr lang="en" sz="1000">
-                <a:solidFill>
-                  <a:srgbClr val="CCCCCC"/>
-                </a:solidFill>
-                <a:highlight>
-                  <a:srgbClr val="1F1F1F"/>
-                </a:highlight>
-                <a:latin typeface="Consolas"/>
-                <a:ea typeface="Consolas"/>
-                <a:cs typeface="Consolas"/>
-                <a:sym typeface="Consolas"/>
-              </a:rPr>
-              <a:t> </a:t>
-            </a:r>
-            <a:r>
-              <a:rPr lang="en" sz="1000">
-                <a:solidFill>
-                  <a:srgbClr val="B5CEA8"/>
-                </a:solidFill>
-                <a:highlight>
-                  <a:srgbClr val="1F1F1F"/>
-                </a:highlight>
-                <a:latin typeface="Consolas"/>
-                <a:ea typeface="Consolas"/>
-                <a:cs typeface="Consolas"/>
-                <a:sym typeface="Consolas"/>
-              </a:rPr>
-              <a:t>10</a:t>
-            </a:r>
-            <a:r>
-              <a:rPr lang="en" sz="1000">
-                <a:solidFill>
-                  <a:srgbClr val="CCCCCC"/>
-                </a:solidFill>
-                <a:highlight>
-                  <a:srgbClr val="1F1F1F"/>
-                </a:highlight>
-                <a:latin typeface="Consolas"/>
-                <a:ea typeface="Consolas"/>
-                <a:cs typeface="Consolas"/>
-                <a:sym typeface="Consolas"/>
-              </a:rPr>
-              <a:t> </a:t>
-            </a:r>
-            <a:r>
-              <a:rPr lang="en" sz="1000">
-                <a:solidFill>
-                  <a:srgbClr val="B5CEA8"/>
-                </a:solidFill>
-                <a:highlight>
-                  <a:srgbClr val="1F1F1F"/>
-                </a:highlight>
-                <a:latin typeface="Consolas"/>
-                <a:ea typeface="Consolas"/>
-                <a:cs typeface="Consolas"/>
-                <a:sym typeface="Consolas"/>
-              </a:rPr>
-              <a:t>09</a:t>
-            </a:r>
-            <a:r>
-              <a:rPr lang="en" sz="1000">
-                <a:solidFill>
-                  <a:srgbClr val="CCCCCC"/>
-                </a:solidFill>
-                <a:highlight>
-                  <a:srgbClr val="1F1F1F"/>
-                </a:highlight>
-                <a:latin typeface="Consolas"/>
-                <a:ea typeface="Consolas"/>
-                <a:cs typeface="Consolas"/>
-                <a:sym typeface="Consolas"/>
-              </a:rPr>
-              <a:t> </a:t>
-            </a:r>
-            <a:r>
-              <a:rPr lang="en" sz="1000">
-                <a:solidFill>
-                  <a:srgbClr val="B5CEA8"/>
-                </a:solidFill>
-                <a:highlight>
-                  <a:srgbClr val="1F1F1F"/>
-                </a:highlight>
-                <a:latin typeface="Consolas"/>
-                <a:ea typeface="Consolas"/>
-                <a:cs typeface="Consolas"/>
-                <a:sym typeface="Consolas"/>
-              </a:rPr>
-              <a:t>11</a:t>
-            </a:r>
-            <a:endParaRPr sz="1000">
-              <a:solidFill>
-                <a:srgbClr val="B5CEA8"/>
-              </a:solidFill>
-              <a:highlight>
-                <a:srgbClr val="1F1F1F"/>
-              </a:highlight>
-              <a:latin typeface="Consolas"/>
-              <a:ea typeface="Consolas"/>
-              <a:cs typeface="Consolas"/>
-              <a:sym typeface="Consolas"/>
-            </a:endParaRPr>
-          </a:p>
-          <a:p>
-            <a:pPr indent="0" lvl="0" marL="0" rtl="0" algn="l">
-              <a:lnSpc>
-                <a:spcPct val="157500"/>
-              </a:lnSpc>
-              <a:spcBef>
-                <a:spcPts val="0"/>
-              </a:spcBef>
-              <a:spcAft>
-                <a:spcPts val="0"/>
-              </a:spcAft>
-              <a:buNone/>
-            </a:pPr>
-            <a:r>
-              <a:rPr lang="en" sz="1000">
-                <a:solidFill>
-                  <a:srgbClr val="B5CEA8"/>
-                </a:solidFill>
-                <a:highlight>
-                  <a:srgbClr val="1F1F1F"/>
-                </a:highlight>
-                <a:latin typeface="Consolas"/>
-                <a:ea typeface="Consolas"/>
-                <a:cs typeface="Consolas"/>
-                <a:sym typeface="Consolas"/>
-              </a:rPr>
-              <a:t>04</a:t>
-            </a:r>
-            <a:r>
-              <a:rPr lang="en" sz="1000">
-                <a:solidFill>
-                  <a:srgbClr val="CCCCCC"/>
-                </a:solidFill>
-                <a:highlight>
-                  <a:srgbClr val="1F1F1F"/>
-                </a:highlight>
-                <a:latin typeface="Consolas"/>
-                <a:ea typeface="Consolas"/>
-                <a:cs typeface="Consolas"/>
-                <a:sym typeface="Consolas"/>
-              </a:rPr>
-              <a:t> </a:t>
-            </a:r>
-            <a:r>
-              <a:rPr lang="en" sz="1000">
-                <a:solidFill>
-                  <a:srgbClr val="B5CEA8"/>
-                </a:solidFill>
-                <a:highlight>
-                  <a:srgbClr val="1F1F1F"/>
-                </a:highlight>
-                <a:latin typeface="Consolas"/>
-                <a:ea typeface="Consolas"/>
-                <a:cs typeface="Consolas"/>
-                <a:sym typeface="Consolas"/>
-              </a:rPr>
-              <a:t>09</a:t>
-            </a:r>
-            <a:r>
-              <a:rPr lang="en" sz="1000">
-                <a:solidFill>
-                  <a:srgbClr val="CCCCCC"/>
-                </a:solidFill>
-                <a:highlight>
-                  <a:srgbClr val="1F1F1F"/>
-                </a:highlight>
-                <a:latin typeface="Consolas"/>
-                <a:ea typeface="Consolas"/>
-                <a:cs typeface="Consolas"/>
-                <a:sym typeface="Consolas"/>
-              </a:rPr>
-              <a:t> </a:t>
-            </a:r>
-            <a:r>
-              <a:rPr lang="en" sz="1000">
-                <a:solidFill>
-                  <a:srgbClr val="B5CEA8"/>
-                </a:solidFill>
-                <a:highlight>
-                  <a:srgbClr val="1F1F1F"/>
-                </a:highlight>
-                <a:latin typeface="Consolas"/>
-                <a:ea typeface="Consolas"/>
-                <a:cs typeface="Consolas"/>
-                <a:sym typeface="Consolas"/>
-              </a:rPr>
-              <a:t>09</a:t>
-            </a:r>
-            <a:r>
-              <a:rPr lang="en" sz="1000">
-                <a:solidFill>
-                  <a:srgbClr val="CCCCCC"/>
-                </a:solidFill>
-                <a:highlight>
-                  <a:srgbClr val="1F1F1F"/>
-                </a:highlight>
-                <a:latin typeface="Consolas"/>
-                <a:ea typeface="Consolas"/>
-                <a:cs typeface="Consolas"/>
-                <a:sym typeface="Consolas"/>
-              </a:rPr>
-              <a:t> </a:t>
-            </a:r>
-            <a:r>
-              <a:rPr lang="en" sz="1000">
-                <a:solidFill>
-                  <a:srgbClr val="B5CEA8"/>
-                </a:solidFill>
-                <a:highlight>
-                  <a:srgbClr val="1F1F1F"/>
-                </a:highlight>
-                <a:latin typeface="Consolas"/>
-                <a:ea typeface="Consolas"/>
-                <a:cs typeface="Consolas"/>
-                <a:sym typeface="Consolas"/>
-              </a:rPr>
-              <a:t>09</a:t>
-            </a:r>
-            <a:r>
-              <a:rPr lang="en" sz="1000">
-                <a:solidFill>
-                  <a:srgbClr val="CCCCCC"/>
-                </a:solidFill>
-                <a:highlight>
-                  <a:srgbClr val="1F1F1F"/>
-                </a:highlight>
-                <a:latin typeface="Consolas"/>
-                <a:ea typeface="Consolas"/>
-                <a:cs typeface="Consolas"/>
-                <a:sym typeface="Consolas"/>
-              </a:rPr>
-              <a:t> </a:t>
-            </a:r>
-            <a:r>
-              <a:rPr lang="en" sz="1000">
-                <a:solidFill>
-                  <a:srgbClr val="B5CEA8"/>
-                </a:solidFill>
-                <a:highlight>
-                  <a:srgbClr val="1F1F1F"/>
-                </a:highlight>
-                <a:latin typeface="Consolas"/>
-                <a:ea typeface="Consolas"/>
-                <a:cs typeface="Consolas"/>
-                <a:sym typeface="Consolas"/>
-              </a:rPr>
-              <a:t>07</a:t>
-            </a:r>
-            <a:endParaRPr sz="1000">
-              <a:solidFill>
-                <a:srgbClr val="B5CEA8"/>
-              </a:solidFill>
-              <a:highlight>
-                <a:srgbClr val="1F1F1F"/>
-              </a:highlight>
-              <a:latin typeface="Consolas"/>
-              <a:ea typeface="Consolas"/>
-              <a:cs typeface="Consolas"/>
-              <a:sym typeface="Consolas"/>
-            </a:endParaRPr>
-          </a:p>
-          <a:p>
-            <a:pPr indent="0" lvl="0" marL="0" rtl="0" algn="l">
-              <a:lnSpc>
-                <a:spcPct val="157500"/>
-              </a:lnSpc>
-              <a:spcBef>
-                <a:spcPts val="0"/>
-              </a:spcBef>
-              <a:spcAft>
-                <a:spcPts val="0"/>
-              </a:spcAft>
-              <a:buNone/>
-            </a:pPr>
-            <a:r>
-              <a:rPr lang="en" sz="1000">
-                <a:solidFill>
-                  <a:srgbClr val="B5CEA8"/>
-                </a:solidFill>
-                <a:highlight>
-                  <a:srgbClr val="1F1F1F"/>
-                </a:highlight>
-                <a:latin typeface="Consolas"/>
-                <a:ea typeface="Consolas"/>
-                <a:cs typeface="Consolas"/>
-                <a:sym typeface="Consolas"/>
-              </a:rPr>
-              <a:t>12</a:t>
-            </a:r>
-            <a:r>
-              <a:rPr lang="en" sz="1000">
-                <a:solidFill>
-                  <a:srgbClr val="CCCCCC"/>
-                </a:solidFill>
-                <a:highlight>
-                  <a:srgbClr val="1F1F1F"/>
-                </a:highlight>
-                <a:latin typeface="Consolas"/>
-                <a:ea typeface="Consolas"/>
-                <a:cs typeface="Consolas"/>
-                <a:sym typeface="Consolas"/>
-              </a:rPr>
-              <a:t> </a:t>
-            </a:r>
-            <a:r>
-              <a:rPr lang="en" sz="1000">
-                <a:solidFill>
-                  <a:srgbClr val="B5CEA8"/>
-                </a:solidFill>
-                <a:highlight>
-                  <a:srgbClr val="1F1F1F"/>
-                </a:highlight>
-                <a:latin typeface="Consolas"/>
-                <a:ea typeface="Consolas"/>
-                <a:cs typeface="Consolas"/>
-                <a:sym typeface="Consolas"/>
-              </a:rPr>
-              <a:t>13</a:t>
-            </a:r>
-            <a:r>
-              <a:rPr lang="en" sz="1000">
-                <a:solidFill>
-                  <a:srgbClr val="CCCCCC"/>
-                </a:solidFill>
-                <a:highlight>
-                  <a:srgbClr val="1F1F1F"/>
-                </a:highlight>
-                <a:latin typeface="Consolas"/>
-                <a:ea typeface="Consolas"/>
-                <a:cs typeface="Consolas"/>
-                <a:sym typeface="Consolas"/>
-              </a:rPr>
-              <a:t> </a:t>
-            </a:r>
-            <a:r>
-              <a:rPr lang="en" sz="1000">
-                <a:solidFill>
-                  <a:srgbClr val="B5CEA8"/>
-                </a:solidFill>
-                <a:highlight>
-                  <a:srgbClr val="1F1F1F"/>
-                </a:highlight>
-                <a:latin typeface="Consolas"/>
-                <a:ea typeface="Consolas"/>
-                <a:cs typeface="Consolas"/>
-                <a:sym typeface="Consolas"/>
-              </a:rPr>
-              <a:t>14</a:t>
-            </a:r>
-            <a:r>
-              <a:rPr lang="en" sz="1000">
-                <a:solidFill>
-                  <a:srgbClr val="CCCCCC"/>
-                </a:solidFill>
-                <a:highlight>
-                  <a:srgbClr val="1F1F1F"/>
-                </a:highlight>
-                <a:latin typeface="Consolas"/>
-                <a:ea typeface="Consolas"/>
-                <a:cs typeface="Consolas"/>
-                <a:sym typeface="Consolas"/>
-              </a:rPr>
-              <a:t> </a:t>
-            </a:r>
-            <a:r>
-              <a:rPr lang="en" sz="1000">
-                <a:solidFill>
-                  <a:srgbClr val="B5CEA8"/>
-                </a:solidFill>
-                <a:highlight>
-                  <a:srgbClr val="1F1F1F"/>
-                </a:highlight>
-                <a:latin typeface="Consolas"/>
-                <a:ea typeface="Consolas"/>
-                <a:cs typeface="Consolas"/>
-                <a:sym typeface="Consolas"/>
-              </a:rPr>
-              <a:t>13</a:t>
-            </a:r>
-            <a:r>
-              <a:rPr lang="en" sz="1000">
-                <a:solidFill>
-                  <a:srgbClr val="CCCCCC"/>
-                </a:solidFill>
-                <a:highlight>
-                  <a:srgbClr val="1F1F1F"/>
-                </a:highlight>
-                <a:latin typeface="Consolas"/>
-                <a:ea typeface="Consolas"/>
-                <a:cs typeface="Consolas"/>
-                <a:sym typeface="Consolas"/>
-              </a:rPr>
-              <a:t> </a:t>
-            </a:r>
-            <a:r>
-              <a:rPr lang="en" sz="1000">
-                <a:solidFill>
-                  <a:srgbClr val="B5CEA8"/>
-                </a:solidFill>
-                <a:highlight>
-                  <a:srgbClr val="1F1F1F"/>
-                </a:highlight>
-                <a:latin typeface="Consolas"/>
-                <a:ea typeface="Consolas"/>
-                <a:cs typeface="Consolas"/>
-                <a:sym typeface="Consolas"/>
-              </a:rPr>
-              <a:t>15</a:t>
-            </a:r>
-            <a:endParaRPr/>
-          </a:p>
         </p:txBody>
       </p:sp>
       <p:pic>
         <p:nvPicPr>
-          <p:cNvPr id="275" name="Picture 275" descr="room_tiles.png"/>
+          <p:cNvPr id="275" name="Picture 275" descr="room.png"/>
           <p:cNvPicPr>
             <a:picLocks noChangeAspect="1"/>
           </p:cNvPicPr>
           <p:nvPr/>
         </p:nvPicPr>
         <p:blipFill>
-          <a:blip r:embed="rId6"/>
+          <a:blip r:embed="rId4"/>
           <a:stretch>
             <a:fillRect/>
           </a:stretch>
         </p:blipFill>
         <p:spPr>
           <a:xfrm>
-            <a:off x="5323925" y="1114550"/>
-            <a:ext cx="3397050" cy="3397050"/>
+            <a:off x="5323925" y="1454255"/>
+            <a:ext cx="3397050" cy="2717640"/>
           </a:xfrm>
           <a:prstGeom prst="rect">
             <a:avLst/>
@@ -11326,7 +10696,7 @@
             </a:pPr>
             <a:r>
               <a:rPr lang="en"/>
-              <a:t>Rearrange the room: move the torches, add cracks</a:t>
+              <a:t>Rearrange the room: draw a wall across the middle</a:t>
             </a:r>
             <a:endParaRPr/>
           </a:p>
@@ -11343,7 +10713,7 @@
             </a:pPr>
             <a:r>
               <a:rPr lang="en"/>
-              <a:t>Then put a 20 in it. What happens, and when?</a:t>
+              <a:t>Then put a 9 in it. What happens, and when?</a:t>
             </a:r>
             <a:endParaRPr/>
           </a:p>
@@ -17304,7 +16674,7 @@
                   <a:schemeClr val="accent5"/>
                 </a:solidFill>
               </a:rPr>
-              <a:t>Exercise: A Beetle From Data</a:t>
+              <a:t>Exercise: A Bug From Data</a:t>
             </a:r>
             <a:endParaRPr>
               <a:solidFill>
@@ -17349,7 +16719,7 @@
             </a:pPr>
             <a:r>
               <a:rPr lang="en"/>
-              <a:t>A beetle is in the atlas image, but not in the data</a:t>
+              <a:t>A bug is in the atlas image, but not in the data</a:t>
             </a:r>
             <a:endParaRPr/>
           </a:p>
@@ -17383,7 +16753,7 @@
             </a:pPr>
             <a:r>
               <a:rPr lang="en"/>
-              <a:t>Make the enemy a beetle: which line of C# changes?</a:t>
+              <a:t>Make the snake eat a bug: which line of C# changes?</a:t>
             </a:r>
             <a:endParaRPr/>
           </a:p>
@@ -17400,7 +16770,7 @@
             </a:pPr>
             <a:r>
               <a:rPr lang="en"/>
-              <a:t>How much C# did you change? And for a beetle next to the apple?</a:t>
+              <a:t>How much C# did you change? And for a bug next to the food?</a:t>
             </a:r>
             <a:endParaRPr/>
           </a:p>
@@ -21637,122 +21007,115 @@
                   <a:srgbClr val="DEE2E6"/>
                 </a:solidFill>
               </a:rPr>
-              <a:t/>
-            </a:r>
-            <a:r>
-              <a:rPr sz="1000">
+              <a:t>&lt;Region name="head-1" x="8" y="0" width="7" height="7" /&gt;</a:t>
+            </a:r>
+          </a:p>
+          <a:p>
+            <a:pPr algn="l"/>
+            <a:r>
+              <a:rPr sz="1300" b="0">
                 <a:solidFill>
                   <a:srgbClr val="DEE2E6"/>
                 </a:solidFill>
-                <a:latin typeface="Consolas"/>
               </a:rPr>
-              <a:t>&lt;Region name="apple-1" x="20" y="0" width="20" height="20" /&gt;</a:t>
+              <a:t>&lt;Region name="head-2" x="16" y="0" width="7" height="7" /&gt;</a:t>
             </a:r>
           </a:p>
           <a:p>
             <a:pPr algn="l"/>
             <a:r>
-              <a:rPr sz="1000">
+              <a:rPr sz="1300" b="0">
                 <a:solidFill>
                   <a:srgbClr val="DEE2E6"/>
                 </a:solidFill>
-                <a:latin typeface="Consolas"/>
               </a:rPr>
-              <a:t>&lt;Region name="apple-2" x="20" y="20" width="20" height="20" /&gt;</a:t>
+              <a:t/>
             </a:r>
           </a:p>
           <a:p>
             <a:pPr algn="l"/>
             <a:r>
-              <a:rPr sz="1000">
+              <a:rPr sz="1300" b="0">
                 <a:solidFill>
                   <a:srgbClr val="DEE2E6"/>
                 </a:solidFill>
-                <a:latin typeface="Consolas"/>
               </a:rPr>
-              <a:t>&lt;Region name="apple-3" x="40" y="0" width="20" height="20" /&gt;</a:t>
+              <a:t>&lt;Animation name="head-animation" delay="250"&gt;</a:t>
             </a:r>
           </a:p>
           <a:p>
             <a:pPr algn="l"/>
             <a:r>
-              <a:rPr sz="1000">
+              <a:rPr sz="1300" b="0">
                 <a:solidFill>
                   <a:srgbClr val="DEE2E6"/>
                 </a:solidFill>
-                <a:latin typeface="Consolas"/>
               </a:rPr>
-              <a:t> </a:t>
+              <a:t>    &lt;Frame region="head-1" /&gt;</a:t>
             </a:r>
           </a:p>
           <a:p>
             <a:pPr algn="l"/>
             <a:r>
-              <a:rPr sz="1000">
+              <a:rPr sz="1300" b="0">
                 <a:solidFill>
                   <a:srgbClr val="DEE2E6"/>
                 </a:solidFill>
-                <a:latin typeface="Consolas"/>
               </a:rPr>
-              <a:t>&lt;Animation name="apple-animation" delay="200"&gt;</a:t>
+              <a:t>    &lt;Frame region="head-1" /&gt;</a:t>
             </a:r>
           </a:p>
           <a:p>
             <a:pPr algn="l"/>
             <a:r>
-              <a:rPr sz="1000">
+              <a:rPr sz="1300" b="0">
                 <a:solidFill>
                   <a:srgbClr val="DEE2E6"/>
                 </a:solidFill>
-                <a:latin typeface="Consolas"/>
               </a:rPr>
-              <a:t>    &lt;Frame region="apple-1" /&gt;</a:t>
+              <a:t>    &lt;Frame region="head-1" /&gt;</a:t>
             </a:r>
           </a:p>
           <a:p>
             <a:pPr algn="l"/>
             <a:r>
-              <a:rPr sz="1000">
+              <a:rPr sz="1300" b="0">
                 <a:solidFill>
                   <a:srgbClr val="DEE2E6"/>
                 </a:solidFill>
-                <a:latin typeface="Consolas"/>
               </a:rPr>
-              <a:t>    &lt;Frame region="apple-2" /&gt;</a:t>
+              <a:t>    &lt;Frame region="head-1" /&gt;</a:t>
             </a:r>
           </a:p>
           <a:p>
             <a:pPr algn="l"/>
             <a:r>
-              <a:rPr sz="1000">
+              <a:rPr sz="1300" b="0">
                 <a:solidFill>
                   <a:srgbClr val="DEE2E6"/>
                 </a:solidFill>
-                <a:latin typeface="Consolas"/>
               </a:rPr>
-              <a:t>    &lt;Frame region="apple-1" /&gt;</a:t>
+              <a:t>    &lt;Frame region="head-1" /&gt;</a:t>
             </a:r>
           </a:p>
           <a:p>
             <a:pPr algn="l"/>
             <a:r>
-              <a:rPr sz="1000">
+              <a:rPr sz="1300" b="0">
                 <a:solidFill>
                   <a:srgbClr val="DEE2E6"/>
                 </a:solidFill>
-                <a:latin typeface="Consolas"/>
               </a:rPr>
-              <a:t>    &lt;Frame region="apple-3" /&gt;</a:t>
+              <a:t>    &lt;Frame region="head-2" /&gt;</a:t>
             </a:r>
           </a:p>
           <a:p>
             <a:pPr algn="l"/>
             <a:r>
-              <a:rPr sz="1000">
+              <a:rPr sz="1300" b="0">
                 <a:solidFill>
                   <a:srgbClr val="DEE2E6"/>
                 </a:solidFill>
-                <a:latin typeface="Consolas"/>
               </a:rPr>
               <a:t>&lt;/Animation&gt;</a:t>
             </a:r>
@@ -21926,14 +21289,14 @@
       </p:sp>
       <p:pic>
         <p:nvPicPr>
-          <p:cNvPr id="64" name="Picture 73" descr="mouse1.png"/>
+          <p:cNvPr id="64" name="Picture 73" descr="single_food1.png"/>
           <p:cNvPicPr>
             <a:picLocks noChangeAspect="1"/>
           </p:cNvPicPr>
           <p:nvPr/>
         </p:nvPicPr>
         <p:blipFill>
-          <a:blip r:embed="rId6"/>
+          <a:blip r:embed="rId10"/>
           <a:stretch>
             <a:fillRect/>
           </a:stretch>
@@ -21950,14 +21313,14 @@
       </p:pic>
       <p:pic>
         <p:nvPicPr>
-          <p:cNvPr id="65" name="Picture 73" descr="snake1.png"/>
+          <p:cNvPr id="65" name="Picture 73" descr="single_body.png"/>
           <p:cNvPicPr>
             <a:picLocks noChangeAspect="1"/>
           </p:cNvPicPr>
           <p:nvPr/>
         </p:nvPicPr>
         <p:blipFill>
-          <a:blip r:embed="rId8"/>
+          <a:blip r:embed="rId5"/>
           <a:stretch>
             <a:fillRect/>
           </a:stretch>
@@ -21974,14 +21337,14 @@
       </p:pic>
       <p:pic>
         <p:nvPicPr>
-          <p:cNvPr id="66" name="Picture 73" descr="snake2.png"/>
+          <p:cNvPr id="66" name="Picture 73" descr="single_head1.png"/>
           <p:cNvPicPr>
             <a:picLocks noChangeAspect="1"/>
           </p:cNvPicPr>
           <p:nvPr/>
         </p:nvPicPr>
         <p:blipFill>
-          <a:blip r:embed="rId7"/>
+          <a:blip r:embed="rId4"/>
           <a:stretch>
             <a:fillRect/>
           </a:stretch>
@@ -22005,15 +21368,15 @@
           <p:nvPr/>
         </p:nvPicPr>
         <p:blipFill>
-          <a:blip r:embed="rId11"/>
+          <a:blip r:embed="rId12"/>
           <a:stretch>
             <a:fillRect/>
           </a:stretch>
         </p:blipFill>
         <p:spPr>
           <a:xfrm>
-            <a:off x="5364642" y="1560179"/>
-            <a:ext cx="1348766" cy="2023149"/>
+            <a:off x="4572000" y="1737360"/>
+            <a:ext cx="2926080" cy="1828800"/>
           </a:xfrm>
           <a:prstGeom prst="rect">
             <a:avLst/>
@@ -22022,14 +21385,14 @@
       </p:pic>
       <p:pic>
         <p:nvPicPr>
-          <p:cNvPr id="68" name="Picture 73" descr="image.png"/>
+          <p:cNvPr id="68" name="Picture 73" descr="single_digit0.png"/>
           <p:cNvPicPr>
             <a:picLocks noChangeAspect="1"/>
           </p:cNvPicPr>
           <p:nvPr/>
         </p:nvPicPr>
         <p:blipFill>
-          <a:blip r:embed="rId9"/>
+          <a:blip r:embed="rId3"/>
           <a:stretch>
             <a:fillRect/>
           </a:stretch>
@@ -22052,8 +21415,8 @@
         </p:nvSpPr>
         <p:spPr>
           <a:xfrm>
-            <a:off x="360725" y="2439050"/>
-            <a:ext cx="670800" cy="323400"/>
+            <a:off x="284645" y="2439050"/>
+            <a:ext cx="822960" cy="323400"/>
           </a:xfrm>
           <a:prstGeom prst="rect">
             <a:avLst/>
@@ -22064,7 +21427,7 @@
           </a:ln>
         </p:spPr>
         <p:txBody>
-          <a:bodyPr anchorCtr="0" anchor="t" bIns="91425" lIns="91425" spcFirstLastPara="1" rIns="91425" wrap="square" tIns="91425">
+          <a:bodyPr anchorCtr="0" anchor="t" bIns="91425" lIns="91425" spcFirstLastPara="1" rIns="91425" wrap="none" tIns="91425">
             <a:noAutofit/>
           </a:bodyPr>
           <a:lstStyle/>
@@ -22088,7 +21451,7 @@
                 <a:cs typeface="VT323"/>
                 <a:sym typeface="VT323"/>
               </a:rPr>
-              <a:t>snake1.png</a:t>
+              <a:t>body.png</a:t>
             </a:r>
             <a:endParaRPr sz="900">
               <a:solidFill>
@@ -22110,8 +21473,8 @@
         </p:nvSpPr>
         <p:spPr>
           <a:xfrm>
-            <a:off x="1076325" y="2439050"/>
-            <a:ext cx="670800" cy="323400"/>
+            <a:off x="1000246" y="2439050"/>
+            <a:ext cx="822960" cy="323400"/>
           </a:xfrm>
           <a:prstGeom prst="rect">
             <a:avLst/>
@@ -22122,7 +21485,7 @@
           </a:ln>
         </p:spPr>
         <p:txBody>
-          <a:bodyPr anchorCtr="0" anchor="t" bIns="91425" lIns="91425" spcFirstLastPara="1" rIns="91425" wrap="square" tIns="91425">
+          <a:bodyPr anchorCtr="0" anchor="t" bIns="91425" lIns="91425" spcFirstLastPara="1" rIns="91425" wrap="none" tIns="91425">
             <a:noAutofit/>
           </a:bodyPr>
           <a:lstStyle/>
@@ -22146,7 +21509,7 @@
                 <a:cs typeface="VT323"/>
                 <a:sym typeface="VT323"/>
               </a:rPr>
-              <a:t>snake2.png</a:t>
+              <a:t>head1.png</a:t>
             </a:r>
             <a:endParaRPr sz="900">
               <a:solidFill>
@@ -22168,8 +21531,8 @@
         </p:nvSpPr>
         <p:spPr>
           <a:xfrm>
-            <a:off x="1791925" y="2439050"/>
-            <a:ext cx="670800" cy="323400"/>
+            <a:off x="1715845" y="2439050"/>
+            <a:ext cx="822960" cy="323400"/>
           </a:xfrm>
           <a:prstGeom prst="rect">
             <a:avLst/>
@@ -22180,7 +21543,7 @@
           </a:ln>
         </p:spPr>
         <p:txBody>
-          <a:bodyPr anchorCtr="0" anchor="t" bIns="91425" lIns="91425" spcFirstLastPara="1" rIns="91425" wrap="square" tIns="91425">
+          <a:bodyPr anchorCtr="0" anchor="t" bIns="91425" lIns="91425" spcFirstLastPara="1" rIns="91425" wrap="none" tIns="91425">
             <a:noAutofit/>
           </a:bodyPr>
           <a:lstStyle/>
@@ -22204,7 +21567,7 @@
                 <a:cs typeface="VT323"/>
                 <a:sym typeface="VT323"/>
               </a:rPr>
-              <a:t>apple1.png</a:t>
+              <a:t>food1.png</a:t>
             </a:r>
             <a:endParaRPr sz="900">
               <a:solidFill>
@@ -22226,8 +21589,8 @@
         </p:nvSpPr>
         <p:spPr>
           <a:xfrm>
-            <a:off x="2574501" y="2439050"/>
-            <a:ext cx="691200" cy="323400"/>
+            <a:off x="2498407" y="2439050"/>
+            <a:ext cx="822960" cy="323400"/>
           </a:xfrm>
           <a:prstGeom prst="rect">
             <a:avLst/>
@@ -22238,7 +21601,7 @@
           </a:ln>
         </p:spPr>
         <p:txBody>
-          <a:bodyPr anchorCtr="0" anchor="t" bIns="91425" lIns="91425" spcFirstLastPara="1" rIns="91425" wrap="square" tIns="91425">
+          <a:bodyPr anchorCtr="0" anchor="t" bIns="91425" lIns="91425" spcFirstLastPara="1" rIns="91425" wrap="none" tIns="91425">
             <a:noAutofit/>
           </a:bodyPr>
           <a:lstStyle/>
@@ -22262,7 +21625,7 @@
                 <a:cs typeface="VT323"/>
                 <a:sym typeface="VT323"/>
               </a:rPr>
-              <a:t>grass.png</a:t>
+              <a:t>digit0.png</a:t>
             </a:r>
             <a:endParaRPr sz="900">
               <a:solidFill>
@@ -22284,7 +21647,7 @@
         </p:nvSpPr>
         <p:spPr>
           <a:xfrm>
-            <a:off x="5703625" y="3645825"/>
+            <a:off x="5699640" y="3657600"/>
             <a:ext cx="670800" cy="323400"/>
           </a:xfrm>
           <a:prstGeom prst="rect">
@@ -22810,15 +22173,15 @@
           <p:nvPr/>
         </p:nvPicPr>
         <p:blipFill>
-          <a:blip r:embed="rId4"/>
+          <a:blip r:embed="rId3"/>
           <a:stretch>
             <a:fillRect/>
           </a:stretch>
         </p:blipFill>
         <p:spPr>
           <a:xfrm>
-            <a:off x="3897617" y="1560179"/>
-            <a:ext cx="1348766" cy="2023149"/>
+            <a:off x="2743200" y="1325880"/>
+            <a:ext cx="3657600" cy="2286000"/>
           </a:xfrm>
           <a:prstGeom prst="rect">
             <a:avLst/>

</xml_diff>

<commit_message>
Decks: the concept figures on the slides
34 slides now carry one of our own figures, 17 of them new slides. They replace
several borrowed images (the coyote cartoon and game screenshot, the
bounding-volumes chart) and a number of box-and-text diagrams.

Co-Authored-By: Claude Opus 5.5 <noreply@anthropic.com>
Claude-Session: https://claude.ai/code/session_012sjsUQBbC7zon57rWHoo9d
</commit_message>
<xml_diff>
--- a/slides/03 Snake.pptx
+++ b/slides/03 Snake.pptx
@@ -32,6 +32,7 @@
     <p:sldId id="290" r:id="rId40"/>
     <p:sldId id="305" r:id="rId27"/>
     <p:sldId id="298" r:id="rId57"/>
+    <p:sldId id="309" r:id="rId55"/>
     <p:sldId id="299" r:id="rId58"/>
     <p:sldId id="300" r:id="rId59"/>
     <p:sldId id="301" r:id="rId60"/>
@@ -1404,6 +1405,69 @@
 </p:notes>
 </file>
 
+<file path=ppt/notesSlides/notesSlide17.xml><?xml version="1.0" encoding="utf-8"?>
+<p:notes xmlns:a="http://schemas.openxmlformats.org/drawingml/2006/main" xmlns:p="http://schemas.openxmlformats.org/presentationml/2006/main" xmlns:r="http://schemas.openxmlformats.org/officeDocument/2006/relationships">
+  <p:cSld>
+    <p:spTree>
+      <p:nvGrpSpPr>
+        <p:cNvPr id="1" name=""/>
+        <p:cNvGrpSpPr/>
+        <p:nvPr/>
+      </p:nvGrpSpPr>
+      <p:grpSpPr>
+        <a:xfrm>
+          <a:off x="0" y="0"/>
+          <a:ext cx="0" cy="0"/>
+          <a:chOff x="0" y="0"/>
+          <a:chExt cx="0" cy="0"/>
+        </a:xfrm>
+      </p:grpSpPr>
+      <p:sp>
+        <p:nvSpPr>
+          <p:cNvPr id="2" name="Slide Image Placeholder 1"/>
+          <p:cNvSpPr>
+            <a:spLocks noGrp="1"/>
+          </p:cNvSpPr>
+          <p:nvPr>
+            <p:ph type="sldImg" idx="2"/>
+          </p:nvPr>
+        </p:nvSpPr>
+        <p:spPr/>
+      </p:sp>
+      <p:sp>
+        <p:nvSpPr>
+          <p:cNvPr id="3" name="Notes Placeholder 2"/>
+          <p:cNvSpPr>
+            <a:spLocks noGrp="1"/>
+          </p:cNvSpPr>
+          <p:nvPr>
+            <p:ph type="body" idx="1"/>
+          </p:nvPr>
+        </p:nvSpPr>
+        <p:spPr/>
+        <p:txBody>
+          <a:bodyPr/>
+          <a:lstStyle/>
+          <a:p>
+            <a:r>
+              <a:t>Frames are uneven; the accumulator collects their time. Every time it passes a tick, the snake moves once and one tick is subtracted.</a:t>
+            </a:r>
+          </a:p>
+          <a:p>
+            <a:r>
+              <a:t>Ask: what happens on a long frame? Answer: two moves in one frame, so the snake keeps its speed.</a:t>
+            </a:r>
+          </a:p>
+        </p:txBody>
+      </p:sp>
+    </p:spTree>
+  </p:cSld>
+  <p:clrMapOvr>
+    <a:masterClrMapping/>
+  </p:clrMapOvr>
+</p:notes>
+</file>
+
 <file path=ppt/notesSlides/notesSlide18.xml><?xml version="1.0" encoding="utf-8"?>
 <p:notes xmlns:a="http://schemas.openxmlformats.org/drawingml/2006/main" xmlns:p="http://schemas.openxmlformats.org/presentationml/2006/main" xmlns:r="http://schemas.openxmlformats.org/officeDocument/2006/relationships">
   <p:cSld>
@@ -2128,6 +2192,16 @@
           <a:p>
             <a:r>
               <a:t>Three levels: distance, shapes (boxes, circles), polygons. Use the simplest that looks right.</a:t>
+            </a:r>
+          </a:p>
+          <a:p>
+            <a:r>
+              <a:t>AABB, Circles</a:t>
+            </a:r>
+          </a:p>
+          <a:p>
+            <a:r>
+              <a:t>Complex polygon checks</a:t>
             </a:r>
           </a:p>
         </p:txBody>
@@ -9295,22 +9369,22 @@
       </p:sp>
       <p:pic>
         <p:nvPicPr>
-          <p:cNvPr id="123" name="Picture 123" descr="animation.png"/>
+          <p:cNvPr id="123" name="Picture 122" descr="animation.png"/>
           <p:cNvPicPr>
             <a:picLocks noChangeAspect="1"/>
           </p:cNvPicPr>
           <p:nvPr/>
         </p:nvPicPr>
         <p:blipFill>
-          <a:blip r:embed="rId3"/>
+          <a:blip r:embed="rId4"/>
           <a:stretch>
             <a:fillRect/>
           </a:stretch>
         </p:blipFill>
         <p:spPr>
           <a:xfrm>
-            <a:off x="2857500" y="857240"/>
-            <a:ext cx="3429000" cy="3429000"/>
+            <a:off x="320039" y="1051560"/>
+            <a:ext cx="8503920" cy="3188970"/>
           </a:xfrm>
           <a:prstGeom prst="rect">
             <a:avLst/>
@@ -11421,6 +11495,80 @@
       <p:grpSpPr/>
       <p:sp>
         <p:nvSpPr>
+          <p:cNvPr id="2" name="Title 1"/>
+          <p:cNvSpPr>
+            <a:spLocks noGrp="1"/>
+          </p:cNvSpPr>
+          <p:nvPr>
+            <p:ph type="title"/>
+          </p:nvPr>
+        </p:nvSpPr>
+        <p:spPr/>
+        <p:txBody>
+          <a:bodyPr/>
+          <a:lstStyle/>
+          <a:p>
+            <a:pPr indent="0" lvl="0" marL="0" rtl="0" algn="l">
+              <a:spcBef>
+                <a:spcPts val="0"/>
+              </a:spcBef>
+              <a:spcAft>
+                <a:spcPts val="0"/>
+              </a:spcAft>
+              <a:buNone/>
+            </a:pPr>
+            <a:r>
+              <a:rPr lang="en"/>
+              <a:t>The Accumulator</a:t>
+            </a:r>
+            <a:endParaRPr/>
+          </a:p>
+        </p:txBody>
+      </p:sp>
+      <p:pic>
+        <p:nvPicPr>
+          <p:cNvPr id="3" name="Picture 2" descr="tick.png"/>
+          <p:cNvPicPr>
+            <a:picLocks noChangeAspect="1"/>
+          </p:cNvPicPr>
+          <p:nvPr/>
+        </p:nvPicPr>
+        <p:blipFill>
+          <a:blip r:embed="rId2"/>
+          <a:stretch>
+            <a:fillRect/>
+          </a:stretch>
+        </p:blipFill>
+        <p:spPr>
+          <a:xfrm>
+            <a:off x="360381" y="1051560"/>
+            <a:ext cx="8423237" cy="3977640"/>
+          </a:xfrm>
+          <a:prstGeom prst="rect">
+            <a:avLst/>
+          </a:prstGeom>
+        </p:spPr>
+      </p:pic>
+    </p:spTree>
+  </p:cSld>
+  <p:clrMapOvr>
+    <a:masterClrMapping/>
+  </p:clrMapOvr>
+</p:sld>
+</file>
+
+<file path=ppt/slides/slide26.xml><?xml version="1.0" encoding="utf-8"?>
+<p:sld xmlns:a="http://schemas.openxmlformats.org/drawingml/2006/main" xmlns:p="http://schemas.openxmlformats.org/presentationml/2006/main" xmlns:r="http://schemas.openxmlformats.org/officeDocument/2006/relationships">
+  <p:cSld>
+    <p:spTree>
+      <p:nvGrpSpPr>
+        <p:cNvPr id="1" name=""/>
+        <p:cNvGrpSpPr/>
+        <p:nvPr/>
+      </p:nvGrpSpPr>
+      <p:grpSpPr/>
+      <p:sp>
+        <p:nvSpPr>
           <p:cNvPr id="140" name="Google Shape;140;p23"/>
           <p:cNvSpPr txBox="1"/>
           <p:nvPr>
@@ -12077,7 +12225,7 @@
 </p:sld>
 </file>
 
-<file path=ppt/slides/slide26.xml><?xml version="1.0" encoding="utf-8"?>
+<file path=ppt/slides/slide27.xml><?xml version="1.0" encoding="utf-8"?>
 <p:sld xmlns:a="http://schemas.openxmlformats.org/drawingml/2006/main" xmlns:p="http://schemas.openxmlformats.org/presentationml/2006/main" xmlns:r="http://schemas.openxmlformats.org/officeDocument/2006/relationships">
   <p:cSld>
     <p:spTree>
@@ -12696,7 +12844,7 @@
 </p:sld>
 </file>
 
-<file path=ppt/slides/slide27.xml><?xml version="1.0" encoding="utf-8"?>
+<file path=ppt/slides/slide28.xml><?xml version="1.0" encoding="utf-8"?>
 <p:sld xmlns:a="http://schemas.openxmlformats.org/drawingml/2006/main" xmlns:p="http://schemas.openxmlformats.org/presentationml/2006/main" xmlns:r="http://schemas.openxmlformats.org/officeDocument/2006/relationships">
   <p:cSld>
     <p:spTree>
@@ -12823,7 +12971,7 @@
 </p:sld>
 </file>
 
-<file path=ppt/slides/slide28.xml><?xml version="1.0" encoding="utf-8"?>
+<file path=ppt/slides/slide29.xml><?xml version="1.0" encoding="utf-8"?>
 <p:sld xmlns:a="http://schemas.openxmlformats.org/drawingml/2006/main" xmlns:p="http://schemas.openxmlformats.org/presentationml/2006/main" xmlns:r="http://schemas.openxmlformats.org/officeDocument/2006/relationships">
   <p:cSld>
     <p:spTree>
@@ -12959,462 +13107,6 @@
   <p:clrMapOvr>
     <a:masterClrMapping/>
   </p:clrMapOvr>
-</p:sld>
-</file>
-
-<file path=ppt/slides/slide29.xml><?xml version="1.0" encoding="utf-8"?>
-<p:sld xmlns:a="http://schemas.openxmlformats.org/drawingml/2006/main" xmlns:r="http://schemas.openxmlformats.org/officeDocument/2006/relationships" xmlns:mc="http://schemas.openxmlformats.org/markup-compatibility/2006" xmlns:mv="urn:schemas-microsoft-com:mac:vml" xmlns:p="http://schemas.openxmlformats.org/presentationml/2006/main" xmlns:c="http://schemas.openxmlformats.org/drawingml/2006/chart" xmlns:dgm="http://schemas.openxmlformats.org/drawingml/2006/diagram" xmlns:o="urn:schemas-microsoft-com:office:office" xmlns:v="urn:schemas-microsoft-com:vml" xmlns:pvml="urn:schemas-microsoft-com:office:powerpoint" xmlns:com="http://schemas.openxmlformats.org/drawingml/2006/compatibility" xmlns:p14="http://schemas.microsoft.com/office/powerpoint/2010/main" xmlns:p15="http://schemas.microsoft.com/office/powerpoint/2012/main" xmlns:ahyp="http://schemas.microsoft.com/office/drawing/2018/hyperlinkcolor">
-  <p:cSld>
-    <p:spTree>
-      <p:nvGrpSpPr>
-        <p:cNvPr id="212" name="Shape 212"/>
-        <p:cNvGrpSpPr/>
-        <p:nvPr/>
-      </p:nvGrpSpPr>
-      <p:grpSpPr>
-        <a:xfrm>
-          <a:off x="0" y="0"/>
-          <a:ext cx="0" cy="0"/>
-          <a:chOff x="0" y="0"/>
-          <a:chExt cx="0" cy="0"/>
-        </a:xfrm>
-      </p:grpSpPr>
-      <p:sp>
-        <p:nvSpPr>
-          <p:cNvPr id="213" name="Google Shape;213;p34"/>
-          <p:cNvSpPr txBox="1"/>
-          <p:nvPr>
-            <p:ph type="title"/>
-          </p:nvPr>
-        </p:nvSpPr>
-        <p:spPr>
-          <a:xfrm>
-            <a:off x="311700" y="195615"/>
-            <a:ext cx="8520600" cy="572700"/>
-          </a:xfrm>
-          <a:prstGeom prst="rect">
-            <a:avLst/>
-          </a:prstGeom>
-        </p:spPr>
-        <p:txBody>
-          <a:bodyPr anchorCtr="0" anchor="t" bIns="91425" lIns="91425" spcFirstLastPara="1" rIns="91425" wrap="square" tIns="91425">
-            <a:normAutofit fontScale="90000"/>
-          </a:bodyPr>
-          <a:lstStyle/>
-          <a:p>
-            <a:pPr indent="0" lvl="0" marL="0" rtl="0" algn="l">
-              <a:spcBef>
-                <a:spcPts val="0"/>
-              </a:spcBef>
-              <a:spcAft>
-                <a:spcPts val="0"/>
-              </a:spcAft>
-              <a:buNone/>
-            </a:pPr>
-            <a:r>
-              <a:rPr lang="en"/>
-              <a:t>Collision Detection</a:t>
-            </a:r>
-            <a:endParaRPr/>
-          </a:p>
-        </p:txBody>
-      </p:sp>
-      <p:sp>
-        <p:nvSpPr>
-          <p:cNvPr id="214" name="Google Shape;214;p34"/>
-          <p:cNvSpPr txBox="1"/>
-          <p:nvPr>
-            <p:ph idx="1" type="body"/>
-          </p:nvPr>
-        </p:nvSpPr>
-        <p:spPr>
-          <a:xfrm>
-            <a:off x="311700" y="890825"/>
-            <a:ext cx="8520600" cy="4023300"/>
-          </a:xfrm>
-          <a:prstGeom prst="rect">
-            <a:avLst/>
-          </a:prstGeom>
-        </p:spPr>
-        <p:txBody>
-          <a:bodyPr anchorCtr="0" anchor="t" bIns="91425" lIns="91425" spcFirstLastPara="1" rIns="91425" wrap="square" tIns="91425">
-            <a:normAutofit/>
-          </a:bodyPr>
-          <a:lstStyle/>
-          <a:p>
-            <a:pPr indent="-330200" lvl="0" marL="457200" rtl="0" algn="l">
-              <a:spcBef>
-                <a:spcPts val="0"/>
-              </a:spcBef>
-              <a:spcAft>
-                <a:spcPts val="0"/>
-              </a:spcAft>
-              <a:buSzPts val="1600"/>
-              <a:buChar char="●"/>
-            </a:pPr>
-            <a:r>
-              <a:rPr lang="en"/>
-              <a:t>Distance</a:t>
-            </a:r>
-            <a:endParaRPr/>
-          </a:p>
-          <a:p>
-            <a:pPr indent="-330200" lvl="0" marL="457200" rtl="0" algn="l">
-              <a:spcBef>
-                <a:spcPts val="0"/>
-              </a:spcBef>
-              <a:spcAft>
-                <a:spcPts val="0"/>
-              </a:spcAft>
-              <a:buSzPts val="1600"/>
-              <a:buChar char="●"/>
-            </a:pPr>
-            <a:r>
-              <a:rPr lang="en"/>
-              <a:t>Shape-based</a:t>
-            </a:r>
-            <a:endParaRPr/>
-          </a:p>
-          <a:p>
-            <a:pPr indent="-317500" lvl="1" marL="914400" rtl="0" algn="l">
-              <a:spcBef>
-                <a:spcPts val="0"/>
-              </a:spcBef>
-              <a:spcAft>
-                <a:spcPts val="0"/>
-              </a:spcAft>
-              <a:buSzPts val="1400"/>
-              <a:buChar char="○"/>
-            </a:pPr>
-            <a:r>
-              <a:rPr lang="en"/>
-              <a:t>AABB, Circles</a:t>
-            </a:r>
-            <a:endParaRPr/>
-          </a:p>
-          <a:p>
-            <a:pPr indent="-330200" lvl="0" marL="457200" rtl="0" algn="l">
-              <a:spcBef>
-                <a:spcPts val="0"/>
-              </a:spcBef>
-              <a:spcAft>
-                <a:spcPts val="0"/>
-              </a:spcAft>
-              <a:buSzPts val="1600"/>
-              <a:buChar char="●"/>
-            </a:pPr>
-            <a:r>
-              <a:rPr lang="en"/>
-              <a:t>Complex polygon checks</a:t>
-            </a:r>
-            <a:endParaRPr/>
-          </a:p>
-        </p:txBody>
-      </p:sp>
-      <p:pic>
-        <p:nvPicPr>
-          <p:cNvPr id="215" name="Google Shape;215;p34"/>
-          <p:cNvPicPr preferRelativeResize="0"/>
-          <p:nvPr/>
-        </p:nvPicPr>
-        <p:blipFill>
-          <a:blip r:embed="rId3">
-            <a:alphaModFix/>
-          </a:blip>
-          <a:stretch>
-            <a:fillRect/>
-          </a:stretch>
-        </p:blipFill>
-        <p:spPr>
-          <a:xfrm>
-            <a:off x="2795325" y="2235425"/>
-            <a:ext cx="3810000" cy="2571750"/>
-          </a:xfrm>
-          <a:prstGeom prst="rect">
-            <a:avLst/>
-          </a:prstGeom>
-          <a:noFill/>
-          <a:ln>
-            <a:noFill/>
-          </a:ln>
-        </p:spPr>
-      </p:pic>
-    </p:spTree>
-  </p:cSld>
-  <p:clrMapOvr>
-    <a:masterClrMapping/>
-  </p:clrMapOvr>
-  <p:timing>
-    <p:tnLst>
-      <p:par>
-        <p:cTn dur="indefinite" nodeType="tmRoot" restart="never">
-          <p:childTnLst>
-            <p:seq concurrent="1" nextAc="seek">
-              <p:cTn dur="indefinite" id="2" nodeType="mainSeq">
-                <p:childTnLst>
-                  <p:par>
-                    <p:cTn fill="hold">
-                      <p:stCondLst>
-                        <p:cond delay="indefinite"/>
-                      </p:stCondLst>
-                      <p:childTnLst>
-                        <p:par>
-                          <p:cTn fill="hold">
-                            <p:stCondLst>
-                              <p:cond delay="0"/>
-                            </p:stCondLst>
-                            <p:childTnLst>
-                              <p:par>
-                                <p:cTn fill="hold" nodeType="clickEffect" presetClass="entr" presetID="1" presetSubtype="0">
-                                  <p:stCondLst>
-                                    <p:cond delay="0"/>
-                                  </p:stCondLst>
-                                  <p:childTnLst>
-                                    <p:set>
-                                      <p:cBhvr>
-                                        <p:cTn dur="1" fill="hold">
-                                          <p:stCondLst>
-                                            <p:cond delay="0"/>
-                                          </p:stCondLst>
-                                        </p:cTn>
-                                        <p:tgtEl>
-                                          <p:spTgt spid="214">
-                                            <p:txEl>
-                                              <p:pRg end="0" st="0"/>
-                                            </p:txEl>
-                                          </p:spTgt>
-                                        </p:tgtEl>
-                                        <p:attrNameLst>
-                                          <p:attrName>style.visibility</p:attrName>
-                                        </p:attrNameLst>
-                                      </p:cBhvr>
-                                      <p:to>
-                                        <p:strVal val="visible"/>
-                                      </p:to>
-                                    </p:set>
-                                  </p:childTnLst>
-                                </p:cTn>
-                              </p:par>
-                            </p:childTnLst>
-                          </p:cTn>
-                        </p:par>
-                      </p:childTnLst>
-                    </p:cTn>
-                  </p:par>
-                  <p:par>
-                    <p:cTn fill="hold">
-                      <p:stCondLst>
-                        <p:cond delay="indefinite"/>
-                      </p:stCondLst>
-                      <p:childTnLst>
-                        <p:par>
-                          <p:cTn fill="hold">
-                            <p:stCondLst>
-                              <p:cond delay="0"/>
-                            </p:stCondLst>
-                            <p:childTnLst>
-                              <p:par>
-                                <p:cTn fill="hold" nodeType="clickEffect" presetClass="entr" presetID="1" presetSubtype="0">
-                                  <p:stCondLst>
-                                    <p:cond delay="0"/>
-                                  </p:stCondLst>
-                                  <p:childTnLst>
-                                    <p:set>
-                                      <p:cBhvr>
-                                        <p:cTn dur="1" fill="hold">
-                                          <p:stCondLst>
-                                            <p:cond delay="0"/>
-                                          </p:stCondLst>
-                                        </p:cTn>
-                                        <p:tgtEl>
-                                          <p:spTgt spid="214">
-                                            <p:txEl>
-                                              <p:pRg end="1" st="1"/>
-                                            </p:txEl>
-                                          </p:spTgt>
-                                        </p:tgtEl>
-                                        <p:attrNameLst>
-                                          <p:attrName>style.visibility</p:attrName>
-                                        </p:attrNameLst>
-                                      </p:cBhvr>
-                                      <p:to>
-                                        <p:strVal val="visible"/>
-                                      </p:to>
-                                    </p:set>
-                                  </p:childTnLst>
-                                </p:cTn>
-                              </p:par>
-                            </p:childTnLst>
-                          </p:cTn>
-                        </p:par>
-                      </p:childTnLst>
-                    </p:cTn>
-                  </p:par>
-                  <p:par>
-                    <p:cTn fill="hold">
-                      <p:stCondLst>
-                        <p:cond delay="indefinite"/>
-                      </p:stCondLst>
-                      <p:childTnLst>
-                        <p:par>
-                          <p:cTn fill="hold">
-                            <p:stCondLst>
-                              <p:cond delay="0"/>
-                            </p:stCondLst>
-                            <p:childTnLst>
-                              <p:par>
-                                <p:cTn fill="hold" nodeType="clickEffect" presetClass="entr" presetID="1" presetSubtype="0">
-                                  <p:stCondLst>
-                                    <p:cond delay="0"/>
-                                  </p:stCondLst>
-                                  <p:childTnLst>
-                                    <p:set>
-                                      <p:cBhvr>
-                                        <p:cTn dur="1" fill="hold">
-                                          <p:stCondLst>
-                                            <p:cond delay="0"/>
-                                          </p:stCondLst>
-                                        </p:cTn>
-                                        <p:tgtEl>
-                                          <p:spTgt spid="214">
-                                            <p:txEl>
-                                              <p:pRg end="2" st="2"/>
-                                            </p:txEl>
-                                          </p:spTgt>
-                                        </p:tgtEl>
-                                        <p:attrNameLst>
-                                          <p:attrName>style.visibility</p:attrName>
-                                        </p:attrNameLst>
-                                      </p:cBhvr>
-                                      <p:to>
-                                        <p:strVal val="visible"/>
-                                      </p:to>
-                                    </p:set>
-                                  </p:childTnLst>
-                                </p:cTn>
-                              </p:par>
-                            </p:childTnLst>
-                          </p:cTn>
-                        </p:par>
-                      </p:childTnLst>
-                    </p:cTn>
-                  </p:par>
-                  <p:par>
-                    <p:cTn fill="hold">
-                      <p:stCondLst>
-                        <p:cond delay="indefinite"/>
-                      </p:stCondLst>
-                      <p:childTnLst>
-                        <p:par>
-                          <p:cTn fill="hold">
-                            <p:stCondLst>
-                              <p:cond delay="0"/>
-                            </p:stCondLst>
-                            <p:childTnLst>
-                              <p:par>
-                                <p:cTn fill="hold" nodeType="clickEffect" presetClass="entr" presetID="1" presetSubtype="0">
-                                  <p:stCondLst>
-                                    <p:cond delay="0"/>
-                                  </p:stCondLst>
-                                  <p:childTnLst>
-                                    <p:set>
-                                      <p:cBhvr>
-                                        <p:cTn dur="1" fill="hold">
-                                          <p:stCondLst>
-                                            <p:cond delay="0"/>
-                                          </p:stCondLst>
-                                        </p:cTn>
-                                        <p:tgtEl>
-                                          <p:spTgt spid="214">
-                                            <p:txEl>
-                                              <p:pRg end="3" st="3"/>
-                                            </p:txEl>
-                                          </p:spTgt>
-                                        </p:tgtEl>
-                                        <p:attrNameLst>
-                                          <p:attrName>style.visibility</p:attrName>
-                                        </p:attrNameLst>
-                                      </p:cBhvr>
-                                      <p:to>
-                                        <p:strVal val="visible"/>
-                                      </p:to>
-                                    </p:set>
-                                  </p:childTnLst>
-                                </p:cTn>
-                              </p:par>
-                            </p:childTnLst>
-                          </p:cTn>
-                        </p:par>
-                      </p:childTnLst>
-                    </p:cTn>
-                  </p:par>
-                  <p:par>
-                    <p:cTn fill="hold">
-                      <p:stCondLst>
-                        <p:cond delay="indefinite"/>
-                      </p:stCondLst>
-                      <p:childTnLst>
-                        <p:par>
-                          <p:cTn fill="hold">
-                            <p:stCondLst>
-                              <p:cond delay="0"/>
-                            </p:stCondLst>
-                            <p:childTnLst>
-                              <p:par>
-                                <p:cTn fill="hold" nodeType="clickEffect" presetClass="entr" presetID="1" presetSubtype="0">
-                                  <p:stCondLst>
-                                    <p:cond delay="0"/>
-                                  </p:stCondLst>
-                                  <p:childTnLst>
-                                    <p:set>
-                                      <p:cBhvr>
-                                        <p:cTn dur="1" fill="hold">
-                                          <p:stCondLst>
-                                            <p:cond delay="0"/>
-                                          </p:stCondLst>
-                                        </p:cTn>
-                                        <p:tgtEl>
-                                          <p:spTgt spid="215"/>
-                                        </p:tgtEl>
-                                        <p:attrNameLst>
-                                          <p:attrName>style.visibility</p:attrName>
-                                        </p:attrNameLst>
-                                      </p:cBhvr>
-                                      <p:to>
-                                        <p:strVal val="visible"/>
-                                      </p:to>
-                                    </p:set>
-                                  </p:childTnLst>
-                                </p:cTn>
-                              </p:par>
-                            </p:childTnLst>
-                          </p:cTn>
-                        </p:par>
-                      </p:childTnLst>
-                    </p:cTn>
-                  </p:par>
-                </p:childTnLst>
-              </p:cTn>
-              <p:prevCondLst>
-                <p:cond evt="onPrev">
-                  <p:tgtEl>
-                    <p:sldTgt/>
-                  </p:tgtEl>
-                </p:cond>
-              </p:prevCondLst>
-              <p:nextCondLst>
-                <p:cond evt="onNext">
-                  <p:tgtEl>
-                    <p:sldTgt/>
-                  </p:tgtEl>
-                </p:cond>
-              </p:nextCondLst>
-            </p:seq>
-          </p:childTnLst>
-        </p:cTn>
-      </p:par>
-    </p:tnLst>
-  </p:timing>
 </p:sld>
 </file>
 
@@ -13508,6 +13200,95 @@
 </file>
 
 <file path=ppt/slides/slide30.xml><?xml version="1.0" encoding="utf-8"?>
+<p:sld xmlns:a="http://schemas.openxmlformats.org/drawingml/2006/main" xmlns:r="http://schemas.openxmlformats.org/officeDocument/2006/relationships" xmlns:mc="http://schemas.openxmlformats.org/markup-compatibility/2006" xmlns:mv="urn:schemas-microsoft-com:mac:vml" xmlns:p="http://schemas.openxmlformats.org/presentationml/2006/main" xmlns:c="http://schemas.openxmlformats.org/drawingml/2006/chart" xmlns:dgm="http://schemas.openxmlformats.org/drawingml/2006/diagram" xmlns:o="urn:schemas-microsoft-com:office:office" xmlns:v="urn:schemas-microsoft-com:vml" xmlns:pvml="urn:schemas-microsoft-com:office:powerpoint" xmlns:com="http://schemas.openxmlformats.org/drawingml/2006/compatibility" xmlns:p14="http://schemas.microsoft.com/office/powerpoint/2010/main" xmlns:p15="http://schemas.microsoft.com/office/powerpoint/2012/main" xmlns:ahyp="http://schemas.microsoft.com/office/drawing/2018/hyperlinkcolor">
+  <p:cSld>
+    <p:spTree>
+      <p:nvGrpSpPr>
+        <p:cNvPr id="212" name="Shape 212"/>
+        <p:cNvGrpSpPr/>
+        <p:nvPr/>
+      </p:nvGrpSpPr>
+      <p:grpSpPr>
+        <a:xfrm>
+          <a:off x="0" y="0"/>
+          <a:ext cx="0" cy="0"/>
+          <a:chOff x="0" y="0"/>
+          <a:chExt cx="0" cy="0"/>
+        </a:xfrm>
+      </p:grpSpPr>
+      <p:sp>
+        <p:nvSpPr>
+          <p:cNvPr id="213" name="Google Shape;213;p34"/>
+          <p:cNvSpPr txBox="1"/>
+          <p:nvPr>
+            <p:ph type="title"/>
+          </p:nvPr>
+        </p:nvSpPr>
+        <p:spPr>
+          <a:xfrm>
+            <a:off x="311700" y="195615"/>
+            <a:ext cx="8520600" cy="572700"/>
+          </a:xfrm>
+          <a:prstGeom prst="rect">
+            <a:avLst/>
+          </a:prstGeom>
+        </p:spPr>
+        <p:txBody>
+          <a:bodyPr anchorCtr="0" anchor="t" bIns="91425" lIns="91425" spcFirstLastPara="1" rIns="91425" wrap="square" tIns="91425">
+            <a:normAutofit fontScale="90000"/>
+          </a:bodyPr>
+          <a:lstStyle/>
+          <a:p>
+            <a:pPr indent="0" lvl="0" marL="0" rtl="0" algn="l">
+              <a:spcBef>
+                <a:spcPts val="0"/>
+              </a:spcBef>
+              <a:spcAft>
+                <a:spcPts val="0"/>
+              </a:spcAft>
+              <a:buNone/>
+            </a:pPr>
+            <a:r>
+              <a:rPr lang="en"/>
+              <a:t>Collision Detection</a:t>
+            </a:r>
+            <a:endParaRPr/>
+          </a:p>
+        </p:txBody>
+      </p:sp>
+      <p:pic>
+        <p:nvPicPr>
+          <p:cNvPr id="215" name="Picture 214" descr="circles.png"/>
+          <p:cNvPicPr>
+            <a:picLocks noChangeAspect="1"/>
+          </p:cNvPicPr>
+          <p:nvPr/>
+        </p:nvPicPr>
+        <p:blipFill>
+          <a:blip r:embed="rId4"/>
+          <a:stretch>
+            <a:fillRect/>
+          </a:stretch>
+        </p:blipFill>
+        <p:spPr>
+          <a:xfrm>
+            <a:off x="320039" y="1051560"/>
+            <a:ext cx="8503920" cy="3543300"/>
+          </a:xfrm>
+          <a:prstGeom prst="rect">
+            <a:avLst/>
+          </a:prstGeom>
+        </p:spPr>
+      </p:pic>
+    </p:spTree>
+  </p:cSld>
+  <p:clrMapOvr>
+    <a:masterClrMapping/>
+  </p:clrMapOvr>
+</p:sld>
+</file>
+
+<file path=ppt/slides/slide31.xml><?xml version="1.0" encoding="utf-8"?>
 <p:sld xmlns:a="http://schemas.openxmlformats.org/drawingml/2006/main" xmlns:r="http://schemas.openxmlformats.org/officeDocument/2006/relationships" xmlns:mc="http://schemas.openxmlformats.org/markup-compatibility/2006" xmlns:mv="urn:schemas-microsoft-com:mac:vml" xmlns:p="http://schemas.openxmlformats.org/presentationml/2006/main" xmlns:c="http://schemas.openxmlformats.org/drawingml/2006/chart" xmlns:dgm="http://schemas.openxmlformats.org/drawingml/2006/diagram" xmlns:o="urn:schemas-microsoft-com:office:office" xmlns:v="urn:schemas-microsoft-com:vml" xmlns:pvml="urn:schemas-microsoft-com:office:powerpoint" xmlns:com="http://schemas.openxmlformats.org/drawingml/2006/compatibility" xmlns:p14="http://schemas.microsoft.com/office/powerpoint/2010/main" xmlns:p15="http://schemas.microsoft.com/office/powerpoint/2012/main" xmlns:ahyp="http://schemas.microsoft.com/office/drawing/2018/hyperlinkcolor">
   <p:cSld>
     <p:spTree>
@@ -15559,7 +15340,7 @@
 </p:sld>
 </file>
 
-<file path=ppt/slides/slide31.xml><?xml version="1.0" encoding="utf-8"?>
+<file path=ppt/slides/slide32.xml><?xml version="1.0" encoding="utf-8"?>
 <p:sld xmlns:a="http://schemas.openxmlformats.org/drawingml/2006/main" xmlns:r="http://schemas.openxmlformats.org/officeDocument/2006/relationships" xmlns:mc="http://schemas.openxmlformats.org/markup-compatibility/2006" xmlns:mv="urn:schemas-microsoft-com:mac:vml" xmlns:p="http://schemas.openxmlformats.org/presentationml/2006/main" xmlns:c="http://schemas.openxmlformats.org/drawingml/2006/chart" xmlns:dgm="http://schemas.openxmlformats.org/drawingml/2006/diagram" xmlns:o="urn:schemas-microsoft-com:office:office" xmlns:v="urn:schemas-microsoft-com:vml" xmlns:pvml="urn:schemas-microsoft-com:office:powerpoint" xmlns:com="http://schemas.openxmlformats.org/drawingml/2006/compatibility" xmlns:p14="http://schemas.microsoft.com/office/powerpoint/2010/main" xmlns:p15="http://schemas.microsoft.com/office/powerpoint/2012/main" xmlns:ahyp="http://schemas.microsoft.com/office/drawing/2018/hyperlinkcolor">
   <p:cSld>
     <p:spTree>
@@ -15734,7 +15515,7 @@
 </p:sld>
 </file>
 
-<file path=ppt/slides/slide32.xml><?xml version="1.0" encoding="utf-8"?>
+<file path=ppt/slides/slide33.xml><?xml version="1.0" encoding="utf-8"?>
 <p:sld xmlns:a="http://schemas.openxmlformats.org/drawingml/2006/main" xmlns:r="http://schemas.openxmlformats.org/officeDocument/2006/relationships" xmlns:mc="http://schemas.openxmlformats.org/markup-compatibility/2006" xmlns:mv="urn:schemas-microsoft-com:mac:vml" xmlns:p="http://schemas.openxmlformats.org/presentationml/2006/main" xmlns:c="http://schemas.openxmlformats.org/drawingml/2006/chart" xmlns:dgm="http://schemas.openxmlformats.org/drawingml/2006/diagram" xmlns:o="urn:schemas-microsoft-com:office:office" xmlns:v="urn:schemas-microsoft-com:vml" xmlns:pvml="urn:schemas-microsoft-com:office:powerpoint" xmlns:com="http://schemas.openxmlformats.org/drawingml/2006/compatibility" xmlns:p14="http://schemas.microsoft.com/office/powerpoint/2010/main" xmlns:p15="http://schemas.microsoft.com/office/powerpoint/2012/main" xmlns:ahyp="http://schemas.microsoft.com/office/drawing/2018/hyperlinkcolor">
   <p:cSld>
     <p:spTree>
@@ -15967,7 +15748,7 @@
 </p:sld>
 </file>
 
-<file path=ppt/slides/slide33.xml><?xml version="1.0" encoding="utf-8"?>
+<file path=ppt/slides/slide34.xml><?xml version="1.0" encoding="utf-8"?>
 <p:sld xmlns:a="http://schemas.openxmlformats.org/drawingml/2006/main" xmlns:r="http://schemas.openxmlformats.org/officeDocument/2006/relationships" xmlns:mc="http://schemas.openxmlformats.org/markup-compatibility/2006" xmlns:mv="urn:schemas-microsoft-com:mac:vml" xmlns:p="http://schemas.openxmlformats.org/presentationml/2006/main" xmlns:c="http://schemas.openxmlformats.org/drawingml/2006/chart" xmlns:dgm="http://schemas.openxmlformats.org/drawingml/2006/diagram" xmlns:o="urn:schemas-microsoft-com:office:office" xmlns:v="urn:schemas-microsoft-com:vml" xmlns:pvml="urn:schemas-microsoft-com:office:powerpoint" xmlns:com="http://schemas.openxmlformats.org/drawingml/2006/compatibility" xmlns:p14="http://schemas.microsoft.com/office/powerpoint/2010/main" xmlns:p15="http://schemas.microsoft.com/office/powerpoint/2012/main" xmlns:ahyp="http://schemas.microsoft.com/office/drawing/2018/hyperlinkcolor">
   <p:cSld>
     <p:spTree>
@@ -16216,7 +15997,7 @@
 </p:sld>
 </file>
 
-<file path=ppt/slides/slide34.xml><?xml version="1.0" encoding="utf-8"?>
+<file path=ppt/slides/slide35.xml><?xml version="1.0" encoding="utf-8"?>
 <p:sld xmlns:a="http://schemas.openxmlformats.org/drawingml/2006/main" xmlns:r="http://schemas.openxmlformats.org/officeDocument/2006/relationships" xmlns:mc="http://schemas.openxmlformats.org/markup-compatibility/2006" xmlns:mv="urn:schemas-microsoft-com:mac:vml" xmlns:p="http://schemas.openxmlformats.org/presentationml/2006/main" xmlns:c="http://schemas.openxmlformats.org/drawingml/2006/chart" xmlns:dgm="http://schemas.openxmlformats.org/drawingml/2006/diagram" xmlns:o="urn:schemas-microsoft-com:office:office" xmlns:v="urn:schemas-microsoft-com:vml" xmlns:pvml="urn:schemas-microsoft-com:office:powerpoint" xmlns:com="http://schemas.openxmlformats.org/drawingml/2006/compatibility" xmlns:p14="http://schemas.microsoft.com/office/powerpoint/2010/main" xmlns:p15="http://schemas.microsoft.com/office/powerpoint/2012/main" xmlns:ahyp="http://schemas.microsoft.com/office/drawing/2018/hyperlinkcolor">
   <p:cSld>
     <p:spTree>
@@ -16485,7 +16266,7 @@
 </p:sld>
 </file>
 
-<file path=ppt/slides/slide35.xml><?xml version="1.0" encoding="utf-8"?>
+<file path=ppt/slides/slide36.xml><?xml version="1.0" encoding="utf-8"?>
 <p:sld xmlns:a="http://schemas.openxmlformats.org/drawingml/2006/main" xmlns:r="http://schemas.openxmlformats.org/officeDocument/2006/relationships" xmlns:mc="http://schemas.openxmlformats.org/markup-compatibility/2006" xmlns:mv="urn:schemas-microsoft-com:mac:vml" xmlns:p="http://schemas.openxmlformats.org/presentationml/2006/main" xmlns:c="http://schemas.openxmlformats.org/drawingml/2006/chart" xmlns:dgm="http://schemas.openxmlformats.org/drawingml/2006/diagram" xmlns:o="urn:schemas-microsoft-com:office:office" xmlns:v="urn:schemas-microsoft-com:vml" xmlns:pvml="urn:schemas-microsoft-com:office:powerpoint" xmlns:com="http://schemas.openxmlformats.org/drawingml/2006/compatibility" xmlns:p14="http://schemas.microsoft.com/office/powerpoint/2010/main" xmlns:p15="http://schemas.microsoft.com/office/powerpoint/2012/main" xmlns:ahyp="http://schemas.microsoft.com/office/drawing/2018/hyperlinkcolor">
   <p:cSld>
     <p:spTree>
@@ -16619,7 +16400,7 @@
 </p:sld>
 </file>
 
-<file path=ppt/slides/slide36.xml><?xml version="1.0" encoding="utf-8"?>
+<file path=ppt/slides/slide37.xml><?xml version="1.0" encoding="utf-8"?>
 <p:sld xmlns:a="http://schemas.openxmlformats.org/drawingml/2006/main" xmlns:r="http://schemas.openxmlformats.org/officeDocument/2006/relationships" xmlns:mc="http://schemas.openxmlformats.org/markup-compatibility/2006" xmlns:mv="urn:schemas-microsoft-com:mac:vml" xmlns:p="http://schemas.openxmlformats.org/presentationml/2006/main" xmlns:c="http://schemas.openxmlformats.org/drawingml/2006/chart" xmlns:dgm="http://schemas.openxmlformats.org/drawingml/2006/diagram" xmlns:o="urn:schemas-microsoft-com:office:office" xmlns:v="urn:schemas-microsoft-com:vml" xmlns:pvml="urn:schemas-microsoft-com:office:powerpoint" xmlns:com="http://schemas.openxmlformats.org/drawingml/2006/compatibility" xmlns:p14="http://schemas.microsoft.com/office/powerpoint/2010/main" xmlns:p15="http://schemas.microsoft.com/office/powerpoint/2012/main" xmlns:ahyp="http://schemas.microsoft.com/office/drawing/2018/hyperlinkcolor">
   <p:cSld>
     <p:spTree>
@@ -17059,855 +16840,6 @@
 </p:sld>
 </file>
 
-<file path=ppt/slides/slide37.xml><?xml version="1.0" encoding="utf-8"?>
-<p:sld xmlns:a="http://schemas.openxmlformats.org/drawingml/2006/main" xmlns:r="http://schemas.openxmlformats.org/officeDocument/2006/relationships" xmlns:mc="http://schemas.openxmlformats.org/markup-compatibility/2006" xmlns:mv="urn:schemas-microsoft-com:mac:vml" xmlns:p="http://schemas.openxmlformats.org/presentationml/2006/main" xmlns:c="http://schemas.openxmlformats.org/drawingml/2006/chart" xmlns:dgm="http://schemas.openxmlformats.org/drawingml/2006/diagram" xmlns:o="urn:schemas-microsoft-com:office:office" xmlns:v="urn:schemas-microsoft-com:vml" xmlns:pvml="urn:schemas-microsoft-com:office:powerpoint" xmlns:com="http://schemas.openxmlformats.org/drawingml/2006/compatibility" xmlns:p14="http://schemas.microsoft.com/office/powerpoint/2010/main" xmlns:p15="http://schemas.microsoft.com/office/powerpoint/2012/main" xmlns:ahyp="http://schemas.microsoft.com/office/drawing/2018/hyperlinkcolor">
-  <p:cSld>
-    <p:spTree>
-      <p:nvGrpSpPr>
-        <p:cNvPr id="292" name="Shape 292"/>
-        <p:cNvGrpSpPr/>
-        <p:nvPr/>
-      </p:nvGrpSpPr>
-      <p:grpSpPr>
-        <a:xfrm>
-          <a:off x="0" y="0"/>
-          <a:ext cx="0" cy="0"/>
-          <a:chOff x="0" y="0"/>
-          <a:chExt cx="0" cy="0"/>
-        </a:xfrm>
-      </p:grpSpPr>
-      <p:sp>
-        <p:nvSpPr>
-          <p:cNvPr id="293" name="Google Shape;293;p45"/>
-          <p:cNvSpPr txBox="1"/>
-          <p:nvPr>
-            <p:ph type="title"/>
-          </p:nvPr>
-        </p:nvSpPr>
-        <p:spPr>
-          <a:xfrm>
-            <a:off x="311700" y="195615"/>
-            <a:ext cx="8520600" cy="572700"/>
-          </a:xfrm>
-          <a:prstGeom prst="rect">
-            <a:avLst/>
-          </a:prstGeom>
-        </p:spPr>
-        <p:txBody>
-          <a:bodyPr anchorCtr="0" anchor="t" bIns="91425" lIns="91425" spcFirstLastPara="1" rIns="91425" wrap="square" tIns="91425">
-            <a:normAutofit fontScale="90000"/>
-          </a:bodyPr>
-          <a:lstStyle/>
-          <a:p>
-            <a:pPr indent="0" lvl="0" marL="0" rtl="0" algn="l">
-              <a:spcBef>
-                <a:spcPts val="0"/>
-              </a:spcBef>
-              <a:spcAft>
-                <a:spcPts val="0"/>
-              </a:spcAft>
-              <a:buNone/>
-            </a:pPr>
-            <a:r>
-              <a:rPr lang="en">
-                <a:solidFill>
-                  <a:schemeClr val="accent5"/>
-                </a:solidFill>
-              </a:rPr>
-              <a:t>Exercises</a:t>
-            </a:r>
-            <a:endParaRPr>
-              <a:solidFill>
-                <a:schemeClr val="accent5"/>
-              </a:solidFill>
-            </a:endParaRPr>
-          </a:p>
-        </p:txBody>
-      </p:sp>
-      <p:sp>
-        <p:nvSpPr>
-          <p:cNvPr id="294" name="Google Shape;294;p45"/>
-          <p:cNvSpPr txBox="1"/>
-          <p:nvPr>
-            <p:ph idx="1" type="body"/>
-          </p:nvPr>
-        </p:nvSpPr>
-        <p:spPr>
-          <a:xfrm>
-            <a:off x="311700" y="885950"/>
-            <a:ext cx="8520600" cy="2057400"/>
-          </a:xfrm>
-          <a:prstGeom prst="rect">
-            <a:avLst/>
-          </a:prstGeom>
-        </p:spPr>
-        <p:txBody>
-          <a:bodyPr anchorCtr="0" anchor="t" bIns="91425" lIns="91425" spcFirstLastPara="1" rIns="91425" wrap="square" tIns="91425">
-            <a:normAutofit/>
-          </a:bodyPr>
-          <a:lstStyle/>
-          <a:p>
-            <a:pPr indent="-330200" lvl="0" marL="457200" rtl="0" algn="l">
-              <a:spcBef>
-                <a:spcPts val="0"/>
-              </a:spcBef>
-              <a:spcAft>
-                <a:spcPts val="0"/>
-              </a:spcAft>
-              <a:buSzPts val="1600"/>
-              <a:buChar char="●"/>
-            </a:pPr>
-            <a:r>
-              <a:rPr lang="en"/>
-              <a:t>Start from Snake9, the finished game</a:t>
-            </a:r>
-            <a:endParaRPr/>
-          </a:p>
-          <a:p>
-            <a:pPr indent="-330200" lvl="0" marL="457200" rtl="0" algn="l">
-              <a:spcBef>
-                <a:spcPts val="0"/>
-              </a:spcBef>
-              <a:spcAft>
-                <a:spcPts val="0"/>
-              </a:spcAft>
-              <a:buSzPts val="1600"/>
-              <a:buChar char="●"/>
-            </a:pPr>
-            <a:r>
-              <a:rPr lang="en"/>
-              <a:t>Speed up: make the tick shorter every time the snake eats</a:t>
-            </a:r>
-            <a:endParaRPr/>
-          </a:p>
-          <a:p>
-            <a:pPr indent="-330200" lvl="0" marL="457200" rtl="0" algn="l">
-              <a:spcBef>
-                <a:spcPts val="0"/>
-              </a:spcBef>
-              <a:spcAft>
-                <a:spcPts val="0"/>
-              </a:spcAft>
-              <a:buSzPts val="1600"/>
-              <a:buChar char="●"/>
-            </a:pPr>
-            <a:r>
-              <a:rPr lang="en"/>
-              <a:t>Where does that rule belong?</a:t>
-            </a:r>
-            <a:endParaRPr/>
-          </a:p>
-          <a:p>
-            <a:pPr indent="-330200" lvl="0" marL="457200" rtl="0" algn="l">
-              <a:spcBef>
-                <a:spcPts val="0"/>
-              </a:spcBef>
-              <a:spcAft>
-                <a:spcPts val="0"/>
-              </a:spcAft>
-              <a:buSzPts val="1600"/>
-              <a:buChar char="●"/>
-            </a:pPr>
-            <a:r>
-              <a:rPr lang="en"/>
-              <a:t>New input: the D-pad, through a GamePadInfo in GARCore</a:t>
-            </a:r>
-            <a:endParaRPr/>
-          </a:p>
-          <a:p>
-            <a:pPr indent="-330200" lvl="0" marL="457200" rtl="0" algn="l">
-              <a:spcBef>
-                <a:spcPts val="0"/>
-              </a:spcBef>
-              <a:spcAft>
-                <a:spcPts val="0"/>
-              </a:spcAft>
-              <a:buSzPts val="1600"/>
-              <a:buChar char="●"/>
-            </a:pPr>
-            <a:r>
-              <a:rPr lang="en"/>
-              <a:t>Pause: while paused, the snake doesn’t move and turns aren’t buffered</a:t>
-            </a:r>
-            <a:endParaRPr/>
-          </a:p>
-        </p:txBody>
-      </p:sp>
-    </p:spTree>
-  </p:cSld>
-  <p:clrMapOvr>
-    <a:masterClrMapping/>
-  </p:clrMapOvr>
-  <p:timing>
-    <p:tnLst>
-      <p:par>
-        <p:cTn dur="indefinite" nodeType="tmRoot" restart="never">
-          <p:childTnLst>
-            <p:seq concurrent="1" nextAc="seek">
-              <p:cTn dur="indefinite" id="2" nodeType="mainSeq">
-                <p:childTnLst>
-                  <p:par>
-                    <p:cTn fill="hold">
-                      <p:stCondLst>
-                        <p:cond delay="indefinite"/>
-                      </p:stCondLst>
-                      <p:childTnLst>
-                        <p:par>
-                          <p:cTn fill="hold">
-                            <p:stCondLst>
-                              <p:cond delay="0"/>
-                            </p:stCondLst>
-                            <p:childTnLst>
-                              <p:par>
-                                <p:cTn fill="hold" nodeType="clickEffect" presetClass="entr" presetID="1" presetSubtype="0">
-                                  <p:stCondLst>
-                                    <p:cond delay="0"/>
-                                  </p:stCondLst>
-                                  <p:childTnLst>
-                                    <p:set>
-                                      <p:cBhvr>
-                                        <p:cTn dur="1" fill="hold">
-                                          <p:stCondLst>
-                                            <p:cond delay="0"/>
-                                          </p:stCondLst>
-                                        </p:cTn>
-                                        <p:tgtEl>
-                                          <p:spTgt spid="294">
-                                            <p:txEl>
-                                              <p:pRg end="0" st="0"/>
-                                            </p:txEl>
-                                          </p:spTgt>
-                                        </p:tgtEl>
-                                        <p:attrNameLst>
-                                          <p:attrName>style.visibility</p:attrName>
-                                        </p:attrNameLst>
-                                      </p:cBhvr>
-                                      <p:to>
-                                        <p:strVal val="visible"/>
-                                      </p:to>
-                                    </p:set>
-                                  </p:childTnLst>
-                                </p:cTn>
-                              </p:par>
-                            </p:childTnLst>
-                          </p:cTn>
-                        </p:par>
-                      </p:childTnLst>
-                    </p:cTn>
-                  </p:par>
-                  <p:par>
-                    <p:cTn fill="hold">
-                      <p:stCondLst>
-                        <p:cond delay="indefinite"/>
-                      </p:stCondLst>
-                      <p:childTnLst>
-                        <p:par>
-                          <p:cTn fill="hold">
-                            <p:stCondLst>
-                              <p:cond delay="0"/>
-                            </p:stCondLst>
-                            <p:childTnLst>
-                              <p:par>
-                                <p:cTn fill="hold" nodeType="clickEffect" presetClass="entr" presetID="1" presetSubtype="0">
-                                  <p:stCondLst>
-                                    <p:cond delay="0"/>
-                                  </p:stCondLst>
-                                  <p:childTnLst>
-                                    <p:set>
-                                      <p:cBhvr>
-                                        <p:cTn dur="1" fill="hold">
-                                          <p:stCondLst>
-                                            <p:cond delay="0"/>
-                                          </p:stCondLst>
-                                        </p:cTn>
-                                        <p:tgtEl>
-                                          <p:spTgt spid="294">
-                                            <p:txEl>
-                                              <p:pRg end="1" st="1"/>
-                                            </p:txEl>
-                                          </p:spTgt>
-                                        </p:tgtEl>
-                                        <p:attrNameLst>
-                                          <p:attrName>style.visibility</p:attrName>
-                                        </p:attrNameLst>
-                                      </p:cBhvr>
-                                      <p:to>
-                                        <p:strVal val="visible"/>
-                                      </p:to>
-                                    </p:set>
-                                  </p:childTnLst>
-                                </p:cTn>
-                              </p:par>
-                            </p:childTnLst>
-                          </p:cTn>
-                        </p:par>
-                      </p:childTnLst>
-                    </p:cTn>
-                  </p:par>
-                  <p:par>
-                    <p:cTn fill="hold">
-                      <p:stCondLst>
-                        <p:cond delay="indefinite"/>
-                      </p:stCondLst>
-                      <p:childTnLst>
-                        <p:par>
-                          <p:cTn fill="hold">
-                            <p:stCondLst>
-                              <p:cond delay="0"/>
-                            </p:stCondLst>
-                            <p:childTnLst>
-                              <p:par>
-                                <p:cTn fill="hold" nodeType="clickEffect" presetClass="entr" presetID="1" presetSubtype="0">
-                                  <p:stCondLst>
-                                    <p:cond delay="0"/>
-                                  </p:stCondLst>
-                                  <p:childTnLst>
-                                    <p:set>
-                                      <p:cBhvr>
-                                        <p:cTn dur="1" fill="hold">
-                                          <p:stCondLst>
-                                            <p:cond delay="0"/>
-                                          </p:stCondLst>
-                                        </p:cTn>
-                                        <p:tgtEl>
-                                          <p:spTgt spid="294">
-                                            <p:txEl>
-                                              <p:pRg end="2" st="2"/>
-                                            </p:txEl>
-                                          </p:spTgt>
-                                        </p:tgtEl>
-                                        <p:attrNameLst>
-                                          <p:attrName>style.visibility</p:attrName>
-                                        </p:attrNameLst>
-                                      </p:cBhvr>
-                                      <p:to>
-                                        <p:strVal val="visible"/>
-                                      </p:to>
-                                    </p:set>
-                                  </p:childTnLst>
-                                </p:cTn>
-                              </p:par>
-                            </p:childTnLst>
-                          </p:cTn>
-                        </p:par>
-                      </p:childTnLst>
-                    </p:cTn>
-                  </p:par>
-                  <p:par>
-                    <p:cTn fill="hold">
-                      <p:stCondLst>
-                        <p:cond delay="indefinite"/>
-                      </p:stCondLst>
-                      <p:childTnLst>
-                        <p:par>
-                          <p:cTn fill="hold">
-                            <p:stCondLst>
-                              <p:cond delay="0"/>
-                            </p:stCondLst>
-                            <p:childTnLst>
-                              <p:par>
-                                <p:cTn fill="hold" nodeType="clickEffect" presetClass="entr" presetID="1" presetSubtype="0">
-                                  <p:stCondLst>
-                                    <p:cond delay="0"/>
-                                  </p:stCondLst>
-                                  <p:childTnLst>
-                                    <p:set>
-                                      <p:cBhvr>
-                                        <p:cTn dur="1" fill="hold">
-                                          <p:stCondLst>
-                                            <p:cond delay="0"/>
-                                          </p:stCondLst>
-                                        </p:cTn>
-                                        <p:tgtEl>
-                                          <p:spTgt spid="294">
-                                            <p:txEl>
-                                              <p:pRg end="3" st="3"/>
-                                            </p:txEl>
-                                          </p:spTgt>
-                                        </p:tgtEl>
-                                        <p:attrNameLst>
-                                          <p:attrName>style.visibility</p:attrName>
-                                        </p:attrNameLst>
-                                      </p:cBhvr>
-                                      <p:to>
-                                        <p:strVal val="visible"/>
-                                      </p:to>
-                                    </p:set>
-                                  </p:childTnLst>
-                                </p:cTn>
-                              </p:par>
-                            </p:childTnLst>
-                          </p:cTn>
-                        </p:par>
-                      </p:childTnLst>
-                    </p:cTn>
-                  </p:par>
-                  <p:par>
-                    <p:cTn fill="hold">
-                      <p:stCondLst>
-                        <p:cond delay="indefinite"/>
-                      </p:stCondLst>
-                      <p:childTnLst>
-                        <p:par>
-                          <p:cTn fill="hold">
-                            <p:stCondLst>
-                              <p:cond delay="0"/>
-                            </p:stCondLst>
-                            <p:childTnLst>
-                              <p:par>
-                                <p:cTn fill="hold" nodeType="clickEffect" presetClass="entr" presetID="1" presetSubtype="0">
-                                  <p:stCondLst>
-                                    <p:cond delay="0"/>
-                                  </p:stCondLst>
-                                  <p:childTnLst>
-                                    <p:set>
-                                      <p:cBhvr>
-                                        <p:cTn dur="1" fill="hold">
-                                          <p:stCondLst>
-                                            <p:cond delay="0"/>
-                                          </p:stCondLst>
-                                        </p:cTn>
-                                        <p:tgtEl>
-                                          <p:spTgt spid="294">
-                                            <p:txEl>
-                                              <p:pRg end="4" st="4"/>
-                                            </p:txEl>
-                                          </p:spTgt>
-                                        </p:tgtEl>
-                                        <p:attrNameLst>
-                                          <p:attrName>style.visibility</p:attrName>
-                                        </p:attrNameLst>
-                                      </p:cBhvr>
-                                      <p:to>
-                                        <p:strVal val="visible"/>
-                                      </p:to>
-                                    </p:set>
-                                  </p:childTnLst>
-                                </p:cTn>
-                              </p:par>
-                            </p:childTnLst>
-                          </p:cTn>
-                        </p:par>
-                      </p:childTnLst>
-                    </p:cTn>
-                  </p:par>
-                  <p:par>
-                    <p:cTn fill="hold">
-                      <p:stCondLst>
-                        <p:cond delay="indefinite"/>
-                      </p:stCondLst>
-                      <p:childTnLst>
-                        <p:par>
-                          <p:cTn fill="hold">
-                            <p:stCondLst>
-                              <p:cond delay="0"/>
-                            </p:stCondLst>
-                            <p:childTnLst>
-                              <p:par>
-                                <p:cTn fill="hold" nodeType="clickEffect" presetClass="entr" presetID="1" presetSubtype="0">
-                                  <p:stCondLst>
-                                    <p:cond delay="0"/>
-                                  </p:stCondLst>
-                                  <p:childTnLst>
-                                    <p:set>
-                                      <p:cBhvr>
-                                        <p:cTn dur="1" fill="hold">
-                                          <p:stCondLst>
-                                            <p:cond delay="0"/>
-                                          </p:stCondLst>
-                                        </p:cTn>
-                                        <p:tgtEl>
-                                          <p:spTgt spid="294">
-                                            <p:txEl>
-                                              <p:pRg end="5" st="5"/>
-                                            </p:txEl>
-                                          </p:spTgt>
-                                        </p:tgtEl>
-                                        <p:attrNameLst>
-                                          <p:attrName>style.visibility</p:attrName>
-                                        </p:attrNameLst>
-                                      </p:cBhvr>
-                                      <p:to>
-                                        <p:strVal val="visible"/>
-                                      </p:to>
-                                    </p:set>
-                                  </p:childTnLst>
-                                </p:cTn>
-                              </p:par>
-                            </p:childTnLst>
-                          </p:cTn>
-                        </p:par>
-                      </p:childTnLst>
-                    </p:cTn>
-                  </p:par>
-                  <p:par>
-                    <p:cTn fill="hold">
-                      <p:stCondLst>
-                        <p:cond delay="indefinite"/>
-                      </p:stCondLst>
-                      <p:childTnLst>
-                        <p:par>
-                          <p:cTn fill="hold">
-                            <p:stCondLst>
-                              <p:cond delay="0"/>
-                            </p:stCondLst>
-                            <p:childTnLst>
-                              <p:par>
-                                <p:cTn fill="hold" nodeType="clickEffect" presetClass="entr" presetID="1" presetSubtype="0">
-                                  <p:stCondLst>
-                                    <p:cond delay="0"/>
-                                  </p:stCondLst>
-                                  <p:childTnLst>
-                                    <p:set>
-                                      <p:cBhvr>
-                                        <p:cTn dur="1" fill="hold">
-                                          <p:stCondLst>
-                                            <p:cond delay="0"/>
-                                          </p:stCondLst>
-                                        </p:cTn>
-                                        <p:tgtEl>
-                                          <p:spTgt spid="294">
-                                            <p:txEl>
-                                              <p:pRg end="6" st="6"/>
-                                            </p:txEl>
-                                          </p:spTgt>
-                                        </p:tgtEl>
-                                        <p:attrNameLst>
-                                          <p:attrName>style.visibility</p:attrName>
-                                        </p:attrNameLst>
-                                      </p:cBhvr>
-                                      <p:to>
-                                        <p:strVal val="visible"/>
-                                      </p:to>
-                                    </p:set>
-                                  </p:childTnLst>
-                                </p:cTn>
-                              </p:par>
-                            </p:childTnLst>
-                          </p:cTn>
-                        </p:par>
-                      </p:childTnLst>
-                    </p:cTn>
-                  </p:par>
-                  <p:par>
-                    <p:cTn fill="hold">
-                      <p:stCondLst>
-                        <p:cond delay="indefinite"/>
-                      </p:stCondLst>
-                      <p:childTnLst>
-                        <p:par>
-                          <p:cTn fill="hold">
-                            <p:stCondLst>
-                              <p:cond delay="0"/>
-                            </p:stCondLst>
-                            <p:childTnLst>
-                              <p:par>
-                                <p:cTn fill="hold" nodeType="clickEffect" presetClass="entr" presetID="1" presetSubtype="0">
-                                  <p:stCondLst>
-                                    <p:cond delay="0"/>
-                                  </p:stCondLst>
-                                  <p:childTnLst>
-                                    <p:set>
-                                      <p:cBhvr>
-                                        <p:cTn dur="1" fill="hold">
-                                          <p:stCondLst>
-                                            <p:cond delay="0"/>
-                                          </p:stCondLst>
-                                        </p:cTn>
-                                        <p:tgtEl>
-                                          <p:spTgt spid="294">
-                                            <p:txEl>
-                                              <p:pRg end="7" st="7"/>
-                                            </p:txEl>
-                                          </p:spTgt>
-                                        </p:tgtEl>
-                                        <p:attrNameLst>
-                                          <p:attrName>style.visibility</p:attrName>
-                                        </p:attrNameLst>
-                                      </p:cBhvr>
-                                      <p:to>
-                                        <p:strVal val="visible"/>
-                                      </p:to>
-                                    </p:set>
-                                  </p:childTnLst>
-                                </p:cTn>
-                              </p:par>
-                            </p:childTnLst>
-                          </p:cTn>
-                        </p:par>
-                      </p:childTnLst>
-                    </p:cTn>
-                  </p:par>
-                  <p:par>
-                    <p:cTn fill="hold">
-                      <p:stCondLst>
-                        <p:cond delay="indefinite"/>
-                      </p:stCondLst>
-                      <p:childTnLst>
-                        <p:par>
-                          <p:cTn fill="hold">
-                            <p:stCondLst>
-                              <p:cond delay="0"/>
-                            </p:stCondLst>
-                            <p:childTnLst>
-                              <p:par>
-                                <p:cTn fill="hold" nodeType="clickEffect" presetClass="entr" presetID="1" presetSubtype="0">
-                                  <p:stCondLst>
-                                    <p:cond delay="0"/>
-                                  </p:stCondLst>
-                                  <p:childTnLst>
-                                    <p:set>
-                                      <p:cBhvr>
-                                        <p:cTn dur="1" fill="hold">
-                                          <p:stCondLst>
-                                            <p:cond delay="0"/>
-                                          </p:stCondLst>
-                                        </p:cTn>
-                                        <p:tgtEl>
-                                          <p:spTgt spid="294">
-                                            <p:txEl>
-                                              <p:pRg end="8" st="8"/>
-                                            </p:txEl>
-                                          </p:spTgt>
-                                        </p:tgtEl>
-                                        <p:attrNameLst>
-                                          <p:attrName>style.visibility</p:attrName>
-                                        </p:attrNameLst>
-                                      </p:cBhvr>
-                                      <p:to>
-                                        <p:strVal val="visible"/>
-                                      </p:to>
-                                    </p:set>
-                                  </p:childTnLst>
-                                </p:cTn>
-                              </p:par>
-                            </p:childTnLst>
-                          </p:cTn>
-                        </p:par>
-                      </p:childTnLst>
-                    </p:cTn>
-                  </p:par>
-                  <p:par>
-                    <p:cTn fill="hold">
-                      <p:stCondLst>
-                        <p:cond delay="indefinite"/>
-                      </p:stCondLst>
-                      <p:childTnLst>
-                        <p:par>
-                          <p:cTn fill="hold">
-                            <p:stCondLst>
-                              <p:cond delay="0"/>
-                            </p:stCondLst>
-                            <p:childTnLst>
-                              <p:par>
-                                <p:cTn fill="hold" nodeType="clickEffect" presetClass="entr" presetID="1" presetSubtype="0">
-                                  <p:stCondLst>
-                                    <p:cond delay="0"/>
-                                  </p:stCondLst>
-                                  <p:childTnLst>
-                                    <p:set>
-                                      <p:cBhvr>
-                                        <p:cTn dur="1" fill="hold">
-                                          <p:stCondLst>
-                                            <p:cond delay="0"/>
-                                          </p:stCondLst>
-                                        </p:cTn>
-                                        <p:tgtEl>
-                                          <p:spTgt spid="294">
-                                            <p:txEl>
-                                              <p:pRg end="9" st="9"/>
-                                            </p:txEl>
-                                          </p:spTgt>
-                                        </p:tgtEl>
-                                        <p:attrNameLst>
-                                          <p:attrName>style.visibility</p:attrName>
-                                        </p:attrNameLst>
-                                      </p:cBhvr>
-                                      <p:to>
-                                        <p:strVal val="visible"/>
-                                      </p:to>
-                                    </p:set>
-                                  </p:childTnLst>
-                                </p:cTn>
-                              </p:par>
-                            </p:childTnLst>
-                          </p:cTn>
-                        </p:par>
-                      </p:childTnLst>
-                    </p:cTn>
-                  </p:par>
-                  <p:par>
-                    <p:cTn fill="hold">
-                      <p:stCondLst>
-                        <p:cond delay="indefinite"/>
-                      </p:stCondLst>
-                      <p:childTnLst>
-                        <p:par>
-                          <p:cTn fill="hold">
-                            <p:stCondLst>
-                              <p:cond delay="0"/>
-                            </p:stCondLst>
-                            <p:childTnLst>
-                              <p:par>
-                                <p:cTn fill="hold" nodeType="clickEffect" presetClass="entr" presetID="1" presetSubtype="0">
-                                  <p:stCondLst>
-                                    <p:cond delay="0"/>
-                                  </p:stCondLst>
-                                  <p:childTnLst>
-                                    <p:set>
-                                      <p:cBhvr>
-                                        <p:cTn dur="1" fill="hold">
-                                          <p:stCondLst>
-                                            <p:cond delay="0"/>
-                                          </p:stCondLst>
-                                        </p:cTn>
-                                        <p:tgtEl>
-                                          <p:spTgt spid="294">
-                                            <p:txEl>
-                                              <p:pRg end="10" st="10"/>
-                                            </p:txEl>
-                                          </p:spTgt>
-                                        </p:tgtEl>
-                                        <p:attrNameLst>
-                                          <p:attrName>style.visibility</p:attrName>
-                                        </p:attrNameLst>
-                                      </p:cBhvr>
-                                      <p:to>
-                                        <p:strVal val="visible"/>
-                                      </p:to>
-                                    </p:set>
-                                  </p:childTnLst>
-                                </p:cTn>
-                              </p:par>
-                            </p:childTnLst>
-                          </p:cTn>
-                        </p:par>
-                      </p:childTnLst>
-                    </p:cTn>
-                  </p:par>
-                  <p:par>
-                    <p:cTn fill="hold">
-                      <p:stCondLst>
-                        <p:cond delay="indefinite"/>
-                      </p:stCondLst>
-                      <p:childTnLst>
-                        <p:par>
-                          <p:cTn fill="hold">
-                            <p:stCondLst>
-                              <p:cond delay="0"/>
-                            </p:stCondLst>
-                            <p:childTnLst>
-                              <p:par>
-                                <p:cTn fill="hold" nodeType="clickEffect" presetClass="entr" presetID="1" presetSubtype="0">
-                                  <p:stCondLst>
-                                    <p:cond delay="0"/>
-                                  </p:stCondLst>
-                                  <p:childTnLst>
-                                    <p:set>
-                                      <p:cBhvr>
-                                        <p:cTn dur="1" fill="hold">
-                                          <p:stCondLst>
-                                            <p:cond delay="0"/>
-                                          </p:stCondLst>
-                                        </p:cTn>
-                                        <p:tgtEl>
-                                          <p:spTgt spid="294">
-                                            <p:txEl>
-                                              <p:pRg end="11" st="11"/>
-                                            </p:txEl>
-                                          </p:spTgt>
-                                        </p:tgtEl>
-                                        <p:attrNameLst>
-                                          <p:attrName>style.visibility</p:attrName>
-                                        </p:attrNameLst>
-                                      </p:cBhvr>
-                                      <p:to>
-                                        <p:strVal val="visible"/>
-                                      </p:to>
-                                    </p:set>
-                                  </p:childTnLst>
-                                </p:cTn>
-                              </p:par>
-                            </p:childTnLst>
-                          </p:cTn>
-                        </p:par>
-                      </p:childTnLst>
-                    </p:cTn>
-                  </p:par>
-                  <p:par>
-                    <p:cTn fill="hold">
-                      <p:stCondLst>
-                        <p:cond delay="indefinite"/>
-                      </p:stCondLst>
-                      <p:childTnLst>
-                        <p:par>
-                          <p:cTn fill="hold">
-                            <p:stCondLst>
-                              <p:cond delay="0"/>
-                            </p:stCondLst>
-                            <p:childTnLst>
-                              <p:par>
-                                <p:cTn fill="hold" nodeType="clickEffect" presetClass="entr" presetID="1" presetSubtype="0">
-                                  <p:stCondLst>
-                                    <p:cond delay="0"/>
-                                  </p:stCondLst>
-                                  <p:childTnLst>
-                                    <p:set>
-                                      <p:cBhvr>
-                                        <p:cTn dur="1" fill="hold">
-                                          <p:stCondLst>
-                                            <p:cond delay="0"/>
-                                          </p:stCondLst>
-                                        </p:cTn>
-                                        <p:tgtEl>
-                                          <p:spTgt spid="294">
-                                            <p:txEl>
-                                              <p:pRg end="12" st="12"/>
-                                            </p:txEl>
-                                          </p:spTgt>
-                                        </p:tgtEl>
-                                        <p:attrNameLst>
-                                          <p:attrName>style.visibility</p:attrName>
-                                        </p:attrNameLst>
-                                      </p:cBhvr>
-                                      <p:to>
-                                        <p:strVal val="visible"/>
-                                      </p:to>
-                                    </p:set>
-                                  </p:childTnLst>
-                                </p:cTn>
-                              </p:par>
-                            </p:childTnLst>
-                          </p:cTn>
-                        </p:par>
-                      </p:childTnLst>
-                    </p:cTn>
-                  </p:par>
-                </p:childTnLst>
-              </p:cTn>
-              <p:prevCondLst>
-                <p:cond evt="onPrev">
-                  <p:tgtEl>
-                    <p:sldTgt/>
-                  </p:tgtEl>
-                </p:cond>
-              </p:prevCondLst>
-              <p:nextCondLst>
-                <p:cond evt="onNext">
-                  <p:tgtEl>
-                    <p:sldTgt/>
-                  </p:tgtEl>
-                </p:cond>
-              </p:nextCondLst>
-            </p:seq>
-          </p:childTnLst>
-        </p:cTn>
-      </p:par>
-    </p:tnLst>
-  </p:timing>
-</p:sld>
-</file>
-
 <file path=ppt/slides/slide38.xml><?xml version="1.0" encoding="utf-8"?>
 <p:sld xmlns:a="http://schemas.openxmlformats.org/drawingml/2006/main" xmlns:r="http://schemas.openxmlformats.org/officeDocument/2006/relationships" xmlns:mc="http://schemas.openxmlformats.org/markup-compatibility/2006" xmlns:mv="urn:schemas-microsoft-com:mac:vml" xmlns:p="http://schemas.openxmlformats.org/presentationml/2006/main" xmlns:c="http://schemas.openxmlformats.org/drawingml/2006/chart" xmlns:dgm="http://schemas.openxmlformats.org/drawingml/2006/diagram" xmlns:o="urn:schemas-microsoft-com:office:office" xmlns:v="urn:schemas-microsoft-com:vml" xmlns:pvml="urn:schemas-microsoft-com:office:powerpoint" xmlns:com="http://schemas.openxmlformats.org/drawingml/2006/compatibility" xmlns:p14="http://schemas.microsoft.com/office/powerpoint/2010/main" xmlns:p15="http://schemas.microsoft.com/office/powerpoint/2012/main" xmlns:ahyp="http://schemas.microsoft.com/office/drawing/2018/hyperlinkcolor">
   <p:cSld>
@@ -17963,7 +16895,7 @@
                   <a:schemeClr val="accent5"/>
                 </a:solidFill>
               </a:rPr>
-              <a:t>Exercise: Refactor (Stretch)</a:t>
+              <a:t>Exercises</a:t>
             </a:r>
             <a:endParaRPr>
               <a:solidFill>
@@ -17984,7 +16916,7 @@
         <p:spPr>
           <a:xfrm>
             <a:off x="311700" y="885950"/>
-            <a:ext cx="8520600" cy="4023300"/>
+            <a:ext cx="8520600" cy="2057400"/>
           </a:xfrm>
           <a:prstGeom prst="rect">
             <a:avLst/>
@@ -18008,7 +16940,7 @@
             </a:pPr>
             <a:r>
               <a:rPr lang="en"/>
-              <a:t>The tick timer lives in the Snake class</a:t>
+              <a:t>Start from Snake9, the finished game</a:t>
             </a:r>
             <a:endParaRPr/>
           </a:p>
@@ -18025,24 +16957,7 @@
             </a:pPr>
             <a:r>
               <a:rPr lang="en"/>
-              <a:t>Move it into a reusable FixedTimer class in GARCore</a:t>
-            </a:r>
-            <a:endParaRPr/>
-          </a:p>
-          <a:p>
-            <a:pPr indent="-317500" lvl="1" marL="914400" rtl="0" algn="l">
-              <a:spcBef>
-                <a:spcPts val="0"/>
-              </a:spcBef>
-              <a:spcAft>
-                <a:spcPts val="0"/>
-              </a:spcAft>
-              <a:buSzPts val="1400"/>
-              <a:buChar char="○"/>
-            </a:pPr>
-            <a:r>
-              <a:rPr lang="en"/>
-              <a:t>It calls back on every tick</a:t>
+              <a:t>Speed up: make the tick shorter every time the snake eats</a:t>
             </a:r>
             <a:endParaRPr/>
           </a:p>
@@ -18059,7 +16974,41 @@
             </a:pPr>
             <a:r>
               <a:rPr lang="en"/>
-              <a:t>Use it for the snake</a:t>
+              <a:t>Where does that rule belong?</a:t>
+            </a:r>
+            <a:endParaRPr/>
+          </a:p>
+          <a:p>
+            <a:pPr indent="-330200" lvl="0" marL="457200" rtl="0" algn="l">
+              <a:spcBef>
+                <a:spcPts val="0"/>
+              </a:spcBef>
+              <a:spcAft>
+                <a:spcPts val="0"/>
+              </a:spcAft>
+              <a:buSzPts val="1600"/>
+              <a:buChar char="●"/>
+            </a:pPr>
+            <a:r>
+              <a:rPr lang="en"/>
+              <a:t>New input: the D-pad, through a GamePadInfo in GARCore</a:t>
+            </a:r>
+            <a:endParaRPr/>
+          </a:p>
+          <a:p>
+            <a:pPr indent="-330200" lvl="0" marL="457200" rtl="0" algn="l">
+              <a:spcBef>
+                <a:spcPts val="0"/>
+              </a:spcBef>
+              <a:spcAft>
+                <a:spcPts val="0"/>
+              </a:spcAft>
+              <a:buSzPts val="1600"/>
+              <a:buChar char="●"/>
+            </a:pPr>
+            <a:r>
+              <a:rPr lang="en"/>
+              <a:t>Pause: while paused, the snake doesn’t move and turns aren’t buffered</a:t>
             </a:r>
             <a:endParaRPr/>
           </a:p>
@@ -18741,28 +17690,43 @@
 </file>
 
 <file path=ppt/slides/slide39.xml><?xml version="1.0" encoding="utf-8"?>
-<p:sld xmlns:a="http://schemas.openxmlformats.org/drawingml/2006/main" xmlns:p="http://schemas.openxmlformats.org/presentationml/2006/main" xmlns:r="http://schemas.openxmlformats.org/officeDocument/2006/relationships">
+<p:sld xmlns:a="http://schemas.openxmlformats.org/drawingml/2006/main" xmlns:r="http://schemas.openxmlformats.org/officeDocument/2006/relationships" xmlns:mc="http://schemas.openxmlformats.org/markup-compatibility/2006" xmlns:mv="urn:schemas-microsoft-com:mac:vml" xmlns:p="http://schemas.openxmlformats.org/presentationml/2006/main" xmlns:c="http://schemas.openxmlformats.org/drawingml/2006/chart" xmlns:dgm="http://schemas.openxmlformats.org/drawingml/2006/diagram" xmlns:o="urn:schemas-microsoft-com:office:office" xmlns:v="urn:schemas-microsoft-com:vml" xmlns:pvml="urn:schemas-microsoft-com:office:powerpoint" xmlns:com="http://schemas.openxmlformats.org/drawingml/2006/compatibility" xmlns:p14="http://schemas.microsoft.com/office/powerpoint/2010/main" xmlns:p15="http://schemas.microsoft.com/office/powerpoint/2012/main" xmlns:ahyp="http://schemas.microsoft.com/office/drawing/2018/hyperlinkcolor">
   <p:cSld>
     <p:spTree>
       <p:nvGrpSpPr>
-        <p:cNvPr id="1" name=""/>
+        <p:cNvPr id="292" name="Shape 292"/>
         <p:cNvGrpSpPr/>
         <p:nvPr/>
       </p:nvGrpSpPr>
-      <p:grpSpPr/>
+      <p:grpSpPr>
+        <a:xfrm>
+          <a:off x="0" y="0"/>
+          <a:ext cx="0" cy="0"/>
+          <a:chOff x="0" y="0"/>
+          <a:chExt cx="0" cy="0"/>
+        </a:xfrm>
+      </p:grpSpPr>
       <p:sp>
         <p:nvSpPr>
-          <p:cNvPr id="2" name="Title 1"/>
-          <p:cNvSpPr>
-            <a:spLocks noGrp="1"/>
-          </p:cNvSpPr>
+          <p:cNvPr id="293" name="Google Shape;293;p45"/>
+          <p:cNvSpPr txBox="1"/>
           <p:nvPr>
             <p:ph type="title"/>
           </p:nvPr>
         </p:nvSpPr>
-        <p:spPr/>
+        <p:spPr>
+          <a:xfrm>
+            <a:off x="311700" y="195615"/>
+            <a:ext cx="8520600" cy="572700"/>
+          </a:xfrm>
+          <a:prstGeom prst="rect">
+            <a:avLst/>
+          </a:prstGeom>
+        </p:spPr>
         <p:txBody>
-          <a:bodyPr/>
+          <a:bodyPr anchorCtr="0" anchor="t" bIns="91425" lIns="91425" spcFirstLastPara="1" rIns="91425" wrap="square" tIns="91425">
+            <a:normAutofit fontScale="90000"/>
+          </a:bodyPr>
           <a:lstStyle/>
           <a:p>
             <a:pPr indent="0" lvl="0" marL="0" rtl="0" algn="l">
@@ -18775,133 +17739,110 @@
               <a:buNone/>
             </a:pPr>
             <a:r>
-              <a:rPr lang="en"/>
-              <a:t>Check Yourself</a:t>
-            </a:r>
-            <a:endParaRPr/>
+              <a:rPr lang="en">
+                <a:solidFill>
+                  <a:schemeClr val="accent5"/>
+                </a:solidFill>
+              </a:rPr>
+              <a:t>Exercise: Refactor (Stretch)</a:t>
+            </a:r>
+            <a:endParaRPr>
+              <a:solidFill>
+                <a:schemeClr val="accent5"/>
+              </a:solidFill>
+            </a:endParaRPr>
           </a:p>
         </p:txBody>
       </p:sp>
       <p:sp>
         <p:nvSpPr>
-          <p:cNvPr id="3" name="Text Placeholder 2"/>
-          <p:cNvSpPr>
-            <a:spLocks noGrp="1"/>
-          </p:cNvSpPr>
+          <p:cNvPr id="294" name="Google Shape;294;p45"/>
+          <p:cNvSpPr txBox="1"/>
           <p:nvPr>
-            <p:ph type="body" idx="1"/>
+            <p:ph idx="1" type="body"/>
           </p:nvPr>
         </p:nvSpPr>
         <p:spPr>
           <a:xfrm>
             <a:off x="311700" y="885950"/>
-            <a:ext cx="8520600" cy="1719072"/>
-          </a:xfrm>
-        </p:spPr>
-        <p:txBody>
-          <a:bodyPr/>
-          <a:lstStyle/>
-          <a:p>
-            <a:pPr indent="-330200" lvl="0" marL="457200" rtl="0" algn="l">
-              <a:spcBef>
-                <a:spcPts val="0"/>
-              </a:spcBef>
-              <a:spcAft>
-                <a:spcPts val="0"/>
-              </a:spcAft>
-              <a:buSzPts val="1600"/>
-              <a:buChar char="●"/>
-            </a:pPr>
-            <a:r>
-              <a:rPr lang="en"/>
-              <a:t>Why prefer a texture atlas over many individual image files?</a:t>
-            </a:r>
-            <a:endParaRPr/>
-          </a:p>
-          <a:p>
-            <a:pPr indent="-330200" lvl="0" marL="457200" rtl="0" algn="l">
-              <a:spcBef>
-                <a:spcPts val="0"/>
-              </a:spcBef>
-              <a:spcAft>
-                <a:spcPts val="0"/>
-              </a:spcAft>
-              <a:buSzPts val="1600"/>
-              <a:buChar char="●"/>
-            </a:pPr>
-            <a:r>
-              <a:rPr lang="en"/>
-              <a:t>Why subtract the tick duration from the accumulator instead of resetting it?</a:t>
-            </a:r>
-            <a:endParaRPr/>
-          </a:p>
-          <a:p>
-            <a:pPr indent="-330200" lvl="0" marL="457200" rtl="0" algn="l">
-              <a:spcBef>
-                <a:spcPts val="0"/>
-              </a:spcBef>
-              <a:spcAft>
-                <a:spcPts val="0"/>
-              </a:spcAft>
-              <a:buSzPts val="1600"/>
-              <a:buChar char="●"/>
-            </a:pPr>
-            <a:r>
-              <a:rPr lang="en"/>
-              <a:t>What problems come from reading the keyboard inside gameplay code?</a:t>
-            </a:r>
-            <a:endParaRPr/>
-          </a:p>
-          <a:p>
-            <a:pPr indent="-330200" lvl="0" marL="457200" rtl="0" algn="l">
-              <a:spcBef>
-                <a:spcPts val="0"/>
-              </a:spcBef>
-              <a:spcAft>
-                <a:spcPts val="0"/>
-              </a:spcAft>
-              <a:buSzPts val="1600"/>
-              <a:buChar char="●"/>
-            </a:pPr>
-            <a:r>
-              <a:rPr lang="en"/>
-              <a:t>Why check a buffered turn against the last buffered direction?</a:t>
-            </a:r>
-            <a:endParaRPr/>
-          </a:p>
-        </p:txBody>
-      </p:sp>
-      <p:sp>
-        <p:nvSpPr>
-          <p:cNvPr id="4" name="TextBox 3"/>
-          <p:cNvSpPr txBox="1"/>
-          <p:nvPr/>
-        </p:nvSpPr>
-        <p:spPr>
-          <a:xfrm>
-            <a:off x="457200" y="3182112"/>
-            <a:ext cx="8229600" cy="457200"/>
+            <a:ext cx="8520600" cy="4023300"/>
           </a:xfrm>
           <a:prstGeom prst="rect">
             <a:avLst/>
           </a:prstGeom>
-          <a:noFill/>
         </p:spPr>
         <p:txBody>
-          <a:bodyPr wrap="square">
-            <a:spAutoFit/>
+          <a:bodyPr anchorCtr="0" anchor="t" bIns="91425" lIns="91425" spcFirstLastPara="1" rIns="91425" wrap="square" tIns="91425">
+            <a:normAutofit/>
           </a:bodyPr>
           <a:lstStyle/>
           <a:p>
-            <a:pPr algn="ctr"/>
-            <a:r>
-              <a:rPr sz="1400" b="0" i="0">
-                <a:solidFill>
-                  <a:srgbClr val="9AA3AB"/>
-                </a:solidFill>
-              </a:rPr>
-              <a:t>The answers, and more questions, are on the course site.</a:t>
-            </a:r>
+            <a:pPr indent="-330200" lvl="0" marL="457200" rtl="0" algn="l">
+              <a:spcBef>
+                <a:spcPts val="0"/>
+              </a:spcBef>
+              <a:spcAft>
+                <a:spcPts val="0"/>
+              </a:spcAft>
+              <a:buSzPts val="1600"/>
+              <a:buChar char="●"/>
+            </a:pPr>
+            <a:r>
+              <a:rPr lang="en"/>
+              <a:t>The tick timer lives in the Snake class</a:t>
+            </a:r>
+            <a:endParaRPr/>
+          </a:p>
+          <a:p>
+            <a:pPr indent="-330200" lvl="0" marL="457200" rtl="0" algn="l">
+              <a:spcBef>
+                <a:spcPts val="0"/>
+              </a:spcBef>
+              <a:spcAft>
+                <a:spcPts val="0"/>
+              </a:spcAft>
+              <a:buSzPts val="1600"/>
+              <a:buChar char="●"/>
+            </a:pPr>
+            <a:r>
+              <a:rPr lang="en"/>
+              <a:t>Move it into a reusable FixedTimer class in GARCore</a:t>
+            </a:r>
+            <a:endParaRPr/>
+          </a:p>
+          <a:p>
+            <a:pPr indent="-317500" lvl="1" marL="914400" rtl="0" algn="l">
+              <a:spcBef>
+                <a:spcPts val="0"/>
+              </a:spcBef>
+              <a:spcAft>
+                <a:spcPts val="0"/>
+              </a:spcAft>
+              <a:buSzPts val="1400"/>
+              <a:buChar char="○"/>
+            </a:pPr>
+            <a:r>
+              <a:rPr lang="en"/>
+              <a:t>It calls back on every tick</a:t>
+            </a:r>
+            <a:endParaRPr/>
+          </a:p>
+          <a:p>
+            <a:pPr indent="-330200" lvl="0" marL="457200" rtl="0" algn="l">
+              <a:spcBef>
+                <a:spcPts val="0"/>
+              </a:spcBef>
+              <a:spcAft>
+                <a:spcPts val="0"/>
+              </a:spcAft>
+              <a:buSzPts val="1600"/>
+              <a:buChar char="●"/>
+            </a:pPr>
+            <a:r>
+              <a:rPr lang="en"/>
+              <a:t>Use it for the snake</a:t>
+            </a:r>
+            <a:endParaRPr/>
           </a:p>
         </p:txBody>
       </p:sp>
@@ -18910,6 +17851,673 @@
   <p:clrMapOvr>
     <a:masterClrMapping/>
   </p:clrMapOvr>
+  <p:timing>
+    <p:tnLst>
+      <p:par>
+        <p:cTn dur="indefinite" nodeType="tmRoot" restart="never">
+          <p:childTnLst>
+            <p:seq concurrent="1" nextAc="seek">
+              <p:cTn dur="indefinite" id="2" nodeType="mainSeq">
+                <p:childTnLst>
+                  <p:par>
+                    <p:cTn fill="hold">
+                      <p:stCondLst>
+                        <p:cond delay="indefinite"/>
+                      </p:stCondLst>
+                      <p:childTnLst>
+                        <p:par>
+                          <p:cTn fill="hold">
+                            <p:stCondLst>
+                              <p:cond delay="0"/>
+                            </p:stCondLst>
+                            <p:childTnLst>
+                              <p:par>
+                                <p:cTn fill="hold" nodeType="clickEffect" presetClass="entr" presetID="1" presetSubtype="0">
+                                  <p:stCondLst>
+                                    <p:cond delay="0"/>
+                                  </p:stCondLst>
+                                  <p:childTnLst>
+                                    <p:set>
+                                      <p:cBhvr>
+                                        <p:cTn dur="1" fill="hold">
+                                          <p:stCondLst>
+                                            <p:cond delay="0"/>
+                                          </p:stCondLst>
+                                        </p:cTn>
+                                        <p:tgtEl>
+                                          <p:spTgt spid="294">
+                                            <p:txEl>
+                                              <p:pRg end="0" st="0"/>
+                                            </p:txEl>
+                                          </p:spTgt>
+                                        </p:tgtEl>
+                                        <p:attrNameLst>
+                                          <p:attrName>style.visibility</p:attrName>
+                                        </p:attrNameLst>
+                                      </p:cBhvr>
+                                      <p:to>
+                                        <p:strVal val="visible"/>
+                                      </p:to>
+                                    </p:set>
+                                  </p:childTnLst>
+                                </p:cTn>
+                              </p:par>
+                            </p:childTnLst>
+                          </p:cTn>
+                        </p:par>
+                      </p:childTnLst>
+                    </p:cTn>
+                  </p:par>
+                  <p:par>
+                    <p:cTn fill="hold">
+                      <p:stCondLst>
+                        <p:cond delay="indefinite"/>
+                      </p:stCondLst>
+                      <p:childTnLst>
+                        <p:par>
+                          <p:cTn fill="hold">
+                            <p:stCondLst>
+                              <p:cond delay="0"/>
+                            </p:stCondLst>
+                            <p:childTnLst>
+                              <p:par>
+                                <p:cTn fill="hold" nodeType="clickEffect" presetClass="entr" presetID="1" presetSubtype="0">
+                                  <p:stCondLst>
+                                    <p:cond delay="0"/>
+                                  </p:stCondLst>
+                                  <p:childTnLst>
+                                    <p:set>
+                                      <p:cBhvr>
+                                        <p:cTn dur="1" fill="hold">
+                                          <p:stCondLst>
+                                            <p:cond delay="0"/>
+                                          </p:stCondLst>
+                                        </p:cTn>
+                                        <p:tgtEl>
+                                          <p:spTgt spid="294">
+                                            <p:txEl>
+                                              <p:pRg end="1" st="1"/>
+                                            </p:txEl>
+                                          </p:spTgt>
+                                        </p:tgtEl>
+                                        <p:attrNameLst>
+                                          <p:attrName>style.visibility</p:attrName>
+                                        </p:attrNameLst>
+                                      </p:cBhvr>
+                                      <p:to>
+                                        <p:strVal val="visible"/>
+                                      </p:to>
+                                    </p:set>
+                                  </p:childTnLst>
+                                </p:cTn>
+                              </p:par>
+                            </p:childTnLst>
+                          </p:cTn>
+                        </p:par>
+                      </p:childTnLst>
+                    </p:cTn>
+                  </p:par>
+                  <p:par>
+                    <p:cTn fill="hold">
+                      <p:stCondLst>
+                        <p:cond delay="indefinite"/>
+                      </p:stCondLst>
+                      <p:childTnLst>
+                        <p:par>
+                          <p:cTn fill="hold">
+                            <p:stCondLst>
+                              <p:cond delay="0"/>
+                            </p:stCondLst>
+                            <p:childTnLst>
+                              <p:par>
+                                <p:cTn fill="hold" nodeType="clickEffect" presetClass="entr" presetID="1" presetSubtype="0">
+                                  <p:stCondLst>
+                                    <p:cond delay="0"/>
+                                  </p:stCondLst>
+                                  <p:childTnLst>
+                                    <p:set>
+                                      <p:cBhvr>
+                                        <p:cTn dur="1" fill="hold">
+                                          <p:stCondLst>
+                                            <p:cond delay="0"/>
+                                          </p:stCondLst>
+                                        </p:cTn>
+                                        <p:tgtEl>
+                                          <p:spTgt spid="294">
+                                            <p:txEl>
+                                              <p:pRg end="2" st="2"/>
+                                            </p:txEl>
+                                          </p:spTgt>
+                                        </p:tgtEl>
+                                        <p:attrNameLst>
+                                          <p:attrName>style.visibility</p:attrName>
+                                        </p:attrNameLst>
+                                      </p:cBhvr>
+                                      <p:to>
+                                        <p:strVal val="visible"/>
+                                      </p:to>
+                                    </p:set>
+                                  </p:childTnLst>
+                                </p:cTn>
+                              </p:par>
+                            </p:childTnLst>
+                          </p:cTn>
+                        </p:par>
+                      </p:childTnLst>
+                    </p:cTn>
+                  </p:par>
+                  <p:par>
+                    <p:cTn fill="hold">
+                      <p:stCondLst>
+                        <p:cond delay="indefinite"/>
+                      </p:stCondLst>
+                      <p:childTnLst>
+                        <p:par>
+                          <p:cTn fill="hold">
+                            <p:stCondLst>
+                              <p:cond delay="0"/>
+                            </p:stCondLst>
+                            <p:childTnLst>
+                              <p:par>
+                                <p:cTn fill="hold" nodeType="clickEffect" presetClass="entr" presetID="1" presetSubtype="0">
+                                  <p:stCondLst>
+                                    <p:cond delay="0"/>
+                                  </p:stCondLst>
+                                  <p:childTnLst>
+                                    <p:set>
+                                      <p:cBhvr>
+                                        <p:cTn dur="1" fill="hold">
+                                          <p:stCondLst>
+                                            <p:cond delay="0"/>
+                                          </p:stCondLst>
+                                        </p:cTn>
+                                        <p:tgtEl>
+                                          <p:spTgt spid="294">
+                                            <p:txEl>
+                                              <p:pRg end="3" st="3"/>
+                                            </p:txEl>
+                                          </p:spTgt>
+                                        </p:tgtEl>
+                                        <p:attrNameLst>
+                                          <p:attrName>style.visibility</p:attrName>
+                                        </p:attrNameLst>
+                                      </p:cBhvr>
+                                      <p:to>
+                                        <p:strVal val="visible"/>
+                                      </p:to>
+                                    </p:set>
+                                  </p:childTnLst>
+                                </p:cTn>
+                              </p:par>
+                            </p:childTnLst>
+                          </p:cTn>
+                        </p:par>
+                      </p:childTnLst>
+                    </p:cTn>
+                  </p:par>
+                  <p:par>
+                    <p:cTn fill="hold">
+                      <p:stCondLst>
+                        <p:cond delay="indefinite"/>
+                      </p:stCondLst>
+                      <p:childTnLst>
+                        <p:par>
+                          <p:cTn fill="hold">
+                            <p:stCondLst>
+                              <p:cond delay="0"/>
+                            </p:stCondLst>
+                            <p:childTnLst>
+                              <p:par>
+                                <p:cTn fill="hold" nodeType="clickEffect" presetClass="entr" presetID="1" presetSubtype="0">
+                                  <p:stCondLst>
+                                    <p:cond delay="0"/>
+                                  </p:stCondLst>
+                                  <p:childTnLst>
+                                    <p:set>
+                                      <p:cBhvr>
+                                        <p:cTn dur="1" fill="hold">
+                                          <p:stCondLst>
+                                            <p:cond delay="0"/>
+                                          </p:stCondLst>
+                                        </p:cTn>
+                                        <p:tgtEl>
+                                          <p:spTgt spid="294">
+                                            <p:txEl>
+                                              <p:pRg end="4" st="4"/>
+                                            </p:txEl>
+                                          </p:spTgt>
+                                        </p:tgtEl>
+                                        <p:attrNameLst>
+                                          <p:attrName>style.visibility</p:attrName>
+                                        </p:attrNameLst>
+                                      </p:cBhvr>
+                                      <p:to>
+                                        <p:strVal val="visible"/>
+                                      </p:to>
+                                    </p:set>
+                                  </p:childTnLst>
+                                </p:cTn>
+                              </p:par>
+                            </p:childTnLst>
+                          </p:cTn>
+                        </p:par>
+                      </p:childTnLst>
+                    </p:cTn>
+                  </p:par>
+                  <p:par>
+                    <p:cTn fill="hold">
+                      <p:stCondLst>
+                        <p:cond delay="indefinite"/>
+                      </p:stCondLst>
+                      <p:childTnLst>
+                        <p:par>
+                          <p:cTn fill="hold">
+                            <p:stCondLst>
+                              <p:cond delay="0"/>
+                            </p:stCondLst>
+                            <p:childTnLst>
+                              <p:par>
+                                <p:cTn fill="hold" nodeType="clickEffect" presetClass="entr" presetID="1" presetSubtype="0">
+                                  <p:stCondLst>
+                                    <p:cond delay="0"/>
+                                  </p:stCondLst>
+                                  <p:childTnLst>
+                                    <p:set>
+                                      <p:cBhvr>
+                                        <p:cTn dur="1" fill="hold">
+                                          <p:stCondLst>
+                                            <p:cond delay="0"/>
+                                          </p:stCondLst>
+                                        </p:cTn>
+                                        <p:tgtEl>
+                                          <p:spTgt spid="294">
+                                            <p:txEl>
+                                              <p:pRg end="5" st="5"/>
+                                            </p:txEl>
+                                          </p:spTgt>
+                                        </p:tgtEl>
+                                        <p:attrNameLst>
+                                          <p:attrName>style.visibility</p:attrName>
+                                        </p:attrNameLst>
+                                      </p:cBhvr>
+                                      <p:to>
+                                        <p:strVal val="visible"/>
+                                      </p:to>
+                                    </p:set>
+                                  </p:childTnLst>
+                                </p:cTn>
+                              </p:par>
+                            </p:childTnLst>
+                          </p:cTn>
+                        </p:par>
+                      </p:childTnLst>
+                    </p:cTn>
+                  </p:par>
+                  <p:par>
+                    <p:cTn fill="hold">
+                      <p:stCondLst>
+                        <p:cond delay="indefinite"/>
+                      </p:stCondLst>
+                      <p:childTnLst>
+                        <p:par>
+                          <p:cTn fill="hold">
+                            <p:stCondLst>
+                              <p:cond delay="0"/>
+                            </p:stCondLst>
+                            <p:childTnLst>
+                              <p:par>
+                                <p:cTn fill="hold" nodeType="clickEffect" presetClass="entr" presetID="1" presetSubtype="0">
+                                  <p:stCondLst>
+                                    <p:cond delay="0"/>
+                                  </p:stCondLst>
+                                  <p:childTnLst>
+                                    <p:set>
+                                      <p:cBhvr>
+                                        <p:cTn dur="1" fill="hold">
+                                          <p:stCondLst>
+                                            <p:cond delay="0"/>
+                                          </p:stCondLst>
+                                        </p:cTn>
+                                        <p:tgtEl>
+                                          <p:spTgt spid="294">
+                                            <p:txEl>
+                                              <p:pRg end="6" st="6"/>
+                                            </p:txEl>
+                                          </p:spTgt>
+                                        </p:tgtEl>
+                                        <p:attrNameLst>
+                                          <p:attrName>style.visibility</p:attrName>
+                                        </p:attrNameLst>
+                                      </p:cBhvr>
+                                      <p:to>
+                                        <p:strVal val="visible"/>
+                                      </p:to>
+                                    </p:set>
+                                  </p:childTnLst>
+                                </p:cTn>
+                              </p:par>
+                            </p:childTnLst>
+                          </p:cTn>
+                        </p:par>
+                      </p:childTnLst>
+                    </p:cTn>
+                  </p:par>
+                  <p:par>
+                    <p:cTn fill="hold">
+                      <p:stCondLst>
+                        <p:cond delay="indefinite"/>
+                      </p:stCondLst>
+                      <p:childTnLst>
+                        <p:par>
+                          <p:cTn fill="hold">
+                            <p:stCondLst>
+                              <p:cond delay="0"/>
+                            </p:stCondLst>
+                            <p:childTnLst>
+                              <p:par>
+                                <p:cTn fill="hold" nodeType="clickEffect" presetClass="entr" presetID="1" presetSubtype="0">
+                                  <p:stCondLst>
+                                    <p:cond delay="0"/>
+                                  </p:stCondLst>
+                                  <p:childTnLst>
+                                    <p:set>
+                                      <p:cBhvr>
+                                        <p:cTn dur="1" fill="hold">
+                                          <p:stCondLst>
+                                            <p:cond delay="0"/>
+                                          </p:stCondLst>
+                                        </p:cTn>
+                                        <p:tgtEl>
+                                          <p:spTgt spid="294">
+                                            <p:txEl>
+                                              <p:pRg end="7" st="7"/>
+                                            </p:txEl>
+                                          </p:spTgt>
+                                        </p:tgtEl>
+                                        <p:attrNameLst>
+                                          <p:attrName>style.visibility</p:attrName>
+                                        </p:attrNameLst>
+                                      </p:cBhvr>
+                                      <p:to>
+                                        <p:strVal val="visible"/>
+                                      </p:to>
+                                    </p:set>
+                                  </p:childTnLst>
+                                </p:cTn>
+                              </p:par>
+                            </p:childTnLst>
+                          </p:cTn>
+                        </p:par>
+                      </p:childTnLst>
+                    </p:cTn>
+                  </p:par>
+                  <p:par>
+                    <p:cTn fill="hold">
+                      <p:stCondLst>
+                        <p:cond delay="indefinite"/>
+                      </p:stCondLst>
+                      <p:childTnLst>
+                        <p:par>
+                          <p:cTn fill="hold">
+                            <p:stCondLst>
+                              <p:cond delay="0"/>
+                            </p:stCondLst>
+                            <p:childTnLst>
+                              <p:par>
+                                <p:cTn fill="hold" nodeType="clickEffect" presetClass="entr" presetID="1" presetSubtype="0">
+                                  <p:stCondLst>
+                                    <p:cond delay="0"/>
+                                  </p:stCondLst>
+                                  <p:childTnLst>
+                                    <p:set>
+                                      <p:cBhvr>
+                                        <p:cTn dur="1" fill="hold">
+                                          <p:stCondLst>
+                                            <p:cond delay="0"/>
+                                          </p:stCondLst>
+                                        </p:cTn>
+                                        <p:tgtEl>
+                                          <p:spTgt spid="294">
+                                            <p:txEl>
+                                              <p:pRg end="8" st="8"/>
+                                            </p:txEl>
+                                          </p:spTgt>
+                                        </p:tgtEl>
+                                        <p:attrNameLst>
+                                          <p:attrName>style.visibility</p:attrName>
+                                        </p:attrNameLst>
+                                      </p:cBhvr>
+                                      <p:to>
+                                        <p:strVal val="visible"/>
+                                      </p:to>
+                                    </p:set>
+                                  </p:childTnLst>
+                                </p:cTn>
+                              </p:par>
+                            </p:childTnLst>
+                          </p:cTn>
+                        </p:par>
+                      </p:childTnLst>
+                    </p:cTn>
+                  </p:par>
+                  <p:par>
+                    <p:cTn fill="hold">
+                      <p:stCondLst>
+                        <p:cond delay="indefinite"/>
+                      </p:stCondLst>
+                      <p:childTnLst>
+                        <p:par>
+                          <p:cTn fill="hold">
+                            <p:stCondLst>
+                              <p:cond delay="0"/>
+                            </p:stCondLst>
+                            <p:childTnLst>
+                              <p:par>
+                                <p:cTn fill="hold" nodeType="clickEffect" presetClass="entr" presetID="1" presetSubtype="0">
+                                  <p:stCondLst>
+                                    <p:cond delay="0"/>
+                                  </p:stCondLst>
+                                  <p:childTnLst>
+                                    <p:set>
+                                      <p:cBhvr>
+                                        <p:cTn dur="1" fill="hold">
+                                          <p:stCondLst>
+                                            <p:cond delay="0"/>
+                                          </p:stCondLst>
+                                        </p:cTn>
+                                        <p:tgtEl>
+                                          <p:spTgt spid="294">
+                                            <p:txEl>
+                                              <p:pRg end="9" st="9"/>
+                                            </p:txEl>
+                                          </p:spTgt>
+                                        </p:tgtEl>
+                                        <p:attrNameLst>
+                                          <p:attrName>style.visibility</p:attrName>
+                                        </p:attrNameLst>
+                                      </p:cBhvr>
+                                      <p:to>
+                                        <p:strVal val="visible"/>
+                                      </p:to>
+                                    </p:set>
+                                  </p:childTnLst>
+                                </p:cTn>
+                              </p:par>
+                            </p:childTnLst>
+                          </p:cTn>
+                        </p:par>
+                      </p:childTnLst>
+                    </p:cTn>
+                  </p:par>
+                  <p:par>
+                    <p:cTn fill="hold">
+                      <p:stCondLst>
+                        <p:cond delay="indefinite"/>
+                      </p:stCondLst>
+                      <p:childTnLst>
+                        <p:par>
+                          <p:cTn fill="hold">
+                            <p:stCondLst>
+                              <p:cond delay="0"/>
+                            </p:stCondLst>
+                            <p:childTnLst>
+                              <p:par>
+                                <p:cTn fill="hold" nodeType="clickEffect" presetClass="entr" presetID="1" presetSubtype="0">
+                                  <p:stCondLst>
+                                    <p:cond delay="0"/>
+                                  </p:stCondLst>
+                                  <p:childTnLst>
+                                    <p:set>
+                                      <p:cBhvr>
+                                        <p:cTn dur="1" fill="hold">
+                                          <p:stCondLst>
+                                            <p:cond delay="0"/>
+                                          </p:stCondLst>
+                                        </p:cTn>
+                                        <p:tgtEl>
+                                          <p:spTgt spid="294">
+                                            <p:txEl>
+                                              <p:pRg end="10" st="10"/>
+                                            </p:txEl>
+                                          </p:spTgt>
+                                        </p:tgtEl>
+                                        <p:attrNameLst>
+                                          <p:attrName>style.visibility</p:attrName>
+                                        </p:attrNameLst>
+                                      </p:cBhvr>
+                                      <p:to>
+                                        <p:strVal val="visible"/>
+                                      </p:to>
+                                    </p:set>
+                                  </p:childTnLst>
+                                </p:cTn>
+                              </p:par>
+                            </p:childTnLst>
+                          </p:cTn>
+                        </p:par>
+                      </p:childTnLst>
+                    </p:cTn>
+                  </p:par>
+                  <p:par>
+                    <p:cTn fill="hold">
+                      <p:stCondLst>
+                        <p:cond delay="indefinite"/>
+                      </p:stCondLst>
+                      <p:childTnLst>
+                        <p:par>
+                          <p:cTn fill="hold">
+                            <p:stCondLst>
+                              <p:cond delay="0"/>
+                            </p:stCondLst>
+                            <p:childTnLst>
+                              <p:par>
+                                <p:cTn fill="hold" nodeType="clickEffect" presetClass="entr" presetID="1" presetSubtype="0">
+                                  <p:stCondLst>
+                                    <p:cond delay="0"/>
+                                  </p:stCondLst>
+                                  <p:childTnLst>
+                                    <p:set>
+                                      <p:cBhvr>
+                                        <p:cTn dur="1" fill="hold">
+                                          <p:stCondLst>
+                                            <p:cond delay="0"/>
+                                          </p:stCondLst>
+                                        </p:cTn>
+                                        <p:tgtEl>
+                                          <p:spTgt spid="294">
+                                            <p:txEl>
+                                              <p:pRg end="11" st="11"/>
+                                            </p:txEl>
+                                          </p:spTgt>
+                                        </p:tgtEl>
+                                        <p:attrNameLst>
+                                          <p:attrName>style.visibility</p:attrName>
+                                        </p:attrNameLst>
+                                      </p:cBhvr>
+                                      <p:to>
+                                        <p:strVal val="visible"/>
+                                      </p:to>
+                                    </p:set>
+                                  </p:childTnLst>
+                                </p:cTn>
+                              </p:par>
+                            </p:childTnLst>
+                          </p:cTn>
+                        </p:par>
+                      </p:childTnLst>
+                    </p:cTn>
+                  </p:par>
+                  <p:par>
+                    <p:cTn fill="hold">
+                      <p:stCondLst>
+                        <p:cond delay="indefinite"/>
+                      </p:stCondLst>
+                      <p:childTnLst>
+                        <p:par>
+                          <p:cTn fill="hold">
+                            <p:stCondLst>
+                              <p:cond delay="0"/>
+                            </p:stCondLst>
+                            <p:childTnLst>
+                              <p:par>
+                                <p:cTn fill="hold" nodeType="clickEffect" presetClass="entr" presetID="1" presetSubtype="0">
+                                  <p:stCondLst>
+                                    <p:cond delay="0"/>
+                                  </p:stCondLst>
+                                  <p:childTnLst>
+                                    <p:set>
+                                      <p:cBhvr>
+                                        <p:cTn dur="1" fill="hold">
+                                          <p:stCondLst>
+                                            <p:cond delay="0"/>
+                                          </p:stCondLst>
+                                        </p:cTn>
+                                        <p:tgtEl>
+                                          <p:spTgt spid="294">
+                                            <p:txEl>
+                                              <p:pRg end="12" st="12"/>
+                                            </p:txEl>
+                                          </p:spTgt>
+                                        </p:tgtEl>
+                                        <p:attrNameLst>
+                                          <p:attrName>style.visibility</p:attrName>
+                                        </p:attrNameLst>
+                                      </p:cBhvr>
+                                      <p:to>
+                                        <p:strVal val="visible"/>
+                                      </p:to>
+                                    </p:set>
+                                  </p:childTnLst>
+                                </p:cTn>
+                              </p:par>
+                            </p:childTnLst>
+                          </p:cTn>
+                        </p:par>
+                      </p:childTnLst>
+                    </p:cTn>
+                  </p:par>
+                </p:childTnLst>
+              </p:cTn>
+              <p:prevCondLst>
+                <p:cond evt="onPrev">
+                  <p:tgtEl>
+                    <p:sldTgt/>
+                  </p:tgtEl>
+                </p:cond>
+              </p:prevCondLst>
+              <p:nextCondLst>
+                <p:cond evt="onNext">
+                  <p:tgtEl>
+                    <p:sldTgt/>
+                  </p:tgtEl>
+                </p:cond>
+              </p:nextCondLst>
+            </p:seq>
+          </p:childTnLst>
+        </p:cTn>
+      </p:par>
+    </p:tnLst>
+  </p:timing>
 </p:sld>
 </file>
 
@@ -19414,6 +19022,179 @@
 </file>
 
 <file path=ppt/slides/slide40.xml><?xml version="1.0" encoding="utf-8"?>
+<p:sld xmlns:a="http://schemas.openxmlformats.org/drawingml/2006/main" xmlns:p="http://schemas.openxmlformats.org/presentationml/2006/main" xmlns:r="http://schemas.openxmlformats.org/officeDocument/2006/relationships">
+  <p:cSld>
+    <p:spTree>
+      <p:nvGrpSpPr>
+        <p:cNvPr id="1" name=""/>
+        <p:cNvGrpSpPr/>
+        <p:nvPr/>
+      </p:nvGrpSpPr>
+      <p:grpSpPr/>
+      <p:sp>
+        <p:nvSpPr>
+          <p:cNvPr id="2" name="Title 1"/>
+          <p:cNvSpPr>
+            <a:spLocks noGrp="1"/>
+          </p:cNvSpPr>
+          <p:nvPr>
+            <p:ph type="title"/>
+          </p:nvPr>
+        </p:nvSpPr>
+        <p:spPr/>
+        <p:txBody>
+          <a:bodyPr/>
+          <a:lstStyle/>
+          <a:p>
+            <a:pPr indent="0" lvl="0" marL="0" rtl="0" algn="l">
+              <a:spcBef>
+                <a:spcPts val="0"/>
+              </a:spcBef>
+              <a:spcAft>
+                <a:spcPts val="0"/>
+              </a:spcAft>
+              <a:buNone/>
+            </a:pPr>
+            <a:r>
+              <a:rPr lang="en"/>
+              <a:t>Check Yourself</a:t>
+            </a:r>
+            <a:endParaRPr/>
+          </a:p>
+        </p:txBody>
+      </p:sp>
+      <p:sp>
+        <p:nvSpPr>
+          <p:cNvPr id="3" name="Text Placeholder 2"/>
+          <p:cNvSpPr>
+            <a:spLocks noGrp="1"/>
+          </p:cNvSpPr>
+          <p:nvPr>
+            <p:ph type="body" idx="1"/>
+          </p:nvPr>
+        </p:nvSpPr>
+        <p:spPr>
+          <a:xfrm>
+            <a:off x="311700" y="885950"/>
+            <a:ext cx="8520600" cy="1719072"/>
+          </a:xfrm>
+        </p:spPr>
+        <p:txBody>
+          <a:bodyPr/>
+          <a:lstStyle/>
+          <a:p>
+            <a:pPr indent="-330200" lvl="0" marL="457200" rtl="0" algn="l">
+              <a:spcBef>
+                <a:spcPts val="0"/>
+              </a:spcBef>
+              <a:spcAft>
+                <a:spcPts val="0"/>
+              </a:spcAft>
+              <a:buSzPts val="1600"/>
+              <a:buChar char="●"/>
+            </a:pPr>
+            <a:r>
+              <a:rPr lang="en"/>
+              <a:t>Why prefer a texture atlas over many individual image files?</a:t>
+            </a:r>
+            <a:endParaRPr/>
+          </a:p>
+          <a:p>
+            <a:pPr indent="-330200" lvl="0" marL="457200" rtl="0" algn="l">
+              <a:spcBef>
+                <a:spcPts val="0"/>
+              </a:spcBef>
+              <a:spcAft>
+                <a:spcPts val="0"/>
+              </a:spcAft>
+              <a:buSzPts val="1600"/>
+              <a:buChar char="●"/>
+            </a:pPr>
+            <a:r>
+              <a:rPr lang="en"/>
+              <a:t>Why subtract the tick duration from the accumulator instead of resetting it?</a:t>
+            </a:r>
+            <a:endParaRPr/>
+          </a:p>
+          <a:p>
+            <a:pPr indent="-330200" lvl="0" marL="457200" rtl="0" algn="l">
+              <a:spcBef>
+                <a:spcPts val="0"/>
+              </a:spcBef>
+              <a:spcAft>
+                <a:spcPts val="0"/>
+              </a:spcAft>
+              <a:buSzPts val="1600"/>
+              <a:buChar char="●"/>
+            </a:pPr>
+            <a:r>
+              <a:rPr lang="en"/>
+              <a:t>What problems come from reading the keyboard inside gameplay code?</a:t>
+            </a:r>
+            <a:endParaRPr/>
+          </a:p>
+          <a:p>
+            <a:pPr indent="-330200" lvl="0" marL="457200" rtl="0" algn="l">
+              <a:spcBef>
+                <a:spcPts val="0"/>
+              </a:spcBef>
+              <a:spcAft>
+                <a:spcPts val="0"/>
+              </a:spcAft>
+              <a:buSzPts val="1600"/>
+              <a:buChar char="●"/>
+            </a:pPr>
+            <a:r>
+              <a:rPr lang="en"/>
+              <a:t>Why check a buffered turn against the last buffered direction?</a:t>
+            </a:r>
+            <a:endParaRPr/>
+          </a:p>
+        </p:txBody>
+      </p:sp>
+      <p:sp>
+        <p:nvSpPr>
+          <p:cNvPr id="4" name="TextBox 3"/>
+          <p:cNvSpPr txBox="1"/>
+          <p:nvPr/>
+        </p:nvSpPr>
+        <p:spPr>
+          <a:xfrm>
+            <a:off x="457200" y="3182112"/>
+            <a:ext cx="8229600" cy="457200"/>
+          </a:xfrm>
+          <a:prstGeom prst="rect">
+            <a:avLst/>
+          </a:prstGeom>
+          <a:noFill/>
+        </p:spPr>
+        <p:txBody>
+          <a:bodyPr wrap="square">
+            <a:spAutoFit/>
+          </a:bodyPr>
+          <a:lstStyle/>
+          <a:p>
+            <a:pPr algn="ctr"/>
+            <a:r>
+              <a:rPr sz="1400" b="0" i="0">
+                <a:solidFill>
+                  <a:srgbClr val="9AA3AB"/>
+                </a:solidFill>
+              </a:rPr>
+              <a:t>The answers, and more questions, are on the course site.</a:t>
+            </a:r>
+          </a:p>
+        </p:txBody>
+      </p:sp>
+    </p:spTree>
+  </p:cSld>
+  <p:clrMapOvr>
+    <a:masterClrMapping/>
+  </p:clrMapOvr>
+</p:sld>
+</file>
+
+<file path=ppt/slides/slide41.xml><?xml version="1.0" encoding="utf-8"?>
 <p:sld xmlns:a="http://schemas.openxmlformats.org/drawingml/2006/main" xmlns:r="http://schemas.openxmlformats.org/officeDocument/2006/relationships" xmlns:mc="http://schemas.openxmlformats.org/markup-compatibility/2006" xmlns:mv="urn:schemas-microsoft-com:mac:vml" xmlns:p="http://schemas.openxmlformats.org/presentationml/2006/main" xmlns:c="http://schemas.openxmlformats.org/drawingml/2006/chart" xmlns:dgm="http://schemas.openxmlformats.org/drawingml/2006/diagram" xmlns:o="urn:schemas-microsoft-com:office:office" xmlns:v="urn:schemas-microsoft-com:vml" xmlns:pvml="urn:schemas-microsoft-com:office:powerpoint" xmlns:com="http://schemas.openxmlformats.org/drawingml/2006/compatibility" xmlns:p14="http://schemas.microsoft.com/office/powerpoint/2010/main" xmlns:p15="http://schemas.microsoft.com/office/powerpoint/2012/main" xmlns:ahyp="http://schemas.microsoft.com/office/drawing/2018/hyperlinkcolor">
   <p:cSld>
     <p:spTree>

</xml_diff>